<commit_message>
Add Option E (slide 11): combined conclusion — impact rail + equation + why GS + testimonial + partners
Co-Authored-By: Claude Fable 5 <noreply@anthropic.com>
Claude-Session: https://claude.ai/code/session_01XoYepLRLVLdWS74xAsgg39
</commit_message>
<xml_diff>
--- a/AkshayaPatra_GS_Pitch.pptx
+++ b/AkshayaPatra_GS_Pitch.pptx
@@ -15,6 +15,7 @@
     <p:sldId id="263" r:id="rId14"/>
     <p:sldId id="264" r:id="rId15"/>
     <p:sldId id="265" r:id="rId16"/>
+    <p:sldId id="266" r:id="rId17"/>
   </p:sldIdLst>
   <p:sldSz cx="9144000" cy="6858000" type="screen4x3"/>
   <p:notesSz cx="6858000" cy="9144000"/>
@@ -8287,6 +8288,2677 @@
           <a:xfrm>
             <a:off x="7933943" y="5376672"/>
             <a:ext cx="789432" cy="384048"/>
+          </a:xfrm>
+          <a:prstGeom prst="rect">
+            <a:avLst/>
+          </a:prstGeom>
+          <a:noFill/>
+        </p:spPr>
+        <p:txBody>
+          <a:bodyPr wrap="square" lIns="0" rIns="0" tIns="0" bIns="0" anchor="ctr">
+            <a:spAutoFit/>
+          </a:bodyPr>
+          <a:lstStyle/>
+          <a:p>
+            <a:pPr algn="ctr">
+              <a:lnSpc>
+                <a:spcPct val="100000"/>
+              </a:lnSpc>
+              <a:spcBef>
+                <a:spcPts val="0"/>
+              </a:spcBef>
+              <a:spcAft>
+                <a:spcPts val="100"/>
+              </a:spcAft>
+            </a:pPr>
+            <a:r>
+              <a:rPr sz="850" b="1" i="0">
+                <a:solidFill>
+                  <a:srgbClr val="727375"/>
+                </a:solidFill>
+                <a:latin typeface="Arial"/>
+              </a:rPr>
+              <a:t>SBI</a:t>
+            </a:r>
+          </a:p>
+        </p:txBody>
+      </p:sp>
+    </p:spTree>
+  </p:cSld>
+  <p:clrMapOvr>
+    <a:masterClrMapping/>
+  </p:clrMapOvr>
+</p:sld>
+</file>
+
+<file path=ppt/slides/slide11.xml><?xml version="1.0" encoding="utf-8"?>
+<p:sld xmlns:a="http://schemas.openxmlformats.org/drawingml/2006/main" xmlns:p="http://schemas.openxmlformats.org/presentationml/2006/main" xmlns:r="http://schemas.openxmlformats.org/officeDocument/2006/relationships">
+  <p:cSld>
+    <p:spTree>
+      <p:nvGrpSpPr>
+        <p:cNvPr id="1" name=""/>
+        <p:cNvGrpSpPr/>
+        <p:nvPr/>
+      </p:nvGrpSpPr>
+      <p:grpSpPr/>
+      <p:sp>
+        <p:nvSpPr>
+          <p:cNvPr id="2" name="Rectangle 1"/>
+          <p:cNvSpPr/>
+          <p:nvPr/>
+        </p:nvSpPr>
+        <p:spPr>
+          <a:xfrm>
+            <a:off x="365760" y="274320"/>
+            <a:ext cx="8412480" cy="23774"/>
+          </a:xfrm>
+          <a:prstGeom prst="rect">
+            <a:avLst/>
+          </a:prstGeom>
+          <a:solidFill>
+            <a:srgbClr val="1B3E6E"/>
+          </a:solidFill>
+          <a:ln>
+            <a:noFill/>
+          </a:ln>
+          <a:effectLst/>
+        </p:spPr>
+        <p:style>
+          <a:lnRef idx="1">
+            <a:schemeClr val="accent1"/>
+          </a:lnRef>
+          <a:fillRef idx="3">
+            <a:schemeClr val="accent1"/>
+          </a:fillRef>
+          <a:effectRef idx="2">
+            <a:schemeClr val="accent1"/>
+          </a:effectRef>
+          <a:fontRef idx="minor">
+            <a:schemeClr val="lt1"/>
+          </a:fontRef>
+        </p:style>
+        <p:txBody>
+          <a:bodyPr rtlCol="0" anchor="ctr"/>
+          <a:lstStyle/>
+          <a:p>
+            <a:pPr algn="ctr"/>
+          </a:p>
+        </p:txBody>
+      </p:sp>
+      <p:sp>
+        <p:nvSpPr>
+          <p:cNvPr id="3" name="TextBox 2"/>
+          <p:cNvSpPr txBox="1"/>
+          <p:nvPr/>
+        </p:nvSpPr>
+        <p:spPr>
+          <a:xfrm>
+            <a:off x="365760" y="365760"/>
+            <a:ext cx="8412480" cy="457200"/>
+          </a:xfrm>
+          <a:prstGeom prst="rect">
+            <a:avLst/>
+          </a:prstGeom>
+          <a:noFill/>
+        </p:spPr>
+        <p:txBody>
+          <a:bodyPr wrap="square" lIns="0" rIns="0" tIns="0" bIns="0" anchor="t">
+            <a:spAutoFit/>
+          </a:bodyPr>
+          <a:lstStyle/>
+          <a:p>
+            <a:pPr algn="l">
+              <a:lnSpc>
+                <a:spcPct val="100000"/>
+              </a:lnSpc>
+              <a:spcBef>
+                <a:spcPts val="0"/>
+              </a:spcBef>
+              <a:spcAft>
+                <a:spcPts val="0"/>
+              </a:spcAft>
+            </a:pPr>
+            <a:r>
+              <a:rPr sz="2000" b="0" i="0">
+                <a:solidFill>
+                  <a:srgbClr val="1B3E6E"/>
+                </a:solidFill>
+                <a:latin typeface="Georgia"/>
+              </a:rPr>
+              <a:t>Conclusion — why Akshaya Patra, and why this proposal wins</a:t>
+            </a:r>
+          </a:p>
+        </p:txBody>
+      </p:sp>
+      <p:sp>
+        <p:nvSpPr>
+          <p:cNvPr id="4" name="TextBox 3"/>
+          <p:cNvSpPr txBox="1"/>
+          <p:nvPr/>
+        </p:nvSpPr>
+        <p:spPr>
+          <a:xfrm>
+            <a:off x="365760" y="822960"/>
+            <a:ext cx="8412480" cy="438912"/>
+          </a:xfrm>
+          <a:prstGeom prst="rect">
+            <a:avLst/>
+          </a:prstGeom>
+          <a:noFill/>
+        </p:spPr>
+        <p:txBody>
+          <a:bodyPr wrap="square" lIns="0" rIns="0" tIns="0" bIns="0" anchor="t">
+            <a:spAutoFit/>
+          </a:bodyPr>
+          <a:lstStyle/>
+          <a:p>
+            <a:pPr algn="l">
+              <a:lnSpc>
+                <a:spcPct val="100000"/>
+              </a:lnSpc>
+              <a:spcBef>
+                <a:spcPts val="0"/>
+              </a:spcBef>
+              <a:spcAft>
+                <a:spcPts val="0"/>
+              </a:spcAft>
+            </a:pPr>
+            <a:r>
+              <a:rPr sz="1050" b="0" i="0">
+                <a:solidFill>
+                  <a:srgbClr val="333333"/>
+                </a:solidFill>
+                <a:latin typeface="Arial"/>
+              </a:rPr>
+              <a:t>A proven engine of social mobility, a grant that compounds instead of depletes, and a partnership only Goldman Sachs can power.</a:t>
+            </a:r>
+          </a:p>
+        </p:txBody>
+      </p:sp>
+      <p:sp>
+        <p:nvSpPr>
+          <p:cNvPr id="5" name="Rectangle 4"/>
+          <p:cNvSpPr/>
+          <p:nvPr/>
+        </p:nvSpPr>
+        <p:spPr>
+          <a:xfrm>
+            <a:off x="502920" y="6071616"/>
+            <a:ext cx="8138159" cy="365760"/>
+          </a:xfrm>
+          <a:prstGeom prst="rect">
+            <a:avLst/>
+          </a:prstGeom>
+          <a:solidFill>
+            <a:srgbClr val="D9D9D9"/>
+          </a:solidFill>
+          <a:ln>
+            <a:noFill/>
+          </a:ln>
+          <a:effectLst/>
+        </p:spPr>
+        <p:style>
+          <a:lnRef idx="1">
+            <a:schemeClr val="accent1"/>
+          </a:lnRef>
+          <a:fillRef idx="3">
+            <a:schemeClr val="accent1"/>
+          </a:fillRef>
+          <a:effectRef idx="2">
+            <a:schemeClr val="accent1"/>
+          </a:effectRef>
+          <a:fontRef idx="minor">
+            <a:schemeClr val="lt1"/>
+          </a:fontRef>
+        </p:style>
+        <p:txBody>
+          <a:bodyPr rtlCol="0" anchor="ctr"/>
+          <a:lstStyle/>
+          <a:p>
+            <a:pPr algn="ctr"/>
+          </a:p>
+        </p:txBody>
+      </p:sp>
+      <p:sp>
+        <p:nvSpPr>
+          <p:cNvPr id="6" name="TextBox 5"/>
+          <p:cNvSpPr txBox="1"/>
+          <p:nvPr/>
+        </p:nvSpPr>
+        <p:spPr>
+          <a:xfrm>
+            <a:off x="640080" y="6071616"/>
+            <a:ext cx="7863840" cy="365760"/>
+          </a:xfrm>
+          <a:prstGeom prst="rect">
+            <a:avLst/>
+          </a:prstGeom>
+          <a:noFill/>
+        </p:spPr>
+        <p:txBody>
+          <a:bodyPr wrap="square" lIns="0" rIns="0" tIns="0" bIns="0" anchor="ctr">
+            <a:spAutoFit/>
+          </a:bodyPr>
+          <a:lstStyle/>
+          <a:p>
+            <a:pPr algn="ctr">
+              <a:lnSpc>
+                <a:spcPct val="95000"/>
+              </a:lnSpc>
+              <a:spcBef>
+                <a:spcPts val="0"/>
+              </a:spcBef>
+              <a:spcAft>
+                <a:spcPts val="0"/>
+              </a:spcAft>
+            </a:pPr>
+            <a:r>
+              <a:rPr sz="1100" b="1" i="0">
+                <a:solidFill>
+                  <a:srgbClr val="1B3E6E"/>
+                </a:solidFill>
+                <a:latin typeface="Georgia"/>
+              </a:rPr>
+              <a:t>$250k that doesn't feed children for a year — it upgrades the engine that feeds them forever.</a:t>
+            </a:r>
+          </a:p>
+        </p:txBody>
+      </p:sp>
+      <p:sp>
+        <p:nvSpPr>
+          <p:cNvPr id="7" name="TextBox 6"/>
+          <p:cNvSpPr txBox="1"/>
+          <p:nvPr/>
+        </p:nvSpPr>
+        <p:spPr>
+          <a:xfrm>
+            <a:off x="365760" y="6492240"/>
+            <a:ext cx="1280160" cy="329184"/>
+          </a:xfrm>
+          <a:prstGeom prst="rect">
+            <a:avLst/>
+          </a:prstGeom>
+          <a:noFill/>
+        </p:spPr>
+        <p:txBody>
+          <a:bodyPr wrap="square" lIns="0" rIns="0" tIns="0" bIns="0" anchor="t">
+            <a:spAutoFit/>
+          </a:bodyPr>
+          <a:lstStyle/>
+          <a:p>
+            <a:pPr algn="l">
+              <a:lnSpc>
+                <a:spcPct val="90000"/>
+              </a:lnSpc>
+              <a:spcBef>
+                <a:spcPts val="0"/>
+              </a:spcBef>
+              <a:spcAft>
+                <a:spcPts val="0"/>
+              </a:spcAft>
+            </a:pPr>
+            <a:r>
+              <a:rPr sz="900" b="1" i="0">
+                <a:solidFill>
+                  <a:srgbClr val="111111"/>
+                </a:solidFill>
+                <a:latin typeface="Georgia"/>
+              </a:rPr>
+              <a:t>Goldman</a:t>
+            </a:r>
+          </a:p>
+          <a:p>
+            <a:pPr algn="l">
+              <a:lnSpc>
+                <a:spcPct val="90000"/>
+              </a:lnSpc>
+              <a:spcBef>
+                <a:spcPts val="0"/>
+              </a:spcBef>
+              <a:spcAft>
+                <a:spcPts val="0"/>
+              </a:spcAft>
+            </a:pPr>
+            <a:r>
+              <a:rPr sz="900" b="1" i="0">
+                <a:solidFill>
+                  <a:srgbClr val="111111"/>
+                </a:solidFill>
+                <a:latin typeface="Georgia"/>
+              </a:rPr>
+              <a:t>Sachs</a:t>
+            </a:r>
+          </a:p>
+        </p:txBody>
+      </p:sp>
+      <p:sp>
+        <p:nvSpPr>
+          <p:cNvPr id="8" name="TextBox 7"/>
+          <p:cNvSpPr txBox="1"/>
+          <p:nvPr/>
+        </p:nvSpPr>
+        <p:spPr>
+          <a:xfrm>
+            <a:off x="8321040" y="6528816"/>
+            <a:ext cx="457200" cy="274320"/>
+          </a:xfrm>
+          <a:prstGeom prst="rect">
+            <a:avLst/>
+          </a:prstGeom>
+          <a:noFill/>
+        </p:spPr>
+        <p:txBody>
+          <a:bodyPr wrap="square" lIns="0" rIns="0" tIns="0" bIns="0" anchor="t">
+            <a:spAutoFit/>
+          </a:bodyPr>
+          <a:lstStyle/>
+          <a:p>
+            <a:pPr algn="r">
+              <a:lnSpc>
+                <a:spcPct val="100000"/>
+              </a:lnSpc>
+              <a:spcBef>
+                <a:spcPts val="0"/>
+              </a:spcBef>
+              <a:spcAft>
+                <a:spcPts val="300"/>
+              </a:spcAft>
+            </a:pPr>
+            <a:r>
+              <a:rPr sz="900" b="0" i="0">
+                <a:solidFill>
+                  <a:srgbClr val="727375"/>
+                </a:solidFill>
+                <a:latin typeface="Arial"/>
+              </a:rPr>
+              <a:t>11</a:t>
+            </a:r>
+          </a:p>
+        </p:txBody>
+      </p:sp>
+      <p:sp>
+        <p:nvSpPr>
+          <p:cNvPr id="9" name="TextBox 8"/>
+          <p:cNvSpPr txBox="1"/>
+          <p:nvPr/>
+        </p:nvSpPr>
+        <p:spPr>
+          <a:xfrm>
+            <a:off x="5486400" y="54864"/>
+            <a:ext cx="3291840" cy="182880"/>
+          </a:xfrm>
+          <a:prstGeom prst="rect">
+            <a:avLst/>
+          </a:prstGeom>
+          <a:noFill/>
+        </p:spPr>
+        <p:txBody>
+          <a:bodyPr wrap="square" lIns="0" rIns="0" tIns="0" bIns="0" anchor="t">
+            <a:spAutoFit/>
+          </a:bodyPr>
+          <a:lstStyle/>
+          <a:p>
+            <a:pPr algn="r">
+              <a:lnSpc>
+                <a:spcPct val="100000"/>
+              </a:lnSpc>
+              <a:spcBef>
+                <a:spcPts val="0"/>
+              </a:spcBef>
+              <a:spcAft>
+                <a:spcPts val="0"/>
+              </a:spcAft>
+            </a:pPr>
+            <a:r>
+              <a:rPr sz="750" b="0" i="1">
+                <a:solidFill>
+                  <a:srgbClr val="727375"/>
+                </a:solidFill>
+                <a:latin typeface="Arial"/>
+              </a:rPr>
+              <a:t>LAYOUT OPTION E — combined</a:t>
+            </a:r>
+          </a:p>
+        </p:txBody>
+      </p:sp>
+      <p:sp>
+        <p:nvSpPr>
+          <p:cNvPr id="10" name="TextBox 9"/>
+          <p:cNvSpPr txBox="1"/>
+          <p:nvPr/>
+        </p:nvSpPr>
+        <p:spPr>
+          <a:xfrm>
+            <a:off x="365760" y="1389888"/>
+            <a:ext cx="2331720" cy="219456"/>
+          </a:xfrm>
+          <a:prstGeom prst="rect">
+            <a:avLst/>
+          </a:prstGeom>
+          <a:noFill/>
+        </p:spPr>
+        <p:txBody>
+          <a:bodyPr wrap="square" lIns="0" rIns="0" tIns="0" bIns="0" anchor="t">
+            <a:spAutoFit/>
+          </a:bodyPr>
+          <a:lstStyle/>
+          <a:p>
+            <a:pPr algn="l">
+              <a:lnSpc>
+                <a:spcPct val="100000"/>
+              </a:lnSpc>
+              <a:spcBef>
+                <a:spcPts val="0"/>
+              </a:spcBef>
+              <a:spcAft>
+                <a:spcPts val="0"/>
+              </a:spcAft>
+            </a:pPr>
+            <a:r>
+              <a:rPr sz="900" b="1" i="0">
+                <a:solidFill>
+                  <a:srgbClr val="1B3E6E"/>
+                </a:solidFill>
+                <a:latin typeface="Arial"/>
+              </a:rPr>
+              <a:t>THE FUND &amp; ITS IMPACT</a:t>
+            </a:r>
+          </a:p>
+        </p:txBody>
+      </p:sp>
+      <p:sp>
+        <p:nvSpPr>
+          <p:cNvPr id="11" name="Rectangle 10"/>
+          <p:cNvSpPr/>
+          <p:nvPr/>
+        </p:nvSpPr>
+        <p:spPr>
+          <a:xfrm>
+            <a:off x="365760" y="1645920"/>
+            <a:ext cx="2331720" cy="12801"/>
+          </a:xfrm>
+          <a:prstGeom prst="rect">
+            <a:avLst/>
+          </a:prstGeom>
+          <a:solidFill>
+            <a:srgbClr val="BFBFBF"/>
+          </a:solidFill>
+          <a:ln>
+            <a:noFill/>
+          </a:ln>
+          <a:effectLst/>
+        </p:spPr>
+        <p:style>
+          <a:lnRef idx="1">
+            <a:schemeClr val="accent1"/>
+          </a:lnRef>
+          <a:fillRef idx="3">
+            <a:schemeClr val="accent1"/>
+          </a:fillRef>
+          <a:effectRef idx="2">
+            <a:schemeClr val="accent1"/>
+          </a:effectRef>
+          <a:fontRef idx="minor">
+            <a:schemeClr val="lt1"/>
+          </a:fontRef>
+        </p:style>
+        <p:txBody>
+          <a:bodyPr rtlCol="0" anchor="ctr"/>
+          <a:lstStyle/>
+          <a:p>
+            <a:pPr algn="ctr"/>
+          </a:p>
+        </p:txBody>
+      </p:sp>
+      <p:sp>
+        <p:nvSpPr>
+          <p:cNvPr id="12" name="TextBox 11"/>
+          <p:cNvSpPr txBox="1"/>
+          <p:nvPr/>
+        </p:nvSpPr>
+        <p:spPr>
+          <a:xfrm>
+            <a:off x="365760" y="1810512"/>
+            <a:ext cx="2331720" cy="841248"/>
+          </a:xfrm>
+          <a:prstGeom prst="rect">
+            <a:avLst/>
+          </a:prstGeom>
+          <a:noFill/>
+        </p:spPr>
+        <p:txBody>
+          <a:bodyPr wrap="square" lIns="0" rIns="0" tIns="0" bIns="0" anchor="t">
+            <a:spAutoFit/>
+          </a:bodyPr>
+          <a:lstStyle/>
+          <a:p>
+            <a:pPr algn="l">
+              <a:lnSpc>
+                <a:spcPct val="100000"/>
+              </a:lnSpc>
+              <a:spcBef>
+                <a:spcPts val="0"/>
+              </a:spcBef>
+              <a:spcAft>
+                <a:spcPts val="100"/>
+              </a:spcAft>
+            </a:pPr>
+            <a:r>
+              <a:rPr sz="2300" b="1" i="0">
+                <a:solidFill>
+                  <a:srgbClr val="1B3E6E"/>
+                </a:solidFill>
+                <a:latin typeface="Georgia"/>
+              </a:rPr>
+              <a:t>$250k</a:t>
+            </a:r>
+          </a:p>
+          <a:p>
+            <a:pPr algn="l">
+              <a:lnSpc>
+                <a:spcPct val="95000"/>
+              </a:lnSpc>
+              <a:spcBef>
+                <a:spcPts val="0"/>
+              </a:spcBef>
+              <a:spcAft>
+                <a:spcPts val="0"/>
+              </a:spcAft>
+            </a:pPr>
+            <a:r>
+              <a:rPr sz="740" b="0" i="0">
+                <a:solidFill>
+                  <a:srgbClr val="727375"/>
+                </a:solidFill>
+                <a:latin typeface="Arial"/>
+              </a:rPr>
+              <a:t>one-time grant</a:t>
+            </a:r>
+          </a:p>
+        </p:txBody>
+      </p:sp>
+      <p:cxnSp>
+        <p:nvCxnSpPr>
+          <p:cNvPr id="13" name="Connector 12"/>
+          <p:cNvCxnSpPr/>
+          <p:nvPr/>
+        </p:nvCxnSpPr>
+        <p:spPr>
+          <a:xfrm>
+            <a:off x="667512" y="2505456"/>
+            <a:ext cx="0" cy="256032"/>
+          </a:xfrm>
+          <a:prstGeom prst="line">
+            <a:avLst/>
+          </a:prstGeom>
+          <a:ln w="12700">
+            <a:solidFill>
+              <a:srgbClr val="BFBFBF"/>
+            </a:solidFill>
+            <a:prstDash val="sysDash"/>
+            <a:tailEnd type="triangle" w="med" len="med"/>
+          </a:ln>
+          <a:effectLst/>
+        </p:spPr>
+        <p:style>
+          <a:lnRef idx="2">
+            <a:schemeClr val="accent1"/>
+          </a:lnRef>
+          <a:fillRef idx="0">
+            <a:schemeClr val="accent1"/>
+          </a:fillRef>
+          <a:effectRef idx="1">
+            <a:schemeClr val="accent1"/>
+          </a:effectRef>
+          <a:fontRef idx="minor">
+            <a:schemeClr val="tx1"/>
+          </a:fontRef>
+        </p:style>
+      </p:cxnSp>
+      <p:sp>
+        <p:nvSpPr>
+          <p:cNvPr id="14" name="TextBox 13"/>
+          <p:cNvSpPr txBox="1"/>
+          <p:nvPr/>
+        </p:nvSpPr>
+        <p:spPr>
+          <a:xfrm>
+            <a:off x="365760" y="2852928"/>
+            <a:ext cx="2331720" cy="841248"/>
+          </a:xfrm>
+          <a:prstGeom prst="rect">
+            <a:avLst/>
+          </a:prstGeom>
+          <a:noFill/>
+        </p:spPr>
+        <p:txBody>
+          <a:bodyPr wrap="square" lIns="0" rIns="0" tIns="0" bIns="0" anchor="t">
+            <a:spAutoFit/>
+          </a:bodyPr>
+          <a:lstStyle/>
+          <a:p>
+            <a:pPr algn="l">
+              <a:lnSpc>
+                <a:spcPct val="100000"/>
+              </a:lnSpc>
+              <a:spcBef>
+                <a:spcPts val="0"/>
+              </a:spcBef>
+              <a:spcAft>
+                <a:spcPts val="100"/>
+              </a:spcAft>
+            </a:pPr>
+            <a:r>
+              <a:rPr sz="1800" b="1" i="0">
+                <a:solidFill>
+                  <a:srgbClr val="398025"/>
+                </a:solidFill>
+                <a:latin typeface="Georgia"/>
+              </a:rPr>
+              <a:t>$310k / yr</a:t>
+            </a:r>
+          </a:p>
+          <a:p>
+            <a:pPr algn="l">
+              <a:lnSpc>
+                <a:spcPct val="95000"/>
+              </a:lnSpc>
+              <a:spcBef>
+                <a:spcPts val="0"/>
+              </a:spcBef>
+              <a:spcAft>
+                <a:spcPts val="0"/>
+              </a:spcAft>
+            </a:pPr>
+            <a:r>
+              <a:rPr sz="740" b="0" i="0">
+                <a:solidFill>
+                  <a:srgbClr val="727375"/>
+                </a:solidFill>
+                <a:latin typeface="Arial"/>
+              </a:rPr>
+              <a:t>returned in audited savings — every single year</a:t>
+            </a:r>
+          </a:p>
+        </p:txBody>
+      </p:sp>
+      <p:cxnSp>
+        <p:nvCxnSpPr>
+          <p:cNvPr id="15" name="Connector 14"/>
+          <p:cNvCxnSpPr/>
+          <p:nvPr/>
+        </p:nvCxnSpPr>
+        <p:spPr>
+          <a:xfrm>
+            <a:off x="667512" y="3547872"/>
+            <a:ext cx="0" cy="256032"/>
+          </a:xfrm>
+          <a:prstGeom prst="line">
+            <a:avLst/>
+          </a:prstGeom>
+          <a:ln w="12700">
+            <a:solidFill>
+              <a:srgbClr val="BFBFBF"/>
+            </a:solidFill>
+            <a:prstDash val="sysDash"/>
+            <a:tailEnd type="triangle" w="med" len="med"/>
+          </a:ln>
+          <a:effectLst/>
+        </p:spPr>
+        <p:style>
+          <a:lnRef idx="2">
+            <a:schemeClr val="accent1"/>
+          </a:lnRef>
+          <a:fillRef idx="0">
+            <a:schemeClr val="accent1"/>
+          </a:fillRef>
+          <a:effectRef idx="1">
+            <a:schemeClr val="accent1"/>
+          </a:effectRef>
+          <a:fontRef idx="minor">
+            <a:schemeClr val="tx1"/>
+          </a:fontRef>
+        </p:style>
+      </p:cxnSp>
+      <p:sp>
+        <p:nvSpPr>
+          <p:cNvPr id="16" name="TextBox 15"/>
+          <p:cNvSpPr txBox="1"/>
+          <p:nvPr/>
+        </p:nvSpPr>
+        <p:spPr>
+          <a:xfrm>
+            <a:off x="365760" y="3895344"/>
+            <a:ext cx="2331720" cy="841248"/>
+          </a:xfrm>
+          <a:prstGeom prst="rect">
+            <a:avLst/>
+          </a:prstGeom>
+          <a:noFill/>
+        </p:spPr>
+        <p:txBody>
+          <a:bodyPr wrap="square" lIns="0" rIns="0" tIns="0" bIns="0" anchor="t">
+            <a:spAutoFit/>
+          </a:bodyPr>
+          <a:lstStyle/>
+          <a:p>
+            <a:pPr algn="l">
+              <a:lnSpc>
+                <a:spcPct val="100000"/>
+              </a:lnSpc>
+              <a:spcBef>
+                <a:spcPts val="0"/>
+              </a:spcBef>
+              <a:spcAft>
+                <a:spcPts val="100"/>
+              </a:spcAft>
+            </a:pPr>
+            <a:r>
+              <a:rPr sz="1800" b="1" i="0">
+                <a:solidFill>
+                  <a:srgbClr val="1B3E6E"/>
+                </a:solidFill>
+                <a:latin typeface="Georgia"/>
+              </a:rPr>
+              <a:t>+105,000</a:t>
+            </a:r>
+          </a:p>
+          <a:p>
+            <a:pPr algn="l">
+              <a:lnSpc>
+                <a:spcPct val="95000"/>
+              </a:lnSpc>
+              <a:spcBef>
+                <a:spcPts val="0"/>
+              </a:spcBef>
+              <a:spcAft>
+                <a:spcPts val="0"/>
+              </a:spcAft>
+            </a:pPr>
+            <a:r>
+              <a:rPr sz="740" b="0" i="0">
+                <a:solidFill>
+                  <a:srgbClr val="727375"/>
+                </a:solidFill>
+                <a:latin typeface="Arial"/>
+              </a:rPr>
+              <a:t>children fed per year at zero extra cost</a:t>
+            </a:r>
+          </a:p>
+        </p:txBody>
+      </p:sp>
+      <p:cxnSp>
+        <p:nvCxnSpPr>
+          <p:cNvPr id="17" name="Connector 16"/>
+          <p:cNvCxnSpPr/>
+          <p:nvPr/>
+        </p:nvCxnSpPr>
+        <p:spPr>
+          <a:xfrm>
+            <a:off x="667512" y="4590288"/>
+            <a:ext cx="0" cy="256032"/>
+          </a:xfrm>
+          <a:prstGeom prst="line">
+            <a:avLst/>
+          </a:prstGeom>
+          <a:ln w="12700">
+            <a:solidFill>
+              <a:srgbClr val="BFBFBF"/>
+            </a:solidFill>
+            <a:prstDash val="sysDash"/>
+            <a:tailEnd type="triangle" w="med" len="med"/>
+          </a:ln>
+          <a:effectLst/>
+        </p:spPr>
+        <p:style>
+          <a:lnRef idx="2">
+            <a:schemeClr val="accent1"/>
+          </a:lnRef>
+          <a:fillRef idx="0">
+            <a:schemeClr val="accent1"/>
+          </a:fillRef>
+          <a:effectRef idx="1">
+            <a:schemeClr val="accent1"/>
+          </a:effectRef>
+          <a:fontRef idx="minor">
+            <a:schemeClr val="tx1"/>
+          </a:fontRef>
+        </p:style>
+      </p:cxnSp>
+      <p:sp>
+        <p:nvSpPr>
+          <p:cNvPr id="18" name="TextBox 17"/>
+          <p:cNvSpPr txBox="1"/>
+          <p:nvPr/>
+        </p:nvSpPr>
+        <p:spPr>
+          <a:xfrm>
+            <a:off x="365760" y="4937759"/>
+            <a:ext cx="2331720" cy="841248"/>
+          </a:xfrm>
+          <a:prstGeom prst="rect">
+            <a:avLst/>
+          </a:prstGeom>
+          <a:noFill/>
+        </p:spPr>
+        <p:txBody>
+          <a:bodyPr wrap="square" lIns="0" rIns="0" tIns="0" bIns="0" anchor="t">
+            <a:spAutoFit/>
+          </a:bodyPr>
+          <a:lstStyle/>
+          <a:p>
+            <a:pPr algn="l">
+              <a:lnSpc>
+                <a:spcPct val="100000"/>
+              </a:lnSpc>
+              <a:spcBef>
+                <a:spcPts val="0"/>
+              </a:spcBef>
+              <a:spcAft>
+                <a:spcPts val="100"/>
+              </a:spcAft>
+            </a:pPr>
+            <a:r>
+              <a:rPr sz="1500" b="1" i="0">
+                <a:solidFill>
+                  <a:srgbClr val="E08A1E"/>
+                </a:solidFill>
+                <a:latin typeface="Georgia"/>
+              </a:rPr>
+              <a:t>&lt; 10 months</a:t>
+            </a:r>
+          </a:p>
+          <a:p>
+            <a:pPr algn="l">
+              <a:lnSpc>
+                <a:spcPct val="95000"/>
+              </a:lnSpc>
+              <a:spcBef>
+                <a:spcPts val="0"/>
+              </a:spcBef>
+              <a:spcAft>
+                <a:spcPts val="0"/>
+              </a:spcAft>
+            </a:pPr>
+            <a:r>
+              <a:rPr sz="740" b="0" i="0">
+                <a:solidFill>
+                  <a:srgbClr val="727375"/>
+                </a:solidFill>
+                <a:latin typeface="Arial"/>
+              </a:rPr>
+              <a:t>payback on the full grant</a:t>
+            </a:r>
+          </a:p>
+        </p:txBody>
+      </p:sp>
+      <p:sp>
+        <p:nvSpPr>
+          <p:cNvPr id="19" name="Rectangle 18"/>
+          <p:cNvSpPr/>
+          <p:nvPr/>
+        </p:nvSpPr>
+        <p:spPr>
+          <a:xfrm>
+            <a:off x="2788920" y="1417320"/>
+            <a:ext cx="10972" cy="4480560"/>
+          </a:xfrm>
+          <a:prstGeom prst="rect">
+            <a:avLst/>
+          </a:prstGeom>
+          <a:solidFill>
+            <a:srgbClr val="DDDDDD"/>
+          </a:solidFill>
+          <a:ln>
+            <a:noFill/>
+          </a:ln>
+          <a:effectLst/>
+        </p:spPr>
+        <p:style>
+          <a:lnRef idx="1">
+            <a:schemeClr val="accent1"/>
+          </a:lnRef>
+          <a:fillRef idx="3">
+            <a:schemeClr val="accent1"/>
+          </a:fillRef>
+          <a:effectRef idx="2">
+            <a:schemeClr val="accent1"/>
+          </a:effectRef>
+          <a:fontRef idx="minor">
+            <a:schemeClr val="lt1"/>
+          </a:fontRef>
+        </p:style>
+        <p:txBody>
+          <a:bodyPr rtlCol="0" anchor="ctr"/>
+          <a:lstStyle/>
+          <a:p>
+            <a:pPr algn="ctr"/>
+          </a:p>
+        </p:txBody>
+      </p:sp>
+      <p:sp>
+        <p:nvSpPr>
+          <p:cNvPr id="20" name="Rectangle 19"/>
+          <p:cNvSpPr/>
+          <p:nvPr/>
+        </p:nvSpPr>
+        <p:spPr>
+          <a:xfrm>
+            <a:off x="3063240" y="1399032"/>
+            <a:ext cx="54864" cy="182880"/>
+          </a:xfrm>
+          <a:prstGeom prst="rect">
+            <a:avLst/>
+          </a:prstGeom>
+          <a:solidFill>
+            <a:srgbClr val="3B6EA5"/>
+          </a:solidFill>
+          <a:ln>
+            <a:noFill/>
+          </a:ln>
+          <a:effectLst/>
+        </p:spPr>
+        <p:style>
+          <a:lnRef idx="1">
+            <a:schemeClr val="accent1"/>
+          </a:lnRef>
+          <a:fillRef idx="3">
+            <a:schemeClr val="accent1"/>
+          </a:fillRef>
+          <a:effectRef idx="2">
+            <a:schemeClr val="accent1"/>
+          </a:effectRef>
+          <a:fontRef idx="minor">
+            <a:schemeClr val="lt1"/>
+          </a:fontRef>
+        </p:style>
+        <p:txBody>
+          <a:bodyPr rtlCol="0" anchor="ctr"/>
+          <a:lstStyle/>
+          <a:p>
+            <a:pPr algn="ctr"/>
+          </a:p>
+        </p:txBody>
+      </p:sp>
+      <p:sp>
+        <p:nvSpPr>
+          <p:cNvPr id="21" name="TextBox 20"/>
+          <p:cNvSpPr txBox="1"/>
+          <p:nvPr/>
+        </p:nvSpPr>
+        <p:spPr>
+          <a:xfrm>
+            <a:off x="3209544" y="1371600"/>
+            <a:ext cx="5568696" cy="256032"/>
+          </a:xfrm>
+          <a:prstGeom prst="rect">
+            <a:avLst/>
+          </a:prstGeom>
+          <a:noFill/>
+        </p:spPr>
+        <p:txBody>
+          <a:bodyPr wrap="square" lIns="0" rIns="0" tIns="0" bIns="0" anchor="t">
+            <a:spAutoFit/>
+          </a:bodyPr>
+          <a:lstStyle/>
+          <a:p>
+            <a:pPr algn="l">
+              <a:lnSpc>
+                <a:spcPct val="100000"/>
+              </a:lnSpc>
+              <a:spcBef>
+                <a:spcPts val="0"/>
+              </a:spcBef>
+              <a:spcAft>
+                <a:spcPts val="0"/>
+              </a:spcAft>
+            </a:pPr>
+            <a:r>
+              <a:rPr sz="1050" b="1" i="0">
+                <a:solidFill>
+                  <a:srgbClr val="1B3E6E"/>
+                </a:solidFill>
+                <a:latin typeface="Arial"/>
+              </a:rPr>
+              <a:t>The partnership equation</a:t>
+            </a:r>
+          </a:p>
+        </p:txBody>
+      </p:sp>
+      <p:sp>
+        <p:nvSpPr>
+          <p:cNvPr id="22" name="Rectangle 21"/>
+          <p:cNvSpPr/>
+          <p:nvPr/>
+        </p:nvSpPr>
+        <p:spPr>
+          <a:xfrm>
+            <a:off x="3063240" y="1645920"/>
+            <a:ext cx="5715000" cy="10972"/>
+          </a:xfrm>
+          <a:prstGeom prst="rect">
+            <a:avLst/>
+          </a:prstGeom>
+          <a:solidFill>
+            <a:srgbClr val="BFBFBF"/>
+          </a:solidFill>
+          <a:ln>
+            <a:noFill/>
+          </a:ln>
+          <a:effectLst/>
+        </p:spPr>
+        <p:style>
+          <a:lnRef idx="1">
+            <a:schemeClr val="accent1"/>
+          </a:lnRef>
+          <a:fillRef idx="3">
+            <a:schemeClr val="accent1"/>
+          </a:fillRef>
+          <a:effectRef idx="2">
+            <a:schemeClr val="accent1"/>
+          </a:effectRef>
+          <a:fontRef idx="minor">
+            <a:schemeClr val="lt1"/>
+          </a:fontRef>
+        </p:style>
+        <p:txBody>
+          <a:bodyPr rtlCol="0" anchor="ctr"/>
+          <a:lstStyle/>
+          <a:p>
+            <a:pPr algn="ctr"/>
+          </a:p>
+        </p:txBody>
+      </p:sp>
+      <p:sp>
+        <p:nvSpPr>
+          <p:cNvPr id="23" name="Oval 22"/>
+          <p:cNvSpPr/>
+          <p:nvPr/>
+        </p:nvSpPr>
+        <p:spPr>
+          <a:xfrm>
+            <a:off x="4009644" y="1755648"/>
+            <a:ext cx="969264" cy="822960"/>
+          </a:xfrm>
+          <a:prstGeom prst="ellipse">
+            <a:avLst/>
+          </a:prstGeom>
+          <a:solidFill>
+            <a:srgbClr val="EEF3F9"/>
+          </a:solidFill>
+          <a:ln w="13970">
+            <a:solidFill>
+              <a:srgbClr val="1B3E6E"/>
+            </a:solidFill>
+          </a:ln>
+          <a:effectLst/>
+        </p:spPr>
+        <p:style>
+          <a:lnRef idx="1">
+            <a:schemeClr val="accent1"/>
+          </a:lnRef>
+          <a:fillRef idx="3">
+            <a:schemeClr val="accent1"/>
+          </a:fillRef>
+          <a:effectRef idx="2">
+            <a:schemeClr val="accent1"/>
+          </a:effectRef>
+          <a:fontRef idx="minor">
+            <a:schemeClr val="lt1"/>
+          </a:fontRef>
+        </p:style>
+        <p:txBody>
+          <a:bodyPr rtlCol="0" anchor="ctr"/>
+          <a:lstStyle/>
+          <a:p>
+            <a:pPr algn="ctr"/>
+          </a:p>
+        </p:txBody>
+      </p:sp>
+      <p:sp>
+        <p:nvSpPr>
+          <p:cNvPr id="24" name="TextBox 23"/>
+          <p:cNvSpPr txBox="1"/>
+          <p:nvPr/>
+        </p:nvSpPr>
+        <p:spPr>
+          <a:xfrm>
+            <a:off x="4009644" y="1856231"/>
+            <a:ext cx="969264" cy="621792"/>
+          </a:xfrm>
+          <a:prstGeom prst="rect">
+            <a:avLst/>
+          </a:prstGeom>
+          <a:noFill/>
+        </p:spPr>
+        <p:txBody>
+          <a:bodyPr wrap="square" lIns="0" rIns="0" tIns="0" bIns="0" anchor="ctr">
+            <a:spAutoFit/>
+          </a:bodyPr>
+          <a:lstStyle/>
+          <a:p>
+            <a:pPr algn="ctr">
+              <a:lnSpc>
+                <a:spcPct val="90000"/>
+              </a:lnSpc>
+              <a:spcBef>
+                <a:spcPts val="0"/>
+              </a:spcBef>
+              <a:spcAft>
+                <a:spcPts val="0"/>
+              </a:spcAft>
+            </a:pPr>
+            <a:r>
+              <a:rPr sz="700" b="1" i="0">
+                <a:solidFill>
+                  <a:srgbClr val="1B3E6E"/>
+                </a:solidFill>
+                <a:latin typeface="Arial"/>
+              </a:rPr>
+              <a:t>GS $250k
+catalytic
+capital</a:t>
+            </a:r>
+          </a:p>
+        </p:txBody>
+      </p:sp>
+      <p:sp>
+        <p:nvSpPr>
+          <p:cNvPr id="25" name="Plus 24"/>
+          <p:cNvSpPr/>
+          <p:nvPr/>
+        </p:nvSpPr>
+        <p:spPr>
+          <a:xfrm>
+            <a:off x="5088636" y="2057400"/>
+            <a:ext cx="237744" cy="219456"/>
+          </a:xfrm>
+          <a:prstGeom prst="mathPlus">
+            <a:avLst/>
+          </a:prstGeom>
+          <a:solidFill>
+            <a:srgbClr val="1B3E6E"/>
+          </a:solidFill>
+          <a:ln>
+            <a:noFill/>
+          </a:ln>
+          <a:effectLst/>
+        </p:spPr>
+        <p:style>
+          <a:lnRef idx="1">
+            <a:schemeClr val="accent1"/>
+          </a:lnRef>
+          <a:fillRef idx="3">
+            <a:schemeClr val="accent1"/>
+          </a:fillRef>
+          <a:effectRef idx="2">
+            <a:schemeClr val="accent1"/>
+          </a:effectRef>
+          <a:fontRef idx="minor">
+            <a:schemeClr val="lt1"/>
+          </a:fontRef>
+        </p:style>
+        <p:txBody>
+          <a:bodyPr rtlCol="0" anchor="ctr"/>
+          <a:lstStyle/>
+          <a:p>
+            <a:pPr algn="ctr"/>
+          </a:p>
+        </p:txBody>
+      </p:sp>
+      <p:sp>
+        <p:nvSpPr>
+          <p:cNvPr id="26" name="Oval 25"/>
+          <p:cNvSpPr/>
+          <p:nvPr/>
+        </p:nvSpPr>
+        <p:spPr>
+          <a:xfrm>
+            <a:off x="5436108" y="1755648"/>
+            <a:ext cx="969264" cy="822960"/>
+          </a:xfrm>
+          <a:prstGeom prst="ellipse">
+            <a:avLst/>
+          </a:prstGeom>
+          <a:solidFill>
+            <a:srgbClr val="FDF6E0"/>
+          </a:solidFill>
+          <a:ln w="13970">
+            <a:solidFill>
+              <a:srgbClr val="E08A1E"/>
+            </a:solidFill>
+          </a:ln>
+          <a:effectLst/>
+        </p:spPr>
+        <p:style>
+          <a:lnRef idx="1">
+            <a:schemeClr val="accent1"/>
+          </a:lnRef>
+          <a:fillRef idx="3">
+            <a:schemeClr val="accent1"/>
+          </a:fillRef>
+          <a:effectRef idx="2">
+            <a:schemeClr val="accent1"/>
+          </a:effectRef>
+          <a:fontRef idx="minor">
+            <a:schemeClr val="lt1"/>
+          </a:fontRef>
+        </p:style>
+        <p:txBody>
+          <a:bodyPr rtlCol="0" anchor="ctr"/>
+          <a:lstStyle/>
+          <a:p>
+            <a:pPr algn="ctr"/>
+          </a:p>
+        </p:txBody>
+      </p:sp>
+      <p:sp>
+        <p:nvSpPr>
+          <p:cNvPr id="27" name="TextBox 26"/>
+          <p:cNvSpPr txBox="1"/>
+          <p:nvPr/>
+        </p:nvSpPr>
+        <p:spPr>
+          <a:xfrm>
+            <a:off x="5436108" y="1856231"/>
+            <a:ext cx="969264" cy="621792"/>
+          </a:xfrm>
+          <a:prstGeom prst="rect">
+            <a:avLst/>
+          </a:prstGeom>
+          <a:noFill/>
+        </p:spPr>
+        <p:txBody>
+          <a:bodyPr wrap="square" lIns="0" rIns="0" tIns="0" bIns="0" anchor="ctr">
+            <a:spAutoFit/>
+          </a:bodyPr>
+          <a:lstStyle/>
+          <a:p>
+            <a:pPr algn="ctr">
+              <a:lnSpc>
+                <a:spcPct val="90000"/>
+              </a:lnSpc>
+              <a:spcBef>
+                <a:spcPts val="0"/>
+              </a:spcBef>
+              <a:spcAft>
+                <a:spcPts val="0"/>
+              </a:spcAft>
+            </a:pPr>
+            <a:r>
+              <a:rPr sz="700" b="1" i="0">
+                <a:solidFill>
+                  <a:srgbClr val="E08A1E"/>
+                </a:solidFill>
+                <a:latin typeface="Arial"/>
+              </a:rPr>
+              <a:t>AP's 2.3M
+meals-a-day
+engine</a:t>
+            </a:r>
+          </a:p>
+        </p:txBody>
+      </p:sp>
+      <p:sp>
+        <p:nvSpPr>
+          <p:cNvPr id="28" name="Equal 27"/>
+          <p:cNvSpPr/>
+          <p:nvPr/>
+        </p:nvSpPr>
+        <p:spPr>
+          <a:xfrm>
+            <a:off x="6515100" y="2057400"/>
+            <a:ext cx="237744" cy="219456"/>
+          </a:xfrm>
+          <a:prstGeom prst="mathEqual">
+            <a:avLst/>
+          </a:prstGeom>
+          <a:solidFill>
+            <a:srgbClr val="1B3E6E"/>
+          </a:solidFill>
+          <a:ln>
+            <a:noFill/>
+          </a:ln>
+          <a:effectLst/>
+        </p:spPr>
+        <p:style>
+          <a:lnRef idx="1">
+            <a:schemeClr val="accent1"/>
+          </a:lnRef>
+          <a:fillRef idx="3">
+            <a:schemeClr val="accent1"/>
+          </a:fillRef>
+          <a:effectRef idx="2">
+            <a:schemeClr val="accent1"/>
+          </a:effectRef>
+          <a:fontRef idx="minor">
+            <a:schemeClr val="lt1"/>
+          </a:fontRef>
+        </p:style>
+        <p:txBody>
+          <a:bodyPr rtlCol="0" anchor="ctr"/>
+          <a:lstStyle/>
+          <a:p>
+            <a:pPr algn="ctr"/>
+          </a:p>
+        </p:txBody>
+      </p:sp>
+      <p:sp>
+        <p:nvSpPr>
+          <p:cNvPr id="29" name="Oval 28"/>
+          <p:cNvSpPr/>
+          <p:nvPr/>
+        </p:nvSpPr>
+        <p:spPr>
+          <a:xfrm>
+            <a:off x="6862572" y="1755648"/>
+            <a:ext cx="969264" cy="822960"/>
+          </a:xfrm>
+          <a:prstGeom prst="ellipse">
+            <a:avLst/>
+          </a:prstGeom>
+          <a:solidFill>
+            <a:srgbClr val="EAF3E6"/>
+          </a:solidFill>
+          <a:ln w="13970">
+            <a:solidFill>
+              <a:srgbClr val="398025"/>
+            </a:solidFill>
+          </a:ln>
+          <a:effectLst/>
+        </p:spPr>
+        <p:style>
+          <a:lnRef idx="1">
+            <a:schemeClr val="accent1"/>
+          </a:lnRef>
+          <a:fillRef idx="3">
+            <a:schemeClr val="accent1"/>
+          </a:fillRef>
+          <a:effectRef idx="2">
+            <a:schemeClr val="accent1"/>
+          </a:effectRef>
+          <a:fontRef idx="minor">
+            <a:schemeClr val="lt1"/>
+          </a:fontRef>
+        </p:style>
+        <p:txBody>
+          <a:bodyPr rtlCol="0" anchor="ctr"/>
+          <a:lstStyle/>
+          <a:p>
+            <a:pPr algn="ctr"/>
+          </a:p>
+        </p:txBody>
+      </p:sp>
+      <p:sp>
+        <p:nvSpPr>
+          <p:cNvPr id="30" name="TextBox 29"/>
+          <p:cNvSpPr txBox="1"/>
+          <p:nvPr/>
+        </p:nvSpPr>
+        <p:spPr>
+          <a:xfrm>
+            <a:off x="6862572" y="1856231"/>
+            <a:ext cx="969264" cy="621792"/>
+          </a:xfrm>
+          <a:prstGeom prst="rect">
+            <a:avLst/>
+          </a:prstGeom>
+          <a:noFill/>
+        </p:spPr>
+        <p:txBody>
+          <a:bodyPr wrap="square" lIns="0" rIns="0" tIns="0" bIns="0" anchor="ctr">
+            <a:spAutoFit/>
+          </a:bodyPr>
+          <a:lstStyle/>
+          <a:p>
+            <a:pPr algn="ctr">
+              <a:lnSpc>
+                <a:spcPct val="90000"/>
+              </a:lnSpc>
+              <a:spcBef>
+                <a:spcPts val="0"/>
+              </a:spcBef>
+              <a:spcAft>
+                <a:spcPts val="0"/>
+              </a:spcAft>
+            </a:pPr>
+            <a:r>
+              <a:rPr sz="700" b="1" i="0">
+                <a:solidFill>
+                  <a:srgbClr val="398025"/>
+                </a:solidFill>
+                <a:latin typeface="Arial"/>
+              </a:rPr>
+              <a:t>Impact that
+compounds
+yearly</a:t>
+            </a:r>
+          </a:p>
+        </p:txBody>
+      </p:sp>
+      <p:sp>
+        <p:nvSpPr>
+          <p:cNvPr id="31" name="TextBox 30"/>
+          <p:cNvSpPr txBox="1"/>
+          <p:nvPr/>
+        </p:nvSpPr>
+        <p:spPr>
+          <a:xfrm>
+            <a:off x="3063240" y="2633472"/>
+            <a:ext cx="5715000" cy="237744"/>
+          </a:xfrm>
+          <a:prstGeom prst="rect">
+            <a:avLst/>
+          </a:prstGeom>
+          <a:noFill/>
+        </p:spPr>
+        <p:txBody>
+          <a:bodyPr wrap="square" lIns="0" rIns="0" tIns="0" bIns="0" anchor="t">
+            <a:spAutoFit/>
+          </a:bodyPr>
+          <a:lstStyle/>
+          <a:p>
+            <a:pPr algn="ctr">
+              <a:lnSpc>
+                <a:spcPct val="100000"/>
+              </a:lnSpc>
+              <a:spcBef>
+                <a:spcPts val="0"/>
+              </a:spcBef>
+              <a:spcAft>
+                <a:spcPts val="0"/>
+              </a:spcAft>
+            </a:pPr>
+            <a:r>
+              <a:rPr sz="700" b="0" i="1">
+                <a:solidFill>
+                  <a:srgbClr val="727375"/>
+                </a:solidFill>
+                <a:latin typeface="Arial"/>
+              </a:rPr>
+              <a:t>One-time capital → permanent capability → recurring savings → more children in school, every year after Year 1</a:t>
+            </a:r>
+          </a:p>
+        </p:txBody>
+      </p:sp>
+      <p:sp>
+        <p:nvSpPr>
+          <p:cNvPr id="32" name="Rectangle 31"/>
+          <p:cNvSpPr/>
+          <p:nvPr/>
+        </p:nvSpPr>
+        <p:spPr>
+          <a:xfrm>
+            <a:off x="3063240" y="3063239"/>
+            <a:ext cx="54864" cy="182880"/>
+          </a:xfrm>
+          <a:prstGeom prst="rect">
+            <a:avLst/>
+          </a:prstGeom>
+          <a:solidFill>
+            <a:srgbClr val="1B3E6E"/>
+          </a:solidFill>
+          <a:ln>
+            <a:noFill/>
+          </a:ln>
+          <a:effectLst/>
+        </p:spPr>
+        <p:style>
+          <a:lnRef idx="1">
+            <a:schemeClr val="accent1"/>
+          </a:lnRef>
+          <a:fillRef idx="3">
+            <a:schemeClr val="accent1"/>
+          </a:fillRef>
+          <a:effectRef idx="2">
+            <a:schemeClr val="accent1"/>
+          </a:effectRef>
+          <a:fontRef idx="minor">
+            <a:schemeClr val="lt1"/>
+          </a:fontRef>
+        </p:style>
+        <p:txBody>
+          <a:bodyPr rtlCol="0" anchor="ctr"/>
+          <a:lstStyle/>
+          <a:p>
+            <a:pPr algn="ctr"/>
+          </a:p>
+        </p:txBody>
+      </p:sp>
+      <p:sp>
+        <p:nvSpPr>
+          <p:cNvPr id="33" name="TextBox 32"/>
+          <p:cNvSpPr txBox="1"/>
+          <p:nvPr/>
+        </p:nvSpPr>
+        <p:spPr>
+          <a:xfrm>
+            <a:off x="3209544" y="3035808"/>
+            <a:ext cx="5568696" cy="256032"/>
+          </a:xfrm>
+          <a:prstGeom prst="rect">
+            <a:avLst/>
+          </a:prstGeom>
+          <a:noFill/>
+        </p:spPr>
+        <p:txBody>
+          <a:bodyPr wrap="square" lIns="0" rIns="0" tIns="0" bIns="0" anchor="t">
+            <a:spAutoFit/>
+          </a:bodyPr>
+          <a:lstStyle/>
+          <a:p>
+            <a:pPr algn="l">
+              <a:lnSpc>
+                <a:spcPct val="100000"/>
+              </a:lnSpc>
+              <a:spcBef>
+                <a:spcPts val="0"/>
+              </a:spcBef>
+              <a:spcAft>
+                <a:spcPts val="0"/>
+              </a:spcAft>
+            </a:pPr>
+            <a:r>
+              <a:rPr sz="1050" b="1" i="0">
+                <a:solidFill>
+                  <a:srgbClr val="1B3E6E"/>
+                </a:solidFill>
+                <a:latin typeface="Arial"/>
+              </a:rPr>
+              <a:t>Why the GS grant stands out here</a:t>
+            </a:r>
+          </a:p>
+        </p:txBody>
+      </p:sp>
+      <p:sp>
+        <p:nvSpPr>
+          <p:cNvPr id="34" name="Rectangle 33"/>
+          <p:cNvSpPr/>
+          <p:nvPr/>
+        </p:nvSpPr>
+        <p:spPr>
+          <a:xfrm>
+            <a:off x="3063240" y="3310127"/>
+            <a:ext cx="5715000" cy="10972"/>
+          </a:xfrm>
+          <a:prstGeom prst="rect">
+            <a:avLst/>
+          </a:prstGeom>
+          <a:solidFill>
+            <a:srgbClr val="BFBFBF"/>
+          </a:solidFill>
+          <a:ln>
+            <a:noFill/>
+          </a:ln>
+          <a:effectLst/>
+        </p:spPr>
+        <p:style>
+          <a:lnRef idx="1">
+            <a:schemeClr val="accent1"/>
+          </a:lnRef>
+          <a:fillRef idx="3">
+            <a:schemeClr val="accent1"/>
+          </a:fillRef>
+          <a:effectRef idx="2">
+            <a:schemeClr val="accent1"/>
+          </a:effectRef>
+          <a:fontRef idx="minor">
+            <a:schemeClr val="lt1"/>
+          </a:fontRef>
+        </p:style>
+        <p:txBody>
+          <a:bodyPr rtlCol="0" anchor="ctr"/>
+          <a:lstStyle/>
+          <a:p>
+            <a:pPr algn="ctr"/>
+          </a:p>
+        </p:txBody>
+      </p:sp>
+      <p:sp>
+        <p:nvSpPr>
+          <p:cNvPr id="35" name="TextBox 34"/>
+          <p:cNvSpPr txBox="1"/>
+          <p:nvPr/>
+        </p:nvSpPr>
+        <p:spPr>
+          <a:xfrm>
+            <a:off x="3063240" y="3401568"/>
+            <a:ext cx="5715000" cy="384048"/>
+          </a:xfrm>
+          <a:prstGeom prst="rect">
+            <a:avLst/>
+          </a:prstGeom>
+          <a:noFill/>
+        </p:spPr>
+        <p:txBody>
+          <a:bodyPr wrap="square" lIns="0" rIns="0" tIns="0" bIns="0" anchor="t">
+            <a:spAutoFit/>
+          </a:bodyPr>
+          <a:lstStyle/>
+          <a:p>
+            <a:pPr algn="l">
+              <a:lnSpc>
+                <a:spcPct val="98000"/>
+              </a:lnSpc>
+              <a:spcBef>
+                <a:spcPts val="0"/>
+              </a:spcBef>
+              <a:spcAft>
+                <a:spcPts val="0"/>
+              </a:spcAft>
+            </a:pPr>
+            <a:r>
+              <a:rPr sz="800" b="1" i="0">
+                <a:solidFill>
+                  <a:srgbClr val="398025"/>
+                </a:solidFill>
+                <a:latin typeface="Arial"/>
+              </a:rPr>
+              <a:t>✓  Structural, not sustenance:  </a:t>
+            </a:r>
+            <a:r>
+              <a:rPr sz="800" b="0" i="0">
+                <a:solidFill>
+                  <a:srgbClr val="333333"/>
+                </a:solidFill>
+                <a:latin typeface="Arial"/>
+              </a:rPr>
+              <a:t>others fund meals for a year; GS funds the technology that makes every future meal cheaper</a:t>
+            </a:r>
+          </a:p>
+        </p:txBody>
+      </p:sp>
+      <p:sp>
+        <p:nvSpPr>
+          <p:cNvPr id="36" name="TextBox 35"/>
+          <p:cNvSpPr txBox="1"/>
+          <p:nvPr/>
+        </p:nvSpPr>
+        <p:spPr>
+          <a:xfrm>
+            <a:off x="3063240" y="3753611"/>
+            <a:ext cx="5715000" cy="384048"/>
+          </a:xfrm>
+          <a:prstGeom prst="rect">
+            <a:avLst/>
+          </a:prstGeom>
+          <a:noFill/>
+        </p:spPr>
+        <p:txBody>
+          <a:bodyPr wrap="square" lIns="0" rIns="0" tIns="0" bIns="0" anchor="t">
+            <a:spAutoFit/>
+          </a:bodyPr>
+          <a:lstStyle/>
+          <a:p>
+            <a:pPr algn="l">
+              <a:lnSpc>
+                <a:spcPct val="98000"/>
+              </a:lnSpc>
+              <a:spcBef>
+                <a:spcPts val="0"/>
+              </a:spcBef>
+              <a:spcAft>
+                <a:spcPts val="0"/>
+              </a:spcAft>
+            </a:pPr>
+            <a:r>
+              <a:rPr sz="800" b="1" i="0">
+                <a:solidFill>
+                  <a:srgbClr val="398025"/>
+                </a:solidFill>
+                <a:latin typeface="Arial"/>
+              </a:rPr>
+              <a:t>✓  Plays to GS DNA:  </a:t>
+            </a:r>
+            <a:r>
+              <a:rPr sz="800" b="0" i="0">
+                <a:solidFill>
+                  <a:srgbClr val="333333"/>
+                </a:solidFill>
+                <a:latin typeface="Arial"/>
+              </a:rPr>
+              <a:t>forecasting, optimisation &amp; risk controls — GS engineering mentors the build pro bono</a:t>
+            </a:r>
+          </a:p>
+        </p:txBody>
+      </p:sp>
+      <p:sp>
+        <p:nvSpPr>
+          <p:cNvPr id="37" name="TextBox 36"/>
+          <p:cNvSpPr txBox="1"/>
+          <p:nvPr/>
+        </p:nvSpPr>
+        <p:spPr>
+          <a:xfrm>
+            <a:off x="3063240" y="4105655"/>
+            <a:ext cx="5715000" cy="384048"/>
+          </a:xfrm>
+          <a:prstGeom prst="rect">
+            <a:avLst/>
+          </a:prstGeom>
+          <a:noFill/>
+        </p:spPr>
+        <p:txBody>
+          <a:bodyPr wrap="square" lIns="0" rIns="0" tIns="0" bIns="0" anchor="t">
+            <a:spAutoFit/>
+          </a:bodyPr>
+          <a:lstStyle/>
+          <a:p>
+            <a:pPr algn="l">
+              <a:lnSpc>
+                <a:spcPct val="98000"/>
+              </a:lnSpc>
+              <a:spcBef>
+                <a:spcPts val="0"/>
+              </a:spcBef>
+              <a:spcAft>
+                <a:spcPts val="0"/>
+              </a:spcAft>
+            </a:pPr>
+            <a:r>
+              <a:rPr sz="800" b="1" i="0">
+                <a:solidFill>
+                  <a:srgbClr val="398025"/>
+                </a:solidFill>
+                <a:latin typeface="Arial"/>
+              </a:rPr>
+              <a:t>✓  Measurable ROI:  </a:t>
+            </a:r>
+            <a:r>
+              <a:rPr sz="800" b="0" i="0">
+                <a:solidFill>
+                  <a:srgbClr val="333333"/>
+                </a:solidFill>
+                <a:latin typeface="Arial"/>
+              </a:rPr>
+              <a:t>$310k/yr audited savings; KPI dashboard shared quarterly with GS</a:t>
+            </a:r>
+          </a:p>
+        </p:txBody>
+      </p:sp>
+      <p:sp>
+        <p:nvSpPr>
+          <p:cNvPr id="38" name="TextBox 37"/>
+          <p:cNvSpPr txBox="1"/>
+          <p:nvPr/>
+        </p:nvSpPr>
+        <p:spPr>
+          <a:xfrm>
+            <a:off x="3063240" y="4457699"/>
+            <a:ext cx="5715000" cy="384048"/>
+          </a:xfrm>
+          <a:prstGeom prst="rect">
+            <a:avLst/>
+          </a:prstGeom>
+          <a:noFill/>
+        </p:spPr>
+        <p:txBody>
+          <a:bodyPr wrap="square" lIns="0" rIns="0" tIns="0" bIns="0" anchor="t">
+            <a:spAutoFit/>
+          </a:bodyPr>
+          <a:lstStyle/>
+          <a:p>
+            <a:pPr algn="l">
+              <a:lnSpc>
+                <a:spcPct val="98000"/>
+              </a:lnSpc>
+              <a:spcBef>
+                <a:spcPts val="0"/>
+              </a:spcBef>
+              <a:spcAft>
+                <a:spcPts val="0"/>
+              </a:spcAft>
+            </a:pPr>
+            <a:r>
+              <a:rPr sz="800" b="1" i="0">
+                <a:solidFill>
+                  <a:srgbClr val="398025"/>
+                </a:solidFill>
+                <a:latin typeface="Arial"/>
+              </a:rPr>
+              <a:t>✓  Scalable blueprint:  </a:t>
+            </a:r>
+            <a:r>
+              <a:rPr sz="800" b="0" i="0">
+                <a:solidFill>
+                  <a:srgbClr val="333333"/>
+                </a:solidFill>
+                <a:latin typeface="Arial"/>
+              </a:rPr>
+              <a:t>proven once, extends to school-feeding programmes across South Asia &amp; Africa</a:t>
+            </a:r>
+          </a:p>
+        </p:txBody>
+      </p:sp>
+      <p:sp>
+        <p:nvSpPr>
+          <p:cNvPr id="39" name="Rectangle 38"/>
+          <p:cNvSpPr/>
+          <p:nvPr/>
+        </p:nvSpPr>
+        <p:spPr>
+          <a:xfrm>
+            <a:off x="3063240" y="4937759"/>
+            <a:ext cx="5715000" cy="10972"/>
+          </a:xfrm>
+          <a:prstGeom prst="rect">
+            <a:avLst/>
+          </a:prstGeom>
+          <a:solidFill>
+            <a:srgbClr val="E0E0E0"/>
+          </a:solidFill>
+          <a:ln>
+            <a:noFill/>
+          </a:ln>
+          <a:effectLst/>
+        </p:spPr>
+        <p:style>
+          <a:lnRef idx="1">
+            <a:schemeClr val="accent1"/>
+          </a:lnRef>
+          <a:fillRef idx="3">
+            <a:schemeClr val="accent1"/>
+          </a:fillRef>
+          <a:effectRef idx="2">
+            <a:schemeClr val="accent1"/>
+          </a:effectRef>
+          <a:fontRef idx="minor">
+            <a:schemeClr val="lt1"/>
+          </a:fontRef>
+        </p:style>
+        <p:txBody>
+          <a:bodyPr rtlCol="0" anchor="ctr"/>
+          <a:lstStyle/>
+          <a:p>
+            <a:pPr algn="ctr"/>
+          </a:p>
+        </p:txBody>
+      </p:sp>
+      <p:sp>
+        <p:nvSpPr>
+          <p:cNvPr id="40" name="Rectangle 39"/>
+          <p:cNvSpPr/>
+          <p:nvPr/>
+        </p:nvSpPr>
+        <p:spPr>
+          <a:xfrm>
+            <a:off x="3063240" y="5029199"/>
+            <a:ext cx="658368" cy="841248"/>
+          </a:xfrm>
+          <a:prstGeom prst="rect">
+            <a:avLst/>
+          </a:prstGeom>
+          <a:solidFill>
+            <a:srgbClr val="F2F2F2"/>
+          </a:solidFill>
+          <a:ln w="12700">
+            <a:solidFill>
+              <a:srgbClr val="727375"/>
+            </a:solidFill>
+            <a:prstDash val="dash"/>
+          </a:ln>
+          <a:effectLst/>
+        </p:spPr>
+        <p:style>
+          <a:lnRef idx="1">
+            <a:schemeClr val="accent1"/>
+          </a:lnRef>
+          <a:fillRef idx="3">
+            <a:schemeClr val="accent1"/>
+          </a:fillRef>
+          <a:effectRef idx="2">
+            <a:schemeClr val="accent1"/>
+          </a:effectRef>
+          <a:fontRef idx="minor">
+            <a:schemeClr val="lt1"/>
+          </a:fontRef>
+        </p:style>
+        <p:txBody>
+          <a:bodyPr rtlCol="0" anchor="ctr"/>
+          <a:lstStyle/>
+          <a:p>
+            <a:pPr algn="ctr"/>
+          </a:p>
+        </p:txBody>
+      </p:sp>
+      <p:sp>
+        <p:nvSpPr>
+          <p:cNvPr id="41" name="TextBox 40"/>
+          <p:cNvSpPr txBox="1"/>
+          <p:nvPr/>
+        </p:nvSpPr>
+        <p:spPr>
+          <a:xfrm>
+            <a:off x="3118104" y="5029199"/>
+            <a:ext cx="548640" cy="841248"/>
+          </a:xfrm>
+          <a:prstGeom prst="rect">
+            <a:avLst/>
+          </a:prstGeom>
+          <a:noFill/>
+        </p:spPr>
+        <p:txBody>
+          <a:bodyPr wrap="square" lIns="0" rIns="0" tIns="0" bIns="0" anchor="ctr">
+            <a:spAutoFit/>
+          </a:bodyPr>
+          <a:lstStyle/>
+          <a:p>
+            <a:pPr algn="ctr">
+              <a:lnSpc>
+                <a:spcPct val="100000"/>
+              </a:lnSpc>
+              <a:spcBef>
+                <a:spcPts val="0"/>
+              </a:spcBef>
+              <a:spcAft>
+                <a:spcPts val="100"/>
+              </a:spcAft>
+            </a:pPr>
+            <a:r>
+              <a:rPr sz="850" b="1" i="0">
+                <a:solidFill>
+                  <a:srgbClr val="727375"/>
+                </a:solidFill>
+                <a:latin typeface="Arial"/>
+              </a:rPr>
+              <a:t>📷
+Krishna
+Kumar</a:t>
+            </a:r>
+          </a:p>
+        </p:txBody>
+      </p:sp>
+      <p:sp>
+        <p:nvSpPr>
+          <p:cNvPr id="42" name="TextBox 41"/>
+          <p:cNvSpPr txBox="1"/>
+          <p:nvPr/>
+        </p:nvSpPr>
+        <p:spPr>
+          <a:xfrm>
+            <a:off x="3849624" y="5047487"/>
+            <a:ext cx="2212848" cy="868680"/>
+          </a:xfrm>
+          <a:prstGeom prst="rect">
+            <a:avLst/>
+          </a:prstGeom>
+          <a:noFill/>
+        </p:spPr>
+        <p:txBody>
+          <a:bodyPr wrap="square" lIns="0" rIns="0" tIns="0" bIns="0" anchor="t">
+            <a:spAutoFit/>
+          </a:bodyPr>
+          <a:lstStyle/>
+          <a:p>
+            <a:pPr algn="l">
+              <a:lnSpc>
+                <a:spcPct val="100000"/>
+              </a:lnSpc>
+              <a:spcBef>
+                <a:spcPts val="0"/>
+              </a:spcBef>
+              <a:spcAft>
+                <a:spcPts val="200"/>
+              </a:spcAft>
+            </a:pPr>
+            <a:r>
+              <a:rPr sz="720" b="0" i="1">
+                <a:solidFill>
+                  <a:srgbClr val="333333"/>
+                </a:solidFill>
+                <a:latin typeface="Arial"/>
+              </a:rPr>
+              <a:t>“The mid-day meal was the reason I stayed in school. Today I manage portfolios instead of an empty stomach.”</a:t>
+            </a:r>
+          </a:p>
+          <a:p>
+            <a:pPr algn="l">
+              <a:lnSpc>
+                <a:spcPct val="100000"/>
+              </a:lnSpc>
+              <a:spcBef>
+                <a:spcPts val="0"/>
+              </a:spcBef>
+              <a:spcAft>
+                <a:spcPts val="0"/>
+              </a:spcAft>
+            </a:pPr>
+            <a:r>
+              <a:rPr sz="680" b="1" i="0">
+                <a:solidFill>
+                  <a:srgbClr val="1B3E6E"/>
+                </a:solidFill>
+                <a:latin typeface="Arial"/>
+              </a:rPr>
+              <a:t>— Krishna Kumar, </a:t>
+            </a:r>
+            <a:r>
+              <a:rPr sz="680" b="0" i="0">
+                <a:solidFill>
+                  <a:srgbClr val="727375"/>
+                </a:solidFill>
+                <a:latin typeface="Arial"/>
+              </a:rPr>
+              <a:t>AVP, HSBC — former beneficiary</a:t>
+            </a:r>
+          </a:p>
+        </p:txBody>
+      </p:sp>
+      <p:sp>
+        <p:nvSpPr>
+          <p:cNvPr id="43" name="Rectangle 42"/>
+          <p:cNvSpPr/>
+          <p:nvPr/>
+        </p:nvSpPr>
+        <p:spPr>
+          <a:xfrm>
+            <a:off x="6227064" y="5029199"/>
+            <a:ext cx="10972" cy="868680"/>
+          </a:xfrm>
+          <a:prstGeom prst="rect">
+            <a:avLst/>
+          </a:prstGeom>
+          <a:solidFill>
+            <a:srgbClr val="DDDDDD"/>
+          </a:solidFill>
+          <a:ln>
+            <a:noFill/>
+          </a:ln>
+          <a:effectLst/>
+        </p:spPr>
+        <p:style>
+          <a:lnRef idx="1">
+            <a:schemeClr val="accent1"/>
+          </a:lnRef>
+          <a:fillRef idx="3">
+            <a:schemeClr val="accent1"/>
+          </a:fillRef>
+          <a:effectRef idx="2">
+            <a:schemeClr val="accent1"/>
+          </a:effectRef>
+          <a:fontRef idx="minor">
+            <a:schemeClr val="lt1"/>
+          </a:fontRef>
+        </p:style>
+        <p:txBody>
+          <a:bodyPr rtlCol="0" anchor="ctr"/>
+          <a:lstStyle/>
+          <a:p>
+            <a:pPr algn="ctr"/>
+          </a:p>
+        </p:txBody>
+      </p:sp>
+      <p:sp>
+        <p:nvSpPr>
+          <p:cNvPr id="44" name="TextBox 43"/>
+          <p:cNvSpPr txBox="1"/>
+          <p:nvPr/>
+        </p:nvSpPr>
+        <p:spPr>
+          <a:xfrm>
+            <a:off x="6373368" y="5029199"/>
+            <a:ext cx="2404872" cy="201168"/>
+          </a:xfrm>
+          <a:prstGeom prst="rect">
+            <a:avLst/>
+          </a:prstGeom>
+          <a:noFill/>
+        </p:spPr>
+        <p:txBody>
+          <a:bodyPr wrap="square" lIns="0" rIns="0" tIns="0" bIns="0" anchor="t">
+            <a:spAutoFit/>
+          </a:bodyPr>
+          <a:lstStyle/>
+          <a:p>
+            <a:pPr algn="l">
+              <a:lnSpc>
+                <a:spcPct val="100000"/>
+              </a:lnSpc>
+              <a:spcBef>
+                <a:spcPts val="0"/>
+              </a:spcBef>
+              <a:spcAft>
+                <a:spcPts val="0"/>
+              </a:spcAft>
+            </a:pPr>
+            <a:r>
+              <a:rPr sz="819" b="1" i="0">
+                <a:solidFill>
+                  <a:srgbClr val="1B3E6E"/>
+                </a:solidFill>
+                <a:latin typeface="Arial"/>
+              </a:rPr>
+              <a:t>Trusted by leading corporates </a:t>
+            </a:r>
+            <a:r>
+              <a:rPr sz="819" b="0" i="0">
+                <a:solidFill>
+                  <a:srgbClr val="727375"/>
+                </a:solidFill>
+                <a:latin typeface="Arial"/>
+              </a:rPr>
+              <a:t>(+200 more)</a:t>
+            </a:r>
+          </a:p>
+        </p:txBody>
+      </p:sp>
+      <p:sp>
+        <p:nvSpPr>
+          <p:cNvPr id="45" name="Rectangle 44"/>
+          <p:cNvSpPr/>
+          <p:nvPr/>
+        </p:nvSpPr>
+        <p:spPr>
+          <a:xfrm>
+            <a:off x="6373368" y="5266943"/>
+            <a:ext cx="765047" cy="292608"/>
+          </a:xfrm>
+          <a:prstGeom prst="rect">
+            <a:avLst/>
+          </a:prstGeom>
+          <a:solidFill>
+            <a:srgbClr val="F2F2F2"/>
+          </a:solidFill>
+          <a:ln w="12700">
+            <a:solidFill>
+              <a:srgbClr val="727375"/>
+            </a:solidFill>
+            <a:prstDash val="dash"/>
+          </a:ln>
+          <a:effectLst/>
+        </p:spPr>
+        <p:style>
+          <a:lnRef idx="1">
+            <a:schemeClr val="accent1"/>
+          </a:lnRef>
+          <a:fillRef idx="3">
+            <a:schemeClr val="accent1"/>
+          </a:fillRef>
+          <a:effectRef idx="2">
+            <a:schemeClr val="accent1"/>
+          </a:effectRef>
+          <a:fontRef idx="minor">
+            <a:schemeClr val="lt1"/>
+          </a:fontRef>
+        </p:style>
+        <p:txBody>
+          <a:bodyPr rtlCol="0" anchor="ctr"/>
+          <a:lstStyle/>
+          <a:p>
+            <a:pPr algn="ctr"/>
+          </a:p>
+        </p:txBody>
+      </p:sp>
+      <p:sp>
+        <p:nvSpPr>
+          <p:cNvPr id="46" name="TextBox 45"/>
+          <p:cNvSpPr txBox="1"/>
+          <p:nvPr/>
+        </p:nvSpPr>
+        <p:spPr>
+          <a:xfrm>
+            <a:off x="6428232" y="5266943"/>
+            <a:ext cx="655319" cy="292608"/>
+          </a:xfrm>
+          <a:prstGeom prst="rect">
+            <a:avLst/>
+          </a:prstGeom>
+          <a:noFill/>
+        </p:spPr>
+        <p:txBody>
+          <a:bodyPr wrap="square" lIns="0" rIns="0" tIns="0" bIns="0" anchor="ctr">
+            <a:spAutoFit/>
+          </a:bodyPr>
+          <a:lstStyle/>
+          <a:p>
+            <a:pPr algn="ctr">
+              <a:lnSpc>
+                <a:spcPct val="100000"/>
+              </a:lnSpc>
+              <a:spcBef>
+                <a:spcPts val="0"/>
+              </a:spcBef>
+              <a:spcAft>
+                <a:spcPts val="100"/>
+              </a:spcAft>
+            </a:pPr>
+            <a:r>
+              <a:rPr sz="850" b="1" i="0">
+                <a:solidFill>
+                  <a:srgbClr val="727375"/>
+                </a:solidFill>
+                <a:latin typeface="Arial"/>
+              </a:rPr>
+              <a:t>Infosys</a:t>
+            </a:r>
+          </a:p>
+        </p:txBody>
+      </p:sp>
+      <p:sp>
+        <p:nvSpPr>
+          <p:cNvPr id="47" name="Rectangle 46"/>
+          <p:cNvSpPr/>
+          <p:nvPr/>
+        </p:nvSpPr>
+        <p:spPr>
+          <a:xfrm>
+            <a:off x="7193280" y="5266943"/>
+            <a:ext cx="765047" cy="292608"/>
+          </a:xfrm>
+          <a:prstGeom prst="rect">
+            <a:avLst/>
+          </a:prstGeom>
+          <a:solidFill>
+            <a:srgbClr val="F2F2F2"/>
+          </a:solidFill>
+          <a:ln w="12700">
+            <a:solidFill>
+              <a:srgbClr val="727375"/>
+            </a:solidFill>
+            <a:prstDash val="dash"/>
+          </a:ln>
+          <a:effectLst/>
+        </p:spPr>
+        <p:style>
+          <a:lnRef idx="1">
+            <a:schemeClr val="accent1"/>
+          </a:lnRef>
+          <a:fillRef idx="3">
+            <a:schemeClr val="accent1"/>
+          </a:fillRef>
+          <a:effectRef idx="2">
+            <a:schemeClr val="accent1"/>
+          </a:effectRef>
+          <a:fontRef idx="minor">
+            <a:schemeClr val="lt1"/>
+          </a:fontRef>
+        </p:style>
+        <p:txBody>
+          <a:bodyPr rtlCol="0" anchor="ctr"/>
+          <a:lstStyle/>
+          <a:p>
+            <a:pPr algn="ctr"/>
+          </a:p>
+        </p:txBody>
+      </p:sp>
+      <p:sp>
+        <p:nvSpPr>
+          <p:cNvPr id="48" name="TextBox 47"/>
+          <p:cNvSpPr txBox="1"/>
+          <p:nvPr/>
+        </p:nvSpPr>
+        <p:spPr>
+          <a:xfrm>
+            <a:off x="7248144" y="5266943"/>
+            <a:ext cx="655319" cy="292608"/>
+          </a:xfrm>
+          <a:prstGeom prst="rect">
+            <a:avLst/>
+          </a:prstGeom>
+          <a:noFill/>
+        </p:spPr>
+        <p:txBody>
+          <a:bodyPr wrap="square" lIns="0" rIns="0" tIns="0" bIns="0" anchor="ctr">
+            <a:spAutoFit/>
+          </a:bodyPr>
+          <a:lstStyle/>
+          <a:p>
+            <a:pPr algn="ctr">
+              <a:lnSpc>
+                <a:spcPct val="100000"/>
+              </a:lnSpc>
+              <a:spcBef>
+                <a:spcPts val="0"/>
+              </a:spcBef>
+              <a:spcAft>
+                <a:spcPts val="100"/>
+              </a:spcAft>
+            </a:pPr>
+            <a:r>
+              <a:rPr sz="850" b="1" i="0">
+                <a:solidFill>
+                  <a:srgbClr val="727375"/>
+                </a:solidFill>
+                <a:latin typeface="Arial"/>
+              </a:rPr>
+              <a:t>TCS</a:t>
+            </a:r>
+          </a:p>
+        </p:txBody>
+      </p:sp>
+      <p:sp>
+        <p:nvSpPr>
+          <p:cNvPr id="49" name="Rectangle 48"/>
+          <p:cNvSpPr/>
+          <p:nvPr/>
+        </p:nvSpPr>
+        <p:spPr>
+          <a:xfrm>
+            <a:off x="8013192" y="5266943"/>
+            <a:ext cx="765047" cy="292608"/>
+          </a:xfrm>
+          <a:prstGeom prst="rect">
+            <a:avLst/>
+          </a:prstGeom>
+          <a:solidFill>
+            <a:srgbClr val="F2F2F2"/>
+          </a:solidFill>
+          <a:ln w="12700">
+            <a:solidFill>
+              <a:srgbClr val="727375"/>
+            </a:solidFill>
+            <a:prstDash val="dash"/>
+          </a:ln>
+          <a:effectLst/>
+        </p:spPr>
+        <p:style>
+          <a:lnRef idx="1">
+            <a:schemeClr val="accent1"/>
+          </a:lnRef>
+          <a:fillRef idx="3">
+            <a:schemeClr val="accent1"/>
+          </a:fillRef>
+          <a:effectRef idx="2">
+            <a:schemeClr val="accent1"/>
+          </a:effectRef>
+          <a:fontRef idx="minor">
+            <a:schemeClr val="lt1"/>
+          </a:fontRef>
+        </p:style>
+        <p:txBody>
+          <a:bodyPr rtlCol="0" anchor="ctr"/>
+          <a:lstStyle/>
+          <a:p>
+            <a:pPr algn="ctr"/>
+          </a:p>
+        </p:txBody>
+      </p:sp>
+      <p:sp>
+        <p:nvSpPr>
+          <p:cNvPr id="50" name="TextBox 49"/>
+          <p:cNvSpPr txBox="1"/>
+          <p:nvPr/>
+        </p:nvSpPr>
+        <p:spPr>
+          <a:xfrm>
+            <a:off x="8068056" y="5266943"/>
+            <a:ext cx="655319" cy="292608"/>
+          </a:xfrm>
+          <a:prstGeom prst="rect">
+            <a:avLst/>
+          </a:prstGeom>
+          <a:noFill/>
+        </p:spPr>
+        <p:txBody>
+          <a:bodyPr wrap="square" lIns="0" rIns="0" tIns="0" bIns="0" anchor="ctr">
+            <a:spAutoFit/>
+          </a:bodyPr>
+          <a:lstStyle/>
+          <a:p>
+            <a:pPr algn="ctr">
+              <a:lnSpc>
+                <a:spcPct val="100000"/>
+              </a:lnSpc>
+              <a:spcBef>
+                <a:spcPts val="0"/>
+              </a:spcBef>
+              <a:spcAft>
+                <a:spcPts val="100"/>
+              </a:spcAft>
+            </a:pPr>
+            <a:r>
+              <a:rPr sz="850" b="1" i="0">
+                <a:solidFill>
+                  <a:srgbClr val="727375"/>
+                </a:solidFill>
+                <a:latin typeface="Arial"/>
+              </a:rPr>
+              <a:t>HDFC</a:t>
+            </a:r>
+          </a:p>
+        </p:txBody>
+      </p:sp>
+      <p:sp>
+        <p:nvSpPr>
+          <p:cNvPr id="51" name="Rectangle 50"/>
+          <p:cNvSpPr/>
+          <p:nvPr/>
+        </p:nvSpPr>
+        <p:spPr>
+          <a:xfrm>
+            <a:off x="6373368" y="5614415"/>
+            <a:ext cx="765047" cy="292608"/>
+          </a:xfrm>
+          <a:prstGeom prst="rect">
+            <a:avLst/>
+          </a:prstGeom>
+          <a:solidFill>
+            <a:srgbClr val="F2F2F2"/>
+          </a:solidFill>
+          <a:ln w="12700">
+            <a:solidFill>
+              <a:srgbClr val="727375"/>
+            </a:solidFill>
+            <a:prstDash val="dash"/>
+          </a:ln>
+          <a:effectLst/>
+        </p:spPr>
+        <p:style>
+          <a:lnRef idx="1">
+            <a:schemeClr val="accent1"/>
+          </a:lnRef>
+          <a:fillRef idx="3">
+            <a:schemeClr val="accent1"/>
+          </a:fillRef>
+          <a:effectRef idx="2">
+            <a:schemeClr val="accent1"/>
+          </a:effectRef>
+          <a:fontRef idx="minor">
+            <a:schemeClr val="lt1"/>
+          </a:fontRef>
+        </p:style>
+        <p:txBody>
+          <a:bodyPr rtlCol="0" anchor="ctr"/>
+          <a:lstStyle/>
+          <a:p>
+            <a:pPr algn="ctr"/>
+          </a:p>
+        </p:txBody>
+      </p:sp>
+      <p:sp>
+        <p:nvSpPr>
+          <p:cNvPr id="52" name="TextBox 51"/>
+          <p:cNvSpPr txBox="1"/>
+          <p:nvPr/>
+        </p:nvSpPr>
+        <p:spPr>
+          <a:xfrm>
+            <a:off x="6428232" y="5614415"/>
+            <a:ext cx="655319" cy="292608"/>
+          </a:xfrm>
+          <a:prstGeom prst="rect">
+            <a:avLst/>
+          </a:prstGeom>
+          <a:noFill/>
+        </p:spPr>
+        <p:txBody>
+          <a:bodyPr wrap="square" lIns="0" rIns="0" tIns="0" bIns="0" anchor="ctr">
+            <a:spAutoFit/>
+          </a:bodyPr>
+          <a:lstStyle/>
+          <a:p>
+            <a:pPr algn="ctr">
+              <a:lnSpc>
+                <a:spcPct val="100000"/>
+              </a:lnSpc>
+              <a:spcBef>
+                <a:spcPts val="0"/>
+              </a:spcBef>
+              <a:spcAft>
+                <a:spcPts val="100"/>
+              </a:spcAft>
+            </a:pPr>
+            <a:r>
+              <a:rPr sz="850" b="1" i="0">
+                <a:solidFill>
+                  <a:srgbClr val="727375"/>
+                </a:solidFill>
+                <a:latin typeface="Arial"/>
+              </a:rPr>
+              <a:t>Amazon</a:t>
+            </a:r>
+          </a:p>
+        </p:txBody>
+      </p:sp>
+      <p:sp>
+        <p:nvSpPr>
+          <p:cNvPr id="53" name="Rectangle 52"/>
+          <p:cNvSpPr/>
+          <p:nvPr/>
+        </p:nvSpPr>
+        <p:spPr>
+          <a:xfrm>
+            <a:off x="7193280" y="5614415"/>
+            <a:ext cx="765047" cy="292608"/>
+          </a:xfrm>
+          <a:prstGeom prst="rect">
+            <a:avLst/>
+          </a:prstGeom>
+          <a:solidFill>
+            <a:srgbClr val="F2F2F2"/>
+          </a:solidFill>
+          <a:ln w="12700">
+            <a:solidFill>
+              <a:srgbClr val="727375"/>
+            </a:solidFill>
+            <a:prstDash val="dash"/>
+          </a:ln>
+          <a:effectLst/>
+        </p:spPr>
+        <p:style>
+          <a:lnRef idx="1">
+            <a:schemeClr val="accent1"/>
+          </a:lnRef>
+          <a:fillRef idx="3">
+            <a:schemeClr val="accent1"/>
+          </a:fillRef>
+          <a:effectRef idx="2">
+            <a:schemeClr val="accent1"/>
+          </a:effectRef>
+          <a:fontRef idx="minor">
+            <a:schemeClr val="lt1"/>
+          </a:fontRef>
+        </p:style>
+        <p:txBody>
+          <a:bodyPr rtlCol="0" anchor="ctr"/>
+          <a:lstStyle/>
+          <a:p>
+            <a:pPr algn="ctr"/>
+          </a:p>
+        </p:txBody>
+      </p:sp>
+      <p:sp>
+        <p:nvSpPr>
+          <p:cNvPr id="54" name="TextBox 53"/>
+          <p:cNvSpPr txBox="1"/>
+          <p:nvPr/>
+        </p:nvSpPr>
+        <p:spPr>
+          <a:xfrm>
+            <a:off x="7248144" y="5614415"/>
+            <a:ext cx="655319" cy="292608"/>
+          </a:xfrm>
+          <a:prstGeom prst="rect">
+            <a:avLst/>
+          </a:prstGeom>
+          <a:noFill/>
+        </p:spPr>
+        <p:txBody>
+          <a:bodyPr wrap="square" lIns="0" rIns="0" tIns="0" bIns="0" anchor="ctr">
+            <a:spAutoFit/>
+          </a:bodyPr>
+          <a:lstStyle/>
+          <a:p>
+            <a:pPr algn="ctr">
+              <a:lnSpc>
+                <a:spcPct val="100000"/>
+              </a:lnSpc>
+              <a:spcBef>
+                <a:spcPts val="0"/>
+              </a:spcBef>
+              <a:spcAft>
+                <a:spcPts val="100"/>
+              </a:spcAft>
+            </a:pPr>
+            <a:r>
+              <a:rPr sz="850" b="1" i="0">
+                <a:solidFill>
+                  <a:srgbClr val="727375"/>
+                </a:solidFill>
+                <a:latin typeface="Arial"/>
+              </a:rPr>
+              <a:t>Airbus</a:t>
+            </a:r>
+          </a:p>
+        </p:txBody>
+      </p:sp>
+      <p:sp>
+        <p:nvSpPr>
+          <p:cNvPr id="55" name="Rectangle 54"/>
+          <p:cNvSpPr/>
+          <p:nvPr/>
+        </p:nvSpPr>
+        <p:spPr>
+          <a:xfrm>
+            <a:off x="8013192" y="5614415"/>
+            <a:ext cx="765047" cy="292608"/>
+          </a:xfrm>
+          <a:prstGeom prst="rect">
+            <a:avLst/>
+          </a:prstGeom>
+          <a:solidFill>
+            <a:srgbClr val="F2F2F2"/>
+          </a:solidFill>
+          <a:ln w="12700">
+            <a:solidFill>
+              <a:srgbClr val="727375"/>
+            </a:solidFill>
+            <a:prstDash val="dash"/>
+          </a:ln>
+          <a:effectLst/>
+        </p:spPr>
+        <p:style>
+          <a:lnRef idx="1">
+            <a:schemeClr val="accent1"/>
+          </a:lnRef>
+          <a:fillRef idx="3">
+            <a:schemeClr val="accent1"/>
+          </a:fillRef>
+          <a:effectRef idx="2">
+            <a:schemeClr val="accent1"/>
+          </a:effectRef>
+          <a:fontRef idx="minor">
+            <a:schemeClr val="lt1"/>
+          </a:fontRef>
+        </p:style>
+        <p:txBody>
+          <a:bodyPr rtlCol="0" anchor="ctr"/>
+          <a:lstStyle/>
+          <a:p>
+            <a:pPr algn="ctr"/>
+          </a:p>
+        </p:txBody>
+      </p:sp>
+      <p:sp>
+        <p:nvSpPr>
+          <p:cNvPr id="56" name="TextBox 55"/>
+          <p:cNvSpPr txBox="1"/>
+          <p:nvPr/>
+        </p:nvSpPr>
+        <p:spPr>
+          <a:xfrm>
+            <a:off x="8068056" y="5614415"/>
+            <a:ext cx="655319" cy="292608"/>
           </a:xfrm>
           <a:prstGeom prst="rect">
             <a:avLst/>

</xml_diff>

<commit_message>
Add proposed slide-3 v2 (slide 7): gaps elaborated + $250k split + solution intros
Co-Authored-By: Claude Fable 5 <noreply@anthropic.com>
Claude-Session: https://claude.ai/code/session_01XoYepLRLVLdWS74xAsgg39
</commit_message>
<xml_diff>
--- a/AkshayaPatra_GS_Pitch.pptx
+++ b/AkshayaPatra_GS_Pitch.pptx
@@ -11,6 +11,7 @@
     <p:sldId id="259" r:id="rId10"/>
     <p:sldId id="260" r:id="rId11"/>
     <p:sldId id="261" r:id="rId12"/>
+    <p:sldId id="262" r:id="rId13"/>
   </p:sldIdLst>
   <p:sldSz cx="9144000" cy="6858000" type="screen4x3"/>
   <p:notesSz cx="6858000" cy="9144000"/>
@@ -17913,6 +17914,1947 @@
                 <a:latin typeface="Arial"/>
               </a:rPr>
               <a:t>SBI</a:t>
+            </a:r>
+          </a:p>
+        </p:txBody>
+      </p:sp>
+    </p:spTree>
+  </p:cSld>
+  <p:clrMapOvr>
+    <a:masterClrMapping/>
+  </p:clrMapOvr>
+</p:sld>
+</file>
+
+<file path=ppt/slides/slide7.xml><?xml version="1.0" encoding="utf-8"?>
+<p:sld xmlns:a="http://schemas.openxmlformats.org/drawingml/2006/main" xmlns:p="http://schemas.openxmlformats.org/presentationml/2006/main" xmlns:r="http://schemas.openxmlformats.org/officeDocument/2006/relationships">
+  <p:cSld>
+    <p:spTree>
+      <p:nvGrpSpPr>
+        <p:cNvPr id="1" name=""/>
+        <p:cNvGrpSpPr/>
+        <p:nvPr/>
+      </p:nvGrpSpPr>
+      <p:grpSpPr/>
+      <p:sp>
+        <p:nvSpPr>
+          <p:cNvPr id="2" name="Rectangle 1"/>
+          <p:cNvSpPr/>
+          <p:nvPr/>
+        </p:nvSpPr>
+        <p:spPr>
+          <a:xfrm>
+            <a:off x="365760" y="274320"/>
+            <a:ext cx="8412480" cy="23774"/>
+          </a:xfrm>
+          <a:prstGeom prst="rect">
+            <a:avLst/>
+          </a:prstGeom>
+          <a:solidFill>
+            <a:srgbClr val="1B3E6E"/>
+          </a:solidFill>
+          <a:ln>
+            <a:noFill/>
+          </a:ln>
+          <a:effectLst/>
+        </p:spPr>
+        <p:style>
+          <a:lnRef idx="1">
+            <a:schemeClr val="accent1"/>
+          </a:lnRef>
+          <a:fillRef idx="3">
+            <a:schemeClr val="accent1"/>
+          </a:fillRef>
+          <a:effectRef idx="2">
+            <a:schemeClr val="accent1"/>
+          </a:effectRef>
+          <a:fontRef idx="minor">
+            <a:schemeClr val="lt1"/>
+          </a:fontRef>
+        </p:style>
+        <p:txBody>
+          <a:bodyPr rtlCol="0" anchor="ctr"/>
+          <a:lstStyle/>
+          <a:p>
+            <a:pPr algn="ctr"/>
+          </a:p>
+        </p:txBody>
+      </p:sp>
+      <p:sp>
+        <p:nvSpPr>
+          <p:cNvPr id="3" name="TextBox 2"/>
+          <p:cNvSpPr txBox="1"/>
+          <p:nvPr/>
+        </p:nvSpPr>
+        <p:spPr>
+          <a:xfrm>
+            <a:off x="365760" y="365760"/>
+            <a:ext cx="8412480" cy="457200"/>
+          </a:xfrm>
+          <a:prstGeom prst="rect">
+            <a:avLst/>
+          </a:prstGeom>
+          <a:noFill/>
+        </p:spPr>
+        <p:txBody>
+          <a:bodyPr wrap="square" lIns="0" rIns="0" tIns="0" bIns="0" anchor="t">
+            <a:spAutoFit/>
+          </a:bodyPr>
+          <a:lstStyle/>
+          <a:p>
+            <a:pPr algn="l">
+              <a:lnSpc>
+                <a:spcPct val="100000"/>
+              </a:lnSpc>
+              <a:spcBef>
+                <a:spcPts val="0"/>
+              </a:spcBef>
+              <a:spcAft>
+                <a:spcPts val="0"/>
+              </a:spcAft>
+            </a:pPr>
+            <a:r>
+              <a:rPr sz="2000" b="0" i="0">
+                <a:solidFill>
+                  <a:srgbClr val="1B3E6E"/>
+                </a:solidFill>
+                <a:latin typeface="Georgia"/>
+              </a:rPr>
+              <a:t>The two gaps — and the $250,000 that closes them</a:t>
+            </a:r>
+          </a:p>
+        </p:txBody>
+      </p:sp>
+      <p:sp>
+        <p:nvSpPr>
+          <p:cNvPr id="4" name="TextBox 3"/>
+          <p:cNvSpPr txBox="1"/>
+          <p:nvPr/>
+        </p:nvSpPr>
+        <p:spPr>
+          <a:xfrm>
+            <a:off x="365760" y="822960"/>
+            <a:ext cx="8412480" cy="438912"/>
+          </a:xfrm>
+          <a:prstGeom prst="rect">
+            <a:avLst/>
+          </a:prstGeom>
+          <a:noFill/>
+        </p:spPr>
+        <p:txBody>
+          <a:bodyPr wrap="square" lIns="0" rIns="0" tIns="0" bIns="0" anchor="t">
+            <a:spAutoFit/>
+          </a:bodyPr>
+          <a:lstStyle/>
+          <a:p>
+            <a:pPr algn="l">
+              <a:lnSpc>
+                <a:spcPct val="100000"/>
+              </a:lnSpc>
+              <a:spcBef>
+                <a:spcPts val="0"/>
+              </a:spcBef>
+              <a:spcAft>
+                <a:spcPts val="0"/>
+              </a:spcAft>
+            </a:pPr>
+            <a:r>
+              <a:rPr sz="1050" b="0" i="0">
+                <a:solidFill>
+                  <a:srgbClr val="333333"/>
+                </a:solidFill>
+                <a:latin typeface="Arial"/>
+              </a:rPr>
+              <a:t>Unpacking the gaps highlighted in the supply chain: what is broken today, how the grant splits across them, and the solution we build for each.</a:t>
+            </a:r>
+          </a:p>
+        </p:txBody>
+      </p:sp>
+      <p:sp>
+        <p:nvSpPr>
+          <p:cNvPr id="5" name="Rectangle 4"/>
+          <p:cNvSpPr/>
+          <p:nvPr/>
+        </p:nvSpPr>
+        <p:spPr>
+          <a:xfrm>
+            <a:off x="502920" y="6071616"/>
+            <a:ext cx="8138159" cy="365760"/>
+          </a:xfrm>
+          <a:prstGeom prst="rect">
+            <a:avLst/>
+          </a:prstGeom>
+          <a:solidFill>
+            <a:srgbClr val="D9D9D9"/>
+          </a:solidFill>
+          <a:ln>
+            <a:noFill/>
+          </a:ln>
+          <a:effectLst/>
+        </p:spPr>
+        <p:style>
+          <a:lnRef idx="1">
+            <a:schemeClr val="accent1"/>
+          </a:lnRef>
+          <a:fillRef idx="3">
+            <a:schemeClr val="accent1"/>
+          </a:fillRef>
+          <a:effectRef idx="2">
+            <a:schemeClr val="accent1"/>
+          </a:effectRef>
+          <a:fontRef idx="minor">
+            <a:schemeClr val="lt1"/>
+          </a:fontRef>
+        </p:style>
+        <p:txBody>
+          <a:bodyPr rtlCol="0" anchor="ctr"/>
+          <a:lstStyle/>
+          <a:p>
+            <a:pPr algn="ctr"/>
+          </a:p>
+        </p:txBody>
+      </p:sp>
+      <p:sp>
+        <p:nvSpPr>
+          <p:cNvPr id="6" name="TextBox 5"/>
+          <p:cNvSpPr txBox="1"/>
+          <p:nvPr/>
+        </p:nvSpPr>
+        <p:spPr>
+          <a:xfrm>
+            <a:off x="640080" y="6071616"/>
+            <a:ext cx="7863840" cy="365760"/>
+          </a:xfrm>
+          <a:prstGeom prst="rect">
+            <a:avLst/>
+          </a:prstGeom>
+          <a:noFill/>
+        </p:spPr>
+        <p:txBody>
+          <a:bodyPr wrap="square" lIns="0" rIns="0" tIns="0" bIns="0" anchor="ctr">
+            <a:spAutoFit/>
+          </a:bodyPr>
+          <a:lstStyle/>
+          <a:p>
+            <a:pPr algn="ctr">
+              <a:lnSpc>
+                <a:spcPct val="95000"/>
+              </a:lnSpc>
+              <a:spcBef>
+                <a:spcPts val="0"/>
+              </a:spcBef>
+              <a:spcAft>
+                <a:spcPts val="0"/>
+              </a:spcAft>
+            </a:pPr>
+            <a:r>
+              <a:rPr sz="1100" b="1" i="0">
+                <a:solidFill>
+                  <a:srgbClr val="1B3E6E"/>
+                </a:solidFill>
+                <a:latin typeface="Georgia"/>
+              </a:rPr>
+              <a:t>Two fixable gaps, two targeted builds — $250k of capital becomes $310k of savings, every year.</a:t>
+            </a:r>
+          </a:p>
+        </p:txBody>
+      </p:sp>
+      <p:sp>
+        <p:nvSpPr>
+          <p:cNvPr id="7" name="TextBox 6"/>
+          <p:cNvSpPr txBox="1"/>
+          <p:nvPr/>
+        </p:nvSpPr>
+        <p:spPr>
+          <a:xfrm>
+            <a:off x="365760" y="6492240"/>
+            <a:ext cx="1280160" cy="329184"/>
+          </a:xfrm>
+          <a:prstGeom prst="rect">
+            <a:avLst/>
+          </a:prstGeom>
+          <a:noFill/>
+        </p:spPr>
+        <p:txBody>
+          <a:bodyPr wrap="square" lIns="0" rIns="0" tIns="0" bIns="0" anchor="t">
+            <a:spAutoFit/>
+          </a:bodyPr>
+          <a:lstStyle/>
+          <a:p>
+            <a:pPr algn="l">
+              <a:lnSpc>
+                <a:spcPct val="90000"/>
+              </a:lnSpc>
+              <a:spcBef>
+                <a:spcPts val="0"/>
+              </a:spcBef>
+              <a:spcAft>
+                <a:spcPts val="0"/>
+              </a:spcAft>
+            </a:pPr>
+            <a:r>
+              <a:rPr sz="900" b="1" i="0">
+                <a:solidFill>
+                  <a:srgbClr val="111111"/>
+                </a:solidFill>
+                <a:latin typeface="Georgia"/>
+              </a:rPr>
+              <a:t>Goldman</a:t>
+            </a:r>
+          </a:p>
+          <a:p>
+            <a:pPr algn="l">
+              <a:lnSpc>
+                <a:spcPct val="90000"/>
+              </a:lnSpc>
+              <a:spcBef>
+                <a:spcPts val="0"/>
+              </a:spcBef>
+              <a:spcAft>
+                <a:spcPts val="0"/>
+              </a:spcAft>
+            </a:pPr>
+            <a:r>
+              <a:rPr sz="900" b="1" i="0">
+                <a:solidFill>
+                  <a:srgbClr val="111111"/>
+                </a:solidFill>
+                <a:latin typeface="Georgia"/>
+              </a:rPr>
+              <a:t>Sachs</a:t>
+            </a:r>
+          </a:p>
+        </p:txBody>
+      </p:sp>
+      <p:sp>
+        <p:nvSpPr>
+          <p:cNvPr id="8" name="TextBox 7"/>
+          <p:cNvSpPr txBox="1"/>
+          <p:nvPr/>
+        </p:nvSpPr>
+        <p:spPr>
+          <a:xfrm>
+            <a:off x="8321040" y="6528816"/>
+            <a:ext cx="457200" cy="274320"/>
+          </a:xfrm>
+          <a:prstGeom prst="rect">
+            <a:avLst/>
+          </a:prstGeom>
+          <a:noFill/>
+        </p:spPr>
+        <p:txBody>
+          <a:bodyPr wrap="square" lIns="0" rIns="0" tIns="0" bIns="0" anchor="t">
+            <a:spAutoFit/>
+          </a:bodyPr>
+          <a:lstStyle/>
+          <a:p>
+            <a:pPr algn="r">
+              <a:lnSpc>
+                <a:spcPct val="100000"/>
+              </a:lnSpc>
+              <a:spcBef>
+                <a:spcPts val="0"/>
+              </a:spcBef>
+              <a:spcAft>
+                <a:spcPts val="300"/>
+              </a:spcAft>
+            </a:pPr>
+            <a:r>
+              <a:rPr sz="900" b="0" i="0">
+                <a:solidFill>
+                  <a:srgbClr val="727375"/>
+                </a:solidFill>
+                <a:latin typeface="Arial"/>
+              </a:rPr>
+              <a:t>7</a:t>
+            </a:r>
+          </a:p>
+        </p:txBody>
+      </p:sp>
+      <p:sp>
+        <p:nvSpPr>
+          <p:cNvPr id="9" name="TextBox 8"/>
+          <p:cNvSpPr txBox="1"/>
+          <p:nvPr/>
+        </p:nvSpPr>
+        <p:spPr>
+          <a:xfrm>
+            <a:off x="5486400" y="54864"/>
+            <a:ext cx="3291840" cy="182880"/>
+          </a:xfrm>
+          <a:prstGeom prst="rect">
+            <a:avLst/>
+          </a:prstGeom>
+          <a:noFill/>
+        </p:spPr>
+        <p:txBody>
+          <a:bodyPr wrap="square" lIns="0" rIns="0" tIns="0" bIns="0" anchor="t">
+            <a:spAutoFit/>
+          </a:bodyPr>
+          <a:lstStyle/>
+          <a:p>
+            <a:pPr algn="r">
+              <a:lnSpc>
+                <a:spcPct val="100000"/>
+              </a:lnSpc>
+              <a:spcBef>
+                <a:spcPts val="0"/>
+              </a:spcBef>
+              <a:spcAft>
+                <a:spcPts val="0"/>
+              </a:spcAft>
+            </a:pPr>
+            <a:r>
+              <a:rPr sz="750" b="0" i="1">
+                <a:solidFill>
+                  <a:srgbClr val="727375"/>
+                </a:solidFill>
+                <a:latin typeface="Arial"/>
+              </a:rPr>
+              <a:t>PROPOSED SLIDE 3 — v2</a:t>
+            </a:r>
+          </a:p>
+        </p:txBody>
+      </p:sp>
+      <p:sp>
+        <p:nvSpPr>
+          <p:cNvPr id="10" name="Rectangle 9"/>
+          <p:cNvSpPr/>
+          <p:nvPr/>
+        </p:nvSpPr>
+        <p:spPr>
+          <a:xfrm>
+            <a:off x="365760" y="1353312"/>
+            <a:ext cx="54864" cy="182880"/>
+          </a:xfrm>
+          <a:prstGeom prst="rect">
+            <a:avLst/>
+          </a:prstGeom>
+          <a:solidFill>
+            <a:srgbClr val="1B3E6E"/>
+          </a:solidFill>
+          <a:ln>
+            <a:noFill/>
+          </a:ln>
+          <a:effectLst/>
+        </p:spPr>
+        <p:style>
+          <a:lnRef idx="1">
+            <a:schemeClr val="accent1"/>
+          </a:lnRef>
+          <a:fillRef idx="3">
+            <a:schemeClr val="accent1"/>
+          </a:fillRef>
+          <a:effectRef idx="2">
+            <a:schemeClr val="accent1"/>
+          </a:effectRef>
+          <a:fontRef idx="minor">
+            <a:schemeClr val="lt1"/>
+          </a:fontRef>
+        </p:style>
+        <p:txBody>
+          <a:bodyPr rtlCol="0" anchor="ctr"/>
+          <a:lstStyle/>
+          <a:p>
+            <a:pPr algn="ctr"/>
+          </a:p>
+        </p:txBody>
+      </p:sp>
+      <p:sp>
+        <p:nvSpPr>
+          <p:cNvPr id="11" name="TextBox 10"/>
+          <p:cNvSpPr txBox="1"/>
+          <p:nvPr/>
+        </p:nvSpPr>
+        <p:spPr>
+          <a:xfrm>
+            <a:off x="512064" y="1325880"/>
+            <a:ext cx="8266175" cy="256032"/>
+          </a:xfrm>
+          <a:prstGeom prst="rect">
+            <a:avLst/>
+          </a:prstGeom>
+          <a:noFill/>
+        </p:spPr>
+        <p:txBody>
+          <a:bodyPr wrap="square" lIns="0" rIns="0" tIns="0" bIns="0" anchor="t">
+            <a:spAutoFit/>
+          </a:bodyPr>
+          <a:lstStyle/>
+          <a:p>
+            <a:pPr algn="l">
+              <a:lnSpc>
+                <a:spcPct val="100000"/>
+              </a:lnSpc>
+              <a:spcBef>
+                <a:spcPts val="0"/>
+              </a:spcBef>
+              <a:spcAft>
+                <a:spcPts val="0"/>
+              </a:spcAft>
+            </a:pPr>
+            <a:r>
+              <a:rPr sz="1150" b="1" i="0">
+                <a:solidFill>
+                  <a:srgbClr val="1B3E6E"/>
+                </a:solidFill>
+                <a:latin typeface="Arial"/>
+              </a:rPr>
+              <a:t>How the $250,000 grant splits across the two gaps</a:t>
+            </a:r>
+          </a:p>
+        </p:txBody>
+      </p:sp>
+      <p:sp>
+        <p:nvSpPr>
+          <p:cNvPr id="12" name="Rectangle 11"/>
+          <p:cNvSpPr/>
+          <p:nvPr/>
+        </p:nvSpPr>
+        <p:spPr>
+          <a:xfrm>
+            <a:off x="365760" y="1600200"/>
+            <a:ext cx="8412480" cy="10972"/>
+          </a:xfrm>
+          <a:prstGeom prst="rect">
+            <a:avLst/>
+          </a:prstGeom>
+          <a:solidFill>
+            <a:srgbClr val="BFBFBF"/>
+          </a:solidFill>
+          <a:ln>
+            <a:noFill/>
+          </a:ln>
+          <a:effectLst/>
+        </p:spPr>
+        <p:style>
+          <a:lnRef idx="1">
+            <a:schemeClr val="accent1"/>
+          </a:lnRef>
+          <a:fillRef idx="3">
+            <a:schemeClr val="accent1"/>
+          </a:fillRef>
+          <a:effectRef idx="2">
+            <a:schemeClr val="accent1"/>
+          </a:effectRef>
+          <a:fontRef idx="minor">
+            <a:schemeClr val="lt1"/>
+          </a:fontRef>
+        </p:style>
+        <p:txBody>
+          <a:bodyPr rtlCol="0" anchor="ctr"/>
+          <a:lstStyle/>
+          <a:p>
+            <a:pPr algn="ctr"/>
+          </a:p>
+        </p:txBody>
+      </p:sp>
+      <p:sp>
+        <p:nvSpPr>
+          <p:cNvPr id="13" name="Rectangle 12"/>
+          <p:cNvSpPr/>
+          <p:nvPr/>
+        </p:nvSpPr>
+        <p:spPr>
+          <a:xfrm>
+            <a:off x="502920" y="1746504"/>
+            <a:ext cx="4882895" cy="420624"/>
+          </a:xfrm>
+          <a:prstGeom prst="rect">
+            <a:avLst/>
+          </a:prstGeom>
+          <a:solidFill>
+            <a:srgbClr val="1B3E6E"/>
+          </a:solidFill>
+          <a:ln>
+            <a:noFill/>
+          </a:ln>
+          <a:effectLst/>
+        </p:spPr>
+        <p:style>
+          <a:lnRef idx="1">
+            <a:schemeClr val="accent1"/>
+          </a:lnRef>
+          <a:fillRef idx="3">
+            <a:schemeClr val="accent1"/>
+          </a:fillRef>
+          <a:effectRef idx="2">
+            <a:schemeClr val="accent1"/>
+          </a:effectRef>
+          <a:fontRef idx="minor">
+            <a:schemeClr val="lt1"/>
+          </a:fontRef>
+        </p:style>
+        <p:txBody>
+          <a:bodyPr rtlCol="0" anchor="ctr"/>
+          <a:lstStyle/>
+          <a:p>
+            <a:pPr algn="ctr"/>
+          </a:p>
+        </p:txBody>
+      </p:sp>
+      <p:sp>
+        <p:nvSpPr>
+          <p:cNvPr id="14" name="Rectangle 13"/>
+          <p:cNvSpPr/>
+          <p:nvPr/>
+        </p:nvSpPr>
+        <p:spPr>
+          <a:xfrm>
+            <a:off x="5385815" y="1746504"/>
+            <a:ext cx="3255263" cy="420624"/>
+          </a:xfrm>
+          <a:prstGeom prst="rect">
+            <a:avLst/>
+          </a:prstGeom>
+          <a:solidFill>
+            <a:srgbClr val="398025"/>
+          </a:solidFill>
+          <a:ln>
+            <a:noFill/>
+          </a:ln>
+          <a:effectLst/>
+        </p:spPr>
+        <p:style>
+          <a:lnRef idx="1">
+            <a:schemeClr val="accent1"/>
+          </a:lnRef>
+          <a:fillRef idx="3">
+            <a:schemeClr val="accent1"/>
+          </a:fillRef>
+          <a:effectRef idx="2">
+            <a:schemeClr val="accent1"/>
+          </a:effectRef>
+          <a:fontRef idx="minor">
+            <a:schemeClr val="lt1"/>
+          </a:fontRef>
+        </p:style>
+        <p:txBody>
+          <a:bodyPr rtlCol="0" anchor="ctr"/>
+          <a:lstStyle/>
+          <a:p>
+            <a:pPr algn="ctr"/>
+          </a:p>
+        </p:txBody>
+      </p:sp>
+      <p:sp>
+        <p:nvSpPr>
+          <p:cNvPr id="15" name="TextBox 14"/>
+          <p:cNvSpPr txBox="1"/>
+          <p:nvPr/>
+        </p:nvSpPr>
+        <p:spPr>
+          <a:xfrm>
+            <a:off x="502920" y="1746504"/>
+            <a:ext cx="4882895" cy="420624"/>
+          </a:xfrm>
+          <a:prstGeom prst="rect">
+            <a:avLst/>
+          </a:prstGeom>
+          <a:noFill/>
+        </p:spPr>
+        <p:txBody>
+          <a:bodyPr wrap="square" lIns="0" rIns="0" tIns="0" bIns="0" anchor="ctr">
+            <a:spAutoFit/>
+          </a:bodyPr>
+          <a:lstStyle/>
+          <a:p>
+            <a:pPr algn="ctr">
+              <a:lnSpc>
+                <a:spcPct val="100000"/>
+              </a:lnSpc>
+              <a:spcBef>
+                <a:spcPts val="0"/>
+              </a:spcBef>
+              <a:spcAft>
+                <a:spcPts val="0"/>
+              </a:spcAft>
+            </a:pPr>
+            <a:r>
+              <a:rPr sz="1000" b="1" i="0">
+                <a:solidFill>
+                  <a:srgbClr val="FFFFFF"/>
+                </a:solidFill>
+                <a:latin typeface="Arial"/>
+              </a:rPr>
+              <a:t>$150k — Gap 1: Procurement (60%)</a:t>
+            </a:r>
+          </a:p>
+        </p:txBody>
+      </p:sp>
+      <p:sp>
+        <p:nvSpPr>
+          <p:cNvPr id="16" name="TextBox 15"/>
+          <p:cNvSpPr txBox="1"/>
+          <p:nvPr/>
+        </p:nvSpPr>
+        <p:spPr>
+          <a:xfrm>
+            <a:off x="5385815" y="1746504"/>
+            <a:ext cx="3255263" cy="420624"/>
+          </a:xfrm>
+          <a:prstGeom prst="rect">
+            <a:avLst/>
+          </a:prstGeom>
+          <a:noFill/>
+        </p:spPr>
+        <p:txBody>
+          <a:bodyPr wrap="square" lIns="0" rIns="0" tIns="0" bIns="0" anchor="ctr">
+            <a:spAutoFit/>
+          </a:bodyPr>
+          <a:lstStyle/>
+          <a:p>
+            <a:pPr algn="ctr">
+              <a:lnSpc>
+                <a:spcPct val="100000"/>
+              </a:lnSpc>
+              <a:spcBef>
+                <a:spcPts val="0"/>
+              </a:spcBef>
+              <a:spcAft>
+                <a:spcPts val="0"/>
+              </a:spcAft>
+            </a:pPr>
+            <a:r>
+              <a:rPr sz="1000" b="1" i="0">
+                <a:solidFill>
+                  <a:srgbClr val="FFFFFF"/>
+                </a:solidFill>
+                <a:latin typeface="Arial"/>
+              </a:rPr>
+              <a:t>$100k — Gap 2: Distribution (40%)</a:t>
+            </a:r>
+          </a:p>
+        </p:txBody>
+      </p:sp>
+      <p:sp>
+        <p:nvSpPr>
+          <p:cNvPr id="17" name="TextBox 16"/>
+          <p:cNvSpPr txBox="1"/>
+          <p:nvPr/>
+        </p:nvSpPr>
+        <p:spPr>
+          <a:xfrm>
+            <a:off x="502920" y="2203704"/>
+            <a:ext cx="4882895" cy="219456"/>
+          </a:xfrm>
+          <a:prstGeom prst="rect">
+            <a:avLst/>
+          </a:prstGeom>
+          <a:noFill/>
+        </p:spPr>
+        <p:txBody>
+          <a:bodyPr wrap="square" lIns="0" rIns="0" tIns="0" bIns="0" anchor="t">
+            <a:spAutoFit/>
+          </a:bodyPr>
+          <a:lstStyle/>
+          <a:p>
+            <a:pPr algn="ctr">
+              <a:lnSpc>
+                <a:spcPct val="100000"/>
+              </a:lnSpc>
+              <a:spcBef>
+                <a:spcPts val="0"/>
+              </a:spcBef>
+              <a:spcAft>
+                <a:spcPts val="0"/>
+              </a:spcAft>
+            </a:pPr>
+            <a:r>
+              <a:rPr sz="720" b="0" i="0">
+                <a:solidFill>
+                  <a:srgbClr val="727375"/>
+                </a:solidFill>
+                <a:latin typeface="Arial"/>
+              </a:rPr>
+              <a:t>The costlier gap first — waste &amp; over-priced buying start at the source</a:t>
+            </a:r>
+          </a:p>
+        </p:txBody>
+      </p:sp>
+      <p:sp>
+        <p:nvSpPr>
+          <p:cNvPr id="18" name="TextBox 17"/>
+          <p:cNvSpPr txBox="1"/>
+          <p:nvPr/>
+        </p:nvSpPr>
+        <p:spPr>
+          <a:xfrm>
+            <a:off x="5385815" y="2203704"/>
+            <a:ext cx="3255263" cy="219456"/>
+          </a:xfrm>
+          <a:prstGeom prst="rect">
+            <a:avLst/>
+          </a:prstGeom>
+          <a:noFill/>
+        </p:spPr>
+        <p:txBody>
+          <a:bodyPr wrap="square" lIns="0" rIns="0" tIns="0" bIns="0" anchor="t">
+            <a:spAutoFit/>
+          </a:bodyPr>
+          <a:lstStyle/>
+          <a:p>
+            <a:pPr algn="ctr">
+              <a:lnSpc>
+                <a:spcPct val="100000"/>
+              </a:lnSpc>
+              <a:spcBef>
+                <a:spcPts val="0"/>
+              </a:spcBef>
+              <a:spcAft>
+                <a:spcPts val="0"/>
+              </a:spcAft>
+            </a:pPr>
+            <a:r>
+              <a:rPr sz="720" b="0" i="0">
+                <a:solidFill>
+                  <a:srgbClr val="727375"/>
+                </a:solidFill>
+                <a:latin typeface="Arial"/>
+              </a:rPr>
+              <a:t>Then seal the last mile — on time, intact, untouched</a:t>
+            </a:r>
+          </a:p>
+        </p:txBody>
+      </p:sp>
+      <p:sp>
+        <p:nvSpPr>
+          <p:cNvPr id="19" name="Rectangle 18"/>
+          <p:cNvSpPr/>
+          <p:nvPr/>
+        </p:nvSpPr>
+        <p:spPr>
+          <a:xfrm>
+            <a:off x="365760" y="2569463"/>
+            <a:ext cx="54864" cy="182880"/>
+          </a:xfrm>
+          <a:prstGeom prst="rect">
+            <a:avLst/>
+          </a:prstGeom>
+          <a:solidFill>
+            <a:srgbClr val="C22310"/>
+          </a:solidFill>
+          <a:ln>
+            <a:noFill/>
+          </a:ln>
+          <a:effectLst/>
+        </p:spPr>
+        <p:style>
+          <a:lnRef idx="1">
+            <a:schemeClr val="accent1"/>
+          </a:lnRef>
+          <a:fillRef idx="3">
+            <a:schemeClr val="accent1"/>
+          </a:fillRef>
+          <a:effectRef idx="2">
+            <a:schemeClr val="accent1"/>
+          </a:effectRef>
+          <a:fontRef idx="minor">
+            <a:schemeClr val="lt1"/>
+          </a:fontRef>
+        </p:style>
+        <p:txBody>
+          <a:bodyPr rtlCol="0" anchor="ctr"/>
+          <a:lstStyle/>
+          <a:p>
+            <a:pPr algn="ctr"/>
+          </a:p>
+        </p:txBody>
+      </p:sp>
+      <p:sp>
+        <p:nvSpPr>
+          <p:cNvPr id="20" name="TextBox 19"/>
+          <p:cNvSpPr txBox="1"/>
+          <p:nvPr/>
+        </p:nvSpPr>
+        <p:spPr>
+          <a:xfrm>
+            <a:off x="512064" y="2542032"/>
+            <a:ext cx="3922776" cy="256032"/>
+          </a:xfrm>
+          <a:prstGeom prst="rect">
+            <a:avLst/>
+          </a:prstGeom>
+          <a:noFill/>
+        </p:spPr>
+        <p:txBody>
+          <a:bodyPr wrap="square" lIns="0" rIns="0" tIns="0" bIns="0" anchor="t">
+            <a:spAutoFit/>
+          </a:bodyPr>
+          <a:lstStyle/>
+          <a:p>
+            <a:pPr algn="l">
+              <a:lnSpc>
+                <a:spcPct val="100000"/>
+              </a:lnSpc>
+              <a:spcBef>
+                <a:spcPts val="0"/>
+              </a:spcBef>
+              <a:spcAft>
+                <a:spcPts val="0"/>
+              </a:spcAft>
+            </a:pPr>
+            <a:r>
+              <a:rPr sz="1050" b="1" i="0">
+                <a:solidFill>
+                  <a:srgbClr val="1B3E6E"/>
+                </a:solidFill>
+                <a:latin typeface="Arial"/>
+              </a:rPr>
+              <a:t>GAP 1 — Procurement: demand is guesswork</a:t>
+            </a:r>
+          </a:p>
+        </p:txBody>
+      </p:sp>
+      <p:sp>
+        <p:nvSpPr>
+          <p:cNvPr id="21" name="Rectangle 20"/>
+          <p:cNvSpPr/>
+          <p:nvPr/>
+        </p:nvSpPr>
+        <p:spPr>
+          <a:xfrm>
+            <a:off x="365760" y="2816351"/>
+            <a:ext cx="4069080" cy="10972"/>
+          </a:xfrm>
+          <a:prstGeom prst="rect">
+            <a:avLst/>
+          </a:prstGeom>
+          <a:solidFill>
+            <a:srgbClr val="BFBFBF"/>
+          </a:solidFill>
+          <a:ln>
+            <a:noFill/>
+          </a:ln>
+          <a:effectLst/>
+        </p:spPr>
+        <p:style>
+          <a:lnRef idx="1">
+            <a:schemeClr val="accent1"/>
+          </a:lnRef>
+          <a:fillRef idx="3">
+            <a:schemeClr val="accent1"/>
+          </a:fillRef>
+          <a:effectRef idx="2">
+            <a:schemeClr val="accent1"/>
+          </a:effectRef>
+          <a:fontRef idx="minor">
+            <a:schemeClr val="lt1"/>
+          </a:fontRef>
+        </p:style>
+        <p:txBody>
+          <a:bodyPr rtlCol="0" anchor="ctr"/>
+          <a:lstStyle/>
+          <a:p>
+            <a:pPr algn="ctr"/>
+          </a:p>
+        </p:txBody>
+      </p:sp>
+      <p:sp>
+        <p:nvSpPr>
+          <p:cNvPr id="22" name="TextBox 21"/>
+          <p:cNvSpPr txBox="1"/>
+          <p:nvPr/>
+        </p:nvSpPr>
+        <p:spPr>
+          <a:xfrm>
+            <a:off x="365760" y="2907791"/>
+            <a:ext cx="4069080" cy="1005840"/>
+          </a:xfrm>
+          <a:prstGeom prst="rect">
+            <a:avLst/>
+          </a:prstGeom>
+          <a:noFill/>
+        </p:spPr>
+        <p:txBody>
+          <a:bodyPr wrap="square" lIns="0" rIns="0" tIns="0" bIns="0" anchor="t">
+            <a:spAutoFit/>
+          </a:bodyPr>
+          <a:lstStyle/>
+          <a:p>
+            <a:pPr algn="l">
+              <a:lnSpc>
+                <a:spcPct val="105000"/>
+              </a:lnSpc>
+              <a:spcBef>
+                <a:spcPts val="0"/>
+              </a:spcBef>
+              <a:spcAft>
+                <a:spcPts val="300"/>
+              </a:spcAft>
+            </a:pPr>
+            <a:r>
+              <a:rPr sz="819" b="1" i="0">
+                <a:solidFill>
+                  <a:srgbClr val="333333"/>
+                </a:solidFill>
+                <a:latin typeface="Arial"/>
+              </a:rPr>
+              <a:t>•  Manual, gut-feel indenting</a:t>
+            </a:r>
+            <a:r>
+              <a:rPr sz="819" b="0" i="0">
+                <a:solidFill>
+                  <a:srgbClr val="333333"/>
+                </a:solidFill>
+                <a:latin typeface="Arial"/>
+              </a:rPr>
+              <a:t> 3 days ahead — blind to attendance swings, exams &amp; holidays</a:t>
+            </a:r>
+          </a:p>
+          <a:p>
+            <a:pPr algn="l">
+              <a:lnSpc>
+                <a:spcPct val="105000"/>
+              </a:lnSpc>
+              <a:spcBef>
+                <a:spcPts val="0"/>
+              </a:spcBef>
+              <a:spcAft>
+                <a:spcPts val="300"/>
+              </a:spcAft>
+            </a:pPr>
+            <a:r>
+              <a:rPr sz="819" b="1" i="0">
+                <a:solidFill>
+                  <a:srgbClr val="333333"/>
+                </a:solidFill>
+                <a:latin typeface="Arial"/>
+              </a:rPr>
+              <a:t>•  Reactive spot-buying</a:t>
+            </a:r>
+            <a:r>
+              <a:rPr sz="819" b="0" i="0">
+                <a:solidFill>
+                  <a:srgbClr val="333333"/>
+                </a:solidFill>
+                <a:latin typeface="Arial"/>
+              </a:rPr>
+              <a:t> at mandi peak prices when stocks run short</a:t>
+            </a:r>
+          </a:p>
+          <a:p>
+            <a:pPr algn="l">
+              <a:lnSpc>
+                <a:spcPct val="105000"/>
+              </a:lnSpc>
+              <a:spcBef>
+                <a:spcPts val="0"/>
+              </a:spcBef>
+              <a:spcAft>
+                <a:spcPts val="300"/>
+              </a:spcAft>
+            </a:pPr>
+            <a:r>
+              <a:rPr sz="819" b="1" i="0">
+                <a:solidFill>
+                  <a:srgbClr val="333333"/>
+                </a:solidFill>
+                <a:latin typeface="Arial"/>
+              </a:rPr>
+              <a:t>•  No price intelligence</a:t>
+            </a:r>
+            <a:r>
+              <a:rPr sz="819" b="0" i="0">
+                <a:solidFill>
+                  <a:srgbClr val="333333"/>
+                </a:solidFill>
+                <a:latin typeface="Arial"/>
+              </a:rPr>
+              <a:t> — cheapest forward-buying windows are missed</a:t>
+            </a:r>
+          </a:p>
+          <a:p>
+            <a:pPr algn="l">
+              <a:lnSpc>
+                <a:spcPct val="105000"/>
+              </a:lnSpc>
+              <a:spcBef>
+                <a:spcPts val="0"/>
+              </a:spcBef>
+              <a:spcAft>
+                <a:spcPts val="0"/>
+              </a:spcAft>
+            </a:pPr>
+            <a:r>
+              <a:rPr sz="819" b="1" i="0">
+                <a:solidFill>
+                  <a:srgbClr val="333333"/>
+                </a:solidFill>
+                <a:latin typeface="Arial"/>
+              </a:rPr>
+              <a:t>•  No feedback loop</a:t>
+            </a:r>
+            <a:r>
+              <a:rPr sz="819" b="0" i="0">
+                <a:solidFill>
+                  <a:srgbClr val="333333"/>
+                </a:solidFill>
+                <a:latin typeface="Arial"/>
+              </a:rPr>
+              <a:t> from schools on actual meal uptake</a:t>
+            </a:r>
+          </a:p>
+        </p:txBody>
+      </p:sp>
+      <p:sp>
+        <p:nvSpPr>
+          <p:cNvPr id="23" name="TextBox 22"/>
+          <p:cNvSpPr txBox="1"/>
+          <p:nvPr/>
+        </p:nvSpPr>
+        <p:spPr>
+          <a:xfrm>
+            <a:off x="365760" y="3931920"/>
+            <a:ext cx="4069080" cy="219456"/>
+          </a:xfrm>
+          <a:prstGeom prst="rect">
+            <a:avLst/>
+          </a:prstGeom>
+          <a:noFill/>
+        </p:spPr>
+        <p:txBody>
+          <a:bodyPr wrap="square" lIns="0" rIns="0" tIns="0" bIns="0" anchor="t">
+            <a:spAutoFit/>
+          </a:bodyPr>
+          <a:lstStyle/>
+          <a:p>
+            <a:pPr algn="l">
+              <a:lnSpc>
+                <a:spcPct val="100000"/>
+              </a:lnSpc>
+              <a:spcBef>
+                <a:spcPts val="0"/>
+              </a:spcBef>
+              <a:spcAft>
+                <a:spcPts val="0"/>
+              </a:spcAft>
+            </a:pPr>
+            <a:r>
+              <a:rPr sz="819" b="1" i="0">
+                <a:solidFill>
+                  <a:srgbClr val="C22310"/>
+                </a:solidFill>
+                <a:latin typeface="Arial"/>
+              </a:rPr>
+              <a:t>Cost today:  8–10% meals over-produced  ·  +12% paid on spot buys [dummy]</a:t>
+            </a:r>
+          </a:p>
+        </p:txBody>
+      </p:sp>
+      <p:cxnSp>
+        <p:nvCxnSpPr>
+          <p:cNvPr id="24" name="Connector 23"/>
+          <p:cNvCxnSpPr/>
+          <p:nvPr/>
+        </p:nvCxnSpPr>
+        <p:spPr>
+          <a:xfrm>
+            <a:off x="2400300" y="4187952"/>
+            <a:ext cx="0" cy="182879"/>
+          </a:xfrm>
+          <a:prstGeom prst="line">
+            <a:avLst/>
+          </a:prstGeom>
+          <a:ln w="15875">
+            <a:solidFill>
+              <a:srgbClr val="1B3E6E"/>
+            </a:solidFill>
+            <a:prstDash val="sysDash"/>
+            <a:tailEnd type="triangle" w="med" len="med"/>
+          </a:ln>
+          <a:effectLst/>
+        </p:spPr>
+        <p:style>
+          <a:lnRef idx="2">
+            <a:schemeClr val="accent1"/>
+          </a:lnRef>
+          <a:fillRef idx="0">
+            <a:schemeClr val="accent1"/>
+          </a:fillRef>
+          <a:effectRef idx="1">
+            <a:schemeClr val="accent1"/>
+          </a:effectRef>
+          <a:fontRef idx="minor">
+            <a:schemeClr val="tx1"/>
+          </a:fontRef>
+        </p:style>
+      </p:cxnSp>
+      <p:sp>
+        <p:nvSpPr>
+          <p:cNvPr id="25" name="Rounded Rectangle 24"/>
+          <p:cNvSpPr/>
+          <p:nvPr/>
+        </p:nvSpPr>
+        <p:spPr>
+          <a:xfrm>
+            <a:off x="365760" y="4425696"/>
+            <a:ext cx="4069080" cy="1389888"/>
+          </a:xfrm>
+          <a:prstGeom prst="roundRect">
+            <a:avLst>
+              <a:gd name="adj" fmla="val 5000"/>
+            </a:avLst>
+          </a:prstGeom>
+          <a:solidFill>
+            <a:srgbClr val="EEF3F9"/>
+          </a:solidFill>
+          <a:ln w="12700">
+            <a:solidFill>
+              <a:srgbClr val="1B3E6E"/>
+            </a:solidFill>
+          </a:ln>
+          <a:effectLst/>
+        </p:spPr>
+        <p:style>
+          <a:lnRef idx="1">
+            <a:schemeClr val="accent1"/>
+          </a:lnRef>
+          <a:fillRef idx="3">
+            <a:schemeClr val="accent1"/>
+          </a:fillRef>
+          <a:effectRef idx="2">
+            <a:schemeClr val="accent1"/>
+          </a:effectRef>
+          <a:fontRef idx="minor">
+            <a:schemeClr val="lt1"/>
+          </a:fontRef>
+        </p:style>
+        <p:txBody>
+          <a:bodyPr rtlCol="0" anchor="ctr"/>
+          <a:lstStyle/>
+          <a:p>
+            <a:pPr algn="ctr"/>
+          </a:p>
+        </p:txBody>
+      </p:sp>
+      <p:sp>
+        <p:nvSpPr>
+          <p:cNvPr id="26" name="TextBox 25"/>
+          <p:cNvSpPr txBox="1"/>
+          <p:nvPr/>
+        </p:nvSpPr>
+        <p:spPr>
+          <a:xfrm>
+            <a:off x="493776" y="4507992"/>
+            <a:ext cx="3813048" cy="1389888"/>
+          </a:xfrm>
+          <a:prstGeom prst="rect">
+            <a:avLst/>
+          </a:prstGeom>
+          <a:noFill/>
+        </p:spPr>
+        <p:txBody>
+          <a:bodyPr wrap="square" lIns="0" rIns="0" tIns="0" bIns="0" anchor="t">
+            <a:spAutoFit/>
+          </a:bodyPr>
+          <a:lstStyle/>
+          <a:p>
+            <a:pPr algn="l">
+              <a:lnSpc>
+                <a:spcPct val="100000"/>
+              </a:lnSpc>
+              <a:spcBef>
+                <a:spcPts val="0"/>
+              </a:spcBef>
+              <a:spcAft>
+                <a:spcPts val="300"/>
+              </a:spcAft>
+            </a:pPr>
+            <a:r>
+              <a:rPr sz="1050" b="1" i="0">
+                <a:solidFill>
+                  <a:srgbClr val="1B3E6E"/>
+                </a:solidFill>
+                <a:latin typeface="Arial"/>
+              </a:rPr>
+              <a:t>SOLUTION 1 — “Annapurna AI”  ·  $150k</a:t>
+            </a:r>
+          </a:p>
+          <a:p>
+            <a:pPr algn="l">
+              <a:lnSpc>
+                <a:spcPct val="105000"/>
+              </a:lnSpc>
+              <a:spcBef>
+                <a:spcPts val="0"/>
+              </a:spcBef>
+              <a:spcAft>
+                <a:spcPts val="300"/>
+              </a:spcAft>
+            </a:pPr>
+            <a:r>
+              <a:rPr sz="819" b="1" i="0">
+                <a:solidFill>
+                  <a:srgbClr val="1B3E6E"/>
+                </a:solidFill>
+                <a:latin typeface="Arial"/>
+              </a:rPr>
+              <a:t>What: </a:t>
+            </a:r>
+            <a:r>
+              <a:rPr sz="819" b="0" i="0">
+                <a:solidFill>
+                  <a:srgbClr val="333333"/>
+                </a:solidFill>
+                <a:latin typeface="Arial"/>
+              </a:rPr>
+              <a:t>ML demand-forecasting &amp; procurement-planning platform across all 68 kitchens</a:t>
+            </a:r>
+          </a:p>
+          <a:p>
+            <a:pPr algn="l">
+              <a:lnSpc>
+                <a:spcPct val="105000"/>
+              </a:lnSpc>
+              <a:spcBef>
+                <a:spcPts val="0"/>
+              </a:spcBef>
+              <a:spcAft>
+                <a:spcPts val="300"/>
+              </a:spcAft>
+            </a:pPr>
+            <a:r>
+              <a:rPr sz="819" b="1" i="0">
+                <a:solidFill>
+                  <a:srgbClr val="1B3E6E"/>
+                </a:solidFill>
+                <a:latin typeface="Arial"/>
+              </a:rPr>
+              <a:t>How: </a:t>
+            </a:r>
+            <a:r>
+              <a:rPr sz="819" b="0" i="0">
+                <a:solidFill>
+                  <a:srgbClr val="333333"/>
+                </a:solidFill>
+                <a:latin typeface="Arial"/>
+              </a:rPr>
+              <a:t>predicts school-level attendance from history, calendars &amp; seasonality; auto-generates daily indents &amp; forward buying schedules</a:t>
+            </a:r>
+          </a:p>
+          <a:p>
+            <a:pPr algn="l">
+              <a:lnSpc>
+                <a:spcPct val="105000"/>
+              </a:lnSpc>
+              <a:spcBef>
+                <a:spcPts val="0"/>
+              </a:spcBef>
+              <a:spcAft>
+                <a:spcPts val="300"/>
+              </a:spcAft>
+            </a:pPr>
+            <a:r>
+              <a:rPr sz="780" b="1" i="0">
+                <a:solidFill>
+                  <a:srgbClr val="727375"/>
+                </a:solidFill>
+                <a:latin typeface="Arial"/>
+              </a:rPr>
+              <a:t>Rollout: </a:t>
+            </a:r>
+            <a:r>
+              <a:rPr sz="780" b="0" i="0">
+                <a:solidFill>
+                  <a:srgbClr val="727375"/>
+                </a:solidFill>
+                <a:latin typeface="Arial"/>
+              </a:rPr>
+              <a:t>3-kitchen pilot (Mo 1–4) → all 68 kitchens by Mo 12</a:t>
+            </a:r>
+          </a:p>
+          <a:p>
+            <a:pPr algn="l">
+              <a:lnSpc>
+                <a:spcPct val="100000"/>
+              </a:lnSpc>
+              <a:spcBef>
+                <a:spcPts val="0"/>
+              </a:spcBef>
+              <a:spcAft>
+                <a:spcPts val="0"/>
+              </a:spcAft>
+            </a:pPr>
+            <a:r>
+              <a:rPr sz="860" b="1" i="0">
+                <a:solidFill>
+                  <a:srgbClr val="398025"/>
+                </a:solidFill>
+                <a:latin typeface="Arial"/>
+              </a:rPr>
+              <a:t>→  ~70% less food waste  ·  est. $230k saved / yr [dummy]</a:t>
+            </a:r>
+          </a:p>
+        </p:txBody>
+      </p:sp>
+      <p:sp>
+        <p:nvSpPr>
+          <p:cNvPr id="27" name="Rectangle 26"/>
+          <p:cNvSpPr/>
+          <p:nvPr/>
+        </p:nvSpPr>
+        <p:spPr>
+          <a:xfrm>
+            <a:off x="4709160" y="2569463"/>
+            <a:ext cx="54864" cy="182880"/>
+          </a:xfrm>
+          <a:prstGeom prst="rect">
+            <a:avLst/>
+          </a:prstGeom>
+          <a:solidFill>
+            <a:srgbClr val="C22310"/>
+          </a:solidFill>
+          <a:ln>
+            <a:noFill/>
+          </a:ln>
+          <a:effectLst/>
+        </p:spPr>
+        <p:style>
+          <a:lnRef idx="1">
+            <a:schemeClr val="accent1"/>
+          </a:lnRef>
+          <a:fillRef idx="3">
+            <a:schemeClr val="accent1"/>
+          </a:fillRef>
+          <a:effectRef idx="2">
+            <a:schemeClr val="accent1"/>
+          </a:effectRef>
+          <a:fontRef idx="minor">
+            <a:schemeClr val="lt1"/>
+          </a:fontRef>
+        </p:style>
+        <p:txBody>
+          <a:bodyPr rtlCol="0" anchor="ctr"/>
+          <a:lstStyle/>
+          <a:p>
+            <a:pPr algn="ctr"/>
+          </a:p>
+        </p:txBody>
+      </p:sp>
+      <p:sp>
+        <p:nvSpPr>
+          <p:cNvPr id="28" name="TextBox 27"/>
+          <p:cNvSpPr txBox="1"/>
+          <p:nvPr/>
+        </p:nvSpPr>
+        <p:spPr>
+          <a:xfrm>
+            <a:off x="4855464" y="2542032"/>
+            <a:ext cx="3922776" cy="256032"/>
+          </a:xfrm>
+          <a:prstGeom prst="rect">
+            <a:avLst/>
+          </a:prstGeom>
+          <a:noFill/>
+        </p:spPr>
+        <p:txBody>
+          <a:bodyPr wrap="square" lIns="0" rIns="0" tIns="0" bIns="0" anchor="t">
+            <a:spAutoFit/>
+          </a:bodyPr>
+          <a:lstStyle/>
+          <a:p>
+            <a:pPr algn="l">
+              <a:lnSpc>
+                <a:spcPct val="100000"/>
+              </a:lnSpc>
+              <a:spcBef>
+                <a:spcPts val="0"/>
+              </a:spcBef>
+              <a:spcAft>
+                <a:spcPts val="0"/>
+              </a:spcAft>
+            </a:pPr>
+            <a:r>
+              <a:rPr sz="1050" b="1" i="0">
+                <a:solidFill>
+                  <a:srgbClr val="1B3E6E"/>
+                </a:solidFill>
+                <a:latin typeface="Arial"/>
+              </a:rPr>
+              <a:t>GAP 2 — Distribution: the last mile is blind</a:t>
+            </a:r>
+          </a:p>
+        </p:txBody>
+      </p:sp>
+      <p:sp>
+        <p:nvSpPr>
+          <p:cNvPr id="29" name="Rectangle 28"/>
+          <p:cNvSpPr/>
+          <p:nvPr/>
+        </p:nvSpPr>
+        <p:spPr>
+          <a:xfrm>
+            <a:off x="4709160" y="2816351"/>
+            <a:ext cx="4069080" cy="10972"/>
+          </a:xfrm>
+          <a:prstGeom prst="rect">
+            <a:avLst/>
+          </a:prstGeom>
+          <a:solidFill>
+            <a:srgbClr val="BFBFBF"/>
+          </a:solidFill>
+          <a:ln>
+            <a:noFill/>
+          </a:ln>
+          <a:effectLst/>
+        </p:spPr>
+        <p:style>
+          <a:lnRef idx="1">
+            <a:schemeClr val="accent1"/>
+          </a:lnRef>
+          <a:fillRef idx="3">
+            <a:schemeClr val="accent1"/>
+          </a:fillRef>
+          <a:effectRef idx="2">
+            <a:schemeClr val="accent1"/>
+          </a:effectRef>
+          <a:fontRef idx="minor">
+            <a:schemeClr val="lt1"/>
+          </a:fontRef>
+        </p:style>
+        <p:txBody>
+          <a:bodyPr rtlCol="0" anchor="ctr"/>
+          <a:lstStyle/>
+          <a:p>
+            <a:pPr algn="ctr"/>
+          </a:p>
+        </p:txBody>
+      </p:sp>
+      <p:sp>
+        <p:nvSpPr>
+          <p:cNvPr id="30" name="TextBox 29"/>
+          <p:cNvSpPr txBox="1"/>
+          <p:nvPr/>
+        </p:nvSpPr>
+        <p:spPr>
+          <a:xfrm>
+            <a:off x="4709160" y="2907791"/>
+            <a:ext cx="4069080" cy="1005840"/>
+          </a:xfrm>
+          <a:prstGeom prst="rect">
+            <a:avLst/>
+          </a:prstGeom>
+          <a:noFill/>
+        </p:spPr>
+        <p:txBody>
+          <a:bodyPr wrap="square" lIns="0" rIns="0" tIns="0" bIns="0" anchor="t">
+            <a:spAutoFit/>
+          </a:bodyPr>
+          <a:lstStyle/>
+          <a:p>
+            <a:pPr algn="l">
+              <a:lnSpc>
+                <a:spcPct val="105000"/>
+              </a:lnSpc>
+              <a:spcBef>
+                <a:spcPts val="0"/>
+              </a:spcBef>
+              <a:spcAft>
+                <a:spcPts val="300"/>
+              </a:spcAft>
+            </a:pPr>
+            <a:r>
+              <a:rPr sz="819" b="1" i="0">
+                <a:solidFill>
+                  <a:srgbClr val="333333"/>
+                </a:solidFill>
+                <a:latin typeface="Arial"/>
+              </a:rPr>
+              <a:t>•  Static, driver-memory routes</a:t>
+            </a:r>
+            <a:r>
+              <a:rPr sz="819" b="0" i="0">
+                <a:solidFill>
+                  <a:srgbClr val="333333"/>
+                </a:solidFill>
+                <a:latin typeface="Arial"/>
+              </a:rPr>
+              <a:t> — 15–30 min past the lunch bell means children stay hungry all day</a:t>
+            </a:r>
+          </a:p>
+          <a:p>
+            <a:pPr algn="l">
+              <a:lnSpc>
+                <a:spcPct val="105000"/>
+              </a:lnSpc>
+              <a:spcBef>
+                <a:spcPts val="0"/>
+              </a:spcBef>
+              <a:spcAft>
+                <a:spcPts val="300"/>
+              </a:spcAft>
+            </a:pPr>
+            <a:r>
+              <a:rPr sz="819" b="1" i="0">
+                <a:solidFill>
+                  <a:srgbClr val="333333"/>
+                </a:solidFill>
+                <a:latin typeface="Arial"/>
+              </a:rPr>
+              <a:t>•  Untracked vessels &amp; utensils</a:t>
+            </a:r>
+            <a:r>
+              <a:rPr sz="819" b="0" i="0">
+                <a:solidFill>
+                  <a:srgbClr val="333333"/>
+                </a:solidFill>
+                <a:latin typeface="Arial"/>
+              </a:rPr>
+              <a:t> — daily losses add to operating cost</a:t>
+            </a:r>
+          </a:p>
+          <a:p>
+            <a:pPr algn="l">
+              <a:lnSpc>
+                <a:spcPct val="105000"/>
+              </a:lnSpc>
+              <a:spcBef>
+                <a:spcPts val="0"/>
+              </a:spcBef>
+              <a:spcAft>
+                <a:spcPts val="300"/>
+              </a:spcAft>
+            </a:pPr>
+            <a:r>
+              <a:rPr sz="819" b="1" i="0">
+                <a:solidFill>
+                  <a:srgbClr val="333333"/>
+                </a:solidFill>
+                <a:latin typeface="Arial"/>
+              </a:rPr>
+              <a:t>•  Adulteration / diversion risk</a:t>
+            </a:r>
+            <a:r>
+              <a:rPr sz="819" b="0" i="0">
+                <a:solidFill>
+                  <a:srgbClr val="333333"/>
+                </a:solidFill>
+                <a:latin typeface="Arial"/>
+              </a:rPr>
+              <a:t> — unsealed vans can be offloaded at roadside dhabas</a:t>
+            </a:r>
+          </a:p>
+          <a:p>
+            <a:pPr algn="l">
+              <a:lnSpc>
+                <a:spcPct val="105000"/>
+              </a:lnSpc>
+              <a:spcBef>
+                <a:spcPts val="0"/>
+              </a:spcBef>
+              <a:spcAft>
+                <a:spcPts val="0"/>
+              </a:spcAft>
+            </a:pPr>
+            <a:r>
+              <a:rPr sz="819" b="1" i="0">
+                <a:solidFill>
+                  <a:srgbClr val="333333"/>
+                </a:solidFill>
+                <a:latin typeface="Arial"/>
+              </a:rPr>
+              <a:t>•  No proof-of-delivery</a:t>
+            </a:r>
+            <a:r>
+              <a:rPr sz="819" b="0" i="0">
+                <a:solidFill>
+                  <a:srgbClr val="333333"/>
+                </a:solidFill>
+                <a:latin typeface="Arial"/>
+              </a:rPr>
+              <a:t> — school shortfall disputes go unresolved</a:t>
+            </a:r>
+          </a:p>
+        </p:txBody>
+      </p:sp>
+      <p:sp>
+        <p:nvSpPr>
+          <p:cNvPr id="31" name="TextBox 30"/>
+          <p:cNvSpPr txBox="1"/>
+          <p:nvPr/>
+        </p:nvSpPr>
+        <p:spPr>
+          <a:xfrm>
+            <a:off x="4709160" y="3931920"/>
+            <a:ext cx="4069080" cy="219456"/>
+          </a:xfrm>
+          <a:prstGeom prst="rect">
+            <a:avLst/>
+          </a:prstGeom>
+          <a:noFill/>
+        </p:spPr>
+        <p:txBody>
+          <a:bodyPr wrap="square" lIns="0" rIns="0" tIns="0" bIns="0" anchor="t">
+            <a:spAutoFit/>
+          </a:bodyPr>
+          <a:lstStyle/>
+          <a:p>
+            <a:pPr algn="l">
+              <a:lnSpc>
+                <a:spcPct val="100000"/>
+              </a:lnSpc>
+              <a:spcBef>
+                <a:spcPts val="0"/>
+              </a:spcBef>
+              <a:spcAft>
+                <a:spcPts val="0"/>
+              </a:spcAft>
+            </a:pPr>
+            <a:r>
+              <a:rPr sz="819" b="1" i="0">
+                <a:solidFill>
+                  <a:srgbClr val="C22310"/>
+                </a:solidFill>
+                <a:latin typeface="Arial"/>
+              </a:rPr>
+              <a:t>Cost today:  6.2% deliveries miss lunch  ·  $35k/yr shrinkage [dummy]</a:t>
+            </a:r>
+          </a:p>
+        </p:txBody>
+      </p:sp>
+      <p:cxnSp>
+        <p:nvCxnSpPr>
+          <p:cNvPr id="32" name="Connector 31"/>
+          <p:cNvCxnSpPr/>
+          <p:nvPr/>
+        </p:nvCxnSpPr>
+        <p:spPr>
+          <a:xfrm>
+            <a:off x="6743700" y="4187952"/>
+            <a:ext cx="0" cy="182879"/>
+          </a:xfrm>
+          <a:prstGeom prst="line">
+            <a:avLst/>
+          </a:prstGeom>
+          <a:ln w="15875">
+            <a:solidFill>
+              <a:srgbClr val="398025"/>
+            </a:solidFill>
+            <a:prstDash val="sysDash"/>
+            <a:tailEnd type="triangle" w="med" len="med"/>
+          </a:ln>
+          <a:effectLst/>
+        </p:spPr>
+        <p:style>
+          <a:lnRef idx="2">
+            <a:schemeClr val="accent1"/>
+          </a:lnRef>
+          <a:fillRef idx="0">
+            <a:schemeClr val="accent1"/>
+          </a:fillRef>
+          <a:effectRef idx="1">
+            <a:schemeClr val="accent1"/>
+          </a:effectRef>
+          <a:fontRef idx="minor">
+            <a:schemeClr val="tx1"/>
+          </a:fontRef>
+        </p:style>
+      </p:cxnSp>
+      <p:sp>
+        <p:nvSpPr>
+          <p:cNvPr id="33" name="Rounded Rectangle 32"/>
+          <p:cNvSpPr/>
+          <p:nvPr/>
+        </p:nvSpPr>
+        <p:spPr>
+          <a:xfrm>
+            <a:off x="4709160" y="4425696"/>
+            <a:ext cx="4069080" cy="1389888"/>
+          </a:xfrm>
+          <a:prstGeom prst="roundRect">
+            <a:avLst>
+              <a:gd name="adj" fmla="val 5000"/>
+            </a:avLst>
+          </a:prstGeom>
+          <a:solidFill>
+            <a:srgbClr val="EAF3E6"/>
+          </a:solidFill>
+          <a:ln w="12700">
+            <a:solidFill>
+              <a:srgbClr val="398025"/>
+            </a:solidFill>
+          </a:ln>
+          <a:effectLst/>
+        </p:spPr>
+        <p:style>
+          <a:lnRef idx="1">
+            <a:schemeClr val="accent1"/>
+          </a:lnRef>
+          <a:fillRef idx="3">
+            <a:schemeClr val="accent1"/>
+          </a:fillRef>
+          <a:effectRef idx="2">
+            <a:schemeClr val="accent1"/>
+          </a:effectRef>
+          <a:fontRef idx="minor">
+            <a:schemeClr val="lt1"/>
+          </a:fontRef>
+        </p:style>
+        <p:txBody>
+          <a:bodyPr rtlCol="0" anchor="ctr"/>
+          <a:lstStyle/>
+          <a:p>
+            <a:pPr algn="ctr"/>
+          </a:p>
+        </p:txBody>
+      </p:sp>
+      <p:sp>
+        <p:nvSpPr>
+          <p:cNvPr id="34" name="TextBox 33"/>
+          <p:cNvSpPr txBox="1"/>
+          <p:nvPr/>
+        </p:nvSpPr>
+        <p:spPr>
+          <a:xfrm>
+            <a:off x="4837176" y="4507992"/>
+            <a:ext cx="3813048" cy="1389888"/>
+          </a:xfrm>
+          <a:prstGeom prst="rect">
+            <a:avLst/>
+          </a:prstGeom>
+          <a:noFill/>
+        </p:spPr>
+        <p:txBody>
+          <a:bodyPr wrap="square" lIns="0" rIns="0" tIns="0" bIns="0" anchor="t">
+            <a:spAutoFit/>
+          </a:bodyPr>
+          <a:lstStyle/>
+          <a:p>
+            <a:pPr algn="l">
+              <a:lnSpc>
+                <a:spcPct val="100000"/>
+              </a:lnSpc>
+              <a:spcBef>
+                <a:spcPts val="0"/>
+              </a:spcBef>
+              <a:spcAft>
+                <a:spcPts val="300"/>
+              </a:spcAft>
+            </a:pPr>
+            <a:r>
+              <a:rPr sz="1050" b="1" i="0">
+                <a:solidFill>
+                  <a:srgbClr val="398025"/>
+                </a:solidFill>
+                <a:latin typeface="Arial"/>
+              </a:rPr>
+              <a:t>SOLUTION 2 — “Last-Mile Shield”  ·  $100k</a:t>
+            </a:r>
+          </a:p>
+          <a:p>
+            <a:pPr algn="l">
+              <a:lnSpc>
+                <a:spcPct val="105000"/>
+              </a:lnSpc>
+              <a:spcBef>
+                <a:spcPts val="0"/>
+              </a:spcBef>
+              <a:spcAft>
+                <a:spcPts val="300"/>
+              </a:spcAft>
+            </a:pPr>
+            <a:r>
+              <a:rPr sz="819" b="1" i="0">
+                <a:solidFill>
+                  <a:srgbClr val="1B3E6E"/>
+                </a:solidFill>
+                <a:latin typeface="Arial"/>
+              </a:rPr>
+              <a:t>What: </a:t>
+            </a:r>
+            <a:r>
+              <a:rPr sz="819" b="0" i="0">
+                <a:solidFill>
+                  <a:srgbClr val="333333"/>
+                </a:solidFill>
+                <a:latin typeface="Arial"/>
+              </a:rPr>
+              <a:t>AI route optimisation + van telematics (GPS, cameras, RFID tags) + geofenced smart locks</a:t>
+            </a:r>
+          </a:p>
+          <a:p>
+            <a:pPr algn="l">
+              <a:lnSpc>
+                <a:spcPct val="105000"/>
+              </a:lnSpc>
+              <a:spcBef>
+                <a:spcPts val="0"/>
+              </a:spcBef>
+              <a:spcAft>
+                <a:spcPts val="300"/>
+              </a:spcAft>
+            </a:pPr>
+            <a:r>
+              <a:rPr sz="819" b="1" i="0">
+                <a:solidFill>
+                  <a:srgbClr val="1B3E6E"/>
+                </a:solidFill>
+                <a:latin typeface="Arial"/>
+              </a:rPr>
+              <a:t>How: </a:t>
+            </a:r>
+            <a:r>
+              <a:rPr sz="819" b="0" i="0">
+                <a:solidFill>
+                  <a:srgbClr val="333333"/>
+                </a:solidFill>
+                <a:latin typeface="Arial"/>
+              </a:rPr>
+              <a:t>routes sequenced to each school's lunch bell; doors unlock only within 150 m of a registered school — diversion becomes impossible</a:t>
+            </a:r>
+          </a:p>
+          <a:p>
+            <a:pPr algn="l">
+              <a:lnSpc>
+                <a:spcPct val="105000"/>
+              </a:lnSpc>
+              <a:spcBef>
+                <a:spcPts val="0"/>
+              </a:spcBef>
+              <a:spcAft>
+                <a:spcPts val="300"/>
+              </a:spcAft>
+            </a:pPr>
+            <a:r>
+              <a:rPr sz="780" b="1" i="0">
+                <a:solidFill>
+                  <a:srgbClr val="727375"/>
+                </a:solidFill>
+                <a:latin typeface="Arial"/>
+              </a:rPr>
+              <a:t>Bonus: </a:t>
+            </a:r>
+            <a:r>
+              <a:rPr sz="780" b="0" i="0">
+                <a:solidFill>
+                  <a:srgbClr val="727375"/>
+                </a:solidFill>
+                <a:latin typeface="Arial"/>
+              </a:rPr>
+              <a:t>hardware amortises over 5+ yrs; 3 vans freed per hub reach new schools</a:t>
+            </a:r>
+          </a:p>
+          <a:p>
+            <a:pPr algn="l">
+              <a:lnSpc>
+                <a:spcPct val="100000"/>
+              </a:lnSpc>
+              <a:spcBef>
+                <a:spcPts val="0"/>
+              </a:spcBef>
+              <a:spcAft>
+                <a:spcPts val="0"/>
+              </a:spcAft>
+            </a:pPr>
+            <a:r>
+              <a:rPr sz="860" b="1" i="0">
+                <a:solidFill>
+                  <a:srgbClr val="398025"/>
+                </a:solidFill>
+                <a:latin typeface="Arial"/>
+              </a:rPr>
+              <a:t>→  99%+ on-time  ·  −18% fleet km  ·  est. $80k saved / yr [dummy]</a:t>
             </a:r>
           </a:p>
         </p:txBody>

</xml_diff>

<commit_message>
Slide-3 candidates: v2 reordered (gaps -> split -> solutions), v3 pie-quadrant layout
Co-Authored-By: Claude Fable 5 <noreply@anthropic.com>
Claude-Session: https://claude.ai/code/session_01XoYepLRLVLdWS74xAsgg39
</commit_message>
<xml_diff>
--- a/AkshayaPatra_GS_Pitch.pptx
+++ b/AkshayaPatra_GS_Pitch.pptx
@@ -12,6 +12,7 @@
     <p:sldId id="260" r:id="rId11"/>
     <p:sldId id="261" r:id="rId12"/>
     <p:sldId id="262" r:id="rId13"/>
+    <p:sldId id="263" r:id="rId14"/>
   </p:sldIdLst>
   <p:sldSz cx="9144000" cy="6858000" type="screen4x3"/>
   <p:notesSz cx="6858000" cy="9144000"/>
@@ -1150,6 +1151,135 @@
         </a:defRPr>
       </a:pPr>
       <a:endParaRPr lang="en-US"/>
+    </a:p>
+  </c:txPr>
+  <c:externalData r:id="rId1">
+    <c:autoUpdate val="0"/>
+  </c:externalData>
+</c:chartSpace>
+</file>
+
+<file path=ppt/charts/chart7.xml><?xml version="1.0" encoding="utf-8"?>
+<c:chartSpace xmlns:c="http://schemas.openxmlformats.org/drawingml/2006/chart" xmlns:a="http://schemas.openxmlformats.org/drawingml/2006/main" xmlns:r="http://schemas.openxmlformats.org/officeDocument/2006/relationships">
+  <c:date1904 val="0"/>
+  <c:roundedCorners val="0"/>
+  <c:chart>
+    <c:autoTitleDeleted val="1"/>
+    <c:plotArea>
+      <c:layout/>
+      <c:doughnutChart>
+        <c:varyColors val="1"/>
+        <c:ser>
+          <c:idx val="0"/>
+          <c:order val="0"/>
+          <c:tx>
+            <c:strRef>
+              <c:f>Sheet1!$B$1</c:f>
+              <c:strCache>
+                <c:ptCount val="1"/>
+                <c:pt idx="0">
+                  <c:v>s</c:v>
+                </c:pt>
+              </c:strCache>
+            </c:strRef>
+          </c:tx>
+          <c:dPt>
+            <c:idx val="0"/>
+            <c:spPr>
+              <a:solidFill>
+                <a:srgbClr val="1B3E6E"/>
+              </a:solidFill>
+              <a:ln w="19050">
+                <a:solidFill>
+                  <a:srgbClr val="FFFFFF"/>
+                </a:solidFill>
+              </a:ln>
+            </c:spPr>
+          </c:dPt>
+          <c:dPt>
+            <c:idx val="1"/>
+            <c:spPr>
+              <a:solidFill>
+                <a:srgbClr val="398025"/>
+              </a:solidFill>
+              <a:ln w="19050">
+                <a:solidFill>
+                  <a:srgbClr val="FFFFFF"/>
+                </a:solidFill>
+              </a:ln>
+            </c:spPr>
+          </c:dPt>
+          <c:cat>
+            <c:strRef>
+              <c:f>Sheet1!$A$2:$A$3</c:f>
+              <c:strCache>
+                <c:ptCount val="2"/>
+                <c:pt idx="0">
+                  <c:v>Solution 1 — $150k</c:v>
+                </c:pt>
+                <c:pt idx="1">
+                  <c:v>Solution 2 — $100k</c:v>
+                </c:pt>
+              </c:strCache>
+            </c:strRef>
+          </c:cat>
+          <c:val>
+            <c:numRef>
+              <c:f>Sheet1!$B$2:$B$3</c:f>
+              <c:numCache>
+                <c:formatCode>General</c:formatCode>
+                <c:ptCount val="2"/>
+                <c:pt idx="0">
+                  <c:v>150</c:v>
+                </c:pt>
+                <c:pt idx="1">
+                  <c:v>100</c:v>
+                </c:pt>
+              </c:numCache>
+            </c:numRef>
+          </c:val>
+        </c:ser>
+        <c:dLbls>
+          <c:numFmt formatCode="&quot;$&quot;0&quot;k&quot;" sourceLinked="0"/>
+          <c:txPr>
+            <a:bodyPr/>
+            <a:lstStyle/>
+            <a:p>
+              <a:pPr>
+                <a:defRPr sz="1000" b="1">
+                  <a:solidFill>
+                    <a:srgbClr val="FFFFFF"/>
+                  </a:solidFill>
+                </a:defRPr>
+              </a:pPr>
+            </a:p>
+          </c:txPr>
+          <c:showLegendKey val="0"/>
+          <c:showVal val="1"/>
+          <c:showCatName val="0"/>
+          <c:showSerName val="0"/>
+          <c:showPercent val="0"/>
+          <c:showBubbleSize val="0"/>
+          <c:showLeaderLines val="1"/>
+        </c:dLbls>
+        <c:firstSliceAng val="0"/>
+        <c:holeSize val="50"/>
+      </c:doughnutChart>
+    </c:plotArea>
+    <c:plotVisOnly val="1"/>
+    <c:dispBlanksAs val="gap"/>
+    <c:showDLblsOverMax val="0"/>
+  </c:chart>
+  <c:txPr>
+    <a:bodyPr/>
+    <a:lstStyle/>
+    <a:p>
+      <a:pPr>
+        <a:defRPr sz="800">
+          <a:latin typeface="Arial"/>
+        </a:defRPr>
+      </a:pPr>
+      <a:endParaRPr/>
     </a:p>
   </c:txPr>
   <c:externalData r:id="rId1">
@@ -18324,7 +18454,657 @@
         </p:nvSpPr>
         <p:spPr>
           <a:xfrm>
-            <a:off x="365760" y="1353312"/>
+            <a:off x="365760" y="1380744"/>
+            <a:ext cx="54864" cy="182880"/>
+          </a:xfrm>
+          <a:prstGeom prst="rect">
+            <a:avLst/>
+          </a:prstGeom>
+          <a:solidFill>
+            <a:srgbClr val="C22310"/>
+          </a:solidFill>
+          <a:ln>
+            <a:noFill/>
+          </a:ln>
+          <a:effectLst/>
+        </p:spPr>
+        <p:style>
+          <a:lnRef idx="1">
+            <a:schemeClr val="accent1"/>
+          </a:lnRef>
+          <a:fillRef idx="3">
+            <a:schemeClr val="accent1"/>
+          </a:fillRef>
+          <a:effectRef idx="2">
+            <a:schemeClr val="accent1"/>
+          </a:effectRef>
+          <a:fontRef idx="minor">
+            <a:schemeClr val="lt1"/>
+          </a:fontRef>
+        </p:style>
+        <p:txBody>
+          <a:bodyPr rtlCol="0" anchor="ctr"/>
+          <a:lstStyle/>
+          <a:p>
+            <a:pPr algn="ctr"/>
+          </a:p>
+        </p:txBody>
+      </p:sp>
+      <p:sp>
+        <p:nvSpPr>
+          <p:cNvPr id="11" name="TextBox 10"/>
+          <p:cNvSpPr txBox="1"/>
+          <p:nvPr/>
+        </p:nvSpPr>
+        <p:spPr>
+          <a:xfrm>
+            <a:off x="512064" y="1353312"/>
+            <a:ext cx="3922776" cy="256032"/>
+          </a:xfrm>
+          <a:prstGeom prst="rect">
+            <a:avLst/>
+          </a:prstGeom>
+          <a:noFill/>
+        </p:spPr>
+        <p:txBody>
+          <a:bodyPr wrap="square" lIns="0" rIns="0" tIns="0" bIns="0" anchor="t">
+            <a:spAutoFit/>
+          </a:bodyPr>
+          <a:lstStyle/>
+          <a:p>
+            <a:pPr algn="l">
+              <a:lnSpc>
+                <a:spcPct val="100000"/>
+              </a:lnSpc>
+              <a:spcBef>
+                <a:spcPts val="0"/>
+              </a:spcBef>
+              <a:spcAft>
+                <a:spcPts val="0"/>
+              </a:spcAft>
+            </a:pPr>
+            <a:r>
+              <a:rPr sz="1050" b="1" i="0">
+                <a:solidFill>
+                  <a:srgbClr val="1B3E6E"/>
+                </a:solidFill>
+                <a:latin typeface="Arial"/>
+              </a:rPr>
+              <a:t>GAP 1 — Procurement: demand is guesswork</a:t>
+            </a:r>
+          </a:p>
+        </p:txBody>
+      </p:sp>
+      <p:sp>
+        <p:nvSpPr>
+          <p:cNvPr id="12" name="Rectangle 11"/>
+          <p:cNvSpPr/>
+          <p:nvPr/>
+        </p:nvSpPr>
+        <p:spPr>
+          <a:xfrm>
+            <a:off x="365760" y="1627632"/>
+            <a:ext cx="4069080" cy="10972"/>
+          </a:xfrm>
+          <a:prstGeom prst="rect">
+            <a:avLst/>
+          </a:prstGeom>
+          <a:solidFill>
+            <a:srgbClr val="BFBFBF"/>
+          </a:solidFill>
+          <a:ln>
+            <a:noFill/>
+          </a:ln>
+          <a:effectLst/>
+        </p:spPr>
+        <p:style>
+          <a:lnRef idx="1">
+            <a:schemeClr val="accent1"/>
+          </a:lnRef>
+          <a:fillRef idx="3">
+            <a:schemeClr val="accent1"/>
+          </a:fillRef>
+          <a:effectRef idx="2">
+            <a:schemeClr val="accent1"/>
+          </a:effectRef>
+          <a:fontRef idx="minor">
+            <a:schemeClr val="lt1"/>
+          </a:fontRef>
+        </p:style>
+        <p:txBody>
+          <a:bodyPr rtlCol="0" anchor="ctr"/>
+          <a:lstStyle/>
+          <a:p>
+            <a:pPr algn="ctr"/>
+          </a:p>
+        </p:txBody>
+      </p:sp>
+      <p:sp>
+        <p:nvSpPr>
+          <p:cNvPr id="13" name="TextBox 12"/>
+          <p:cNvSpPr txBox="1"/>
+          <p:nvPr/>
+        </p:nvSpPr>
+        <p:spPr>
+          <a:xfrm>
+            <a:off x="365760" y="1719072"/>
+            <a:ext cx="4069080" cy="960120"/>
+          </a:xfrm>
+          <a:prstGeom prst="rect">
+            <a:avLst/>
+          </a:prstGeom>
+          <a:noFill/>
+        </p:spPr>
+        <p:txBody>
+          <a:bodyPr wrap="square" lIns="0" rIns="0" tIns="0" bIns="0" anchor="t">
+            <a:spAutoFit/>
+          </a:bodyPr>
+          <a:lstStyle/>
+          <a:p>
+            <a:pPr algn="l">
+              <a:lnSpc>
+                <a:spcPct val="102000"/>
+              </a:lnSpc>
+              <a:spcBef>
+                <a:spcPts val="0"/>
+              </a:spcBef>
+              <a:spcAft>
+                <a:spcPts val="300"/>
+              </a:spcAft>
+            </a:pPr>
+            <a:r>
+              <a:rPr sz="819" b="1" i="0">
+                <a:solidFill>
+                  <a:srgbClr val="333333"/>
+                </a:solidFill>
+                <a:latin typeface="Arial"/>
+              </a:rPr>
+              <a:t>•  Manual, gut-feel indenting</a:t>
+            </a:r>
+            <a:r>
+              <a:rPr sz="819" b="0" i="0">
+                <a:solidFill>
+                  <a:srgbClr val="333333"/>
+                </a:solidFill>
+                <a:latin typeface="Arial"/>
+              </a:rPr>
+              <a:t> 3 days ahead — blind to attendance swings, exams &amp; holidays</a:t>
+            </a:r>
+          </a:p>
+          <a:p>
+            <a:pPr algn="l">
+              <a:lnSpc>
+                <a:spcPct val="102000"/>
+              </a:lnSpc>
+              <a:spcBef>
+                <a:spcPts val="0"/>
+              </a:spcBef>
+              <a:spcAft>
+                <a:spcPts val="300"/>
+              </a:spcAft>
+            </a:pPr>
+            <a:r>
+              <a:rPr sz="819" b="1" i="0">
+                <a:solidFill>
+                  <a:srgbClr val="333333"/>
+                </a:solidFill>
+                <a:latin typeface="Arial"/>
+              </a:rPr>
+              <a:t>•  Reactive spot-buying</a:t>
+            </a:r>
+            <a:r>
+              <a:rPr sz="819" b="0" i="0">
+                <a:solidFill>
+                  <a:srgbClr val="333333"/>
+                </a:solidFill>
+                <a:latin typeface="Arial"/>
+              </a:rPr>
+              <a:t> at mandi peak prices when stocks run short</a:t>
+            </a:r>
+          </a:p>
+          <a:p>
+            <a:pPr algn="l">
+              <a:lnSpc>
+                <a:spcPct val="102000"/>
+              </a:lnSpc>
+              <a:spcBef>
+                <a:spcPts val="0"/>
+              </a:spcBef>
+              <a:spcAft>
+                <a:spcPts val="300"/>
+              </a:spcAft>
+            </a:pPr>
+            <a:r>
+              <a:rPr sz="819" b="1" i="0">
+                <a:solidFill>
+                  <a:srgbClr val="333333"/>
+                </a:solidFill>
+                <a:latin typeface="Arial"/>
+              </a:rPr>
+              <a:t>•  No price intelligence</a:t>
+            </a:r>
+            <a:r>
+              <a:rPr sz="819" b="0" i="0">
+                <a:solidFill>
+                  <a:srgbClr val="333333"/>
+                </a:solidFill>
+                <a:latin typeface="Arial"/>
+              </a:rPr>
+              <a:t> — cheapest forward-buying windows are missed</a:t>
+            </a:r>
+          </a:p>
+          <a:p>
+            <a:pPr algn="l">
+              <a:lnSpc>
+                <a:spcPct val="102000"/>
+              </a:lnSpc>
+              <a:spcBef>
+                <a:spcPts val="0"/>
+              </a:spcBef>
+              <a:spcAft>
+                <a:spcPts val="0"/>
+              </a:spcAft>
+            </a:pPr>
+            <a:r>
+              <a:rPr sz="819" b="1" i="0">
+                <a:solidFill>
+                  <a:srgbClr val="333333"/>
+                </a:solidFill>
+                <a:latin typeface="Arial"/>
+              </a:rPr>
+              <a:t>•  No feedback loop</a:t>
+            </a:r>
+            <a:r>
+              <a:rPr sz="819" b="0" i="0">
+                <a:solidFill>
+                  <a:srgbClr val="333333"/>
+                </a:solidFill>
+                <a:latin typeface="Arial"/>
+              </a:rPr>
+              <a:t> from schools on actual meal uptake</a:t>
+            </a:r>
+          </a:p>
+        </p:txBody>
+      </p:sp>
+      <p:sp>
+        <p:nvSpPr>
+          <p:cNvPr id="14" name="TextBox 13"/>
+          <p:cNvSpPr txBox="1"/>
+          <p:nvPr/>
+        </p:nvSpPr>
+        <p:spPr>
+          <a:xfrm>
+            <a:off x="365760" y="2724912"/>
+            <a:ext cx="4069080" cy="219456"/>
+          </a:xfrm>
+          <a:prstGeom prst="rect">
+            <a:avLst/>
+          </a:prstGeom>
+          <a:noFill/>
+        </p:spPr>
+        <p:txBody>
+          <a:bodyPr wrap="square" lIns="0" rIns="0" tIns="0" bIns="0" anchor="t">
+            <a:spAutoFit/>
+          </a:bodyPr>
+          <a:lstStyle/>
+          <a:p>
+            <a:pPr algn="l">
+              <a:lnSpc>
+                <a:spcPct val="100000"/>
+              </a:lnSpc>
+              <a:spcBef>
+                <a:spcPts val="0"/>
+              </a:spcBef>
+              <a:spcAft>
+                <a:spcPts val="0"/>
+              </a:spcAft>
+            </a:pPr>
+            <a:r>
+              <a:rPr sz="819" b="1" i="0">
+                <a:solidFill>
+                  <a:srgbClr val="C22310"/>
+                </a:solidFill>
+                <a:latin typeface="Arial"/>
+              </a:rPr>
+              <a:t>Cost today:  8–10% meals over-produced  ·  +12% paid on spot buys [dummy]</a:t>
+            </a:r>
+          </a:p>
+        </p:txBody>
+      </p:sp>
+      <p:sp>
+        <p:nvSpPr>
+          <p:cNvPr id="15" name="Rectangle 14"/>
+          <p:cNvSpPr/>
+          <p:nvPr/>
+        </p:nvSpPr>
+        <p:spPr>
+          <a:xfrm>
+            <a:off x="4709160" y="1380744"/>
+            <a:ext cx="54864" cy="182880"/>
+          </a:xfrm>
+          <a:prstGeom prst="rect">
+            <a:avLst/>
+          </a:prstGeom>
+          <a:solidFill>
+            <a:srgbClr val="C22310"/>
+          </a:solidFill>
+          <a:ln>
+            <a:noFill/>
+          </a:ln>
+          <a:effectLst/>
+        </p:spPr>
+        <p:style>
+          <a:lnRef idx="1">
+            <a:schemeClr val="accent1"/>
+          </a:lnRef>
+          <a:fillRef idx="3">
+            <a:schemeClr val="accent1"/>
+          </a:fillRef>
+          <a:effectRef idx="2">
+            <a:schemeClr val="accent1"/>
+          </a:effectRef>
+          <a:fontRef idx="minor">
+            <a:schemeClr val="lt1"/>
+          </a:fontRef>
+        </p:style>
+        <p:txBody>
+          <a:bodyPr rtlCol="0" anchor="ctr"/>
+          <a:lstStyle/>
+          <a:p>
+            <a:pPr algn="ctr"/>
+          </a:p>
+        </p:txBody>
+      </p:sp>
+      <p:sp>
+        <p:nvSpPr>
+          <p:cNvPr id="16" name="TextBox 15"/>
+          <p:cNvSpPr txBox="1"/>
+          <p:nvPr/>
+        </p:nvSpPr>
+        <p:spPr>
+          <a:xfrm>
+            <a:off x="4855464" y="1353312"/>
+            <a:ext cx="3922776" cy="256032"/>
+          </a:xfrm>
+          <a:prstGeom prst="rect">
+            <a:avLst/>
+          </a:prstGeom>
+          <a:noFill/>
+        </p:spPr>
+        <p:txBody>
+          <a:bodyPr wrap="square" lIns="0" rIns="0" tIns="0" bIns="0" anchor="t">
+            <a:spAutoFit/>
+          </a:bodyPr>
+          <a:lstStyle/>
+          <a:p>
+            <a:pPr algn="l">
+              <a:lnSpc>
+                <a:spcPct val="100000"/>
+              </a:lnSpc>
+              <a:spcBef>
+                <a:spcPts val="0"/>
+              </a:spcBef>
+              <a:spcAft>
+                <a:spcPts val="0"/>
+              </a:spcAft>
+            </a:pPr>
+            <a:r>
+              <a:rPr sz="1050" b="1" i="0">
+                <a:solidFill>
+                  <a:srgbClr val="1B3E6E"/>
+                </a:solidFill>
+                <a:latin typeface="Arial"/>
+              </a:rPr>
+              <a:t>GAP 2 — Distribution: the last mile is blind</a:t>
+            </a:r>
+          </a:p>
+        </p:txBody>
+      </p:sp>
+      <p:sp>
+        <p:nvSpPr>
+          <p:cNvPr id="17" name="Rectangle 16"/>
+          <p:cNvSpPr/>
+          <p:nvPr/>
+        </p:nvSpPr>
+        <p:spPr>
+          <a:xfrm>
+            <a:off x="4709160" y="1627632"/>
+            <a:ext cx="4069080" cy="10972"/>
+          </a:xfrm>
+          <a:prstGeom prst="rect">
+            <a:avLst/>
+          </a:prstGeom>
+          <a:solidFill>
+            <a:srgbClr val="BFBFBF"/>
+          </a:solidFill>
+          <a:ln>
+            <a:noFill/>
+          </a:ln>
+          <a:effectLst/>
+        </p:spPr>
+        <p:style>
+          <a:lnRef idx="1">
+            <a:schemeClr val="accent1"/>
+          </a:lnRef>
+          <a:fillRef idx="3">
+            <a:schemeClr val="accent1"/>
+          </a:fillRef>
+          <a:effectRef idx="2">
+            <a:schemeClr val="accent1"/>
+          </a:effectRef>
+          <a:fontRef idx="minor">
+            <a:schemeClr val="lt1"/>
+          </a:fontRef>
+        </p:style>
+        <p:txBody>
+          <a:bodyPr rtlCol="0" anchor="ctr"/>
+          <a:lstStyle/>
+          <a:p>
+            <a:pPr algn="ctr"/>
+          </a:p>
+        </p:txBody>
+      </p:sp>
+      <p:sp>
+        <p:nvSpPr>
+          <p:cNvPr id="18" name="TextBox 17"/>
+          <p:cNvSpPr txBox="1"/>
+          <p:nvPr/>
+        </p:nvSpPr>
+        <p:spPr>
+          <a:xfrm>
+            <a:off x="4709160" y="1719072"/>
+            <a:ext cx="4069080" cy="960120"/>
+          </a:xfrm>
+          <a:prstGeom prst="rect">
+            <a:avLst/>
+          </a:prstGeom>
+          <a:noFill/>
+        </p:spPr>
+        <p:txBody>
+          <a:bodyPr wrap="square" lIns="0" rIns="0" tIns="0" bIns="0" anchor="t">
+            <a:spAutoFit/>
+          </a:bodyPr>
+          <a:lstStyle/>
+          <a:p>
+            <a:pPr algn="l">
+              <a:lnSpc>
+                <a:spcPct val="102000"/>
+              </a:lnSpc>
+              <a:spcBef>
+                <a:spcPts val="0"/>
+              </a:spcBef>
+              <a:spcAft>
+                <a:spcPts val="300"/>
+              </a:spcAft>
+            </a:pPr>
+            <a:r>
+              <a:rPr sz="819" b="1" i="0">
+                <a:solidFill>
+                  <a:srgbClr val="333333"/>
+                </a:solidFill>
+                <a:latin typeface="Arial"/>
+              </a:rPr>
+              <a:t>•  Static, driver-memory routes</a:t>
+            </a:r>
+            <a:r>
+              <a:rPr sz="819" b="0" i="0">
+                <a:solidFill>
+                  <a:srgbClr val="333333"/>
+                </a:solidFill>
+                <a:latin typeface="Arial"/>
+              </a:rPr>
+              <a:t> — 15–30 min past the lunch bell means children stay hungry all day</a:t>
+            </a:r>
+          </a:p>
+          <a:p>
+            <a:pPr algn="l">
+              <a:lnSpc>
+                <a:spcPct val="102000"/>
+              </a:lnSpc>
+              <a:spcBef>
+                <a:spcPts val="0"/>
+              </a:spcBef>
+              <a:spcAft>
+                <a:spcPts val="300"/>
+              </a:spcAft>
+            </a:pPr>
+            <a:r>
+              <a:rPr sz="819" b="1" i="0">
+                <a:solidFill>
+                  <a:srgbClr val="333333"/>
+                </a:solidFill>
+                <a:latin typeface="Arial"/>
+              </a:rPr>
+              <a:t>•  Untracked vessels &amp; utensils</a:t>
+            </a:r>
+            <a:r>
+              <a:rPr sz="819" b="0" i="0">
+                <a:solidFill>
+                  <a:srgbClr val="333333"/>
+                </a:solidFill>
+                <a:latin typeface="Arial"/>
+              </a:rPr>
+              <a:t> — daily losses add to operating cost</a:t>
+            </a:r>
+          </a:p>
+          <a:p>
+            <a:pPr algn="l">
+              <a:lnSpc>
+                <a:spcPct val="102000"/>
+              </a:lnSpc>
+              <a:spcBef>
+                <a:spcPts val="0"/>
+              </a:spcBef>
+              <a:spcAft>
+                <a:spcPts val="300"/>
+              </a:spcAft>
+            </a:pPr>
+            <a:r>
+              <a:rPr sz="819" b="1" i="0">
+                <a:solidFill>
+                  <a:srgbClr val="333333"/>
+                </a:solidFill>
+                <a:latin typeface="Arial"/>
+              </a:rPr>
+              <a:t>•  Adulteration / diversion risk</a:t>
+            </a:r>
+            <a:r>
+              <a:rPr sz="819" b="0" i="0">
+                <a:solidFill>
+                  <a:srgbClr val="333333"/>
+                </a:solidFill>
+                <a:latin typeface="Arial"/>
+              </a:rPr>
+              <a:t> — unsealed vans can be offloaded at roadside dhabas</a:t>
+            </a:r>
+          </a:p>
+          <a:p>
+            <a:pPr algn="l">
+              <a:lnSpc>
+                <a:spcPct val="102000"/>
+              </a:lnSpc>
+              <a:spcBef>
+                <a:spcPts val="0"/>
+              </a:spcBef>
+              <a:spcAft>
+                <a:spcPts val="0"/>
+              </a:spcAft>
+            </a:pPr>
+            <a:r>
+              <a:rPr sz="819" b="1" i="0">
+                <a:solidFill>
+                  <a:srgbClr val="333333"/>
+                </a:solidFill>
+                <a:latin typeface="Arial"/>
+              </a:rPr>
+              <a:t>•  No proof-of-delivery</a:t>
+            </a:r>
+            <a:r>
+              <a:rPr sz="819" b="0" i="0">
+                <a:solidFill>
+                  <a:srgbClr val="333333"/>
+                </a:solidFill>
+                <a:latin typeface="Arial"/>
+              </a:rPr>
+              <a:t> — school shortfall disputes go unresolved</a:t>
+            </a:r>
+          </a:p>
+        </p:txBody>
+      </p:sp>
+      <p:sp>
+        <p:nvSpPr>
+          <p:cNvPr id="19" name="TextBox 18"/>
+          <p:cNvSpPr txBox="1"/>
+          <p:nvPr/>
+        </p:nvSpPr>
+        <p:spPr>
+          <a:xfrm>
+            <a:off x="4709160" y="2724912"/>
+            <a:ext cx="4069080" cy="219456"/>
+          </a:xfrm>
+          <a:prstGeom prst="rect">
+            <a:avLst/>
+          </a:prstGeom>
+          <a:noFill/>
+        </p:spPr>
+        <p:txBody>
+          <a:bodyPr wrap="square" lIns="0" rIns="0" tIns="0" bIns="0" anchor="t">
+            <a:spAutoFit/>
+          </a:bodyPr>
+          <a:lstStyle/>
+          <a:p>
+            <a:pPr algn="l">
+              <a:lnSpc>
+                <a:spcPct val="100000"/>
+              </a:lnSpc>
+              <a:spcBef>
+                <a:spcPts val="0"/>
+              </a:spcBef>
+              <a:spcAft>
+                <a:spcPts val="0"/>
+              </a:spcAft>
+            </a:pPr>
+            <a:r>
+              <a:rPr sz="819" b="1" i="0">
+                <a:solidFill>
+                  <a:srgbClr val="C22310"/>
+                </a:solidFill>
+                <a:latin typeface="Arial"/>
+              </a:rPr>
+              <a:t>Cost today:  6.2% deliveries miss lunch  ·  $35k/yr shrinkage [dummy]</a:t>
+            </a:r>
+          </a:p>
+        </p:txBody>
+      </p:sp>
+      <p:sp>
+        <p:nvSpPr>
+          <p:cNvPr id="20" name="Rectangle 19"/>
+          <p:cNvSpPr/>
+          <p:nvPr/>
+        </p:nvSpPr>
+        <p:spPr>
+          <a:xfrm>
+            <a:off x="365760" y="3026663"/>
             <a:ext cx="54864" cy="182880"/>
           </a:xfrm>
           <a:prstGeom prst="rect">
@@ -18362,13 +19142,13 @@
       </p:sp>
       <p:sp>
         <p:nvSpPr>
-          <p:cNvPr id="11" name="TextBox 10"/>
+          <p:cNvPr id="21" name="TextBox 20"/>
           <p:cNvSpPr txBox="1"/>
           <p:nvPr/>
         </p:nvSpPr>
         <p:spPr>
           <a:xfrm>
-            <a:off x="512064" y="1325880"/>
+            <a:off x="512064" y="2999232"/>
             <a:ext cx="8266175" cy="256032"/>
           </a:xfrm>
           <a:prstGeom prst="rect">
@@ -18407,13 +19187,13 @@
       </p:sp>
       <p:sp>
         <p:nvSpPr>
-          <p:cNvPr id="12" name="Rectangle 11"/>
+          <p:cNvPr id="22" name="Rectangle 21"/>
           <p:cNvSpPr/>
           <p:nvPr/>
         </p:nvSpPr>
         <p:spPr>
           <a:xfrm>
-            <a:off x="365760" y="1600200"/>
+            <a:off x="365760" y="3273551"/>
             <a:ext cx="8412480" cy="10972"/>
           </a:xfrm>
           <a:prstGeom prst="rect">
@@ -18451,14 +19231,14 @@
       </p:sp>
       <p:sp>
         <p:nvSpPr>
-          <p:cNvPr id="13" name="Rectangle 12"/>
+          <p:cNvPr id="23" name="Rectangle 22"/>
           <p:cNvSpPr/>
           <p:nvPr/>
         </p:nvSpPr>
         <p:spPr>
           <a:xfrm>
-            <a:off x="502920" y="1746504"/>
-            <a:ext cx="4882895" cy="420624"/>
+            <a:off x="502920" y="3383279"/>
+            <a:ext cx="4882895" cy="402336"/>
           </a:xfrm>
           <a:prstGeom prst="rect">
             <a:avLst/>
@@ -18495,14 +19275,14 @@
       </p:sp>
       <p:sp>
         <p:nvSpPr>
-          <p:cNvPr id="14" name="Rectangle 13"/>
+          <p:cNvPr id="24" name="Rectangle 23"/>
           <p:cNvSpPr/>
           <p:nvPr/>
         </p:nvSpPr>
         <p:spPr>
           <a:xfrm>
-            <a:off x="5385815" y="1746504"/>
-            <a:ext cx="3255263" cy="420624"/>
+            <a:off x="5385815" y="3383279"/>
+            <a:ext cx="3255263" cy="402336"/>
           </a:xfrm>
           <a:prstGeom prst="rect">
             <a:avLst/>
@@ -18539,14 +19319,14 @@
       </p:sp>
       <p:sp>
         <p:nvSpPr>
-          <p:cNvPr id="15" name="TextBox 14"/>
+          <p:cNvPr id="25" name="TextBox 24"/>
           <p:cNvSpPr txBox="1"/>
           <p:nvPr/>
         </p:nvSpPr>
         <p:spPr>
           <a:xfrm>
-            <a:off x="502920" y="1746504"/>
-            <a:ext cx="4882895" cy="420624"/>
+            <a:off x="502920" y="3383279"/>
+            <a:ext cx="4882895" cy="402336"/>
           </a:xfrm>
           <a:prstGeom prst="rect">
             <a:avLst/>
@@ -18584,14 +19364,14 @@
       </p:sp>
       <p:sp>
         <p:nvSpPr>
-          <p:cNvPr id="16" name="TextBox 15"/>
+          <p:cNvPr id="26" name="TextBox 25"/>
           <p:cNvSpPr txBox="1"/>
           <p:nvPr/>
         </p:nvSpPr>
         <p:spPr>
           <a:xfrm>
-            <a:off x="5385815" y="1746504"/>
-            <a:ext cx="3255263" cy="420624"/>
+            <a:off x="5385815" y="3383279"/>
+            <a:ext cx="3255263" cy="402336"/>
           </a:xfrm>
           <a:prstGeom prst="rect">
             <a:avLst/>
@@ -18629,14 +19409,14 @@
       </p:sp>
       <p:sp>
         <p:nvSpPr>
-          <p:cNvPr id="17" name="TextBox 16"/>
+          <p:cNvPr id="27" name="TextBox 26"/>
           <p:cNvSpPr txBox="1"/>
           <p:nvPr/>
         </p:nvSpPr>
         <p:spPr>
           <a:xfrm>
-            <a:off x="502920" y="2203704"/>
-            <a:ext cx="4882895" cy="219456"/>
+            <a:off x="502920" y="3813048"/>
+            <a:ext cx="4882895" cy="201168"/>
           </a:xfrm>
           <a:prstGeom prst="rect">
             <a:avLst/>
@@ -18674,14 +19454,14 @@
       </p:sp>
       <p:sp>
         <p:nvSpPr>
-          <p:cNvPr id="18" name="TextBox 17"/>
+          <p:cNvPr id="28" name="TextBox 27"/>
           <p:cNvSpPr txBox="1"/>
           <p:nvPr/>
         </p:nvSpPr>
         <p:spPr>
           <a:xfrm>
-            <a:off x="5385815" y="2203704"/>
-            <a:ext cx="3255263" cy="219456"/>
+            <a:off x="5385815" y="3813048"/>
+            <a:ext cx="3255263" cy="201168"/>
           </a:xfrm>
           <a:prstGeom prst="rect">
             <a:avLst/>
@@ -18717,343 +19497,18 @@
           </a:p>
         </p:txBody>
       </p:sp>
-      <p:sp>
-        <p:nvSpPr>
-          <p:cNvPr id="19" name="Rectangle 18"/>
-          <p:cNvSpPr/>
-          <p:nvPr/>
-        </p:nvSpPr>
-        <p:spPr>
-          <a:xfrm>
-            <a:off x="365760" y="2569463"/>
-            <a:ext cx="54864" cy="182880"/>
-          </a:xfrm>
-          <a:prstGeom prst="rect">
-            <a:avLst/>
-          </a:prstGeom>
-          <a:solidFill>
-            <a:srgbClr val="C22310"/>
-          </a:solidFill>
-          <a:ln>
-            <a:noFill/>
-          </a:ln>
-          <a:effectLst/>
-        </p:spPr>
-        <p:style>
-          <a:lnRef idx="1">
-            <a:schemeClr val="accent1"/>
-          </a:lnRef>
-          <a:fillRef idx="3">
-            <a:schemeClr val="accent1"/>
-          </a:fillRef>
-          <a:effectRef idx="2">
-            <a:schemeClr val="accent1"/>
-          </a:effectRef>
-          <a:fontRef idx="minor">
-            <a:schemeClr val="lt1"/>
-          </a:fontRef>
-        </p:style>
-        <p:txBody>
-          <a:bodyPr rtlCol="0" anchor="ctr"/>
-          <a:lstStyle/>
-          <a:p>
-            <a:pPr algn="ctr"/>
-          </a:p>
-        </p:txBody>
-      </p:sp>
-      <p:sp>
-        <p:nvSpPr>
-          <p:cNvPr id="20" name="TextBox 19"/>
-          <p:cNvSpPr txBox="1"/>
-          <p:nvPr/>
-        </p:nvSpPr>
-        <p:spPr>
-          <a:xfrm>
-            <a:off x="512064" y="2542032"/>
-            <a:ext cx="3922776" cy="256032"/>
-          </a:xfrm>
-          <a:prstGeom prst="rect">
-            <a:avLst/>
-          </a:prstGeom>
-          <a:noFill/>
-        </p:spPr>
-        <p:txBody>
-          <a:bodyPr wrap="square" lIns="0" rIns="0" tIns="0" bIns="0" anchor="t">
-            <a:spAutoFit/>
-          </a:bodyPr>
-          <a:lstStyle/>
-          <a:p>
-            <a:pPr algn="l">
-              <a:lnSpc>
-                <a:spcPct val="100000"/>
-              </a:lnSpc>
-              <a:spcBef>
-                <a:spcPts val="0"/>
-              </a:spcBef>
-              <a:spcAft>
-                <a:spcPts val="0"/>
-              </a:spcAft>
-            </a:pPr>
-            <a:r>
-              <a:rPr sz="1050" b="1" i="0">
-                <a:solidFill>
-                  <a:srgbClr val="1B3E6E"/>
-                </a:solidFill>
-                <a:latin typeface="Arial"/>
-              </a:rPr>
-              <a:t>GAP 1 — Procurement: demand is guesswork</a:t>
-            </a:r>
-          </a:p>
-        </p:txBody>
-      </p:sp>
-      <p:sp>
-        <p:nvSpPr>
-          <p:cNvPr id="21" name="Rectangle 20"/>
-          <p:cNvSpPr/>
-          <p:nvPr/>
-        </p:nvSpPr>
-        <p:spPr>
-          <a:xfrm>
-            <a:off x="365760" y="2816351"/>
-            <a:ext cx="4069080" cy="10972"/>
-          </a:xfrm>
-          <a:prstGeom prst="rect">
-            <a:avLst/>
-          </a:prstGeom>
-          <a:solidFill>
-            <a:srgbClr val="BFBFBF"/>
-          </a:solidFill>
-          <a:ln>
-            <a:noFill/>
-          </a:ln>
-          <a:effectLst/>
-        </p:spPr>
-        <p:style>
-          <a:lnRef idx="1">
-            <a:schemeClr val="accent1"/>
-          </a:lnRef>
-          <a:fillRef idx="3">
-            <a:schemeClr val="accent1"/>
-          </a:fillRef>
-          <a:effectRef idx="2">
-            <a:schemeClr val="accent1"/>
-          </a:effectRef>
-          <a:fontRef idx="minor">
-            <a:schemeClr val="lt1"/>
-          </a:fontRef>
-        </p:style>
-        <p:txBody>
-          <a:bodyPr rtlCol="0" anchor="ctr"/>
-          <a:lstStyle/>
-          <a:p>
-            <a:pPr algn="ctr"/>
-          </a:p>
-        </p:txBody>
-      </p:sp>
-      <p:sp>
-        <p:nvSpPr>
-          <p:cNvPr id="22" name="TextBox 21"/>
-          <p:cNvSpPr txBox="1"/>
-          <p:nvPr/>
-        </p:nvSpPr>
-        <p:spPr>
-          <a:xfrm>
-            <a:off x="365760" y="2907791"/>
-            <a:ext cx="4069080" cy="1005840"/>
-          </a:xfrm>
-          <a:prstGeom prst="rect">
-            <a:avLst/>
-          </a:prstGeom>
-          <a:noFill/>
-        </p:spPr>
-        <p:txBody>
-          <a:bodyPr wrap="square" lIns="0" rIns="0" tIns="0" bIns="0" anchor="t">
-            <a:spAutoFit/>
-          </a:bodyPr>
-          <a:lstStyle/>
-          <a:p>
-            <a:pPr algn="l">
-              <a:lnSpc>
-                <a:spcPct val="105000"/>
-              </a:lnSpc>
-              <a:spcBef>
-                <a:spcPts val="0"/>
-              </a:spcBef>
-              <a:spcAft>
-                <a:spcPts val="300"/>
-              </a:spcAft>
-            </a:pPr>
-            <a:r>
-              <a:rPr sz="819" b="1" i="0">
-                <a:solidFill>
-                  <a:srgbClr val="333333"/>
-                </a:solidFill>
-                <a:latin typeface="Arial"/>
-              </a:rPr>
-              <a:t>•  Manual, gut-feel indenting</a:t>
-            </a:r>
-            <a:r>
-              <a:rPr sz="819" b="0" i="0">
-                <a:solidFill>
-                  <a:srgbClr val="333333"/>
-                </a:solidFill>
-                <a:latin typeface="Arial"/>
-              </a:rPr>
-              <a:t> 3 days ahead — blind to attendance swings, exams &amp; holidays</a:t>
-            </a:r>
-          </a:p>
-          <a:p>
-            <a:pPr algn="l">
-              <a:lnSpc>
-                <a:spcPct val="105000"/>
-              </a:lnSpc>
-              <a:spcBef>
-                <a:spcPts val="0"/>
-              </a:spcBef>
-              <a:spcAft>
-                <a:spcPts val="300"/>
-              </a:spcAft>
-            </a:pPr>
-            <a:r>
-              <a:rPr sz="819" b="1" i="0">
-                <a:solidFill>
-                  <a:srgbClr val="333333"/>
-                </a:solidFill>
-                <a:latin typeface="Arial"/>
-              </a:rPr>
-              <a:t>•  Reactive spot-buying</a:t>
-            </a:r>
-            <a:r>
-              <a:rPr sz="819" b="0" i="0">
-                <a:solidFill>
-                  <a:srgbClr val="333333"/>
-                </a:solidFill>
-                <a:latin typeface="Arial"/>
-              </a:rPr>
-              <a:t> at mandi peak prices when stocks run short</a:t>
-            </a:r>
-          </a:p>
-          <a:p>
-            <a:pPr algn="l">
-              <a:lnSpc>
-                <a:spcPct val="105000"/>
-              </a:lnSpc>
-              <a:spcBef>
-                <a:spcPts val="0"/>
-              </a:spcBef>
-              <a:spcAft>
-                <a:spcPts val="300"/>
-              </a:spcAft>
-            </a:pPr>
-            <a:r>
-              <a:rPr sz="819" b="1" i="0">
-                <a:solidFill>
-                  <a:srgbClr val="333333"/>
-                </a:solidFill>
-                <a:latin typeface="Arial"/>
-              </a:rPr>
-              <a:t>•  No price intelligence</a:t>
-            </a:r>
-            <a:r>
-              <a:rPr sz="819" b="0" i="0">
-                <a:solidFill>
-                  <a:srgbClr val="333333"/>
-                </a:solidFill>
-                <a:latin typeface="Arial"/>
-              </a:rPr>
-              <a:t> — cheapest forward-buying windows are missed</a:t>
-            </a:r>
-          </a:p>
-          <a:p>
-            <a:pPr algn="l">
-              <a:lnSpc>
-                <a:spcPct val="105000"/>
-              </a:lnSpc>
-              <a:spcBef>
-                <a:spcPts val="0"/>
-              </a:spcBef>
-              <a:spcAft>
-                <a:spcPts val="0"/>
-              </a:spcAft>
-            </a:pPr>
-            <a:r>
-              <a:rPr sz="819" b="1" i="0">
-                <a:solidFill>
-                  <a:srgbClr val="333333"/>
-                </a:solidFill>
-                <a:latin typeface="Arial"/>
-              </a:rPr>
-              <a:t>•  No feedback loop</a:t>
-            </a:r>
-            <a:r>
-              <a:rPr sz="819" b="0" i="0">
-                <a:solidFill>
-                  <a:srgbClr val="333333"/>
-                </a:solidFill>
-                <a:latin typeface="Arial"/>
-              </a:rPr>
-              <a:t> from schools on actual meal uptake</a:t>
-            </a:r>
-          </a:p>
-        </p:txBody>
-      </p:sp>
-      <p:sp>
-        <p:nvSpPr>
-          <p:cNvPr id="23" name="TextBox 22"/>
-          <p:cNvSpPr txBox="1"/>
-          <p:nvPr/>
-        </p:nvSpPr>
-        <p:spPr>
-          <a:xfrm>
-            <a:off x="365760" y="3931920"/>
-            <a:ext cx="4069080" cy="219456"/>
-          </a:xfrm>
-          <a:prstGeom prst="rect">
-            <a:avLst/>
-          </a:prstGeom>
-          <a:noFill/>
-        </p:spPr>
-        <p:txBody>
-          <a:bodyPr wrap="square" lIns="0" rIns="0" tIns="0" bIns="0" anchor="t">
-            <a:spAutoFit/>
-          </a:bodyPr>
-          <a:lstStyle/>
-          <a:p>
-            <a:pPr algn="l">
-              <a:lnSpc>
-                <a:spcPct val="100000"/>
-              </a:lnSpc>
-              <a:spcBef>
-                <a:spcPts val="0"/>
-              </a:spcBef>
-              <a:spcAft>
-                <a:spcPts val="0"/>
-              </a:spcAft>
-            </a:pPr>
-            <a:r>
-              <a:rPr sz="819" b="1" i="0">
-                <a:solidFill>
-                  <a:srgbClr val="C22310"/>
-                </a:solidFill>
-                <a:latin typeface="Arial"/>
-              </a:rPr>
-              <a:t>Cost today:  8–10% meals over-produced  ·  +12% paid on spot buys [dummy]</a:t>
-            </a:r>
-          </a:p>
-        </p:txBody>
-      </p:sp>
       <p:cxnSp>
         <p:nvCxnSpPr>
-          <p:cNvPr id="24" name="Connector 23"/>
+          <p:cNvPr id="29" name="Connector 28"/>
           <p:cNvCxnSpPr/>
           <p:nvPr/>
         </p:nvCxnSpPr>
         <p:spPr>
-          <a:xfrm>
-            <a:off x="2400300" y="4187952"/>
-            <a:ext cx="0" cy="182879"/>
-          </a:xfrm>
-          <a:prstGeom prst="line">
+          <a:xfrm flipH="1">
+            <a:off x="2400300" y="4023359"/>
+            <a:ext cx="544068" cy="164593"/>
+          </a:xfrm>
+          <a:prstGeom prst="curvedConnector3">
             <a:avLst/>
           </a:prstGeom>
           <a:ln w="15875">
@@ -19080,16 +19535,54 @@
           </a:fontRef>
         </p:style>
       </p:cxnSp>
-      <p:sp>
-        <p:nvSpPr>
-          <p:cNvPr id="25" name="Rounded Rectangle 24"/>
+      <p:cxnSp>
+        <p:nvCxnSpPr>
+          <p:cNvPr id="30" name="Connector 29"/>
+          <p:cNvCxnSpPr/>
+          <p:nvPr/>
+        </p:nvCxnSpPr>
+        <p:spPr>
+          <a:xfrm flipH="1">
+            <a:off x="6743700" y="4023359"/>
+            <a:ext cx="269747" cy="164593"/>
+          </a:xfrm>
+          <a:prstGeom prst="curvedConnector3">
+            <a:avLst/>
+          </a:prstGeom>
+          <a:ln w="15875">
+            <a:solidFill>
+              <a:srgbClr val="398025"/>
+            </a:solidFill>
+            <a:prstDash val="sysDash"/>
+            <a:tailEnd type="triangle" w="med" len="med"/>
+          </a:ln>
+          <a:effectLst/>
+        </p:spPr>
+        <p:style>
+          <a:lnRef idx="2">
+            <a:schemeClr val="accent1"/>
+          </a:lnRef>
+          <a:fillRef idx="0">
+            <a:schemeClr val="accent1"/>
+          </a:fillRef>
+          <a:effectRef idx="1">
+            <a:schemeClr val="accent1"/>
+          </a:effectRef>
+          <a:fontRef idx="minor">
+            <a:schemeClr val="tx1"/>
+          </a:fontRef>
+        </p:style>
+      </p:cxnSp>
+      <p:sp>
+        <p:nvSpPr>
+          <p:cNvPr id="31" name="Rounded Rectangle 30"/>
           <p:cNvSpPr/>
           <p:nvPr/>
         </p:nvSpPr>
         <p:spPr>
           <a:xfrm>
-            <a:off x="365760" y="4425696"/>
-            <a:ext cx="4069080" cy="1389888"/>
+            <a:off x="365760" y="4224528"/>
+            <a:ext cx="4069080" cy="1664208"/>
           </a:xfrm>
           <a:prstGeom prst="roundRect">
             <a:avLst>
@@ -19130,14 +19623,14 @@
       </p:sp>
       <p:sp>
         <p:nvSpPr>
-          <p:cNvPr id="26" name="TextBox 25"/>
+          <p:cNvPr id="32" name="TextBox 31"/>
           <p:cNvSpPr txBox="1"/>
           <p:nvPr/>
         </p:nvSpPr>
         <p:spPr>
           <a:xfrm>
-            <a:off x="493776" y="4507992"/>
-            <a:ext cx="3813048" cy="1389888"/>
+            <a:off x="493776" y="4306824"/>
+            <a:ext cx="3813048" cy="1517904"/>
           </a:xfrm>
           <a:prstGeom prst="rect">
             <a:avLst/>
@@ -19290,377 +19783,14 @@
       </p:sp>
       <p:sp>
         <p:nvSpPr>
-          <p:cNvPr id="27" name="Rectangle 26"/>
-          <p:cNvSpPr/>
-          <p:nvPr/>
-        </p:nvSpPr>
-        <p:spPr>
-          <a:xfrm>
-            <a:off x="4709160" y="2569463"/>
-            <a:ext cx="54864" cy="182880"/>
-          </a:xfrm>
-          <a:prstGeom prst="rect">
-            <a:avLst/>
-          </a:prstGeom>
-          <a:solidFill>
-            <a:srgbClr val="C22310"/>
-          </a:solidFill>
-          <a:ln>
-            <a:noFill/>
-          </a:ln>
-          <a:effectLst/>
-        </p:spPr>
-        <p:style>
-          <a:lnRef idx="1">
-            <a:schemeClr val="accent1"/>
-          </a:lnRef>
-          <a:fillRef idx="3">
-            <a:schemeClr val="accent1"/>
-          </a:fillRef>
-          <a:effectRef idx="2">
-            <a:schemeClr val="accent1"/>
-          </a:effectRef>
-          <a:fontRef idx="minor">
-            <a:schemeClr val="lt1"/>
-          </a:fontRef>
-        </p:style>
-        <p:txBody>
-          <a:bodyPr rtlCol="0" anchor="ctr"/>
-          <a:lstStyle/>
-          <a:p>
-            <a:pPr algn="ctr"/>
-          </a:p>
-        </p:txBody>
-      </p:sp>
-      <p:sp>
-        <p:nvSpPr>
-          <p:cNvPr id="28" name="TextBox 27"/>
-          <p:cNvSpPr txBox="1"/>
-          <p:nvPr/>
-        </p:nvSpPr>
-        <p:spPr>
-          <a:xfrm>
-            <a:off x="4855464" y="2542032"/>
-            <a:ext cx="3922776" cy="256032"/>
-          </a:xfrm>
-          <a:prstGeom prst="rect">
-            <a:avLst/>
-          </a:prstGeom>
-          <a:noFill/>
-        </p:spPr>
-        <p:txBody>
-          <a:bodyPr wrap="square" lIns="0" rIns="0" tIns="0" bIns="0" anchor="t">
-            <a:spAutoFit/>
-          </a:bodyPr>
-          <a:lstStyle/>
-          <a:p>
-            <a:pPr algn="l">
-              <a:lnSpc>
-                <a:spcPct val="100000"/>
-              </a:lnSpc>
-              <a:spcBef>
-                <a:spcPts val="0"/>
-              </a:spcBef>
-              <a:spcAft>
-                <a:spcPts val="0"/>
-              </a:spcAft>
-            </a:pPr>
-            <a:r>
-              <a:rPr sz="1050" b="1" i="0">
-                <a:solidFill>
-                  <a:srgbClr val="1B3E6E"/>
-                </a:solidFill>
-                <a:latin typeface="Arial"/>
-              </a:rPr>
-              <a:t>GAP 2 — Distribution: the last mile is blind</a:t>
-            </a:r>
-          </a:p>
-        </p:txBody>
-      </p:sp>
-      <p:sp>
-        <p:nvSpPr>
-          <p:cNvPr id="29" name="Rectangle 28"/>
-          <p:cNvSpPr/>
-          <p:nvPr/>
-        </p:nvSpPr>
-        <p:spPr>
-          <a:xfrm>
-            <a:off x="4709160" y="2816351"/>
-            <a:ext cx="4069080" cy="10972"/>
-          </a:xfrm>
-          <a:prstGeom prst="rect">
-            <a:avLst/>
-          </a:prstGeom>
-          <a:solidFill>
-            <a:srgbClr val="BFBFBF"/>
-          </a:solidFill>
-          <a:ln>
-            <a:noFill/>
-          </a:ln>
-          <a:effectLst/>
-        </p:spPr>
-        <p:style>
-          <a:lnRef idx="1">
-            <a:schemeClr val="accent1"/>
-          </a:lnRef>
-          <a:fillRef idx="3">
-            <a:schemeClr val="accent1"/>
-          </a:fillRef>
-          <a:effectRef idx="2">
-            <a:schemeClr val="accent1"/>
-          </a:effectRef>
-          <a:fontRef idx="minor">
-            <a:schemeClr val="lt1"/>
-          </a:fontRef>
-        </p:style>
-        <p:txBody>
-          <a:bodyPr rtlCol="0" anchor="ctr"/>
-          <a:lstStyle/>
-          <a:p>
-            <a:pPr algn="ctr"/>
-          </a:p>
-        </p:txBody>
-      </p:sp>
-      <p:sp>
-        <p:nvSpPr>
-          <p:cNvPr id="30" name="TextBox 29"/>
-          <p:cNvSpPr txBox="1"/>
-          <p:nvPr/>
-        </p:nvSpPr>
-        <p:spPr>
-          <a:xfrm>
-            <a:off x="4709160" y="2907791"/>
-            <a:ext cx="4069080" cy="1005840"/>
-          </a:xfrm>
-          <a:prstGeom prst="rect">
-            <a:avLst/>
-          </a:prstGeom>
-          <a:noFill/>
-        </p:spPr>
-        <p:txBody>
-          <a:bodyPr wrap="square" lIns="0" rIns="0" tIns="0" bIns="0" anchor="t">
-            <a:spAutoFit/>
-          </a:bodyPr>
-          <a:lstStyle/>
-          <a:p>
-            <a:pPr algn="l">
-              <a:lnSpc>
-                <a:spcPct val="105000"/>
-              </a:lnSpc>
-              <a:spcBef>
-                <a:spcPts val="0"/>
-              </a:spcBef>
-              <a:spcAft>
-                <a:spcPts val="300"/>
-              </a:spcAft>
-            </a:pPr>
-            <a:r>
-              <a:rPr sz="819" b="1" i="0">
-                <a:solidFill>
-                  <a:srgbClr val="333333"/>
-                </a:solidFill>
-                <a:latin typeface="Arial"/>
-              </a:rPr>
-              <a:t>•  Static, driver-memory routes</a:t>
-            </a:r>
-            <a:r>
-              <a:rPr sz="819" b="0" i="0">
-                <a:solidFill>
-                  <a:srgbClr val="333333"/>
-                </a:solidFill>
-                <a:latin typeface="Arial"/>
-              </a:rPr>
-              <a:t> — 15–30 min past the lunch bell means children stay hungry all day</a:t>
-            </a:r>
-          </a:p>
-          <a:p>
-            <a:pPr algn="l">
-              <a:lnSpc>
-                <a:spcPct val="105000"/>
-              </a:lnSpc>
-              <a:spcBef>
-                <a:spcPts val="0"/>
-              </a:spcBef>
-              <a:spcAft>
-                <a:spcPts val="300"/>
-              </a:spcAft>
-            </a:pPr>
-            <a:r>
-              <a:rPr sz="819" b="1" i="0">
-                <a:solidFill>
-                  <a:srgbClr val="333333"/>
-                </a:solidFill>
-                <a:latin typeface="Arial"/>
-              </a:rPr>
-              <a:t>•  Untracked vessels &amp; utensils</a:t>
-            </a:r>
-            <a:r>
-              <a:rPr sz="819" b="0" i="0">
-                <a:solidFill>
-                  <a:srgbClr val="333333"/>
-                </a:solidFill>
-                <a:latin typeface="Arial"/>
-              </a:rPr>
-              <a:t> — daily losses add to operating cost</a:t>
-            </a:r>
-          </a:p>
-          <a:p>
-            <a:pPr algn="l">
-              <a:lnSpc>
-                <a:spcPct val="105000"/>
-              </a:lnSpc>
-              <a:spcBef>
-                <a:spcPts val="0"/>
-              </a:spcBef>
-              <a:spcAft>
-                <a:spcPts val="300"/>
-              </a:spcAft>
-            </a:pPr>
-            <a:r>
-              <a:rPr sz="819" b="1" i="0">
-                <a:solidFill>
-                  <a:srgbClr val="333333"/>
-                </a:solidFill>
-                <a:latin typeface="Arial"/>
-              </a:rPr>
-              <a:t>•  Adulteration / diversion risk</a:t>
-            </a:r>
-            <a:r>
-              <a:rPr sz="819" b="0" i="0">
-                <a:solidFill>
-                  <a:srgbClr val="333333"/>
-                </a:solidFill>
-                <a:latin typeface="Arial"/>
-              </a:rPr>
-              <a:t> — unsealed vans can be offloaded at roadside dhabas</a:t>
-            </a:r>
-          </a:p>
-          <a:p>
-            <a:pPr algn="l">
-              <a:lnSpc>
-                <a:spcPct val="105000"/>
-              </a:lnSpc>
-              <a:spcBef>
-                <a:spcPts val="0"/>
-              </a:spcBef>
-              <a:spcAft>
-                <a:spcPts val="0"/>
-              </a:spcAft>
-            </a:pPr>
-            <a:r>
-              <a:rPr sz="819" b="1" i="0">
-                <a:solidFill>
-                  <a:srgbClr val="333333"/>
-                </a:solidFill>
-                <a:latin typeface="Arial"/>
-              </a:rPr>
-              <a:t>•  No proof-of-delivery</a:t>
-            </a:r>
-            <a:r>
-              <a:rPr sz="819" b="0" i="0">
-                <a:solidFill>
-                  <a:srgbClr val="333333"/>
-                </a:solidFill>
-                <a:latin typeface="Arial"/>
-              </a:rPr>
-              <a:t> — school shortfall disputes go unresolved</a:t>
-            </a:r>
-          </a:p>
-        </p:txBody>
-      </p:sp>
-      <p:sp>
-        <p:nvSpPr>
-          <p:cNvPr id="31" name="TextBox 30"/>
-          <p:cNvSpPr txBox="1"/>
-          <p:nvPr/>
-        </p:nvSpPr>
-        <p:spPr>
-          <a:xfrm>
-            <a:off x="4709160" y="3931920"/>
-            <a:ext cx="4069080" cy="219456"/>
-          </a:xfrm>
-          <a:prstGeom prst="rect">
-            <a:avLst/>
-          </a:prstGeom>
-          <a:noFill/>
-        </p:spPr>
-        <p:txBody>
-          <a:bodyPr wrap="square" lIns="0" rIns="0" tIns="0" bIns="0" anchor="t">
-            <a:spAutoFit/>
-          </a:bodyPr>
-          <a:lstStyle/>
-          <a:p>
-            <a:pPr algn="l">
-              <a:lnSpc>
-                <a:spcPct val="100000"/>
-              </a:lnSpc>
-              <a:spcBef>
-                <a:spcPts val="0"/>
-              </a:spcBef>
-              <a:spcAft>
-                <a:spcPts val="0"/>
-              </a:spcAft>
-            </a:pPr>
-            <a:r>
-              <a:rPr sz="819" b="1" i="0">
-                <a:solidFill>
-                  <a:srgbClr val="C22310"/>
-                </a:solidFill>
-                <a:latin typeface="Arial"/>
-              </a:rPr>
-              <a:t>Cost today:  6.2% deliveries miss lunch  ·  $35k/yr shrinkage [dummy]</a:t>
-            </a:r>
-          </a:p>
-        </p:txBody>
-      </p:sp>
-      <p:cxnSp>
-        <p:nvCxnSpPr>
-          <p:cNvPr id="32" name="Connector 31"/>
-          <p:cNvCxnSpPr/>
-          <p:nvPr/>
-        </p:nvCxnSpPr>
-        <p:spPr>
-          <a:xfrm>
-            <a:off x="6743700" y="4187952"/>
-            <a:ext cx="0" cy="182879"/>
-          </a:xfrm>
-          <a:prstGeom prst="line">
-            <a:avLst/>
-          </a:prstGeom>
-          <a:ln w="15875">
-            <a:solidFill>
-              <a:srgbClr val="398025"/>
-            </a:solidFill>
-            <a:prstDash val="sysDash"/>
-            <a:tailEnd type="triangle" w="med" len="med"/>
-          </a:ln>
-          <a:effectLst/>
-        </p:spPr>
-        <p:style>
-          <a:lnRef idx="2">
-            <a:schemeClr val="accent1"/>
-          </a:lnRef>
-          <a:fillRef idx="0">
-            <a:schemeClr val="accent1"/>
-          </a:fillRef>
-          <a:effectRef idx="1">
-            <a:schemeClr val="accent1"/>
-          </a:effectRef>
-          <a:fontRef idx="minor">
-            <a:schemeClr val="tx1"/>
-          </a:fontRef>
-        </p:style>
-      </p:cxnSp>
-      <p:sp>
-        <p:nvSpPr>
           <p:cNvPr id="33" name="Rounded Rectangle 32"/>
           <p:cNvSpPr/>
           <p:nvPr/>
         </p:nvSpPr>
         <p:spPr>
           <a:xfrm>
-            <a:off x="4709160" y="4425696"/>
-            <a:ext cx="4069080" cy="1389888"/>
+            <a:off x="4709160" y="4224528"/>
+            <a:ext cx="4069080" cy="1664208"/>
           </a:xfrm>
           <a:prstGeom prst="roundRect">
             <a:avLst>
@@ -19707,8 +19837,8 @@
         </p:nvSpPr>
         <p:spPr>
           <a:xfrm>
-            <a:off x="4837176" y="4507992"/>
-            <a:ext cx="3813048" cy="1389888"/>
+            <a:off x="4837176" y="4306824"/>
+            <a:ext cx="3813048" cy="1517904"/>
           </a:xfrm>
           <a:prstGeom prst="rect">
             <a:avLst/>
@@ -19855,6 +19985,1539 @@
                 <a:latin typeface="Arial"/>
               </a:rPr>
               <a:t>→  99%+ on-time  ·  −18% fleet km  ·  est. $80k saved / yr [dummy]</a:t>
+            </a:r>
+          </a:p>
+        </p:txBody>
+      </p:sp>
+    </p:spTree>
+  </p:cSld>
+  <p:clrMapOvr>
+    <a:masterClrMapping/>
+  </p:clrMapOvr>
+</p:sld>
+</file>
+
+<file path=ppt/slides/slide8.xml><?xml version="1.0" encoding="utf-8"?>
+<p:sld xmlns:a="http://schemas.openxmlformats.org/drawingml/2006/main" xmlns:p="http://schemas.openxmlformats.org/presentationml/2006/main" xmlns:r="http://schemas.openxmlformats.org/officeDocument/2006/relationships">
+  <p:cSld>
+    <p:spTree>
+      <p:nvGrpSpPr>
+        <p:cNvPr id="1" name=""/>
+        <p:cNvGrpSpPr/>
+        <p:nvPr/>
+      </p:nvGrpSpPr>
+      <p:grpSpPr/>
+      <p:sp>
+        <p:nvSpPr>
+          <p:cNvPr id="2" name="Rectangle 1"/>
+          <p:cNvSpPr/>
+          <p:nvPr/>
+        </p:nvSpPr>
+        <p:spPr>
+          <a:xfrm>
+            <a:off x="365760" y="274320"/>
+            <a:ext cx="8412480" cy="23774"/>
+          </a:xfrm>
+          <a:prstGeom prst="rect">
+            <a:avLst/>
+          </a:prstGeom>
+          <a:solidFill>
+            <a:srgbClr val="1B3E6E"/>
+          </a:solidFill>
+          <a:ln>
+            <a:noFill/>
+          </a:ln>
+          <a:effectLst/>
+        </p:spPr>
+        <p:style>
+          <a:lnRef idx="1">
+            <a:schemeClr val="accent1"/>
+          </a:lnRef>
+          <a:fillRef idx="3">
+            <a:schemeClr val="accent1"/>
+          </a:fillRef>
+          <a:effectRef idx="2">
+            <a:schemeClr val="accent1"/>
+          </a:effectRef>
+          <a:fontRef idx="minor">
+            <a:schemeClr val="lt1"/>
+          </a:fontRef>
+        </p:style>
+        <p:txBody>
+          <a:bodyPr rtlCol="0" anchor="ctr"/>
+          <a:lstStyle/>
+          <a:p>
+            <a:pPr algn="ctr"/>
+          </a:p>
+        </p:txBody>
+      </p:sp>
+      <p:sp>
+        <p:nvSpPr>
+          <p:cNvPr id="3" name="TextBox 2"/>
+          <p:cNvSpPr txBox="1"/>
+          <p:nvPr/>
+        </p:nvSpPr>
+        <p:spPr>
+          <a:xfrm>
+            <a:off x="365760" y="365760"/>
+            <a:ext cx="8412480" cy="457200"/>
+          </a:xfrm>
+          <a:prstGeom prst="rect">
+            <a:avLst/>
+          </a:prstGeom>
+          <a:noFill/>
+        </p:spPr>
+        <p:txBody>
+          <a:bodyPr wrap="square" lIns="0" rIns="0" tIns="0" bIns="0" anchor="t">
+            <a:spAutoFit/>
+          </a:bodyPr>
+          <a:lstStyle/>
+          <a:p>
+            <a:pPr algn="l">
+              <a:lnSpc>
+                <a:spcPct val="100000"/>
+              </a:lnSpc>
+              <a:spcBef>
+                <a:spcPts val="0"/>
+              </a:spcBef>
+              <a:spcAft>
+                <a:spcPts val="0"/>
+              </a:spcAft>
+            </a:pPr>
+            <a:r>
+              <a:rPr sz="2000" b="0" i="0">
+                <a:solidFill>
+                  <a:srgbClr val="1B3E6E"/>
+                </a:solidFill>
+                <a:latin typeface="Georgia"/>
+              </a:rPr>
+              <a:t>The two gaps — and the $250,000 that closes them</a:t>
+            </a:r>
+          </a:p>
+        </p:txBody>
+      </p:sp>
+      <p:sp>
+        <p:nvSpPr>
+          <p:cNvPr id="4" name="TextBox 3"/>
+          <p:cNvSpPr txBox="1"/>
+          <p:nvPr/>
+        </p:nvSpPr>
+        <p:spPr>
+          <a:xfrm>
+            <a:off x="365760" y="822960"/>
+            <a:ext cx="8412480" cy="438912"/>
+          </a:xfrm>
+          <a:prstGeom prst="rect">
+            <a:avLst/>
+          </a:prstGeom>
+          <a:noFill/>
+        </p:spPr>
+        <p:txBody>
+          <a:bodyPr wrap="square" lIns="0" rIns="0" tIns="0" bIns="0" anchor="t">
+            <a:spAutoFit/>
+          </a:bodyPr>
+          <a:lstStyle/>
+          <a:p>
+            <a:pPr algn="l">
+              <a:lnSpc>
+                <a:spcPct val="100000"/>
+              </a:lnSpc>
+              <a:spcBef>
+                <a:spcPts val="0"/>
+              </a:spcBef>
+              <a:spcAft>
+                <a:spcPts val="0"/>
+              </a:spcAft>
+            </a:pPr>
+            <a:r>
+              <a:rPr sz="1050" b="0" i="0">
+                <a:solidFill>
+                  <a:srgbClr val="333333"/>
+                </a:solidFill>
+                <a:latin typeface="Arial"/>
+              </a:rPr>
+              <a:t>The gaps highlighted in the supply chain, the grant that closes them, and the solution we build for each — all in one view.</a:t>
+            </a:r>
+          </a:p>
+        </p:txBody>
+      </p:sp>
+      <p:sp>
+        <p:nvSpPr>
+          <p:cNvPr id="5" name="Rectangle 4"/>
+          <p:cNvSpPr/>
+          <p:nvPr/>
+        </p:nvSpPr>
+        <p:spPr>
+          <a:xfrm>
+            <a:off x="502920" y="6071616"/>
+            <a:ext cx="8138159" cy="365760"/>
+          </a:xfrm>
+          <a:prstGeom prst="rect">
+            <a:avLst/>
+          </a:prstGeom>
+          <a:solidFill>
+            <a:srgbClr val="D9D9D9"/>
+          </a:solidFill>
+          <a:ln>
+            <a:noFill/>
+          </a:ln>
+          <a:effectLst/>
+        </p:spPr>
+        <p:style>
+          <a:lnRef idx="1">
+            <a:schemeClr val="accent1"/>
+          </a:lnRef>
+          <a:fillRef idx="3">
+            <a:schemeClr val="accent1"/>
+          </a:fillRef>
+          <a:effectRef idx="2">
+            <a:schemeClr val="accent1"/>
+          </a:effectRef>
+          <a:fontRef idx="minor">
+            <a:schemeClr val="lt1"/>
+          </a:fontRef>
+        </p:style>
+        <p:txBody>
+          <a:bodyPr rtlCol="0" anchor="ctr"/>
+          <a:lstStyle/>
+          <a:p>
+            <a:pPr algn="ctr"/>
+          </a:p>
+        </p:txBody>
+      </p:sp>
+      <p:sp>
+        <p:nvSpPr>
+          <p:cNvPr id="6" name="TextBox 5"/>
+          <p:cNvSpPr txBox="1"/>
+          <p:nvPr/>
+        </p:nvSpPr>
+        <p:spPr>
+          <a:xfrm>
+            <a:off x="640080" y="6071616"/>
+            <a:ext cx="7863840" cy="365760"/>
+          </a:xfrm>
+          <a:prstGeom prst="rect">
+            <a:avLst/>
+          </a:prstGeom>
+          <a:noFill/>
+        </p:spPr>
+        <p:txBody>
+          <a:bodyPr wrap="square" lIns="0" rIns="0" tIns="0" bIns="0" anchor="ctr">
+            <a:spAutoFit/>
+          </a:bodyPr>
+          <a:lstStyle/>
+          <a:p>
+            <a:pPr algn="ctr">
+              <a:lnSpc>
+                <a:spcPct val="95000"/>
+              </a:lnSpc>
+              <a:spcBef>
+                <a:spcPts val="0"/>
+              </a:spcBef>
+              <a:spcAft>
+                <a:spcPts val="0"/>
+              </a:spcAft>
+            </a:pPr>
+            <a:r>
+              <a:rPr sz="1100" b="1" i="0">
+                <a:solidFill>
+                  <a:srgbClr val="1B3E6E"/>
+                </a:solidFill>
+                <a:latin typeface="Georgia"/>
+              </a:rPr>
+              <a:t>Two fixable gaps, two targeted builds — $250k of capital becomes $310k of savings, every year.</a:t>
+            </a:r>
+          </a:p>
+        </p:txBody>
+      </p:sp>
+      <p:sp>
+        <p:nvSpPr>
+          <p:cNvPr id="7" name="TextBox 6"/>
+          <p:cNvSpPr txBox="1"/>
+          <p:nvPr/>
+        </p:nvSpPr>
+        <p:spPr>
+          <a:xfrm>
+            <a:off x="365760" y="6492240"/>
+            <a:ext cx="1280160" cy="329184"/>
+          </a:xfrm>
+          <a:prstGeom prst="rect">
+            <a:avLst/>
+          </a:prstGeom>
+          <a:noFill/>
+        </p:spPr>
+        <p:txBody>
+          <a:bodyPr wrap="square" lIns="0" rIns="0" tIns="0" bIns="0" anchor="t">
+            <a:spAutoFit/>
+          </a:bodyPr>
+          <a:lstStyle/>
+          <a:p>
+            <a:pPr algn="l">
+              <a:lnSpc>
+                <a:spcPct val="90000"/>
+              </a:lnSpc>
+              <a:spcBef>
+                <a:spcPts val="0"/>
+              </a:spcBef>
+              <a:spcAft>
+                <a:spcPts val="0"/>
+              </a:spcAft>
+            </a:pPr>
+            <a:r>
+              <a:rPr sz="900" b="1" i="0">
+                <a:solidFill>
+                  <a:srgbClr val="111111"/>
+                </a:solidFill>
+                <a:latin typeface="Georgia"/>
+              </a:rPr>
+              <a:t>Goldman</a:t>
+            </a:r>
+          </a:p>
+          <a:p>
+            <a:pPr algn="l">
+              <a:lnSpc>
+                <a:spcPct val="90000"/>
+              </a:lnSpc>
+              <a:spcBef>
+                <a:spcPts val="0"/>
+              </a:spcBef>
+              <a:spcAft>
+                <a:spcPts val="0"/>
+              </a:spcAft>
+            </a:pPr>
+            <a:r>
+              <a:rPr sz="900" b="1" i="0">
+                <a:solidFill>
+                  <a:srgbClr val="111111"/>
+                </a:solidFill>
+                <a:latin typeface="Georgia"/>
+              </a:rPr>
+              <a:t>Sachs</a:t>
+            </a:r>
+          </a:p>
+        </p:txBody>
+      </p:sp>
+      <p:sp>
+        <p:nvSpPr>
+          <p:cNvPr id="8" name="TextBox 7"/>
+          <p:cNvSpPr txBox="1"/>
+          <p:nvPr/>
+        </p:nvSpPr>
+        <p:spPr>
+          <a:xfrm>
+            <a:off x="8321040" y="6528816"/>
+            <a:ext cx="457200" cy="274320"/>
+          </a:xfrm>
+          <a:prstGeom prst="rect">
+            <a:avLst/>
+          </a:prstGeom>
+          <a:noFill/>
+        </p:spPr>
+        <p:txBody>
+          <a:bodyPr wrap="square" lIns="0" rIns="0" tIns="0" bIns="0" anchor="t">
+            <a:spAutoFit/>
+          </a:bodyPr>
+          <a:lstStyle/>
+          <a:p>
+            <a:pPr algn="r">
+              <a:lnSpc>
+                <a:spcPct val="100000"/>
+              </a:lnSpc>
+              <a:spcBef>
+                <a:spcPts val="0"/>
+              </a:spcBef>
+              <a:spcAft>
+                <a:spcPts val="300"/>
+              </a:spcAft>
+            </a:pPr>
+            <a:r>
+              <a:rPr sz="900" b="0" i="0">
+                <a:solidFill>
+                  <a:srgbClr val="727375"/>
+                </a:solidFill>
+                <a:latin typeface="Arial"/>
+              </a:rPr>
+              <a:t>8</a:t>
+            </a:r>
+          </a:p>
+        </p:txBody>
+      </p:sp>
+      <p:sp>
+        <p:nvSpPr>
+          <p:cNvPr id="9" name="TextBox 8"/>
+          <p:cNvSpPr txBox="1"/>
+          <p:nvPr/>
+        </p:nvSpPr>
+        <p:spPr>
+          <a:xfrm>
+            <a:off x="5486400" y="54864"/>
+            <a:ext cx="3291840" cy="182880"/>
+          </a:xfrm>
+          <a:prstGeom prst="rect">
+            <a:avLst/>
+          </a:prstGeom>
+          <a:noFill/>
+        </p:spPr>
+        <p:txBody>
+          <a:bodyPr wrap="square" lIns="0" rIns="0" tIns="0" bIns="0" anchor="t">
+            <a:spAutoFit/>
+          </a:bodyPr>
+          <a:lstStyle/>
+          <a:p>
+            <a:pPr algn="r">
+              <a:lnSpc>
+                <a:spcPct val="100000"/>
+              </a:lnSpc>
+              <a:spcBef>
+                <a:spcPts val="0"/>
+              </a:spcBef>
+              <a:spcAft>
+                <a:spcPts val="0"/>
+              </a:spcAft>
+            </a:pPr>
+            <a:r>
+              <a:rPr sz="750" b="0" i="1">
+                <a:solidFill>
+                  <a:srgbClr val="727375"/>
+                </a:solidFill>
+                <a:latin typeface="Arial"/>
+              </a:rPr>
+              <a:t>PROPOSED SLIDE 3 — v3 (pie quadrant)</a:t>
+            </a:r>
+          </a:p>
+        </p:txBody>
+      </p:sp>
+      <p:sp>
+        <p:nvSpPr>
+          <p:cNvPr id="10" name="Rectangle 9"/>
+          <p:cNvSpPr/>
+          <p:nvPr/>
+        </p:nvSpPr>
+        <p:spPr>
+          <a:xfrm>
+            <a:off x="365760" y="1399032"/>
+            <a:ext cx="54864" cy="182880"/>
+          </a:xfrm>
+          <a:prstGeom prst="rect">
+            <a:avLst/>
+          </a:prstGeom>
+          <a:solidFill>
+            <a:srgbClr val="C22310"/>
+          </a:solidFill>
+          <a:ln>
+            <a:noFill/>
+          </a:ln>
+          <a:effectLst/>
+        </p:spPr>
+        <p:style>
+          <a:lnRef idx="1">
+            <a:schemeClr val="accent1"/>
+          </a:lnRef>
+          <a:fillRef idx="3">
+            <a:schemeClr val="accent1"/>
+          </a:fillRef>
+          <a:effectRef idx="2">
+            <a:schemeClr val="accent1"/>
+          </a:effectRef>
+          <a:fontRef idx="minor">
+            <a:schemeClr val="lt1"/>
+          </a:fontRef>
+        </p:style>
+        <p:txBody>
+          <a:bodyPr rtlCol="0" anchor="ctr"/>
+          <a:lstStyle/>
+          <a:p>
+            <a:pPr algn="ctr"/>
+          </a:p>
+        </p:txBody>
+      </p:sp>
+      <p:sp>
+        <p:nvSpPr>
+          <p:cNvPr id="11" name="TextBox 10"/>
+          <p:cNvSpPr txBox="1"/>
+          <p:nvPr/>
+        </p:nvSpPr>
+        <p:spPr>
+          <a:xfrm>
+            <a:off x="512064" y="1371600"/>
+            <a:ext cx="2642615" cy="256032"/>
+          </a:xfrm>
+          <a:prstGeom prst="rect">
+            <a:avLst/>
+          </a:prstGeom>
+          <a:noFill/>
+        </p:spPr>
+        <p:txBody>
+          <a:bodyPr wrap="square" lIns="0" rIns="0" tIns="0" bIns="0" anchor="t">
+            <a:spAutoFit/>
+          </a:bodyPr>
+          <a:lstStyle/>
+          <a:p>
+            <a:pPr algn="l">
+              <a:lnSpc>
+                <a:spcPct val="100000"/>
+              </a:lnSpc>
+              <a:spcBef>
+                <a:spcPts val="0"/>
+              </a:spcBef>
+              <a:spcAft>
+                <a:spcPts val="0"/>
+              </a:spcAft>
+            </a:pPr>
+            <a:r>
+              <a:rPr sz="1050" b="1" i="0">
+                <a:solidFill>
+                  <a:srgbClr val="1B3E6E"/>
+                </a:solidFill>
+                <a:latin typeface="Arial"/>
+              </a:rPr>
+              <a:t>GAP 1 — Procurement</a:t>
+            </a:r>
+          </a:p>
+        </p:txBody>
+      </p:sp>
+      <p:sp>
+        <p:nvSpPr>
+          <p:cNvPr id="12" name="Rectangle 11"/>
+          <p:cNvSpPr/>
+          <p:nvPr/>
+        </p:nvSpPr>
+        <p:spPr>
+          <a:xfrm>
+            <a:off x="365760" y="1645920"/>
+            <a:ext cx="2788920" cy="10972"/>
+          </a:xfrm>
+          <a:prstGeom prst="rect">
+            <a:avLst/>
+          </a:prstGeom>
+          <a:solidFill>
+            <a:srgbClr val="BFBFBF"/>
+          </a:solidFill>
+          <a:ln>
+            <a:noFill/>
+          </a:ln>
+          <a:effectLst/>
+        </p:spPr>
+        <p:style>
+          <a:lnRef idx="1">
+            <a:schemeClr val="accent1"/>
+          </a:lnRef>
+          <a:fillRef idx="3">
+            <a:schemeClr val="accent1"/>
+          </a:fillRef>
+          <a:effectRef idx="2">
+            <a:schemeClr val="accent1"/>
+          </a:effectRef>
+          <a:fontRef idx="minor">
+            <a:schemeClr val="lt1"/>
+          </a:fontRef>
+        </p:style>
+        <p:txBody>
+          <a:bodyPr rtlCol="0" anchor="ctr"/>
+          <a:lstStyle/>
+          <a:p>
+            <a:pPr algn="ctr"/>
+          </a:p>
+        </p:txBody>
+      </p:sp>
+      <p:sp>
+        <p:nvSpPr>
+          <p:cNvPr id="13" name="TextBox 12"/>
+          <p:cNvSpPr txBox="1"/>
+          <p:nvPr/>
+        </p:nvSpPr>
+        <p:spPr>
+          <a:xfrm>
+            <a:off x="365760" y="1737360"/>
+            <a:ext cx="2788920" cy="1188720"/>
+          </a:xfrm>
+          <a:prstGeom prst="rect">
+            <a:avLst/>
+          </a:prstGeom>
+          <a:noFill/>
+        </p:spPr>
+        <p:txBody>
+          <a:bodyPr wrap="square" lIns="0" rIns="0" tIns="0" bIns="0" anchor="t">
+            <a:spAutoFit/>
+          </a:bodyPr>
+          <a:lstStyle/>
+          <a:p>
+            <a:pPr algn="l">
+              <a:lnSpc>
+                <a:spcPct val="100000"/>
+              </a:lnSpc>
+              <a:spcBef>
+                <a:spcPts val="0"/>
+              </a:spcBef>
+              <a:spcAft>
+                <a:spcPts val="300"/>
+              </a:spcAft>
+            </a:pPr>
+            <a:r>
+              <a:rPr sz="780" b="1" i="0">
+                <a:solidFill>
+                  <a:srgbClr val="333333"/>
+                </a:solidFill>
+                <a:latin typeface="Arial"/>
+              </a:rPr>
+              <a:t>•  Manual indenting</a:t>
+            </a:r>
+            <a:r>
+              <a:rPr sz="780" b="0" i="0">
+                <a:solidFill>
+                  <a:srgbClr val="333333"/>
+                </a:solidFill>
+                <a:latin typeface="Arial"/>
+              </a:rPr>
+              <a:t> — blind to attendance, exams &amp; holidays</a:t>
+            </a:r>
+          </a:p>
+          <a:p>
+            <a:pPr algn="l">
+              <a:lnSpc>
+                <a:spcPct val="100000"/>
+              </a:lnSpc>
+              <a:spcBef>
+                <a:spcPts val="0"/>
+              </a:spcBef>
+              <a:spcAft>
+                <a:spcPts val="300"/>
+              </a:spcAft>
+            </a:pPr>
+            <a:r>
+              <a:rPr sz="780" b="1" i="0">
+                <a:solidFill>
+                  <a:srgbClr val="333333"/>
+                </a:solidFill>
+                <a:latin typeface="Arial"/>
+              </a:rPr>
+              <a:t>•  Spot-buying</a:t>
+            </a:r>
+            <a:r>
+              <a:rPr sz="780" b="0" i="0">
+                <a:solidFill>
+                  <a:srgbClr val="333333"/>
+                </a:solidFill>
+                <a:latin typeface="Arial"/>
+              </a:rPr>
+              <a:t> at mandi peak prices; no price intelligence</a:t>
+            </a:r>
+          </a:p>
+          <a:p>
+            <a:pPr algn="l">
+              <a:lnSpc>
+                <a:spcPct val="100000"/>
+              </a:lnSpc>
+              <a:spcBef>
+                <a:spcPts val="0"/>
+              </a:spcBef>
+              <a:spcAft>
+                <a:spcPts val="300"/>
+              </a:spcAft>
+            </a:pPr>
+            <a:r>
+              <a:rPr sz="780" b="1" i="0">
+                <a:solidFill>
+                  <a:srgbClr val="333333"/>
+                </a:solidFill>
+                <a:latin typeface="Arial"/>
+              </a:rPr>
+              <a:t>•  No feedback loop</a:t>
+            </a:r>
+            <a:r>
+              <a:rPr sz="780" b="0" i="0">
+                <a:solidFill>
+                  <a:srgbClr val="333333"/>
+                </a:solidFill>
+                <a:latin typeface="Arial"/>
+              </a:rPr>
+              <a:t> on actual meal uptake</a:t>
+            </a:r>
+          </a:p>
+          <a:p>
+            <a:pPr algn="l">
+              <a:lnSpc>
+                <a:spcPct val="100000"/>
+              </a:lnSpc>
+              <a:spcBef>
+                <a:spcPts val="0"/>
+              </a:spcBef>
+              <a:spcAft>
+                <a:spcPts val="0"/>
+              </a:spcAft>
+            </a:pPr>
+            <a:r>
+              <a:rPr sz="780" b="1" i="0">
+                <a:solidFill>
+                  <a:srgbClr val="C22310"/>
+                </a:solidFill>
+                <a:latin typeface="Arial"/>
+              </a:rPr>
+              <a:t>8–10% over-produced · +12% spot premium [dummy]</a:t>
+            </a:r>
+          </a:p>
+        </p:txBody>
+      </p:sp>
+      <p:sp>
+        <p:nvSpPr>
+          <p:cNvPr id="14" name="Rectangle 13"/>
+          <p:cNvSpPr/>
+          <p:nvPr/>
+        </p:nvSpPr>
+        <p:spPr>
+          <a:xfrm>
+            <a:off x="5989320" y="1399032"/>
+            <a:ext cx="54864" cy="182880"/>
+          </a:xfrm>
+          <a:prstGeom prst="rect">
+            <a:avLst/>
+          </a:prstGeom>
+          <a:solidFill>
+            <a:srgbClr val="C22310"/>
+          </a:solidFill>
+          <a:ln>
+            <a:noFill/>
+          </a:ln>
+          <a:effectLst/>
+        </p:spPr>
+        <p:style>
+          <a:lnRef idx="1">
+            <a:schemeClr val="accent1"/>
+          </a:lnRef>
+          <a:fillRef idx="3">
+            <a:schemeClr val="accent1"/>
+          </a:fillRef>
+          <a:effectRef idx="2">
+            <a:schemeClr val="accent1"/>
+          </a:effectRef>
+          <a:fontRef idx="minor">
+            <a:schemeClr val="lt1"/>
+          </a:fontRef>
+        </p:style>
+        <p:txBody>
+          <a:bodyPr rtlCol="0" anchor="ctr"/>
+          <a:lstStyle/>
+          <a:p>
+            <a:pPr algn="ctr"/>
+          </a:p>
+        </p:txBody>
+      </p:sp>
+      <p:sp>
+        <p:nvSpPr>
+          <p:cNvPr id="15" name="TextBox 14"/>
+          <p:cNvSpPr txBox="1"/>
+          <p:nvPr/>
+        </p:nvSpPr>
+        <p:spPr>
+          <a:xfrm>
+            <a:off x="6135624" y="1371600"/>
+            <a:ext cx="2642615" cy="256032"/>
+          </a:xfrm>
+          <a:prstGeom prst="rect">
+            <a:avLst/>
+          </a:prstGeom>
+          <a:noFill/>
+        </p:spPr>
+        <p:txBody>
+          <a:bodyPr wrap="square" lIns="0" rIns="0" tIns="0" bIns="0" anchor="t">
+            <a:spAutoFit/>
+          </a:bodyPr>
+          <a:lstStyle/>
+          <a:p>
+            <a:pPr algn="l">
+              <a:lnSpc>
+                <a:spcPct val="100000"/>
+              </a:lnSpc>
+              <a:spcBef>
+                <a:spcPts val="0"/>
+              </a:spcBef>
+              <a:spcAft>
+                <a:spcPts val="0"/>
+              </a:spcAft>
+            </a:pPr>
+            <a:r>
+              <a:rPr sz="1050" b="1" i="0">
+                <a:solidFill>
+                  <a:srgbClr val="1B3E6E"/>
+                </a:solidFill>
+                <a:latin typeface="Arial"/>
+              </a:rPr>
+              <a:t>GAP 2 — Distribution</a:t>
+            </a:r>
+          </a:p>
+        </p:txBody>
+      </p:sp>
+      <p:sp>
+        <p:nvSpPr>
+          <p:cNvPr id="16" name="Rectangle 15"/>
+          <p:cNvSpPr/>
+          <p:nvPr/>
+        </p:nvSpPr>
+        <p:spPr>
+          <a:xfrm>
+            <a:off x="5989320" y="1645920"/>
+            <a:ext cx="2788920" cy="10972"/>
+          </a:xfrm>
+          <a:prstGeom prst="rect">
+            <a:avLst/>
+          </a:prstGeom>
+          <a:solidFill>
+            <a:srgbClr val="BFBFBF"/>
+          </a:solidFill>
+          <a:ln>
+            <a:noFill/>
+          </a:ln>
+          <a:effectLst/>
+        </p:spPr>
+        <p:style>
+          <a:lnRef idx="1">
+            <a:schemeClr val="accent1"/>
+          </a:lnRef>
+          <a:fillRef idx="3">
+            <a:schemeClr val="accent1"/>
+          </a:fillRef>
+          <a:effectRef idx="2">
+            <a:schemeClr val="accent1"/>
+          </a:effectRef>
+          <a:fontRef idx="minor">
+            <a:schemeClr val="lt1"/>
+          </a:fontRef>
+        </p:style>
+        <p:txBody>
+          <a:bodyPr rtlCol="0" anchor="ctr"/>
+          <a:lstStyle/>
+          <a:p>
+            <a:pPr algn="ctr"/>
+          </a:p>
+        </p:txBody>
+      </p:sp>
+      <p:sp>
+        <p:nvSpPr>
+          <p:cNvPr id="17" name="TextBox 16"/>
+          <p:cNvSpPr txBox="1"/>
+          <p:nvPr/>
+        </p:nvSpPr>
+        <p:spPr>
+          <a:xfrm>
+            <a:off x="5989320" y="1737360"/>
+            <a:ext cx="2788920" cy="1188720"/>
+          </a:xfrm>
+          <a:prstGeom prst="rect">
+            <a:avLst/>
+          </a:prstGeom>
+          <a:noFill/>
+        </p:spPr>
+        <p:txBody>
+          <a:bodyPr wrap="square" lIns="0" rIns="0" tIns="0" bIns="0" anchor="t">
+            <a:spAutoFit/>
+          </a:bodyPr>
+          <a:lstStyle/>
+          <a:p>
+            <a:pPr algn="l">
+              <a:lnSpc>
+                <a:spcPct val="100000"/>
+              </a:lnSpc>
+              <a:spcBef>
+                <a:spcPts val="0"/>
+              </a:spcBef>
+              <a:spcAft>
+                <a:spcPts val="300"/>
+              </a:spcAft>
+            </a:pPr>
+            <a:r>
+              <a:rPr sz="780" b="1" i="0">
+                <a:solidFill>
+                  <a:srgbClr val="333333"/>
+                </a:solidFill>
+                <a:latin typeface="Arial"/>
+              </a:rPr>
+              <a:t>•  Static, driver-memory routes</a:t>
+            </a:r>
+            <a:r>
+              <a:rPr sz="780" b="0" i="0">
+                <a:solidFill>
+                  <a:srgbClr val="333333"/>
+                </a:solidFill>
+                <a:latin typeface="Arial"/>
+              </a:rPr>
+              <a:t> — late vans mean children stay hungry all day</a:t>
+            </a:r>
+          </a:p>
+          <a:p>
+            <a:pPr algn="l">
+              <a:lnSpc>
+                <a:spcPct val="100000"/>
+              </a:lnSpc>
+              <a:spcBef>
+                <a:spcPts val="0"/>
+              </a:spcBef>
+              <a:spcAft>
+                <a:spcPts val="300"/>
+              </a:spcAft>
+            </a:pPr>
+            <a:r>
+              <a:rPr sz="780" b="1" i="0">
+                <a:solidFill>
+                  <a:srgbClr val="333333"/>
+                </a:solidFill>
+                <a:latin typeface="Arial"/>
+              </a:rPr>
+              <a:t>•  Untracked vessels</a:t>
+            </a:r>
+            <a:r>
+              <a:rPr sz="780" b="0" i="0">
+                <a:solidFill>
+                  <a:srgbClr val="333333"/>
+                </a:solidFill>
+                <a:latin typeface="Arial"/>
+              </a:rPr>
+              <a:t>; adulteration &amp; diversion risk en route</a:t>
+            </a:r>
+          </a:p>
+          <a:p>
+            <a:pPr algn="l">
+              <a:lnSpc>
+                <a:spcPct val="100000"/>
+              </a:lnSpc>
+              <a:spcBef>
+                <a:spcPts val="0"/>
+              </a:spcBef>
+              <a:spcAft>
+                <a:spcPts val="300"/>
+              </a:spcAft>
+            </a:pPr>
+            <a:r>
+              <a:rPr sz="780" b="1" i="0">
+                <a:solidFill>
+                  <a:srgbClr val="333333"/>
+                </a:solidFill>
+                <a:latin typeface="Arial"/>
+              </a:rPr>
+              <a:t>•  No proof-of-delivery</a:t>
+            </a:r>
+            <a:r>
+              <a:rPr sz="780" b="0" i="0">
+                <a:solidFill>
+                  <a:srgbClr val="333333"/>
+                </a:solidFill>
+                <a:latin typeface="Arial"/>
+              </a:rPr>
+              <a:t> — disputes go unresolved</a:t>
+            </a:r>
+          </a:p>
+          <a:p>
+            <a:pPr algn="l">
+              <a:lnSpc>
+                <a:spcPct val="100000"/>
+              </a:lnSpc>
+              <a:spcBef>
+                <a:spcPts val="0"/>
+              </a:spcBef>
+              <a:spcAft>
+                <a:spcPts val="0"/>
+              </a:spcAft>
+            </a:pPr>
+            <a:r>
+              <a:rPr sz="780" b="1" i="0">
+                <a:solidFill>
+                  <a:srgbClr val="C22310"/>
+                </a:solidFill>
+                <a:latin typeface="Arial"/>
+              </a:rPr>
+              <a:t>6.2% miss lunch window · $35k/yr shrinkage [dummy]</a:t>
+            </a:r>
+          </a:p>
+        </p:txBody>
+      </p:sp>
+      <p:graphicFrame>
+        <p:nvGraphicFramePr>
+          <p:cNvPr id="18" name="Chart 17"/>
+          <p:cNvGraphicFramePr>
+            <a:graphicFrameLocks noGrp="1"/>
+          </p:cNvGraphicFramePr>
+          <p:nvPr/>
+        </p:nvGraphicFramePr>
+        <p:xfrm>
+          <a:off x="3273552" y="2331720"/>
+          <a:ext cx="2606040" cy="2240280"/>
+        </p:xfrm>
+        <a:graphic>
+          <a:graphicData uri="http://schemas.openxmlformats.org/drawingml/2006/chart">
+            <c:chart xmlns:c="http://schemas.openxmlformats.org/drawingml/2006/chart" r:id="rId2"/>
+          </a:graphicData>
+        </a:graphic>
+      </p:graphicFrame>
+      <p:sp>
+        <p:nvSpPr>
+          <p:cNvPr id="19" name="TextBox 18"/>
+          <p:cNvSpPr txBox="1"/>
+          <p:nvPr/>
+        </p:nvSpPr>
+        <p:spPr>
+          <a:xfrm>
+            <a:off x="3273552" y="4626864"/>
+            <a:ext cx="2606040" cy="402336"/>
+          </a:xfrm>
+          <a:prstGeom prst="rect">
+            <a:avLst/>
+          </a:prstGeom>
+          <a:noFill/>
+        </p:spPr>
+        <p:txBody>
+          <a:bodyPr wrap="square" lIns="0" rIns="0" tIns="0" bIns="0" anchor="t">
+            <a:spAutoFit/>
+          </a:bodyPr>
+          <a:lstStyle/>
+          <a:p>
+            <a:pPr algn="ctr">
+              <a:lnSpc>
+                <a:spcPct val="100000"/>
+              </a:lnSpc>
+              <a:spcBef>
+                <a:spcPts val="0"/>
+              </a:spcBef>
+              <a:spcAft>
+                <a:spcPts val="100"/>
+              </a:spcAft>
+            </a:pPr>
+            <a:r>
+              <a:rPr sz="950" b="1" i="0">
+                <a:solidFill>
+                  <a:srgbClr val="1B3E6E"/>
+                </a:solidFill>
+                <a:latin typeface="Arial"/>
+              </a:rPr>
+              <a:t>THE $250k GRANT</a:t>
+            </a:r>
+          </a:p>
+          <a:p>
+            <a:pPr algn="ctr">
+              <a:lnSpc>
+                <a:spcPct val="100000"/>
+              </a:lnSpc>
+              <a:spcBef>
+                <a:spcPts val="0"/>
+              </a:spcBef>
+              <a:spcAft>
+                <a:spcPts val="0"/>
+              </a:spcAft>
+            </a:pPr>
+            <a:r>
+              <a:rPr sz="720" b="0" i="1">
+                <a:solidFill>
+                  <a:srgbClr val="727375"/>
+                </a:solidFill>
+                <a:latin typeface="Arial"/>
+              </a:rPr>
+              <a:t>60 / 40 — weighted to the costlier gap</a:t>
+            </a:r>
+          </a:p>
+        </p:txBody>
+      </p:sp>
+      <p:cxnSp>
+        <p:nvCxnSpPr>
+          <p:cNvPr id="20" name="Connector 19"/>
+          <p:cNvCxnSpPr/>
+          <p:nvPr/>
+        </p:nvCxnSpPr>
+        <p:spPr>
+          <a:xfrm>
+            <a:off x="3246120" y="2331720"/>
+            <a:ext cx="548640" cy="548640"/>
+          </a:xfrm>
+          <a:prstGeom prst="curvedConnector3">
+            <a:avLst/>
+          </a:prstGeom>
+          <a:ln w="13970">
+            <a:solidFill>
+              <a:srgbClr val="C22310"/>
+            </a:solidFill>
+            <a:prstDash val="sysDash"/>
+            <a:tailEnd type="triangle" w="med" len="med"/>
+          </a:ln>
+          <a:effectLst/>
+        </p:spPr>
+        <p:style>
+          <a:lnRef idx="2">
+            <a:schemeClr val="accent1"/>
+          </a:lnRef>
+          <a:fillRef idx="0">
+            <a:schemeClr val="accent1"/>
+          </a:fillRef>
+          <a:effectRef idx="1">
+            <a:schemeClr val="accent1"/>
+          </a:effectRef>
+          <a:fontRef idx="minor">
+            <a:schemeClr val="tx1"/>
+          </a:fontRef>
+        </p:style>
+      </p:cxnSp>
+      <p:cxnSp>
+        <p:nvCxnSpPr>
+          <p:cNvPr id="21" name="Connector 20"/>
+          <p:cNvCxnSpPr/>
+          <p:nvPr/>
+        </p:nvCxnSpPr>
+        <p:spPr>
+          <a:xfrm flipH="1">
+            <a:off x="5349240" y="2331720"/>
+            <a:ext cx="548640" cy="548640"/>
+          </a:xfrm>
+          <a:prstGeom prst="curvedConnector3">
+            <a:avLst/>
+          </a:prstGeom>
+          <a:ln w="13970">
+            <a:solidFill>
+              <a:srgbClr val="C22310"/>
+            </a:solidFill>
+            <a:prstDash val="sysDash"/>
+            <a:tailEnd type="triangle" w="med" len="med"/>
+          </a:ln>
+          <a:effectLst/>
+        </p:spPr>
+        <p:style>
+          <a:lnRef idx="2">
+            <a:schemeClr val="accent1"/>
+          </a:lnRef>
+          <a:fillRef idx="0">
+            <a:schemeClr val="accent1"/>
+          </a:fillRef>
+          <a:effectRef idx="1">
+            <a:schemeClr val="accent1"/>
+          </a:effectRef>
+          <a:fontRef idx="minor">
+            <a:schemeClr val="tx1"/>
+          </a:fontRef>
+        </p:style>
+      </p:cxnSp>
+      <p:cxnSp>
+        <p:nvCxnSpPr>
+          <p:cNvPr id="22" name="Connector 21"/>
+          <p:cNvCxnSpPr/>
+          <p:nvPr/>
+        </p:nvCxnSpPr>
+        <p:spPr>
+          <a:xfrm flipH="1">
+            <a:off x="3209544" y="4160520"/>
+            <a:ext cx="539495" cy="457200"/>
+          </a:xfrm>
+          <a:prstGeom prst="curvedConnector3">
+            <a:avLst/>
+          </a:prstGeom>
+          <a:ln w="13970">
+            <a:solidFill>
+              <a:srgbClr val="1B3E6E"/>
+            </a:solidFill>
+            <a:prstDash val="sysDash"/>
+            <a:tailEnd type="triangle" w="med" len="med"/>
+          </a:ln>
+          <a:effectLst/>
+        </p:spPr>
+        <p:style>
+          <a:lnRef idx="2">
+            <a:schemeClr val="accent1"/>
+          </a:lnRef>
+          <a:fillRef idx="0">
+            <a:schemeClr val="accent1"/>
+          </a:fillRef>
+          <a:effectRef idx="1">
+            <a:schemeClr val="accent1"/>
+          </a:effectRef>
+          <a:fontRef idx="minor">
+            <a:schemeClr val="tx1"/>
+          </a:fontRef>
+        </p:style>
+      </p:cxnSp>
+      <p:cxnSp>
+        <p:nvCxnSpPr>
+          <p:cNvPr id="23" name="Connector 22"/>
+          <p:cNvCxnSpPr/>
+          <p:nvPr/>
+        </p:nvCxnSpPr>
+        <p:spPr>
+          <a:xfrm>
+            <a:off x="5394960" y="4160520"/>
+            <a:ext cx="539496" cy="457200"/>
+          </a:xfrm>
+          <a:prstGeom prst="curvedConnector3">
+            <a:avLst/>
+          </a:prstGeom>
+          <a:ln w="13970">
+            <a:solidFill>
+              <a:srgbClr val="398025"/>
+            </a:solidFill>
+            <a:prstDash val="sysDash"/>
+            <a:tailEnd type="triangle" w="med" len="med"/>
+          </a:ln>
+          <a:effectLst/>
+        </p:spPr>
+        <p:style>
+          <a:lnRef idx="2">
+            <a:schemeClr val="accent1"/>
+          </a:lnRef>
+          <a:fillRef idx="0">
+            <a:schemeClr val="accent1"/>
+          </a:fillRef>
+          <a:effectRef idx="1">
+            <a:schemeClr val="accent1"/>
+          </a:effectRef>
+          <a:fontRef idx="minor">
+            <a:schemeClr val="tx1"/>
+          </a:fontRef>
+        </p:style>
+      </p:cxnSp>
+      <p:sp>
+        <p:nvSpPr>
+          <p:cNvPr id="24" name="Rounded Rectangle 23"/>
+          <p:cNvSpPr/>
+          <p:nvPr/>
+        </p:nvSpPr>
+        <p:spPr>
+          <a:xfrm>
+            <a:off x="365760" y="3931920"/>
+            <a:ext cx="2788920" cy="1783080"/>
+          </a:xfrm>
+          <a:prstGeom prst="roundRect">
+            <a:avLst>
+              <a:gd name="adj" fmla="val 5000"/>
+            </a:avLst>
+          </a:prstGeom>
+          <a:solidFill>
+            <a:srgbClr val="EEF3F9"/>
+          </a:solidFill>
+          <a:ln w="12700">
+            <a:solidFill>
+              <a:srgbClr val="1B3E6E"/>
+            </a:solidFill>
+          </a:ln>
+          <a:effectLst/>
+        </p:spPr>
+        <p:style>
+          <a:lnRef idx="1">
+            <a:schemeClr val="accent1"/>
+          </a:lnRef>
+          <a:fillRef idx="3">
+            <a:schemeClr val="accent1"/>
+          </a:fillRef>
+          <a:effectRef idx="2">
+            <a:schemeClr val="accent1"/>
+          </a:effectRef>
+          <a:fontRef idx="minor">
+            <a:schemeClr val="lt1"/>
+          </a:fontRef>
+        </p:style>
+        <p:txBody>
+          <a:bodyPr rtlCol="0" anchor="ctr"/>
+          <a:lstStyle/>
+          <a:p>
+            <a:pPr algn="ctr"/>
+          </a:p>
+        </p:txBody>
+      </p:sp>
+      <p:sp>
+        <p:nvSpPr>
+          <p:cNvPr id="25" name="TextBox 24"/>
+          <p:cNvSpPr txBox="1"/>
+          <p:nvPr/>
+        </p:nvSpPr>
+        <p:spPr>
+          <a:xfrm>
+            <a:off x="484632" y="4014215"/>
+            <a:ext cx="2551176" cy="1645920"/>
+          </a:xfrm>
+          <a:prstGeom prst="rect">
+            <a:avLst/>
+          </a:prstGeom>
+          <a:noFill/>
+        </p:spPr>
+        <p:txBody>
+          <a:bodyPr wrap="square" lIns="0" rIns="0" tIns="0" bIns="0" anchor="t">
+            <a:spAutoFit/>
+          </a:bodyPr>
+          <a:lstStyle/>
+          <a:p>
+            <a:pPr algn="l">
+              <a:lnSpc>
+                <a:spcPct val="95000"/>
+              </a:lnSpc>
+              <a:spcBef>
+                <a:spcPts val="0"/>
+              </a:spcBef>
+              <a:spcAft>
+                <a:spcPts val="300"/>
+              </a:spcAft>
+            </a:pPr>
+            <a:r>
+              <a:rPr sz="950" b="1" i="0">
+                <a:solidFill>
+                  <a:srgbClr val="1B3E6E"/>
+                </a:solidFill>
+                <a:latin typeface="Arial"/>
+              </a:rPr>
+              <a:t>SOLUTION 1
+“Annapurna AI” · $150k</a:t>
+            </a:r>
+          </a:p>
+          <a:p>
+            <a:pPr algn="l">
+              <a:lnSpc>
+                <a:spcPct val="104000"/>
+              </a:lnSpc>
+              <a:spcBef>
+                <a:spcPts val="0"/>
+              </a:spcBef>
+              <a:spcAft>
+                <a:spcPts val="300"/>
+              </a:spcAft>
+            </a:pPr>
+            <a:r>
+              <a:rPr sz="819" b="1" i="0">
+                <a:solidFill>
+                  <a:srgbClr val="1B3E6E"/>
+                </a:solidFill>
+                <a:latin typeface="Arial"/>
+              </a:rPr>
+              <a:t>What: </a:t>
+            </a:r>
+            <a:r>
+              <a:rPr sz="819" b="0" i="0">
+                <a:solidFill>
+                  <a:srgbClr val="333333"/>
+                </a:solidFill>
+                <a:latin typeface="Arial"/>
+              </a:rPr>
+              <a:t>ML demand-forecasting &amp; procurement planning for all 68 kitchens</a:t>
+            </a:r>
+          </a:p>
+          <a:p>
+            <a:pPr algn="l">
+              <a:lnSpc>
+                <a:spcPct val="104000"/>
+              </a:lnSpc>
+              <a:spcBef>
+                <a:spcPts val="0"/>
+              </a:spcBef>
+              <a:spcAft>
+                <a:spcPts val="300"/>
+              </a:spcAft>
+            </a:pPr>
+            <a:r>
+              <a:rPr sz="819" b="1" i="0">
+                <a:solidFill>
+                  <a:srgbClr val="1B3E6E"/>
+                </a:solidFill>
+                <a:latin typeface="Arial"/>
+              </a:rPr>
+              <a:t>How: </a:t>
+            </a:r>
+            <a:r>
+              <a:rPr sz="819" b="0" i="0">
+                <a:solidFill>
+                  <a:srgbClr val="333333"/>
+                </a:solidFill>
+                <a:latin typeface="Arial"/>
+              </a:rPr>
+              <a:t>predicts school-level attendance; auto-generates indents &amp; buying schedules</a:t>
+            </a:r>
+          </a:p>
+          <a:p>
+            <a:pPr algn="l">
+              <a:lnSpc>
+                <a:spcPct val="105000"/>
+              </a:lnSpc>
+              <a:spcBef>
+                <a:spcPts val="0"/>
+              </a:spcBef>
+              <a:spcAft>
+                <a:spcPts val="0"/>
+              </a:spcAft>
+            </a:pPr>
+            <a:r>
+              <a:rPr sz="830" b="1" i="0">
+                <a:solidFill>
+                  <a:srgbClr val="398025"/>
+                </a:solidFill>
+                <a:latin typeface="Arial"/>
+              </a:rPr>
+              <a:t>→ ~70% less waste  ·  est. $230k saved / yr [dummy]</a:t>
+            </a:r>
+          </a:p>
+        </p:txBody>
+      </p:sp>
+      <p:sp>
+        <p:nvSpPr>
+          <p:cNvPr id="26" name="Rounded Rectangle 25"/>
+          <p:cNvSpPr/>
+          <p:nvPr/>
+        </p:nvSpPr>
+        <p:spPr>
+          <a:xfrm>
+            <a:off x="5989320" y="3931920"/>
+            <a:ext cx="2788920" cy="1783080"/>
+          </a:xfrm>
+          <a:prstGeom prst="roundRect">
+            <a:avLst>
+              <a:gd name="adj" fmla="val 5000"/>
+            </a:avLst>
+          </a:prstGeom>
+          <a:solidFill>
+            <a:srgbClr val="EAF3E6"/>
+          </a:solidFill>
+          <a:ln w="12700">
+            <a:solidFill>
+              <a:srgbClr val="398025"/>
+            </a:solidFill>
+          </a:ln>
+          <a:effectLst/>
+        </p:spPr>
+        <p:style>
+          <a:lnRef idx="1">
+            <a:schemeClr val="accent1"/>
+          </a:lnRef>
+          <a:fillRef idx="3">
+            <a:schemeClr val="accent1"/>
+          </a:fillRef>
+          <a:effectRef idx="2">
+            <a:schemeClr val="accent1"/>
+          </a:effectRef>
+          <a:fontRef idx="minor">
+            <a:schemeClr val="lt1"/>
+          </a:fontRef>
+        </p:style>
+        <p:txBody>
+          <a:bodyPr rtlCol="0" anchor="ctr"/>
+          <a:lstStyle/>
+          <a:p>
+            <a:pPr algn="ctr"/>
+          </a:p>
+        </p:txBody>
+      </p:sp>
+      <p:sp>
+        <p:nvSpPr>
+          <p:cNvPr id="27" name="TextBox 26"/>
+          <p:cNvSpPr txBox="1"/>
+          <p:nvPr/>
+        </p:nvSpPr>
+        <p:spPr>
+          <a:xfrm>
+            <a:off x="6108192" y="4014215"/>
+            <a:ext cx="2551176" cy="1645920"/>
+          </a:xfrm>
+          <a:prstGeom prst="rect">
+            <a:avLst/>
+          </a:prstGeom>
+          <a:noFill/>
+        </p:spPr>
+        <p:txBody>
+          <a:bodyPr wrap="square" lIns="0" rIns="0" tIns="0" bIns="0" anchor="t">
+            <a:spAutoFit/>
+          </a:bodyPr>
+          <a:lstStyle/>
+          <a:p>
+            <a:pPr algn="l">
+              <a:lnSpc>
+                <a:spcPct val="95000"/>
+              </a:lnSpc>
+              <a:spcBef>
+                <a:spcPts val="0"/>
+              </a:spcBef>
+              <a:spcAft>
+                <a:spcPts val="300"/>
+              </a:spcAft>
+            </a:pPr>
+            <a:r>
+              <a:rPr sz="950" b="1" i="0">
+                <a:solidFill>
+                  <a:srgbClr val="398025"/>
+                </a:solidFill>
+                <a:latin typeface="Arial"/>
+              </a:rPr>
+              <a:t>SOLUTION 2
+“Last-Mile Shield” · $100k</a:t>
+            </a:r>
+          </a:p>
+          <a:p>
+            <a:pPr algn="l">
+              <a:lnSpc>
+                <a:spcPct val="104000"/>
+              </a:lnSpc>
+              <a:spcBef>
+                <a:spcPts val="0"/>
+              </a:spcBef>
+              <a:spcAft>
+                <a:spcPts val="300"/>
+              </a:spcAft>
+            </a:pPr>
+            <a:r>
+              <a:rPr sz="819" b="1" i="0">
+                <a:solidFill>
+                  <a:srgbClr val="1B3E6E"/>
+                </a:solidFill>
+                <a:latin typeface="Arial"/>
+              </a:rPr>
+              <a:t>What: </a:t>
+            </a:r>
+            <a:r>
+              <a:rPr sz="819" b="0" i="0">
+                <a:solidFill>
+                  <a:srgbClr val="333333"/>
+                </a:solidFill>
+                <a:latin typeface="Arial"/>
+              </a:rPr>
+              <a:t>AI routing + telematics (GPS, cameras, RFID) + geofenced smart locks</a:t>
+            </a:r>
+          </a:p>
+          <a:p>
+            <a:pPr algn="l">
+              <a:lnSpc>
+                <a:spcPct val="104000"/>
+              </a:lnSpc>
+              <a:spcBef>
+                <a:spcPts val="0"/>
+              </a:spcBef>
+              <a:spcAft>
+                <a:spcPts val="300"/>
+              </a:spcAft>
+            </a:pPr>
+            <a:r>
+              <a:rPr sz="819" b="1" i="0">
+                <a:solidFill>
+                  <a:srgbClr val="1B3E6E"/>
+                </a:solidFill>
+                <a:latin typeface="Arial"/>
+              </a:rPr>
+              <a:t>How: </a:t>
+            </a:r>
+            <a:r>
+              <a:rPr sz="819" b="0" i="0">
+                <a:solidFill>
+                  <a:srgbClr val="333333"/>
+                </a:solidFill>
+                <a:latin typeface="Arial"/>
+              </a:rPr>
+              <a:t>drops sequenced to lunch bells; doors unlock only near a registered school</a:t>
+            </a:r>
+          </a:p>
+          <a:p>
+            <a:pPr algn="l">
+              <a:lnSpc>
+                <a:spcPct val="105000"/>
+              </a:lnSpc>
+              <a:spcBef>
+                <a:spcPts val="0"/>
+              </a:spcBef>
+              <a:spcAft>
+                <a:spcPts val="0"/>
+              </a:spcAft>
+            </a:pPr>
+            <a:r>
+              <a:rPr sz="830" b="1" i="0">
+                <a:solidFill>
+                  <a:srgbClr val="398025"/>
+                </a:solidFill>
+                <a:latin typeface="Arial"/>
+              </a:rPr>
+              <a:t>→ 99%+ on-time · −18% km  ·  est. $80k saved / yr [dummy]</a:t>
             </a:r>
           </a:p>
         </p:txBody>

</xml_diff>

<commit_message>
Slide 8: solid center pie inside 2x2 quadrant grid (gaps top, solutions bottom)
Co-Authored-By: Claude Fable 5 <noreply@anthropic.com>
Claude-Session: https://claude.ai/code/session_01XoYepLRLVLdWS74xAsgg39
</commit_message>
<xml_diff>
--- a/AkshayaPatra_GS_Pitch.pptx
+++ b/AkshayaPatra_GS_Pitch.pptx
@@ -1161,13 +1161,10 @@
 
 <file path=ppt/charts/chart7.xml><?xml version="1.0" encoding="utf-8"?>
 <c:chartSpace xmlns:c="http://schemas.openxmlformats.org/drawingml/2006/chart" xmlns:a="http://schemas.openxmlformats.org/drawingml/2006/main" xmlns:r="http://schemas.openxmlformats.org/officeDocument/2006/relationships">
-  <c:date1904 val="0"/>
-  <c:roundedCorners val="0"/>
   <c:chart>
     <c:autoTitleDeleted val="1"/>
     <c:plotArea>
-      <c:layout/>
-      <c:doughnutChart>
+      <c:pieChart>
         <c:varyColors val="1"/>
         <c:ser>
           <c:idx val="0"/>
@@ -1189,7 +1186,7 @@
               <a:solidFill>
                 <a:srgbClr val="1B3E6E"/>
               </a:solidFill>
-              <a:ln w="19050">
+              <a:ln w="25400">
                 <a:solidFill>
                   <a:srgbClr val="FFFFFF"/>
                 </a:solidFill>
@@ -1202,7 +1199,7 @@
               <a:solidFill>
                 <a:srgbClr val="398025"/>
               </a:solidFill>
-              <a:ln w="19050">
+              <a:ln w="25400">
                 <a:solidFill>
                   <a:srgbClr val="FFFFFF"/>
                 </a:solidFill>
@@ -1246,7 +1243,7 @@
             <a:lstStyle/>
             <a:p>
               <a:pPr>
-                <a:defRPr sz="1000" b="1">
+                <a:defRPr sz="1100" b="1">
                   <a:solidFill>
                     <a:srgbClr val="FFFFFF"/>
                   </a:solidFill>
@@ -1262,26 +1259,28 @@
           <c:showBubbleSize val="0"/>
           <c:showLeaderLines val="1"/>
         </c:dLbls>
-        <c:firstSliceAng val="0"/>
-        <c:holeSize val="50"/>
-      </c:doughnutChart>
+      </c:pieChart>
     </c:plotArea>
-    <c:plotVisOnly val="1"/>
     <c:dispBlanksAs val="gap"/>
-    <c:showDLblsOverMax val="0"/>
   </c:chart>
   <c:txPr>
     <a:bodyPr/>
     <a:lstStyle/>
     <a:p>
       <a:pPr>
-        <a:defRPr sz="800">
+        <a:defRPr sz="900">
           <a:latin typeface="Arial"/>
         </a:defRPr>
       </a:pPr>
-      <a:endParaRPr/>
+      <a:endParaRPr lang="en-US"/>
     </a:p>
   </c:txPr>
+  <c:spPr>
+    <a:noFill/>
+    <a:ln>
+      <a:noFill/>
+    </a:ln>
+  </c:spPr>
   <c:externalData r:id="rId1">
     <c:autoUpdate val="0"/>
   </c:externalData>
@@ -20395,7 +20394,183 @@
         </p:nvSpPr>
         <p:spPr>
           <a:xfrm>
-            <a:off x="365760" y="1399032"/>
+            <a:off x="365760" y="1335024"/>
+            <a:ext cx="4133087" cy="2249424"/>
+          </a:xfrm>
+          <a:prstGeom prst="rect">
+            <a:avLst/>
+          </a:prstGeom>
+          <a:solidFill>
+            <a:srgbClr val="F4F4F4"/>
+          </a:solidFill>
+          <a:ln>
+            <a:noFill/>
+          </a:ln>
+          <a:effectLst/>
+        </p:spPr>
+        <p:style>
+          <a:lnRef idx="1">
+            <a:schemeClr val="accent1"/>
+          </a:lnRef>
+          <a:fillRef idx="3">
+            <a:schemeClr val="accent1"/>
+          </a:fillRef>
+          <a:effectRef idx="2">
+            <a:schemeClr val="accent1"/>
+          </a:effectRef>
+          <a:fontRef idx="minor">
+            <a:schemeClr val="lt1"/>
+          </a:fontRef>
+        </p:style>
+        <p:txBody>
+          <a:bodyPr rtlCol="0" anchor="ctr"/>
+          <a:lstStyle/>
+          <a:p>
+            <a:pPr algn="ctr"/>
+          </a:p>
+        </p:txBody>
+      </p:sp>
+      <p:sp>
+        <p:nvSpPr>
+          <p:cNvPr id="11" name="Rectangle 10"/>
+          <p:cNvSpPr/>
+          <p:nvPr/>
+        </p:nvSpPr>
+        <p:spPr>
+          <a:xfrm>
+            <a:off x="365760" y="3675887"/>
+            <a:ext cx="4133087" cy="2231136"/>
+          </a:xfrm>
+          <a:prstGeom prst="rect">
+            <a:avLst/>
+          </a:prstGeom>
+          <a:solidFill>
+            <a:srgbClr val="F4F4F4"/>
+          </a:solidFill>
+          <a:ln>
+            <a:noFill/>
+          </a:ln>
+          <a:effectLst/>
+        </p:spPr>
+        <p:style>
+          <a:lnRef idx="1">
+            <a:schemeClr val="accent1"/>
+          </a:lnRef>
+          <a:fillRef idx="3">
+            <a:schemeClr val="accent1"/>
+          </a:fillRef>
+          <a:effectRef idx="2">
+            <a:schemeClr val="accent1"/>
+          </a:effectRef>
+          <a:fontRef idx="minor">
+            <a:schemeClr val="lt1"/>
+          </a:fontRef>
+        </p:style>
+        <p:txBody>
+          <a:bodyPr rtlCol="0" anchor="ctr"/>
+          <a:lstStyle/>
+          <a:p>
+            <a:pPr algn="ctr"/>
+          </a:p>
+        </p:txBody>
+      </p:sp>
+      <p:sp>
+        <p:nvSpPr>
+          <p:cNvPr id="12" name="Rectangle 11"/>
+          <p:cNvSpPr/>
+          <p:nvPr/>
+        </p:nvSpPr>
+        <p:spPr>
+          <a:xfrm>
+            <a:off x="4645152" y="1335024"/>
+            <a:ext cx="4133087" cy="2249424"/>
+          </a:xfrm>
+          <a:prstGeom prst="rect">
+            <a:avLst/>
+          </a:prstGeom>
+          <a:solidFill>
+            <a:srgbClr val="F4F4F4"/>
+          </a:solidFill>
+          <a:ln>
+            <a:noFill/>
+          </a:ln>
+          <a:effectLst/>
+        </p:spPr>
+        <p:style>
+          <a:lnRef idx="1">
+            <a:schemeClr val="accent1"/>
+          </a:lnRef>
+          <a:fillRef idx="3">
+            <a:schemeClr val="accent1"/>
+          </a:fillRef>
+          <a:effectRef idx="2">
+            <a:schemeClr val="accent1"/>
+          </a:effectRef>
+          <a:fontRef idx="minor">
+            <a:schemeClr val="lt1"/>
+          </a:fontRef>
+        </p:style>
+        <p:txBody>
+          <a:bodyPr rtlCol="0" anchor="ctr"/>
+          <a:lstStyle/>
+          <a:p>
+            <a:pPr algn="ctr"/>
+          </a:p>
+        </p:txBody>
+      </p:sp>
+      <p:sp>
+        <p:nvSpPr>
+          <p:cNvPr id="13" name="Rectangle 12"/>
+          <p:cNvSpPr/>
+          <p:nvPr/>
+        </p:nvSpPr>
+        <p:spPr>
+          <a:xfrm>
+            <a:off x="4645152" y="3675887"/>
+            <a:ext cx="4133087" cy="2231136"/>
+          </a:xfrm>
+          <a:prstGeom prst="rect">
+            <a:avLst/>
+          </a:prstGeom>
+          <a:solidFill>
+            <a:srgbClr val="F4F4F4"/>
+          </a:solidFill>
+          <a:ln>
+            <a:noFill/>
+          </a:ln>
+          <a:effectLst/>
+        </p:spPr>
+        <p:style>
+          <a:lnRef idx="1">
+            <a:schemeClr val="accent1"/>
+          </a:lnRef>
+          <a:fillRef idx="3">
+            <a:schemeClr val="accent1"/>
+          </a:fillRef>
+          <a:effectRef idx="2">
+            <a:schemeClr val="accent1"/>
+          </a:effectRef>
+          <a:fontRef idx="minor">
+            <a:schemeClr val="lt1"/>
+          </a:fontRef>
+        </p:style>
+        <p:txBody>
+          <a:bodyPr rtlCol="0" anchor="ctr"/>
+          <a:lstStyle/>
+          <a:p>
+            <a:pPr algn="ctr"/>
+          </a:p>
+        </p:txBody>
+      </p:sp>
+      <p:sp>
+        <p:nvSpPr>
+          <p:cNvPr id="14" name="Rectangle 13"/>
+          <p:cNvSpPr/>
+          <p:nvPr/>
+        </p:nvSpPr>
+        <p:spPr>
+          <a:xfrm>
+            <a:off x="502920" y="1472184"/>
             <a:ext cx="54864" cy="182880"/>
           </a:xfrm>
           <a:prstGeom prst="rect">
@@ -20433,14 +20608,14 @@
       </p:sp>
       <p:sp>
         <p:nvSpPr>
-          <p:cNvPr id="11" name="TextBox 10"/>
+          <p:cNvPr id="15" name="TextBox 14"/>
           <p:cNvSpPr txBox="1"/>
           <p:nvPr/>
         </p:nvSpPr>
         <p:spPr>
           <a:xfrm>
-            <a:off x="512064" y="1371600"/>
-            <a:ext cx="2642615" cy="256032"/>
+            <a:off x="640080" y="1444752"/>
+            <a:ext cx="2926080" cy="237744"/>
           </a:xfrm>
           <a:prstGeom prst="rect">
             <a:avLst/>
@@ -20478,58 +20653,14 @@
       </p:sp>
       <p:sp>
         <p:nvSpPr>
-          <p:cNvPr id="12" name="Rectangle 11"/>
-          <p:cNvSpPr/>
-          <p:nvPr/>
-        </p:nvSpPr>
-        <p:spPr>
-          <a:xfrm>
-            <a:off x="365760" y="1645920"/>
-            <a:ext cx="2788920" cy="10972"/>
-          </a:xfrm>
-          <a:prstGeom prst="rect">
-            <a:avLst/>
-          </a:prstGeom>
-          <a:solidFill>
-            <a:srgbClr val="BFBFBF"/>
-          </a:solidFill>
-          <a:ln>
-            <a:noFill/>
-          </a:ln>
-          <a:effectLst/>
-        </p:spPr>
-        <p:style>
-          <a:lnRef idx="1">
-            <a:schemeClr val="accent1"/>
-          </a:lnRef>
-          <a:fillRef idx="3">
-            <a:schemeClr val="accent1"/>
-          </a:fillRef>
-          <a:effectRef idx="2">
-            <a:schemeClr val="accent1"/>
-          </a:effectRef>
-          <a:fontRef idx="minor">
-            <a:schemeClr val="lt1"/>
-          </a:fontRef>
-        </p:style>
-        <p:txBody>
-          <a:bodyPr rtlCol="0" anchor="ctr"/>
-          <a:lstStyle/>
-          <a:p>
-            <a:pPr algn="ctr"/>
-          </a:p>
-        </p:txBody>
-      </p:sp>
-      <p:sp>
-        <p:nvSpPr>
-          <p:cNvPr id="13" name="TextBox 12"/>
+          <p:cNvPr id="16" name="TextBox 15"/>
           <p:cNvSpPr txBox="1"/>
           <p:nvPr/>
         </p:nvSpPr>
         <p:spPr>
           <a:xfrm>
-            <a:off x="365760" y="1737360"/>
-            <a:ext cx="2788920" cy="1188720"/>
+            <a:off x="530352" y="1792224"/>
+            <a:ext cx="2788920" cy="1691640"/>
           </a:xfrm>
           <a:prstGeom prst="rect">
             <a:avLst/>
@@ -20544,7 +20675,7 @@
           <a:p>
             <a:pPr algn="l">
               <a:lnSpc>
-                <a:spcPct val="100000"/>
+                <a:spcPct val="104000"/>
               </a:lnSpc>
               <a:spcBef>
                 <a:spcPts val="0"/>
@@ -20554,28 +20685,28 @@
               </a:spcAft>
             </a:pPr>
             <a:r>
-              <a:rPr sz="780" b="1" i="0">
+              <a:rPr sz="800" b="1" i="0">
                 <a:solidFill>
                   <a:srgbClr val="333333"/>
                 </a:solidFill>
                 <a:latin typeface="Arial"/>
               </a:rPr>
-              <a:t>•  Manual indenting</a:t>
-            </a:r>
-            <a:r>
-              <a:rPr sz="780" b="0" i="0">
+              <a:t>•  Manual, gut-feel indenting</a:t>
+            </a:r>
+            <a:r>
+              <a:rPr sz="800" b="0" i="0">
                 <a:solidFill>
                   <a:srgbClr val="333333"/>
                 </a:solidFill>
                 <a:latin typeface="Arial"/>
               </a:rPr>
-              <a:t> — blind to attendance, exams &amp; holidays</a:t>
+              <a:t> — blind to attendance swings, exams &amp; holidays</a:t>
             </a:r>
           </a:p>
           <a:p>
             <a:pPr algn="l">
               <a:lnSpc>
-                <a:spcPct val="100000"/>
+                <a:spcPct val="104000"/>
               </a:lnSpc>
               <a:spcBef>
                 <a:spcPts val="0"/>
@@ -20585,16 +20716,16 @@
               </a:spcAft>
             </a:pPr>
             <a:r>
-              <a:rPr sz="780" b="1" i="0">
+              <a:rPr sz="800" b="1" i="0">
                 <a:solidFill>
                   <a:srgbClr val="333333"/>
                 </a:solidFill>
                 <a:latin typeface="Arial"/>
               </a:rPr>
-              <a:t>•  Spot-buying</a:t>
-            </a:r>
-            <a:r>
-              <a:rPr sz="780" b="0" i="0">
+              <a:t>•  Reactive spot-buying</a:t>
+            </a:r>
+            <a:r>
+              <a:rPr sz="800" b="0" i="0">
                 <a:solidFill>
                   <a:srgbClr val="333333"/>
                 </a:solidFill>
@@ -20606,7 +20737,7 @@
           <a:p>
             <a:pPr algn="l">
               <a:lnSpc>
-                <a:spcPct val="100000"/>
+                <a:spcPct val="104000"/>
               </a:lnSpc>
               <a:spcBef>
                 <a:spcPts val="0"/>
@@ -20616,7 +20747,7 @@
               </a:spcAft>
             </a:pPr>
             <a:r>
-              <a:rPr sz="780" b="1" i="0">
+              <a:rPr sz="800" b="1" i="0">
                 <a:solidFill>
                   <a:srgbClr val="333333"/>
                 </a:solidFill>
@@ -20625,48 +20756,48 @@
               <a:t>•  No feedback loop</a:t>
             </a:r>
             <a:r>
-              <a:rPr sz="780" b="0" i="0">
+              <a:rPr sz="800" b="0" i="0">
                 <a:solidFill>
                   <a:srgbClr val="333333"/>
                 </a:solidFill>
                 <a:latin typeface="Arial"/>
               </a:rPr>
-              <a:t> on actual meal uptake</a:t>
+              <a:t> from schools on actual meal uptake</a:t>
             </a:r>
           </a:p>
           <a:p>
             <a:pPr algn="l">
               <a:lnSpc>
-                <a:spcPct val="100000"/>
-              </a:lnSpc>
-              <a:spcBef>
-                <a:spcPts val="0"/>
-              </a:spcBef>
-              <a:spcAft>
-                <a:spcPts val="0"/>
-              </a:spcAft>
-            </a:pPr>
-            <a:r>
-              <a:rPr sz="780" b="1" i="0">
+                <a:spcPct val="104000"/>
+              </a:lnSpc>
+              <a:spcBef>
+                <a:spcPts val="0"/>
+              </a:spcBef>
+              <a:spcAft>
+                <a:spcPts val="0"/>
+              </a:spcAft>
+            </a:pPr>
+            <a:r>
+              <a:rPr sz="800" b="1" i="0">
                 <a:solidFill>
                   <a:srgbClr val="C22310"/>
                 </a:solidFill>
                 <a:latin typeface="Arial"/>
               </a:rPr>
-              <a:t>8–10% over-produced · +12% spot premium [dummy]</a:t>
-            </a:r>
-          </a:p>
-        </p:txBody>
-      </p:sp>
-      <p:sp>
-        <p:nvSpPr>
-          <p:cNvPr id="14" name="Rectangle 13"/>
+              <a:t>Cost today:  8–10% meals over-produced · +12% spot premium [dummy]</a:t>
+            </a:r>
+          </a:p>
+        </p:txBody>
+      </p:sp>
+      <p:sp>
+        <p:nvSpPr>
+          <p:cNvPr id="17" name="Rectangle 16"/>
           <p:cNvSpPr/>
           <p:nvPr/>
         </p:nvSpPr>
         <p:spPr>
           <a:xfrm>
-            <a:off x="5989320" y="1399032"/>
+            <a:off x="5833872" y="1472184"/>
             <a:ext cx="54864" cy="182880"/>
           </a:xfrm>
           <a:prstGeom prst="rect">
@@ -20704,14 +20835,14 @@
       </p:sp>
       <p:sp>
         <p:nvSpPr>
-          <p:cNvPr id="15" name="TextBox 14"/>
+          <p:cNvPr id="18" name="TextBox 17"/>
           <p:cNvSpPr txBox="1"/>
           <p:nvPr/>
         </p:nvSpPr>
         <p:spPr>
           <a:xfrm>
-            <a:off x="6135624" y="1371600"/>
-            <a:ext cx="2642615" cy="256032"/>
+            <a:off x="5971032" y="1444752"/>
+            <a:ext cx="2926080" cy="237744"/>
           </a:xfrm>
           <a:prstGeom prst="rect">
             <a:avLst/>
@@ -20749,20 +20880,158 @@
       </p:sp>
       <p:sp>
         <p:nvSpPr>
-          <p:cNvPr id="16" name="Rectangle 15"/>
+          <p:cNvPr id="19" name="TextBox 18"/>
+          <p:cNvSpPr txBox="1"/>
+          <p:nvPr/>
+        </p:nvSpPr>
+        <p:spPr>
+          <a:xfrm>
+            <a:off x="5852160" y="1792224"/>
+            <a:ext cx="2788920" cy="1691640"/>
+          </a:xfrm>
+          <a:prstGeom prst="rect">
+            <a:avLst/>
+          </a:prstGeom>
+          <a:noFill/>
+        </p:spPr>
+        <p:txBody>
+          <a:bodyPr wrap="square" lIns="0" rIns="0" tIns="0" bIns="0" anchor="t">
+            <a:spAutoFit/>
+          </a:bodyPr>
+          <a:lstStyle/>
+          <a:p>
+            <a:pPr algn="l">
+              <a:lnSpc>
+                <a:spcPct val="104000"/>
+              </a:lnSpc>
+              <a:spcBef>
+                <a:spcPts val="0"/>
+              </a:spcBef>
+              <a:spcAft>
+                <a:spcPts val="300"/>
+              </a:spcAft>
+            </a:pPr>
+            <a:r>
+              <a:rPr sz="800" b="1" i="0">
+                <a:solidFill>
+                  <a:srgbClr val="333333"/>
+                </a:solidFill>
+                <a:latin typeface="Arial"/>
+              </a:rPr>
+              <a:t>•  Static, driver-memory routes</a:t>
+            </a:r>
+            <a:r>
+              <a:rPr sz="800" b="0" i="0">
+                <a:solidFill>
+                  <a:srgbClr val="333333"/>
+                </a:solidFill>
+                <a:latin typeface="Arial"/>
+              </a:rPr>
+              <a:t> — late vans mean children stay hungry all day</a:t>
+            </a:r>
+          </a:p>
+          <a:p>
+            <a:pPr algn="l">
+              <a:lnSpc>
+                <a:spcPct val="104000"/>
+              </a:lnSpc>
+              <a:spcBef>
+                <a:spcPts val="0"/>
+              </a:spcBef>
+              <a:spcAft>
+                <a:spcPts val="300"/>
+              </a:spcAft>
+            </a:pPr>
+            <a:r>
+              <a:rPr sz="800" b="1" i="0">
+                <a:solidFill>
+                  <a:srgbClr val="333333"/>
+                </a:solidFill>
+                <a:latin typeface="Arial"/>
+              </a:rPr>
+              <a:t>•  Untracked vessels &amp; utensils</a:t>
+            </a:r>
+            <a:r>
+              <a:rPr sz="800" b="0" i="0">
+                <a:solidFill>
+                  <a:srgbClr val="333333"/>
+                </a:solidFill>
+                <a:latin typeface="Arial"/>
+              </a:rPr>
+              <a:t>; adulteration &amp; diversion risk en route</a:t>
+            </a:r>
+          </a:p>
+          <a:p>
+            <a:pPr algn="l">
+              <a:lnSpc>
+                <a:spcPct val="104000"/>
+              </a:lnSpc>
+              <a:spcBef>
+                <a:spcPts val="0"/>
+              </a:spcBef>
+              <a:spcAft>
+                <a:spcPts val="300"/>
+              </a:spcAft>
+            </a:pPr>
+            <a:r>
+              <a:rPr sz="800" b="1" i="0">
+                <a:solidFill>
+                  <a:srgbClr val="333333"/>
+                </a:solidFill>
+                <a:latin typeface="Arial"/>
+              </a:rPr>
+              <a:t>•  No proof-of-delivery</a:t>
+            </a:r>
+            <a:r>
+              <a:rPr sz="800" b="0" i="0">
+                <a:solidFill>
+                  <a:srgbClr val="333333"/>
+                </a:solidFill>
+                <a:latin typeface="Arial"/>
+              </a:rPr>
+              <a:t> — school shortfall disputes go unresolved</a:t>
+            </a:r>
+          </a:p>
+          <a:p>
+            <a:pPr algn="l">
+              <a:lnSpc>
+                <a:spcPct val="104000"/>
+              </a:lnSpc>
+              <a:spcBef>
+                <a:spcPts val="0"/>
+              </a:spcBef>
+              <a:spcAft>
+                <a:spcPts val="0"/>
+              </a:spcAft>
+            </a:pPr>
+            <a:r>
+              <a:rPr sz="800" b="1" i="0">
+                <a:solidFill>
+                  <a:srgbClr val="C22310"/>
+                </a:solidFill>
+                <a:latin typeface="Arial"/>
+              </a:rPr>
+              <a:t>Cost today:  6.2% miss the lunch window · $35k/yr shrinkage [dummy]</a:t>
+            </a:r>
+          </a:p>
+        </p:txBody>
+      </p:sp>
+      <p:sp>
+        <p:nvSpPr>
+          <p:cNvPr id="20" name="Rectangle 19"/>
           <p:cNvSpPr/>
           <p:nvPr/>
         </p:nvSpPr>
         <p:spPr>
           <a:xfrm>
-            <a:off x="5989320" y="1645920"/>
-            <a:ext cx="2788920" cy="10972"/>
+            <a:off x="502920" y="3813048"/>
+            <a:ext cx="54864" cy="182880"/>
           </a:xfrm>
           <a:prstGeom prst="rect">
             <a:avLst/>
           </a:prstGeom>
           <a:solidFill>
-            <a:srgbClr val="BFBFBF"/>
+            <a:srgbClr val="1B3E6E"/>
           </a:solidFill>
           <a:ln>
             <a:noFill/>
@@ -20793,14 +21062,14 @@
       </p:sp>
       <p:sp>
         <p:nvSpPr>
-          <p:cNvPr id="17" name="TextBox 16"/>
+          <p:cNvPr id="21" name="TextBox 20"/>
           <p:cNvSpPr txBox="1"/>
           <p:nvPr/>
         </p:nvSpPr>
         <p:spPr>
           <a:xfrm>
-            <a:off x="5989320" y="1737360"/>
-            <a:ext cx="2788920" cy="1188720"/>
+            <a:off x="640080" y="3785615"/>
+            <a:ext cx="2926080" cy="237744"/>
           </a:xfrm>
           <a:prstGeom prst="rect">
             <a:avLst/>
@@ -20821,32 +21090,388 @@
                 <a:spcPts val="0"/>
               </a:spcBef>
               <a:spcAft>
+                <a:spcPts val="0"/>
+              </a:spcAft>
+            </a:pPr>
+            <a:r>
+              <a:rPr sz="1050" b="1" i="0">
+                <a:solidFill>
+                  <a:srgbClr val="1B3E6E"/>
+                </a:solidFill>
+                <a:latin typeface="Arial"/>
+              </a:rPr>
+              <a:t>SOLUTION 1 — “Annapurna AI” · $150k</a:t>
+            </a:r>
+          </a:p>
+        </p:txBody>
+      </p:sp>
+      <p:sp>
+        <p:nvSpPr>
+          <p:cNvPr id="22" name="TextBox 21"/>
+          <p:cNvSpPr txBox="1"/>
+          <p:nvPr/>
+        </p:nvSpPr>
+        <p:spPr>
+          <a:xfrm>
+            <a:off x="530352" y="4133087"/>
+            <a:ext cx="2788920" cy="1691640"/>
+          </a:xfrm>
+          <a:prstGeom prst="rect">
+            <a:avLst/>
+          </a:prstGeom>
+          <a:noFill/>
+        </p:spPr>
+        <p:txBody>
+          <a:bodyPr wrap="square" lIns="0" rIns="0" tIns="0" bIns="0" anchor="t">
+            <a:spAutoFit/>
+          </a:bodyPr>
+          <a:lstStyle/>
+          <a:p>
+            <a:pPr algn="l">
+              <a:lnSpc>
+                <a:spcPct val="104000"/>
+              </a:lnSpc>
+              <a:spcBef>
+                <a:spcPts val="0"/>
+              </a:spcBef>
+              <a:spcAft>
                 <a:spcPts val="300"/>
               </a:spcAft>
             </a:pPr>
             <a:r>
+              <a:rPr sz="800" b="1" i="0">
+                <a:solidFill>
+                  <a:srgbClr val="1B3E6E"/>
+                </a:solidFill>
+                <a:latin typeface="Arial"/>
+              </a:rPr>
+              <a:t>What: </a:t>
+            </a:r>
+            <a:r>
+              <a:rPr sz="800" b="0" i="0">
+                <a:solidFill>
+                  <a:srgbClr val="333333"/>
+                </a:solidFill>
+                <a:latin typeface="Arial"/>
+              </a:rPr>
+              <a:t>ML demand-forecasting &amp; procurement planning across all 68 kitchens</a:t>
+            </a:r>
+          </a:p>
+          <a:p>
+            <a:pPr algn="l">
+              <a:lnSpc>
+                <a:spcPct val="104000"/>
+              </a:lnSpc>
+              <a:spcBef>
+                <a:spcPts val="0"/>
+              </a:spcBef>
+              <a:spcAft>
+                <a:spcPts val="300"/>
+              </a:spcAft>
+            </a:pPr>
+            <a:r>
+              <a:rPr sz="800" b="1" i="0">
+                <a:solidFill>
+                  <a:srgbClr val="1B3E6E"/>
+                </a:solidFill>
+                <a:latin typeface="Arial"/>
+              </a:rPr>
+              <a:t>How: </a:t>
+            </a:r>
+            <a:r>
+              <a:rPr sz="800" b="0" i="0">
+                <a:solidFill>
+                  <a:srgbClr val="333333"/>
+                </a:solidFill>
+                <a:latin typeface="Arial"/>
+              </a:rPr>
+              <a:t>predicts school-level attendance; auto-generates daily indents &amp; forward buying schedules</a:t>
+            </a:r>
+          </a:p>
+          <a:p>
+            <a:pPr algn="l">
+              <a:lnSpc>
+                <a:spcPct val="104000"/>
+              </a:lnSpc>
+              <a:spcBef>
+                <a:spcPts val="0"/>
+              </a:spcBef>
+              <a:spcAft>
+                <a:spcPts val="300"/>
+              </a:spcAft>
+            </a:pPr>
+            <a:r>
               <a:rPr sz="780" b="1" i="0">
                 <a:solidFill>
+                  <a:srgbClr val="727375"/>
+                </a:solidFill>
+                <a:latin typeface="Arial"/>
+              </a:rPr>
+              <a:t>Rollout: </a:t>
+            </a:r>
+            <a:r>
+              <a:rPr sz="780" b="0" i="0">
+                <a:solidFill>
+                  <a:srgbClr val="727375"/>
+                </a:solidFill>
+                <a:latin typeface="Arial"/>
+              </a:rPr>
+              <a:t>3-kitchen pilot (Mo 1–4) → all 68 kitchens by Mo 12</a:t>
+            </a:r>
+          </a:p>
+          <a:p>
+            <a:pPr algn="l">
+              <a:lnSpc>
+                <a:spcPct val="104000"/>
+              </a:lnSpc>
+              <a:spcBef>
+                <a:spcPts val="0"/>
+              </a:spcBef>
+              <a:spcAft>
+                <a:spcPts val="300"/>
+              </a:spcAft>
+            </a:pPr>
+            <a:r>
+              <a:rPr sz="819" b="1" i="0">
+                <a:solidFill>
+                  <a:srgbClr val="398025"/>
+                </a:solidFill>
+                <a:latin typeface="Arial"/>
+              </a:rPr>
+              <a:t>→  ~70% less food waste</a:t>
+            </a:r>
+          </a:p>
+          <a:p>
+            <a:pPr algn="l">
+              <a:lnSpc>
+                <a:spcPct val="104000"/>
+              </a:lnSpc>
+              <a:spcBef>
+                <a:spcPts val="0"/>
+              </a:spcBef>
+              <a:spcAft>
+                <a:spcPts val="0"/>
+              </a:spcAft>
+            </a:pPr>
+            <a:r>
+              <a:rPr sz="819" b="1" i="0">
+                <a:solidFill>
+                  <a:srgbClr val="398025"/>
+                </a:solidFill>
+                <a:latin typeface="Arial"/>
+              </a:rPr>
+              <a:t>→  est. $230k saved / yr [dummy]</a:t>
+            </a:r>
+          </a:p>
+        </p:txBody>
+      </p:sp>
+      <p:sp>
+        <p:nvSpPr>
+          <p:cNvPr id="23" name="Rectangle 22"/>
+          <p:cNvSpPr/>
+          <p:nvPr/>
+        </p:nvSpPr>
+        <p:spPr>
+          <a:xfrm>
+            <a:off x="5833872" y="3813048"/>
+            <a:ext cx="54864" cy="182880"/>
+          </a:xfrm>
+          <a:prstGeom prst="rect">
+            <a:avLst/>
+          </a:prstGeom>
+          <a:solidFill>
+            <a:srgbClr val="398025"/>
+          </a:solidFill>
+          <a:ln>
+            <a:noFill/>
+          </a:ln>
+          <a:effectLst/>
+        </p:spPr>
+        <p:style>
+          <a:lnRef idx="1">
+            <a:schemeClr val="accent1"/>
+          </a:lnRef>
+          <a:fillRef idx="3">
+            <a:schemeClr val="accent1"/>
+          </a:fillRef>
+          <a:effectRef idx="2">
+            <a:schemeClr val="accent1"/>
+          </a:effectRef>
+          <a:fontRef idx="minor">
+            <a:schemeClr val="lt1"/>
+          </a:fontRef>
+        </p:style>
+        <p:txBody>
+          <a:bodyPr rtlCol="0" anchor="ctr"/>
+          <a:lstStyle/>
+          <a:p>
+            <a:pPr algn="ctr"/>
+          </a:p>
+        </p:txBody>
+      </p:sp>
+      <p:sp>
+        <p:nvSpPr>
+          <p:cNvPr id="24" name="TextBox 23"/>
+          <p:cNvSpPr txBox="1"/>
+          <p:nvPr/>
+        </p:nvSpPr>
+        <p:spPr>
+          <a:xfrm>
+            <a:off x="5971032" y="3785615"/>
+            <a:ext cx="2926080" cy="237744"/>
+          </a:xfrm>
+          <a:prstGeom prst="rect">
+            <a:avLst/>
+          </a:prstGeom>
+          <a:noFill/>
+        </p:spPr>
+        <p:txBody>
+          <a:bodyPr wrap="square" lIns="0" rIns="0" tIns="0" bIns="0" anchor="t">
+            <a:spAutoFit/>
+          </a:bodyPr>
+          <a:lstStyle/>
+          <a:p>
+            <a:pPr algn="l">
+              <a:lnSpc>
+                <a:spcPct val="100000"/>
+              </a:lnSpc>
+              <a:spcBef>
+                <a:spcPts val="0"/>
+              </a:spcBef>
+              <a:spcAft>
+                <a:spcPts val="0"/>
+              </a:spcAft>
+            </a:pPr>
+            <a:r>
+              <a:rPr sz="1050" b="1" i="0">
+                <a:solidFill>
+                  <a:srgbClr val="1B3E6E"/>
+                </a:solidFill>
+                <a:latin typeface="Arial"/>
+              </a:rPr>
+              <a:t>SOLUTION 2 — “Last-Mile Shield” · $100k</a:t>
+            </a:r>
+          </a:p>
+        </p:txBody>
+      </p:sp>
+      <p:sp>
+        <p:nvSpPr>
+          <p:cNvPr id="25" name="TextBox 24"/>
+          <p:cNvSpPr txBox="1"/>
+          <p:nvPr/>
+        </p:nvSpPr>
+        <p:spPr>
+          <a:xfrm>
+            <a:off x="5852160" y="4133087"/>
+            <a:ext cx="2788920" cy="1691640"/>
+          </a:xfrm>
+          <a:prstGeom prst="rect">
+            <a:avLst/>
+          </a:prstGeom>
+          <a:noFill/>
+        </p:spPr>
+        <p:txBody>
+          <a:bodyPr wrap="square" lIns="0" rIns="0" tIns="0" bIns="0" anchor="t">
+            <a:spAutoFit/>
+          </a:bodyPr>
+          <a:lstStyle/>
+          <a:p>
+            <a:pPr algn="l">
+              <a:lnSpc>
+                <a:spcPct val="104000"/>
+              </a:lnSpc>
+              <a:spcBef>
+                <a:spcPts val="0"/>
+              </a:spcBef>
+              <a:spcAft>
+                <a:spcPts val="300"/>
+              </a:spcAft>
+            </a:pPr>
+            <a:r>
+              <a:rPr sz="800" b="1" i="0">
+                <a:solidFill>
+                  <a:srgbClr val="1B3E6E"/>
+                </a:solidFill>
+                <a:latin typeface="Arial"/>
+              </a:rPr>
+              <a:t>What: </a:t>
+            </a:r>
+            <a:r>
+              <a:rPr sz="800" b="0" i="0">
+                <a:solidFill>
                   <a:srgbClr val="333333"/>
                 </a:solidFill>
                 <a:latin typeface="Arial"/>
               </a:rPr>
-              <a:t>•  Static, driver-memory routes</a:t>
+              <a:t>AI route optimisation + telematics (GPS, cameras, RFID) + geofenced smart locks</a:t>
+            </a:r>
+          </a:p>
+          <a:p>
+            <a:pPr algn="l">
+              <a:lnSpc>
+                <a:spcPct val="104000"/>
+              </a:lnSpc>
+              <a:spcBef>
+                <a:spcPts val="0"/>
+              </a:spcBef>
+              <a:spcAft>
+                <a:spcPts val="300"/>
+              </a:spcAft>
+            </a:pPr>
+            <a:r>
+              <a:rPr sz="800" b="1" i="0">
+                <a:solidFill>
+                  <a:srgbClr val="1B3E6E"/>
+                </a:solidFill>
+                <a:latin typeface="Arial"/>
+              </a:rPr>
+              <a:t>How: </a:t>
+            </a:r>
+            <a:r>
+              <a:rPr sz="800" b="0" i="0">
+                <a:solidFill>
+                  <a:srgbClr val="333333"/>
+                </a:solidFill>
+                <a:latin typeface="Arial"/>
+              </a:rPr>
+              <a:t>drops sequenced to each school's lunch bell; doors unlock only near a registered school</a:t>
+            </a:r>
+          </a:p>
+          <a:p>
+            <a:pPr algn="l">
+              <a:lnSpc>
+                <a:spcPct val="104000"/>
+              </a:lnSpc>
+              <a:spcBef>
+                <a:spcPts val="0"/>
+              </a:spcBef>
+              <a:spcAft>
+                <a:spcPts val="300"/>
+              </a:spcAft>
+            </a:pPr>
+            <a:r>
+              <a:rPr sz="780" b="1" i="0">
+                <a:solidFill>
+                  <a:srgbClr val="727375"/>
+                </a:solidFill>
+                <a:latin typeface="Arial"/>
+              </a:rPr>
+              <a:t>Bonus: </a:t>
             </a:r>
             <a:r>
               <a:rPr sz="780" b="0" i="0">
                 <a:solidFill>
-                  <a:srgbClr val="333333"/>
-                </a:solidFill>
-                <a:latin typeface="Arial"/>
-              </a:rPr>
-              <a:t> — late vans mean children stay hungry all day</a:t>
+                  <a:srgbClr val="727375"/>
+                </a:solidFill>
+                <a:latin typeface="Arial"/>
+              </a:rPr>
+              <a:t>3 vans freed per hub redeployed to reach new schools</a:t>
             </a:r>
           </a:p>
           <a:p>
             <a:pPr algn="l">
               <a:lnSpc>
-                <a:spcPct val="100000"/>
+                <a:spcPct val="104000"/>
               </a:lnSpc>
               <a:spcBef>
                 <a:spcPts val="0"/>
@@ -20856,90 +21481,96 @@
               </a:spcAft>
             </a:pPr>
             <a:r>
-              <a:rPr sz="780" b="1" i="0">
-                <a:solidFill>
-                  <a:srgbClr val="333333"/>
-                </a:solidFill>
-                <a:latin typeface="Arial"/>
-              </a:rPr>
-              <a:t>•  Untracked vessels</a:t>
-            </a:r>
-            <a:r>
-              <a:rPr sz="780" b="0" i="0">
-                <a:solidFill>
-                  <a:srgbClr val="333333"/>
-                </a:solidFill>
-                <a:latin typeface="Arial"/>
-              </a:rPr>
-              <a:t>; adulteration &amp; diversion risk en route</a:t>
+              <a:rPr sz="819" b="1" i="0">
+                <a:solidFill>
+                  <a:srgbClr val="398025"/>
+                </a:solidFill>
+                <a:latin typeface="Arial"/>
+              </a:rPr>
+              <a:t>→  99%+ on-time · −18% fleet km</a:t>
             </a:r>
           </a:p>
           <a:p>
             <a:pPr algn="l">
               <a:lnSpc>
-                <a:spcPct val="100000"/>
-              </a:lnSpc>
-              <a:spcBef>
-                <a:spcPts val="0"/>
-              </a:spcBef>
-              <a:spcAft>
-                <a:spcPts val="300"/>
-              </a:spcAft>
-            </a:pPr>
-            <a:r>
-              <a:rPr sz="780" b="1" i="0">
-                <a:solidFill>
-                  <a:srgbClr val="333333"/>
-                </a:solidFill>
-                <a:latin typeface="Arial"/>
-              </a:rPr>
-              <a:t>•  No proof-of-delivery</a:t>
-            </a:r>
-            <a:r>
-              <a:rPr sz="780" b="0" i="0">
-                <a:solidFill>
-                  <a:srgbClr val="333333"/>
-                </a:solidFill>
-                <a:latin typeface="Arial"/>
-              </a:rPr>
-              <a:t> — disputes go unresolved</a:t>
-            </a:r>
-          </a:p>
-          <a:p>
-            <a:pPr algn="l">
-              <a:lnSpc>
-                <a:spcPct val="100000"/>
-              </a:lnSpc>
-              <a:spcBef>
-                <a:spcPts val="0"/>
-              </a:spcBef>
-              <a:spcAft>
-                <a:spcPts val="0"/>
-              </a:spcAft>
-            </a:pPr>
-            <a:r>
-              <a:rPr sz="780" b="1" i="0">
-                <a:solidFill>
-                  <a:srgbClr val="C22310"/>
-                </a:solidFill>
-                <a:latin typeface="Arial"/>
-              </a:rPr>
-              <a:t>6.2% miss lunch window · $35k/yr shrinkage [dummy]</a:t>
-            </a:r>
+                <a:spcPct val="104000"/>
+              </a:lnSpc>
+              <a:spcBef>
+                <a:spcPts val="0"/>
+              </a:spcBef>
+              <a:spcAft>
+                <a:spcPts val="0"/>
+              </a:spcAft>
+            </a:pPr>
+            <a:r>
+              <a:rPr sz="819" b="1" i="0">
+                <a:solidFill>
+                  <a:srgbClr val="398025"/>
+                </a:solidFill>
+                <a:latin typeface="Arial"/>
+              </a:rPr>
+              <a:t>→  est. $80k saved / yr [dummy]</a:t>
+            </a:r>
+          </a:p>
+        </p:txBody>
+      </p:sp>
+      <p:sp>
+        <p:nvSpPr>
+          <p:cNvPr id="26" name="Oval 25"/>
+          <p:cNvSpPr/>
+          <p:nvPr/>
+        </p:nvSpPr>
+        <p:spPr>
+          <a:xfrm>
+            <a:off x="3337560" y="2386584"/>
+            <a:ext cx="2468880" cy="2468880"/>
+          </a:xfrm>
+          <a:prstGeom prst="ellipse">
+            <a:avLst/>
+          </a:prstGeom>
+          <a:solidFill>
+            <a:srgbClr val="FFFFFF"/>
+          </a:solidFill>
+          <a:ln w="12700">
+            <a:solidFill>
+              <a:srgbClr val="BFBFBF"/>
+            </a:solidFill>
+          </a:ln>
+          <a:effectLst/>
+        </p:spPr>
+        <p:style>
+          <a:lnRef idx="1">
+            <a:schemeClr val="accent1"/>
+          </a:lnRef>
+          <a:fillRef idx="3">
+            <a:schemeClr val="accent1"/>
+          </a:fillRef>
+          <a:effectRef idx="2">
+            <a:schemeClr val="accent1"/>
+          </a:effectRef>
+          <a:fontRef idx="minor">
+            <a:schemeClr val="lt1"/>
+          </a:fontRef>
+        </p:style>
+        <p:txBody>
+          <a:bodyPr rtlCol="0" anchor="ctr"/>
+          <a:lstStyle/>
+          <a:p>
+            <a:pPr algn="ctr"/>
           </a:p>
         </p:txBody>
       </p:sp>
       <p:graphicFrame>
         <p:nvGraphicFramePr>
-          <p:cNvPr id="18" name="Chart 17"/>
+          <p:cNvPr id="27" name="Chart 26"/>
           <p:cNvGraphicFramePr>
             <a:graphicFrameLocks noGrp="1"/>
           </p:cNvGraphicFramePr>
           <p:nvPr/>
         </p:nvGraphicFramePr>
         <p:xfrm>
-          <a:off x="3273552" y="2331720"/>
-          <a:ext cx="2606040" cy="2240280"/>
+          <a:off x="3406140" y="2455164"/>
+          <a:ext cx="2331720" cy="2331720"/>
         </p:xfrm>
         <a:graphic>
           <a:graphicData uri="http://schemas.openxmlformats.org/drawingml/2006/chart">
@@ -20949,245 +21580,26 @@
       </p:graphicFrame>
       <p:sp>
         <p:nvSpPr>
-          <p:cNvPr id="19" name="TextBox 18"/>
-          <p:cNvSpPr txBox="1"/>
-          <p:nvPr/>
-        </p:nvSpPr>
-        <p:spPr>
-          <a:xfrm>
-            <a:off x="3273552" y="4626864"/>
-            <a:ext cx="2606040" cy="402336"/>
-          </a:xfrm>
-          <a:prstGeom prst="rect">
-            <a:avLst/>
-          </a:prstGeom>
-          <a:noFill/>
-        </p:spPr>
-        <p:txBody>
-          <a:bodyPr wrap="square" lIns="0" rIns="0" tIns="0" bIns="0" anchor="t">
-            <a:spAutoFit/>
-          </a:bodyPr>
-          <a:lstStyle/>
-          <a:p>
-            <a:pPr algn="ctr">
-              <a:lnSpc>
-                <a:spcPct val="100000"/>
-              </a:lnSpc>
-              <a:spcBef>
-                <a:spcPts val="0"/>
-              </a:spcBef>
-              <a:spcAft>
-                <a:spcPts val="100"/>
-              </a:spcAft>
-            </a:pPr>
-            <a:r>
-              <a:rPr sz="950" b="1" i="0">
-                <a:solidFill>
-                  <a:srgbClr val="1B3E6E"/>
-                </a:solidFill>
-                <a:latin typeface="Arial"/>
-              </a:rPr>
-              <a:t>THE $250k GRANT</a:t>
-            </a:r>
-          </a:p>
-          <a:p>
-            <a:pPr algn="ctr">
-              <a:lnSpc>
-                <a:spcPct val="100000"/>
-              </a:lnSpc>
-              <a:spcBef>
-                <a:spcPts val="0"/>
-              </a:spcBef>
-              <a:spcAft>
-                <a:spcPts val="0"/>
-              </a:spcAft>
-            </a:pPr>
-            <a:r>
-              <a:rPr sz="720" b="0" i="1">
-                <a:solidFill>
-                  <a:srgbClr val="727375"/>
-                </a:solidFill>
-                <a:latin typeface="Arial"/>
-              </a:rPr>
-              <a:t>60 / 40 — weighted to the costlier gap</a:t>
-            </a:r>
-          </a:p>
-        </p:txBody>
-      </p:sp>
-      <p:cxnSp>
-        <p:nvCxnSpPr>
-          <p:cNvPr id="20" name="Connector 19"/>
-          <p:cNvCxnSpPr/>
-          <p:nvPr/>
-        </p:nvCxnSpPr>
-        <p:spPr>
-          <a:xfrm>
-            <a:off x="3246120" y="2331720"/>
-            <a:ext cx="548640" cy="548640"/>
-          </a:xfrm>
-          <a:prstGeom prst="curvedConnector3">
-            <a:avLst/>
-          </a:prstGeom>
-          <a:ln w="13970">
-            <a:solidFill>
-              <a:srgbClr val="C22310"/>
-            </a:solidFill>
-            <a:prstDash val="sysDash"/>
-            <a:tailEnd type="triangle" w="med" len="med"/>
-          </a:ln>
-          <a:effectLst/>
-        </p:spPr>
-        <p:style>
-          <a:lnRef idx="2">
-            <a:schemeClr val="accent1"/>
-          </a:lnRef>
-          <a:fillRef idx="0">
-            <a:schemeClr val="accent1"/>
-          </a:fillRef>
-          <a:effectRef idx="1">
-            <a:schemeClr val="accent1"/>
-          </a:effectRef>
-          <a:fontRef idx="minor">
-            <a:schemeClr val="tx1"/>
-          </a:fontRef>
-        </p:style>
-      </p:cxnSp>
-      <p:cxnSp>
-        <p:nvCxnSpPr>
-          <p:cNvPr id="21" name="Connector 20"/>
-          <p:cNvCxnSpPr/>
-          <p:nvPr/>
-        </p:nvCxnSpPr>
-        <p:spPr>
-          <a:xfrm flipH="1">
-            <a:off x="5349240" y="2331720"/>
-            <a:ext cx="548640" cy="548640"/>
-          </a:xfrm>
-          <a:prstGeom prst="curvedConnector3">
-            <a:avLst/>
-          </a:prstGeom>
-          <a:ln w="13970">
-            <a:solidFill>
-              <a:srgbClr val="C22310"/>
-            </a:solidFill>
-            <a:prstDash val="sysDash"/>
-            <a:tailEnd type="triangle" w="med" len="med"/>
-          </a:ln>
-          <a:effectLst/>
-        </p:spPr>
-        <p:style>
-          <a:lnRef idx="2">
-            <a:schemeClr val="accent1"/>
-          </a:lnRef>
-          <a:fillRef idx="0">
-            <a:schemeClr val="accent1"/>
-          </a:fillRef>
-          <a:effectRef idx="1">
-            <a:schemeClr val="accent1"/>
-          </a:effectRef>
-          <a:fontRef idx="minor">
-            <a:schemeClr val="tx1"/>
-          </a:fontRef>
-        </p:style>
-      </p:cxnSp>
-      <p:cxnSp>
-        <p:nvCxnSpPr>
-          <p:cNvPr id="22" name="Connector 21"/>
-          <p:cNvCxnSpPr/>
-          <p:nvPr/>
-        </p:nvCxnSpPr>
-        <p:spPr>
-          <a:xfrm flipH="1">
-            <a:off x="3209544" y="4160520"/>
-            <a:ext cx="539495" cy="457200"/>
-          </a:xfrm>
-          <a:prstGeom prst="curvedConnector3">
-            <a:avLst/>
-          </a:prstGeom>
-          <a:ln w="13970">
-            <a:solidFill>
-              <a:srgbClr val="1B3E6E"/>
-            </a:solidFill>
-            <a:prstDash val="sysDash"/>
-            <a:tailEnd type="triangle" w="med" len="med"/>
-          </a:ln>
-          <a:effectLst/>
-        </p:spPr>
-        <p:style>
-          <a:lnRef idx="2">
-            <a:schemeClr val="accent1"/>
-          </a:lnRef>
-          <a:fillRef idx="0">
-            <a:schemeClr val="accent1"/>
-          </a:fillRef>
-          <a:effectRef idx="1">
-            <a:schemeClr val="accent1"/>
-          </a:effectRef>
-          <a:fontRef idx="minor">
-            <a:schemeClr val="tx1"/>
-          </a:fontRef>
-        </p:style>
-      </p:cxnSp>
-      <p:cxnSp>
-        <p:nvCxnSpPr>
-          <p:cNvPr id="23" name="Connector 22"/>
-          <p:cNvCxnSpPr/>
-          <p:nvPr/>
-        </p:nvCxnSpPr>
-        <p:spPr>
-          <a:xfrm>
-            <a:off x="5394960" y="4160520"/>
-            <a:ext cx="539496" cy="457200"/>
-          </a:xfrm>
-          <a:prstGeom prst="curvedConnector3">
-            <a:avLst/>
-          </a:prstGeom>
-          <a:ln w="13970">
-            <a:solidFill>
-              <a:srgbClr val="398025"/>
-            </a:solidFill>
-            <a:prstDash val="sysDash"/>
-            <a:tailEnd type="triangle" w="med" len="med"/>
-          </a:ln>
-          <a:effectLst/>
-        </p:spPr>
-        <p:style>
-          <a:lnRef idx="2">
-            <a:schemeClr val="accent1"/>
-          </a:lnRef>
-          <a:fillRef idx="0">
-            <a:schemeClr val="accent1"/>
-          </a:fillRef>
-          <a:effectRef idx="1">
-            <a:schemeClr val="accent1"/>
-          </a:effectRef>
-          <a:fontRef idx="minor">
-            <a:schemeClr val="tx1"/>
-          </a:fontRef>
-        </p:style>
-      </p:cxnSp>
-      <p:sp>
-        <p:nvSpPr>
-          <p:cNvPr id="24" name="Rounded Rectangle 23"/>
+          <p:cNvPr id="28" name="Rounded Rectangle 27"/>
           <p:cNvSpPr/>
           <p:nvPr/>
         </p:nvSpPr>
         <p:spPr>
           <a:xfrm>
-            <a:off x="365760" y="3931920"/>
-            <a:ext cx="2788920" cy="1783080"/>
+            <a:off x="3520440" y="4837176"/>
+            <a:ext cx="2103120" cy="365760"/>
           </a:xfrm>
           <a:prstGeom prst="roundRect">
             <a:avLst>
-              <a:gd name="adj" fmla="val 5000"/>
+              <a:gd name="adj" fmla="val 50000"/>
             </a:avLst>
           </a:prstGeom>
           <a:solidFill>
-            <a:srgbClr val="EEF3F9"/>
+            <a:srgbClr val="FFFFFF"/>
           </a:solidFill>
-          <a:ln w="12700">
+          <a:ln w="11430">
             <a:solidFill>
-              <a:srgbClr val="1B3E6E"/>
+              <a:srgbClr val="BFBFBF"/>
             </a:solidFill>
           </a:ln>
           <a:effectLst/>
@@ -21216,14 +21628,14 @@
       </p:sp>
       <p:sp>
         <p:nvSpPr>
-          <p:cNvPr id="25" name="TextBox 24"/>
+          <p:cNvPr id="29" name="TextBox 28"/>
           <p:cNvSpPr txBox="1"/>
           <p:nvPr/>
         </p:nvSpPr>
         <p:spPr>
           <a:xfrm>
-            <a:off x="484632" y="4014215"/>
-            <a:ext cx="2551176" cy="1645920"/>
+            <a:off x="3520440" y="4860036"/>
+            <a:ext cx="2103120" cy="320040"/>
           </a:xfrm>
           <a:prstGeom prst="rect">
             <a:avLst/>
@@ -21231,293 +21643,52 @@
           <a:noFill/>
         </p:spPr>
         <p:txBody>
-          <a:bodyPr wrap="square" lIns="0" rIns="0" tIns="0" bIns="0" anchor="t">
+          <a:bodyPr wrap="square" lIns="0" rIns="0" tIns="0" bIns="0" anchor="ctr">
             <a:spAutoFit/>
           </a:bodyPr>
           <a:lstStyle/>
           <a:p>
-            <a:pPr algn="l">
-              <a:lnSpc>
-                <a:spcPct val="95000"/>
-              </a:lnSpc>
-              <a:spcBef>
-                <a:spcPts val="0"/>
-              </a:spcBef>
-              <a:spcAft>
-                <a:spcPts val="300"/>
-              </a:spcAft>
-            </a:pPr>
-            <a:r>
-              <a:rPr sz="950" b="1" i="0">
+            <a:pPr algn="ctr">
+              <a:lnSpc>
+                <a:spcPct val="100000"/>
+              </a:lnSpc>
+              <a:spcBef>
+                <a:spcPts val="0"/>
+              </a:spcBef>
+              <a:spcAft>
+                <a:spcPts val="0"/>
+              </a:spcAft>
+            </a:pPr>
+            <a:r>
+              <a:rPr sz="850" b="1" i="0">
                 <a:solidFill>
                   <a:srgbClr val="1B3E6E"/>
                 </a:solidFill>
                 <a:latin typeface="Arial"/>
               </a:rPr>
-              <a:t>SOLUTION 1
-“Annapurna AI” · $150k</a:t>
-            </a:r>
-          </a:p>
-          <a:p>
-            <a:pPr algn="l">
-              <a:lnSpc>
-                <a:spcPct val="104000"/>
-              </a:lnSpc>
-              <a:spcBef>
-                <a:spcPts val="0"/>
-              </a:spcBef>
-              <a:spcAft>
-                <a:spcPts val="300"/>
-              </a:spcAft>
-            </a:pPr>
-            <a:r>
-              <a:rPr sz="819" b="1" i="0">
-                <a:solidFill>
-                  <a:srgbClr val="1B3E6E"/>
-                </a:solidFill>
-                <a:latin typeface="Arial"/>
-              </a:rPr>
-              <a:t>What: </a:t>
-            </a:r>
-            <a:r>
-              <a:rPr sz="819" b="0" i="0">
-                <a:solidFill>
-                  <a:srgbClr val="333333"/>
-                </a:solidFill>
-                <a:latin typeface="Arial"/>
-              </a:rPr>
-              <a:t>ML demand-forecasting &amp; procurement planning for all 68 kitchens</a:t>
-            </a:r>
-          </a:p>
-          <a:p>
-            <a:pPr algn="l">
-              <a:lnSpc>
-                <a:spcPct val="104000"/>
-              </a:lnSpc>
-              <a:spcBef>
-                <a:spcPts val="0"/>
-              </a:spcBef>
-              <a:spcAft>
-                <a:spcPts val="300"/>
-              </a:spcAft>
-            </a:pPr>
-            <a:r>
-              <a:rPr sz="819" b="1" i="0">
-                <a:solidFill>
-                  <a:srgbClr val="1B3E6E"/>
-                </a:solidFill>
-                <a:latin typeface="Arial"/>
-              </a:rPr>
-              <a:t>How: </a:t>
-            </a:r>
-            <a:r>
-              <a:rPr sz="819" b="0" i="0">
-                <a:solidFill>
-                  <a:srgbClr val="333333"/>
-                </a:solidFill>
-                <a:latin typeface="Arial"/>
-              </a:rPr>
-              <a:t>predicts school-level attendance; auto-generates indents &amp; buying schedules</a:t>
-            </a:r>
-          </a:p>
-          <a:p>
-            <a:pPr algn="l">
-              <a:lnSpc>
-                <a:spcPct val="105000"/>
-              </a:lnSpc>
-              <a:spcBef>
-                <a:spcPts val="0"/>
-              </a:spcBef>
-              <a:spcAft>
-                <a:spcPts val="0"/>
-              </a:spcAft>
-            </a:pPr>
-            <a:r>
-              <a:rPr sz="830" b="1" i="0">
-                <a:solidFill>
-                  <a:srgbClr val="398025"/>
-                </a:solidFill>
-                <a:latin typeface="Arial"/>
-              </a:rPr>
-              <a:t>→ ~70% less waste  ·  est. $230k saved / yr [dummy]</a:t>
-            </a:r>
-          </a:p>
-        </p:txBody>
-      </p:sp>
-      <p:sp>
-        <p:nvSpPr>
-          <p:cNvPr id="26" name="Rounded Rectangle 25"/>
-          <p:cNvSpPr/>
-          <p:nvPr/>
-        </p:nvSpPr>
-        <p:spPr>
-          <a:xfrm>
-            <a:off x="5989320" y="3931920"/>
-            <a:ext cx="2788920" cy="1783080"/>
-          </a:xfrm>
-          <a:prstGeom prst="roundRect">
-            <a:avLst>
-              <a:gd name="adj" fmla="val 5000"/>
-            </a:avLst>
-          </a:prstGeom>
-          <a:solidFill>
-            <a:srgbClr val="EAF3E6"/>
-          </a:solidFill>
-          <a:ln w="12700">
-            <a:solidFill>
-              <a:srgbClr val="398025"/>
-            </a:solidFill>
-          </a:ln>
-          <a:effectLst/>
-        </p:spPr>
-        <p:style>
-          <a:lnRef idx="1">
-            <a:schemeClr val="accent1"/>
-          </a:lnRef>
-          <a:fillRef idx="3">
-            <a:schemeClr val="accent1"/>
-          </a:fillRef>
-          <a:effectRef idx="2">
-            <a:schemeClr val="accent1"/>
-          </a:effectRef>
-          <a:fontRef idx="minor">
-            <a:schemeClr val="lt1"/>
-          </a:fontRef>
-        </p:style>
-        <p:txBody>
-          <a:bodyPr rtlCol="0" anchor="ctr"/>
-          <a:lstStyle/>
-          <a:p>
-            <a:pPr algn="ctr"/>
-          </a:p>
-        </p:txBody>
-      </p:sp>
-      <p:sp>
-        <p:nvSpPr>
-          <p:cNvPr id="27" name="TextBox 26"/>
-          <p:cNvSpPr txBox="1"/>
-          <p:nvPr/>
-        </p:nvSpPr>
-        <p:spPr>
-          <a:xfrm>
-            <a:off x="6108192" y="4014215"/>
-            <a:ext cx="2551176" cy="1645920"/>
-          </a:xfrm>
-          <a:prstGeom prst="rect">
-            <a:avLst/>
-          </a:prstGeom>
-          <a:noFill/>
-        </p:spPr>
-        <p:txBody>
-          <a:bodyPr wrap="square" lIns="0" rIns="0" tIns="0" bIns="0" anchor="t">
-            <a:spAutoFit/>
-          </a:bodyPr>
-          <a:lstStyle/>
-          <a:p>
-            <a:pPr algn="l">
-              <a:lnSpc>
-                <a:spcPct val="95000"/>
-              </a:lnSpc>
-              <a:spcBef>
-                <a:spcPts val="0"/>
-              </a:spcBef>
-              <a:spcAft>
-                <a:spcPts val="300"/>
-              </a:spcAft>
-            </a:pPr>
-            <a:r>
-              <a:rPr sz="950" b="1" i="0">
-                <a:solidFill>
-                  <a:srgbClr val="398025"/>
-                </a:solidFill>
-                <a:latin typeface="Arial"/>
-              </a:rPr>
-              <a:t>SOLUTION 2
-“Last-Mile Shield” · $100k</a:t>
-            </a:r>
-          </a:p>
-          <a:p>
-            <a:pPr algn="l">
-              <a:lnSpc>
-                <a:spcPct val="104000"/>
-              </a:lnSpc>
-              <a:spcBef>
-                <a:spcPts val="0"/>
-              </a:spcBef>
-              <a:spcAft>
-                <a:spcPts val="300"/>
-              </a:spcAft>
-            </a:pPr>
-            <a:r>
-              <a:rPr sz="819" b="1" i="0">
-                <a:solidFill>
-                  <a:srgbClr val="1B3E6E"/>
-                </a:solidFill>
-                <a:latin typeface="Arial"/>
-              </a:rPr>
-              <a:t>What: </a:t>
-            </a:r>
-            <a:r>
-              <a:rPr sz="819" b="0" i="0">
-                <a:solidFill>
-                  <a:srgbClr val="333333"/>
-                </a:solidFill>
-                <a:latin typeface="Arial"/>
-              </a:rPr>
-              <a:t>AI routing + telematics (GPS, cameras, RFID) + geofenced smart locks</a:t>
-            </a:r>
-          </a:p>
-          <a:p>
-            <a:pPr algn="l">
-              <a:lnSpc>
-                <a:spcPct val="104000"/>
-              </a:lnSpc>
-              <a:spcBef>
-                <a:spcPts val="0"/>
-              </a:spcBef>
-              <a:spcAft>
-                <a:spcPts val="300"/>
-              </a:spcAft>
-            </a:pPr>
-            <a:r>
-              <a:rPr sz="819" b="1" i="0">
-                <a:solidFill>
-                  <a:srgbClr val="1B3E6E"/>
-                </a:solidFill>
-                <a:latin typeface="Arial"/>
-              </a:rPr>
-              <a:t>How: </a:t>
-            </a:r>
-            <a:r>
-              <a:rPr sz="819" b="0" i="0">
-                <a:solidFill>
-                  <a:srgbClr val="333333"/>
-                </a:solidFill>
-                <a:latin typeface="Arial"/>
-              </a:rPr>
-              <a:t>drops sequenced to lunch bells; doors unlock only near a registered school</a:t>
-            </a:r>
-          </a:p>
-          <a:p>
-            <a:pPr algn="l">
-              <a:lnSpc>
-                <a:spcPct val="105000"/>
-              </a:lnSpc>
-              <a:spcBef>
-                <a:spcPts val="0"/>
-              </a:spcBef>
-              <a:spcAft>
-                <a:spcPts val="0"/>
-              </a:spcAft>
-            </a:pPr>
-            <a:r>
-              <a:rPr sz="830" b="1" i="0">
-                <a:solidFill>
-                  <a:srgbClr val="398025"/>
-                </a:solidFill>
-                <a:latin typeface="Arial"/>
-              </a:rPr>
-              <a:t>→ 99%+ on-time · −18% km  ·  est. $80k saved / yr [dummy]</a:t>
+              <a:t>THE $250k GRANT</a:t>
+            </a:r>
+          </a:p>
+          <a:p>
+            <a:pPr algn="ctr">
+              <a:lnSpc>
+                <a:spcPct val="100000"/>
+              </a:lnSpc>
+              <a:spcBef>
+                <a:spcPts val="0"/>
+              </a:spcBef>
+              <a:spcAft>
+                <a:spcPts val="0"/>
+              </a:spcAft>
+            </a:pPr>
+            <a:r>
+              <a:rPr sz="660" b="0" i="1">
+                <a:solidFill>
+                  <a:srgbClr val="727375"/>
+                </a:solidFill>
+                <a:latin typeface="Arial"/>
+              </a:rPr>
+              <a:t>60 / 40 — weighted to the costlier gap</a:t>
             </a:r>
           </a:p>
         </p:txBody>

</xml_diff>

<commit_message>
Add slide 11: proposed savings-waterfall graph for slide 4 (compare with slide 9)
Co-Authored-By: Claude Fable 5 <noreply@anthropic.com>
Claude-Session: https://claude.ai/code/session_01XoYepLRLVLdWS74xAsgg39
</commit_message>
<xml_diff>
--- a/AkshayaPatra_GS_Pitch.pptx
+++ b/AkshayaPatra_GS_Pitch.pptx
@@ -15,6 +15,7 @@
     <p:sldId id="263" r:id="rId14"/>
     <p:sldId id="264" r:id="rId15"/>
     <p:sldId id="265" r:id="rId16"/>
+    <p:sldId id="266" r:id="rId17"/>
   </p:sldIdLst>
   <p:sldSz cx="9144000" cy="6858000" type="screen4x3"/>
   <p:notesSz cx="6858000" cy="9144000"/>
@@ -1541,6 +1542,173 @@
     <a:p>
       <a:pPr>
         <a:defRPr sz="700">
+          <a:solidFill>
+            <a:srgbClr val="333333"/>
+          </a:solidFill>
+          <a:latin typeface="Arial"/>
+        </a:defRPr>
+      </a:pPr>
+      <a:endParaRPr lang="en-US"/>
+    </a:p>
+  </c:txPr>
+  <c:externalData r:id="rId1">
+    <c:autoUpdate val="0"/>
+  </c:externalData>
+</c:chartSpace>
+</file>
+
+<file path=ppt/charts/chart9.xml><?xml version="1.0" encoding="utf-8"?>
+<c:chartSpace xmlns:c="http://schemas.openxmlformats.org/drawingml/2006/chart" xmlns:a="http://schemas.openxmlformats.org/drawingml/2006/main" xmlns:r="http://schemas.openxmlformats.org/officeDocument/2006/relationships">
+  <c:date1904 val="0"/>
+  <c:chart>
+    <c:autoTitleDeleted val="1"/>
+    <c:plotArea>
+      <c:barChart>
+        <c:barDir val="col"/>
+        <c:grouping val="clustered"/>
+        <c:ser>
+          <c:idx val="0"/>
+          <c:order val="0"/>
+          <c:tx>
+            <c:strRef>
+              <c:f>Sheet1!$B$1</c:f>
+              <c:strCache>
+                <c:ptCount val="1"/>
+                <c:pt idx="0">
+                  <c:v>saved</c:v>
+                </c:pt>
+              </c:strCache>
+            </c:strRef>
+          </c:tx>
+          <c:spPr>
+            <a:solidFill>
+              <a:srgbClr val="398025"/>
+            </a:solidFill>
+            <a:ln>
+              <a:noFill/>
+            </a:ln>
+          </c:spPr>
+          <c:cat>
+            <c:strRef>
+              <c:f>Sheet1!$A$2:$A$5</c:f>
+              <c:strCache>
+                <c:ptCount val="4"/>
+                <c:pt idx="0">
+                  <c:v>2026</c:v>
+                </c:pt>
+                <c:pt idx="1">
+                  <c:v>2027</c:v>
+                </c:pt>
+                <c:pt idx="2">
+                  <c:v>2028</c:v>
+                </c:pt>
+                <c:pt idx="3">
+                  <c:v>2029</c:v>
+                </c:pt>
+              </c:strCache>
+            </c:strRef>
+          </c:cat>
+          <c:val>
+            <c:numRef>
+              <c:f>Sheet1!$B$2:$B$5</c:f>
+              <c:numCache>
+                <c:formatCode>General</c:formatCode>
+                <c:ptCount val="4"/>
+                <c:pt idx="0">
+                  <c:v>1.8</c:v>
+                </c:pt>
+                <c:pt idx="1">
+                  <c:v>3.6</c:v>
+                </c:pt>
+                <c:pt idx="2">
+                  <c:v>5.1</c:v>
+                </c:pt>
+                <c:pt idx="3">
+                  <c:v>5.1</c:v>
+                </c:pt>
+              </c:numCache>
+            </c:numRef>
+          </c:val>
+        </c:ser>
+        <c:dLbls>
+          <c:txPr>
+            <a:bodyPr/>
+            <a:lstStyle/>
+            <a:p>
+              <a:pPr>
+                <a:defRPr sz="650" b="1">
+                  <a:solidFill>
+                    <a:srgbClr val="1B3E6E"/>
+                  </a:solidFill>
+                </a:defRPr>
+              </a:pPr>
+            </a:p>
+          </c:txPr>
+          <c:showLegendKey val="0"/>
+          <c:showVal val="1"/>
+          <c:showCatName val="0"/>
+          <c:showSerName val="0"/>
+          <c:showPercent val="0"/>
+          <c:showBubbleSize val="0"/>
+          <c:showLeaderLines val="1"/>
+        </c:dLbls>
+        <c:gapWidth val="60"/>
+        <c:axId val="-2068027336"/>
+        <c:axId val="-2113994440"/>
+      </c:barChart>
+      <c:catAx>
+        <c:axId val="-2068027336"/>
+        <c:scaling>
+          <c:orientation val="minMax"/>
+        </c:scaling>
+        <c:delete val="0"/>
+        <c:axPos val="b"/>
+        <c:majorTickMark val="out"/>
+        <c:minorTickMark val="none"/>
+        <c:tickLblPos val="nextTo"/>
+        <c:spPr>
+          <a:ln>
+            <a:solidFill>
+              <a:srgbClr val="BFBFBF"/>
+            </a:solidFill>
+          </a:ln>
+        </c:spPr>
+        <c:txPr>
+          <a:bodyPr/>
+          <a:lstStyle/>
+          <a:p>
+            <a:pPr>
+              <a:defRPr sz="650"/>
+            </a:pPr>
+          </a:p>
+        </c:txPr>
+        <c:crossAx val="-2113994440"/>
+        <c:crosses val="autoZero"/>
+        <c:auto val="1"/>
+        <c:lblAlgn val="ctr"/>
+        <c:lblOffset val="100"/>
+        <c:noMultiLvlLbl val="0"/>
+      </c:catAx>
+      <c:valAx>
+        <c:axId val="-2113994440"/>
+        <c:scaling/>
+        <c:delete/>
+        <c:axPos val="l"/>
+        <c:majorTickMark val="out"/>
+        <c:minorTickMark val="none"/>
+        <c:tickLblPos val="nextTo"/>
+        <c:crossAx val="-2068027336"/>
+        <c:crosses val="autoZero"/>
+      </c:valAx>
+    </c:plotArea>
+    <c:dispBlanksAs val="gap"/>
+  </c:chart>
+  <c:txPr>
+    <a:bodyPr/>
+    <a:lstStyle/>
+    <a:p>
+      <a:pPr>
+        <a:defRPr sz="650">
           <a:solidFill>
             <a:srgbClr val="333333"/>
           </a:solidFill>
@@ -9429,6 +9597,2263 @@
                 <a:latin typeface="Arial"/>
               </a:rPr>
               <a:t>Deutsche Bank (Pune kitchen '26) · IOCL (solar) + leading corporates</a:t>
+            </a:r>
+          </a:p>
+        </p:txBody>
+      </p:sp>
+    </p:spTree>
+  </p:cSld>
+  <p:clrMapOvr>
+    <a:masterClrMapping/>
+  </p:clrMapOvr>
+</p:sld>
+</file>
+
+<file path=ppt/slides/slide11.xml><?xml version="1.0" encoding="utf-8"?>
+<p:sld xmlns:a="http://schemas.openxmlformats.org/drawingml/2006/main" xmlns:p="http://schemas.openxmlformats.org/presentationml/2006/main" xmlns:r="http://schemas.openxmlformats.org/officeDocument/2006/relationships">
+  <p:cSld>
+    <p:spTree>
+      <p:nvGrpSpPr>
+        <p:cNvPr id="1" name=""/>
+        <p:cNvGrpSpPr/>
+        <p:nvPr/>
+      </p:nvGrpSpPr>
+      <p:grpSpPr/>
+      <p:sp>
+        <p:nvSpPr>
+          <p:cNvPr id="2" name="Rectangle 1"/>
+          <p:cNvSpPr/>
+          <p:nvPr/>
+        </p:nvSpPr>
+        <p:spPr>
+          <a:xfrm>
+            <a:off x="365760" y="274320"/>
+            <a:ext cx="8412480" cy="23774"/>
+          </a:xfrm>
+          <a:prstGeom prst="rect">
+            <a:avLst/>
+          </a:prstGeom>
+          <a:solidFill>
+            <a:srgbClr val="1B3E6E"/>
+          </a:solidFill>
+          <a:ln>
+            <a:noFill/>
+          </a:ln>
+          <a:effectLst/>
+        </p:spPr>
+        <p:style>
+          <a:lnRef idx="1">
+            <a:schemeClr val="accent1"/>
+          </a:lnRef>
+          <a:fillRef idx="3">
+            <a:schemeClr val="accent1"/>
+          </a:fillRef>
+          <a:effectRef idx="2">
+            <a:schemeClr val="accent1"/>
+          </a:effectRef>
+          <a:fontRef idx="minor">
+            <a:schemeClr val="lt1"/>
+          </a:fontRef>
+        </p:style>
+        <p:txBody>
+          <a:bodyPr rtlCol="0" anchor="ctr"/>
+          <a:lstStyle/>
+          <a:p>
+            <a:pPr algn="ctr"/>
+          </a:p>
+        </p:txBody>
+      </p:sp>
+      <p:sp>
+        <p:nvSpPr>
+          <p:cNvPr id="3" name="TextBox 2"/>
+          <p:cNvSpPr txBox="1"/>
+          <p:nvPr/>
+        </p:nvSpPr>
+        <p:spPr>
+          <a:xfrm>
+            <a:off x="365760" y="365760"/>
+            <a:ext cx="8412480" cy="457200"/>
+          </a:xfrm>
+          <a:prstGeom prst="rect">
+            <a:avLst/>
+          </a:prstGeom>
+          <a:noFill/>
+        </p:spPr>
+        <p:txBody>
+          <a:bodyPr wrap="square" lIns="0" rIns="0" tIns="0" bIns="0" anchor="t">
+            <a:spAutoFit/>
+          </a:bodyPr>
+          <a:lstStyle/>
+          <a:p>
+            <a:pPr algn="l">
+              <a:lnSpc>
+                <a:spcPct val="100000"/>
+              </a:lnSpc>
+              <a:spcBef>
+                <a:spcPts val="0"/>
+              </a:spcBef>
+              <a:spcAft>
+                <a:spcPts val="0"/>
+              </a:spcAft>
+            </a:pPr>
+            <a:r>
+              <a:rPr sz="2000" b="0" i="0">
+                <a:solidFill>
+                  <a:srgbClr val="1B3E6E"/>
+                </a:solidFill>
+                <a:latin typeface="Georgia"/>
+              </a:rPr>
+              <a:t>Solution 1 — where the savings come from, and what they buy</a:t>
+            </a:r>
+          </a:p>
+        </p:txBody>
+      </p:sp>
+      <p:sp>
+        <p:nvSpPr>
+          <p:cNvPr id="4" name="TextBox 3"/>
+          <p:cNvSpPr txBox="1"/>
+          <p:nvPr/>
+        </p:nvSpPr>
+        <p:spPr>
+          <a:xfrm>
+            <a:off x="365760" y="822960"/>
+            <a:ext cx="8412480" cy="438912"/>
+          </a:xfrm>
+          <a:prstGeom prst="rect">
+            <a:avLst/>
+          </a:prstGeom>
+          <a:noFill/>
+        </p:spPr>
+        <p:txBody>
+          <a:bodyPr wrap="square" lIns="0" rIns="0" tIns="0" bIns="0" anchor="t">
+            <a:spAutoFit/>
+          </a:bodyPr>
+          <a:lstStyle/>
+          <a:p>
+            <a:pPr algn="l">
+              <a:lnSpc>
+                <a:spcPct val="100000"/>
+              </a:lnSpc>
+              <a:spcBef>
+                <a:spcPts val="0"/>
+              </a:spcBef>
+              <a:spcAft>
+                <a:spcPts val="0"/>
+              </a:spcAft>
+            </a:pPr>
+            <a:r>
+              <a:rPr sz="1050" b="0" i="0">
+                <a:solidFill>
+                  <a:srgbClr val="333333"/>
+                </a:solidFill>
+                <a:latin typeface="Arial"/>
+              </a:rPr>
+              <a:t>Every bar is a number from TAPF's own data — wastage logs and seasonal price spreads — built up transparently into recurring annual impact.</a:t>
+            </a:r>
+          </a:p>
+        </p:txBody>
+      </p:sp>
+      <p:sp>
+        <p:nvSpPr>
+          <p:cNvPr id="5" name="Rectangle 4"/>
+          <p:cNvSpPr/>
+          <p:nvPr/>
+        </p:nvSpPr>
+        <p:spPr>
+          <a:xfrm>
+            <a:off x="502920" y="6071616"/>
+            <a:ext cx="8138159" cy="365760"/>
+          </a:xfrm>
+          <a:prstGeom prst="rect">
+            <a:avLst/>
+          </a:prstGeom>
+          <a:solidFill>
+            <a:srgbClr val="D9D9D9"/>
+          </a:solidFill>
+          <a:ln>
+            <a:noFill/>
+          </a:ln>
+          <a:effectLst/>
+        </p:spPr>
+        <p:style>
+          <a:lnRef idx="1">
+            <a:schemeClr val="accent1"/>
+          </a:lnRef>
+          <a:fillRef idx="3">
+            <a:schemeClr val="accent1"/>
+          </a:fillRef>
+          <a:effectRef idx="2">
+            <a:schemeClr val="accent1"/>
+          </a:effectRef>
+          <a:fontRef idx="minor">
+            <a:schemeClr val="lt1"/>
+          </a:fontRef>
+        </p:style>
+        <p:txBody>
+          <a:bodyPr rtlCol="0" anchor="ctr"/>
+          <a:lstStyle/>
+          <a:p>
+            <a:pPr algn="ctr"/>
+          </a:p>
+        </p:txBody>
+      </p:sp>
+      <p:sp>
+        <p:nvSpPr>
+          <p:cNvPr id="6" name="TextBox 5"/>
+          <p:cNvSpPr txBox="1"/>
+          <p:nvPr/>
+        </p:nvSpPr>
+        <p:spPr>
+          <a:xfrm>
+            <a:off x="640080" y="6071616"/>
+            <a:ext cx="7863840" cy="365760"/>
+          </a:xfrm>
+          <a:prstGeom prst="rect">
+            <a:avLst/>
+          </a:prstGeom>
+          <a:noFill/>
+        </p:spPr>
+        <p:txBody>
+          <a:bodyPr wrap="square" lIns="0" rIns="0" tIns="0" bIns="0" anchor="ctr">
+            <a:spAutoFit/>
+          </a:bodyPr>
+          <a:lstStyle/>
+          <a:p>
+            <a:pPr algn="ctr">
+              <a:lnSpc>
+                <a:spcPct val="95000"/>
+              </a:lnSpc>
+              <a:spcBef>
+                <a:spcPts val="0"/>
+              </a:spcBef>
+              <a:spcAft>
+                <a:spcPts val="0"/>
+              </a:spcAft>
+            </a:pPr>
+            <a:r>
+              <a:rPr sz="1100" b="1" i="0">
+                <a:solidFill>
+                  <a:srgbClr val="1B3E6E"/>
+                </a:solidFill>
+                <a:latin typeface="Georgia"/>
+              </a:rPr>
+              <a:t>₹6 Cr saved every year = 9M+ more meals = 40,000+ children fed for a full year — recurring, audited, conservative.</a:t>
+            </a:r>
+          </a:p>
+        </p:txBody>
+      </p:sp>
+      <p:sp>
+        <p:nvSpPr>
+          <p:cNvPr id="7" name="TextBox 6"/>
+          <p:cNvSpPr txBox="1"/>
+          <p:nvPr/>
+        </p:nvSpPr>
+        <p:spPr>
+          <a:xfrm>
+            <a:off x="365760" y="6492240"/>
+            <a:ext cx="1280160" cy="329184"/>
+          </a:xfrm>
+          <a:prstGeom prst="rect">
+            <a:avLst/>
+          </a:prstGeom>
+          <a:noFill/>
+        </p:spPr>
+        <p:txBody>
+          <a:bodyPr wrap="square" lIns="0" rIns="0" tIns="0" bIns="0" anchor="t">
+            <a:spAutoFit/>
+          </a:bodyPr>
+          <a:lstStyle/>
+          <a:p>
+            <a:pPr algn="l">
+              <a:lnSpc>
+                <a:spcPct val="90000"/>
+              </a:lnSpc>
+              <a:spcBef>
+                <a:spcPts val="0"/>
+              </a:spcBef>
+              <a:spcAft>
+                <a:spcPts val="0"/>
+              </a:spcAft>
+            </a:pPr>
+            <a:r>
+              <a:rPr sz="900" b="1" i="0">
+                <a:solidFill>
+                  <a:srgbClr val="111111"/>
+                </a:solidFill>
+                <a:latin typeface="Georgia"/>
+              </a:rPr>
+              <a:t>Goldman</a:t>
+            </a:r>
+          </a:p>
+          <a:p>
+            <a:pPr algn="l">
+              <a:lnSpc>
+                <a:spcPct val="90000"/>
+              </a:lnSpc>
+              <a:spcBef>
+                <a:spcPts val="0"/>
+              </a:spcBef>
+              <a:spcAft>
+                <a:spcPts val="0"/>
+              </a:spcAft>
+            </a:pPr>
+            <a:r>
+              <a:rPr sz="900" b="1" i="0">
+                <a:solidFill>
+                  <a:srgbClr val="111111"/>
+                </a:solidFill>
+                <a:latin typeface="Georgia"/>
+              </a:rPr>
+              <a:t>Sachs</a:t>
+            </a:r>
+          </a:p>
+        </p:txBody>
+      </p:sp>
+      <p:sp>
+        <p:nvSpPr>
+          <p:cNvPr id="8" name="TextBox 7"/>
+          <p:cNvSpPr txBox="1"/>
+          <p:nvPr/>
+        </p:nvSpPr>
+        <p:spPr>
+          <a:xfrm>
+            <a:off x="8321040" y="6528816"/>
+            <a:ext cx="457200" cy="274320"/>
+          </a:xfrm>
+          <a:prstGeom prst="rect">
+            <a:avLst/>
+          </a:prstGeom>
+          <a:noFill/>
+        </p:spPr>
+        <p:txBody>
+          <a:bodyPr wrap="square" lIns="0" rIns="0" tIns="0" bIns="0" anchor="t">
+            <a:spAutoFit/>
+          </a:bodyPr>
+          <a:lstStyle/>
+          <a:p>
+            <a:pPr algn="r">
+              <a:lnSpc>
+                <a:spcPct val="100000"/>
+              </a:lnSpc>
+              <a:spcBef>
+                <a:spcPts val="0"/>
+              </a:spcBef>
+              <a:spcAft>
+                <a:spcPts val="300"/>
+              </a:spcAft>
+            </a:pPr>
+            <a:r>
+              <a:rPr sz="900" b="0" i="0">
+                <a:solidFill>
+                  <a:srgbClr val="727375"/>
+                </a:solidFill>
+                <a:latin typeface="Arial"/>
+              </a:rPr>
+              <a:t>11</a:t>
+            </a:r>
+          </a:p>
+        </p:txBody>
+      </p:sp>
+      <p:sp>
+        <p:nvSpPr>
+          <p:cNvPr id="9" name="TextBox 8"/>
+          <p:cNvSpPr txBox="1"/>
+          <p:nvPr/>
+        </p:nvSpPr>
+        <p:spPr>
+          <a:xfrm>
+            <a:off x="5120640" y="54864"/>
+            <a:ext cx="3657600" cy="182880"/>
+          </a:xfrm>
+          <a:prstGeom prst="rect">
+            <a:avLst/>
+          </a:prstGeom>
+          <a:noFill/>
+        </p:spPr>
+        <p:txBody>
+          <a:bodyPr wrap="square" lIns="0" rIns="0" tIns="0" bIns="0" anchor="t">
+            <a:spAutoFit/>
+          </a:bodyPr>
+          <a:lstStyle/>
+          <a:p>
+            <a:pPr algn="r">
+              <a:lnSpc>
+                <a:spcPct val="100000"/>
+              </a:lnSpc>
+              <a:spcBef>
+                <a:spcPts val="0"/>
+              </a:spcBef>
+              <a:spcAft>
+                <a:spcPts val="0"/>
+              </a:spcAft>
+            </a:pPr>
+            <a:r>
+              <a:rPr sz="750" b="0" i="1">
+                <a:solidFill>
+                  <a:srgbClr val="727375"/>
+                </a:solidFill>
+                <a:latin typeface="Arial"/>
+              </a:rPr>
+              <a:t>PROPOSED SLIDE 4 GRAPH — v2 (compare with slide 9)</a:t>
+            </a:r>
+          </a:p>
+        </p:txBody>
+      </p:sp>
+      <p:sp>
+        <p:nvSpPr>
+          <p:cNvPr id="10" name="Rectangle 9"/>
+          <p:cNvSpPr/>
+          <p:nvPr/>
+        </p:nvSpPr>
+        <p:spPr>
+          <a:xfrm>
+            <a:off x="365760" y="1399032"/>
+            <a:ext cx="54864" cy="182880"/>
+          </a:xfrm>
+          <a:prstGeom prst="rect">
+            <a:avLst/>
+          </a:prstGeom>
+          <a:solidFill>
+            <a:srgbClr val="1B3E6E"/>
+          </a:solidFill>
+          <a:ln>
+            <a:noFill/>
+          </a:ln>
+          <a:effectLst/>
+        </p:spPr>
+        <p:style>
+          <a:lnRef idx="1">
+            <a:schemeClr val="accent1"/>
+          </a:lnRef>
+          <a:fillRef idx="3">
+            <a:schemeClr val="accent1"/>
+          </a:fillRef>
+          <a:effectRef idx="2">
+            <a:schemeClr val="accent1"/>
+          </a:effectRef>
+          <a:fontRef idx="minor">
+            <a:schemeClr val="lt1"/>
+          </a:fontRef>
+        </p:style>
+        <p:txBody>
+          <a:bodyPr rtlCol="0" anchor="ctr"/>
+          <a:lstStyle/>
+          <a:p>
+            <a:pPr algn="ctr"/>
+          </a:p>
+        </p:txBody>
+      </p:sp>
+      <p:sp>
+        <p:nvSpPr>
+          <p:cNvPr id="11" name="TextBox 10"/>
+          <p:cNvSpPr txBox="1"/>
+          <p:nvPr/>
+        </p:nvSpPr>
+        <p:spPr>
+          <a:xfrm>
+            <a:off x="512064" y="1371600"/>
+            <a:ext cx="4974336" cy="256032"/>
+          </a:xfrm>
+          <a:prstGeom prst="rect">
+            <a:avLst/>
+          </a:prstGeom>
+          <a:noFill/>
+        </p:spPr>
+        <p:txBody>
+          <a:bodyPr wrap="square" lIns="0" rIns="0" tIns="0" bIns="0" anchor="t">
+            <a:spAutoFit/>
+          </a:bodyPr>
+          <a:lstStyle/>
+          <a:p>
+            <a:pPr algn="l">
+              <a:lnSpc>
+                <a:spcPct val="100000"/>
+              </a:lnSpc>
+              <a:spcBef>
+                <a:spcPts val="0"/>
+              </a:spcBef>
+              <a:spcAft>
+                <a:spcPts val="0"/>
+              </a:spcAft>
+            </a:pPr>
+            <a:r>
+              <a:rPr sz="1150" b="1" i="0">
+                <a:solidFill>
+                  <a:srgbClr val="1B3E6E"/>
+                </a:solidFill>
+                <a:latin typeface="Arial"/>
+              </a:rPr>
+              <a:t>Annual savings build-up (₹ Cr / year)</a:t>
+            </a:r>
+          </a:p>
+        </p:txBody>
+      </p:sp>
+      <p:sp>
+        <p:nvSpPr>
+          <p:cNvPr id="12" name="Rectangle 11"/>
+          <p:cNvSpPr/>
+          <p:nvPr/>
+        </p:nvSpPr>
+        <p:spPr>
+          <a:xfrm>
+            <a:off x="365760" y="1645920"/>
+            <a:ext cx="5120640" cy="10972"/>
+          </a:xfrm>
+          <a:prstGeom prst="rect">
+            <a:avLst/>
+          </a:prstGeom>
+          <a:solidFill>
+            <a:srgbClr val="BFBFBF"/>
+          </a:solidFill>
+          <a:ln>
+            <a:noFill/>
+          </a:ln>
+          <a:effectLst/>
+        </p:spPr>
+        <p:style>
+          <a:lnRef idx="1">
+            <a:schemeClr val="accent1"/>
+          </a:lnRef>
+          <a:fillRef idx="3">
+            <a:schemeClr val="accent1"/>
+          </a:fillRef>
+          <a:effectRef idx="2">
+            <a:schemeClr val="accent1"/>
+          </a:effectRef>
+          <a:fontRef idx="minor">
+            <a:schemeClr val="lt1"/>
+          </a:fontRef>
+        </p:style>
+        <p:txBody>
+          <a:bodyPr rtlCol="0" anchor="ctr"/>
+          <a:lstStyle/>
+          <a:p>
+            <a:pPr algn="ctr"/>
+          </a:p>
+        </p:txBody>
+      </p:sp>
+      <p:sp>
+        <p:nvSpPr>
+          <p:cNvPr id="13" name="Rectangle 12"/>
+          <p:cNvSpPr/>
+          <p:nvPr/>
+        </p:nvSpPr>
+        <p:spPr>
+          <a:xfrm>
+            <a:off x="365760" y="4846320"/>
+            <a:ext cx="5074920" cy="12801"/>
+          </a:xfrm>
+          <a:prstGeom prst="rect">
+            <a:avLst/>
+          </a:prstGeom>
+          <a:solidFill>
+            <a:srgbClr val="BFBFBF"/>
+          </a:solidFill>
+          <a:ln>
+            <a:noFill/>
+          </a:ln>
+          <a:effectLst/>
+        </p:spPr>
+        <p:style>
+          <a:lnRef idx="1">
+            <a:schemeClr val="accent1"/>
+          </a:lnRef>
+          <a:fillRef idx="3">
+            <a:schemeClr val="accent1"/>
+          </a:fillRef>
+          <a:effectRef idx="2">
+            <a:schemeClr val="accent1"/>
+          </a:effectRef>
+          <a:fontRef idx="minor">
+            <a:schemeClr val="lt1"/>
+          </a:fontRef>
+        </p:style>
+        <p:txBody>
+          <a:bodyPr rtlCol="0" anchor="ctr"/>
+          <a:lstStyle/>
+          <a:p>
+            <a:pPr algn="ctr"/>
+          </a:p>
+        </p:txBody>
+      </p:sp>
+      <p:sp>
+        <p:nvSpPr>
+          <p:cNvPr id="14" name="Rectangle 13"/>
+          <p:cNvSpPr/>
+          <p:nvPr/>
+        </p:nvSpPr>
+        <p:spPr>
+          <a:xfrm>
+            <a:off x="566928" y="3421684"/>
+            <a:ext cx="731520" cy="1424635"/>
+          </a:xfrm>
+          <a:prstGeom prst="rect">
+            <a:avLst/>
+          </a:prstGeom>
+          <a:solidFill>
+            <a:srgbClr val="398025"/>
+          </a:solidFill>
+          <a:ln>
+            <a:noFill/>
+          </a:ln>
+          <a:effectLst/>
+        </p:spPr>
+        <p:style>
+          <a:lnRef idx="1">
+            <a:schemeClr val="accent1"/>
+          </a:lnRef>
+          <a:fillRef idx="3">
+            <a:schemeClr val="accent1"/>
+          </a:fillRef>
+          <a:effectRef idx="2">
+            <a:schemeClr val="accent1"/>
+          </a:effectRef>
+          <a:fontRef idx="minor">
+            <a:schemeClr val="lt1"/>
+          </a:fontRef>
+        </p:style>
+        <p:txBody>
+          <a:bodyPr rtlCol="0" anchor="ctr"/>
+          <a:lstStyle/>
+          <a:p>
+            <a:pPr algn="ctr"/>
+          </a:p>
+        </p:txBody>
+      </p:sp>
+      <p:sp>
+        <p:nvSpPr>
+          <p:cNvPr id="15" name="TextBox 14"/>
+          <p:cNvSpPr txBox="1"/>
+          <p:nvPr/>
+        </p:nvSpPr>
+        <p:spPr>
+          <a:xfrm>
+            <a:off x="429768" y="3202228"/>
+            <a:ext cx="1005840" cy="201168"/>
+          </a:xfrm>
+          <a:prstGeom prst="rect">
+            <a:avLst/>
+          </a:prstGeom>
+          <a:noFill/>
+        </p:spPr>
+        <p:txBody>
+          <a:bodyPr wrap="square" lIns="0" rIns="0" tIns="0" bIns="0" anchor="t">
+            <a:spAutoFit/>
+          </a:bodyPr>
+          <a:lstStyle/>
+          <a:p>
+            <a:pPr algn="ctr">
+              <a:lnSpc>
+                <a:spcPct val="100000"/>
+              </a:lnSpc>
+              <a:spcBef>
+                <a:spcPts val="0"/>
+              </a:spcBef>
+              <a:spcAft>
+                <a:spcPts val="0"/>
+              </a:spcAft>
+            </a:pPr>
+            <a:r>
+              <a:rPr sz="950" b="1" i="0">
+                <a:solidFill>
+                  <a:srgbClr val="1B3E6E"/>
+                </a:solidFill>
+                <a:latin typeface="Arial"/>
+              </a:rPr>
+              <a:t>+4.1</a:t>
+            </a:r>
+          </a:p>
+        </p:txBody>
+      </p:sp>
+      <p:sp>
+        <p:nvSpPr>
+          <p:cNvPr id="16" name="TextBox 15"/>
+          <p:cNvSpPr txBox="1"/>
+          <p:nvPr/>
+        </p:nvSpPr>
+        <p:spPr>
+          <a:xfrm>
+            <a:off x="420623" y="4901183"/>
+            <a:ext cx="1024128" cy="502920"/>
+          </a:xfrm>
+          <a:prstGeom prst="rect">
+            <a:avLst/>
+          </a:prstGeom>
+          <a:noFill/>
+        </p:spPr>
+        <p:txBody>
+          <a:bodyPr wrap="square" lIns="0" rIns="0" tIns="0" bIns="0" anchor="t">
+            <a:spAutoFit/>
+          </a:bodyPr>
+          <a:lstStyle/>
+          <a:p>
+            <a:pPr algn="ctr">
+              <a:lnSpc>
+                <a:spcPct val="90000"/>
+              </a:lnSpc>
+              <a:spcBef>
+                <a:spcPts val="0"/>
+              </a:spcBef>
+              <a:spcAft>
+                <a:spcPts val="100"/>
+              </a:spcAft>
+            </a:pPr>
+            <a:r>
+              <a:rPr sz="690" b="1" i="0">
+                <a:solidFill>
+                  <a:srgbClr val="333333"/>
+                </a:solidFill>
+                <a:latin typeface="Arial"/>
+              </a:rPr>
+              <a:t>Veg waste cut
+4.9% → 2%</a:t>
+            </a:r>
+          </a:p>
+          <a:p>
+            <a:pPr algn="ctr">
+              <a:lnSpc>
+                <a:spcPct val="100000"/>
+              </a:lnSpc>
+              <a:spcBef>
+                <a:spcPts val="0"/>
+              </a:spcBef>
+              <a:spcAft>
+                <a:spcPts val="0"/>
+              </a:spcAft>
+            </a:pPr>
+            <a:r>
+              <a:rPr sz="600" b="0" i="1">
+                <a:solidFill>
+                  <a:srgbClr val="727375"/>
+                </a:solidFill>
+                <a:latin typeface="Arial"/>
+              </a:rPr>
+              <a:t>TAPF wastage logs</a:t>
+            </a:r>
+          </a:p>
+        </p:txBody>
+      </p:sp>
+      <p:sp>
+        <p:nvSpPr>
+          <p:cNvPr id="17" name="Rectangle 16"/>
+          <p:cNvSpPr/>
+          <p:nvPr/>
+        </p:nvSpPr>
+        <p:spPr>
+          <a:xfrm>
+            <a:off x="1554480" y="2761487"/>
+            <a:ext cx="731520" cy="660196"/>
+          </a:xfrm>
+          <a:prstGeom prst="rect">
+            <a:avLst/>
+          </a:prstGeom>
+          <a:solidFill>
+            <a:srgbClr val="095F61"/>
+          </a:solidFill>
+          <a:ln>
+            <a:noFill/>
+          </a:ln>
+          <a:effectLst/>
+        </p:spPr>
+        <p:style>
+          <a:lnRef idx="1">
+            <a:schemeClr val="accent1"/>
+          </a:lnRef>
+          <a:fillRef idx="3">
+            <a:schemeClr val="accent1"/>
+          </a:fillRef>
+          <a:effectRef idx="2">
+            <a:schemeClr val="accent1"/>
+          </a:effectRef>
+          <a:fontRef idx="minor">
+            <a:schemeClr val="lt1"/>
+          </a:fontRef>
+        </p:style>
+        <p:txBody>
+          <a:bodyPr rtlCol="0" anchor="ctr"/>
+          <a:lstStyle/>
+          <a:p>
+            <a:pPr algn="ctr"/>
+          </a:p>
+        </p:txBody>
+      </p:sp>
+      <p:sp>
+        <p:nvSpPr>
+          <p:cNvPr id="18" name="TextBox 17"/>
+          <p:cNvSpPr txBox="1"/>
+          <p:nvPr/>
+        </p:nvSpPr>
+        <p:spPr>
+          <a:xfrm>
+            <a:off x="1417320" y="2542031"/>
+            <a:ext cx="1005840" cy="201168"/>
+          </a:xfrm>
+          <a:prstGeom prst="rect">
+            <a:avLst/>
+          </a:prstGeom>
+          <a:noFill/>
+        </p:spPr>
+        <p:txBody>
+          <a:bodyPr wrap="square" lIns="0" rIns="0" tIns="0" bIns="0" anchor="t">
+            <a:spAutoFit/>
+          </a:bodyPr>
+          <a:lstStyle/>
+          <a:p>
+            <a:pPr algn="ctr">
+              <a:lnSpc>
+                <a:spcPct val="100000"/>
+              </a:lnSpc>
+              <a:spcBef>
+                <a:spcPts val="0"/>
+              </a:spcBef>
+              <a:spcAft>
+                <a:spcPts val="0"/>
+              </a:spcAft>
+            </a:pPr>
+            <a:r>
+              <a:rPr sz="950" b="1" i="0">
+                <a:solidFill>
+                  <a:srgbClr val="1B3E6E"/>
+                </a:solidFill>
+                <a:latin typeface="Arial"/>
+              </a:rPr>
+              <a:t>+1.9</a:t>
+            </a:r>
+          </a:p>
+        </p:txBody>
+      </p:sp>
+      <p:sp>
+        <p:nvSpPr>
+          <p:cNvPr id="19" name="TextBox 18"/>
+          <p:cNvSpPr txBox="1"/>
+          <p:nvPr/>
+        </p:nvSpPr>
+        <p:spPr>
+          <a:xfrm>
+            <a:off x="1408176" y="4901183"/>
+            <a:ext cx="1024128" cy="502920"/>
+          </a:xfrm>
+          <a:prstGeom prst="rect">
+            <a:avLst/>
+          </a:prstGeom>
+          <a:noFill/>
+        </p:spPr>
+        <p:txBody>
+          <a:bodyPr wrap="square" lIns="0" rIns="0" tIns="0" bIns="0" anchor="t">
+            <a:spAutoFit/>
+          </a:bodyPr>
+          <a:lstStyle/>
+          <a:p>
+            <a:pPr algn="ctr">
+              <a:lnSpc>
+                <a:spcPct val="90000"/>
+              </a:lnSpc>
+              <a:spcBef>
+                <a:spcPts val="0"/>
+              </a:spcBef>
+              <a:spcAft>
+                <a:spcPts val="100"/>
+              </a:spcAft>
+            </a:pPr>
+            <a:r>
+              <a:rPr sz="690" b="1" i="0">
+                <a:solidFill>
+                  <a:srgbClr val="333333"/>
+                </a:solidFill>
+                <a:latin typeface="Arial"/>
+              </a:rPr>
+              <a:t>Dhals buy-timing
+6–7% spread</a:t>
+            </a:r>
+          </a:p>
+          <a:p>
+            <a:pPr algn="ctr">
+              <a:lnSpc>
+                <a:spcPct val="100000"/>
+              </a:lnSpc>
+              <a:spcBef>
+                <a:spcPts val="0"/>
+              </a:spcBef>
+              <a:spcAft>
+                <a:spcPts val="0"/>
+              </a:spcAft>
+            </a:pPr>
+            <a:r>
+              <a:rPr sz="600" b="0" i="1">
+                <a:solidFill>
+                  <a:srgbClr val="727375"/>
+                </a:solidFill>
+                <a:latin typeface="Arial"/>
+              </a:rPr>
+              <a:t>TAPF price data</a:t>
+            </a:r>
+          </a:p>
+        </p:txBody>
+      </p:sp>
+      <p:cxnSp>
+        <p:nvCxnSpPr>
+          <p:cNvPr id="20" name="Connector 19"/>
+          <p:cNvCxnSpPr/>
+          <p:nvPr/>
+        </p:nvCxnSpPr>
+        <p:spPr>
+          <a:xfrm>
+            <a:off x="1298448" y="3421684"/>
+            <a:ext cx="256032" cy="0"/>
+          </a:xfrm>
+          <a:prstGeom prst="line">
+            <a:avLst/>
+          </a:prstGeom>
+          <a:ln w="11430">
+            <a:solidFill>
+              <a:srgbClr val="727375"/>
+            </a:solidFill>
+            <a:prstDash val="sysDash"/>
+          </a:ln>
+          <a:effectLst/>
+        </p:spPr>
+        <p:style>
+          <a:lnRef idx="2">
+            <a:schemeClr val="accent1"/>
+          </a:lnRef>
+          <a:fillRef idx="0">
+            <a:schemeClr val="accent1"/>
+          </a:fillRef>
+          <a:effectRef idx="1">
+            <a:schemeClr val="accent1"/>
+          </a:effectRef>
+          <a:fontRef idx="minor">
+            <a:schemeClr val="tx1"/>
+          </a:fontRef>
+        </p:style>
+      </p:cxnSp>
+      <p:sp>
+        <p:nvSpPr>
+          <p:cNvPr id="21" name="Rectangle 20"/>
+          <p:cNvSpPr/>
+          <p:nvPr/>
+        </p:nvSpPr>
+        <p:spPr>
+          <a:xfrm>
+            <a:off x="2542032" y="2483510"/>
+            <a:ext cx="731520" cy="277977"/>
+          </a:xfrm>
+          <a:prstGeom prst="rect">
+            <a:avLst/>
+          </a:prstGeom>
+          <a:solidFill>
+            <a:srgbClr val="F3C43F"/>
+          </a:solidFill>
+          <a:ln>
+            <a:noFill/>
+          </a:ln>
+          <a:effectLst/>
+        </p:spPr>
+        <p:style>
+          <a:lnRef idx="1">
+            <a:schemeClr val="accent1"/>
+          </a:lnRef>
+          <a:fillRef idx="3">
+            <a:schemeClr val="accent1"/>
+          </a:fillRef>
+          <a:effectRef idx="2">
+            <a:schemeClr val="accent1"/>
+          </a:effectRef>
+          <a:fontRef idx="minor">
+            <a:schemeClr val="lt1"/>
+          </a:fontRef>
+        </p:style>
+        <p:txBody>
+          <a:bodyPr rtlCol="0" anchor="ctr"/>
+          <a:lstStyle/>
+          <a:p>
+            <a:pPr algn="ctr"/>
+          </a:p>
+        </p:txBody>
+      </p:sp>
+      <p:sp>
+        <p:nvSpPr>
+          <p:cNvPr id="22" name="TextBox 21"/>
+          <p:cNvSpPr txBox="1"/>
+          <p:nvPr/>
+        </p:nvSpPr>
+        <p:spPr>
+          <a:xfrm>
+            <a:off x="2404872" y="2264054"/>
+            <a:ext cx="1005840" cy="201168"/>
+          </a:xfrm>
+          <a:prstGeom prst="rect">
+            <a:avLst/>
+          </a:prstGeom>
+          <a:noFill/>
+        </p:spPr>
+        <p:txBody>
+          <a:bodyPr wrap="square" lIns="0" rIns="0" tIns="0" bIns="0" anchor="t">
+            <a:spAutoFit/>
+          </a:bodyPr>
+          <a:lstStyle/>
+          <a:p>
+            <a:pPr algn="ctr">
+              <a:lnSpc>
+                <a:spcPct val="100000"/>
+              </a:lnSpc>
+              <a:spcBef>
+                <a:spcPts val="0"/>
+              </a:spcBef>
+              <a:spcAft>
+                <a:spcPts val="0"/>
+              </a:spcAft>
+            </a:pPr>
+            <a:r>
+              <a:rPr sz="950" b="1" i="0">
+                <a:solidFill>
+                  <a:srgbClr val="1B3E6E"/>
+                </a:solidFill>
+                <a:latin typeface="Arial"/>
+              </a:rPr>
+              <a:t>+0.8</a:t>
+            </a:r>
+          </a:p>
+        </p:txBody>
+      </p:sp>
+      <p:sp>
+        <p:nvSpPr>
+          <p:cNvPr id="23" name="TextBox 22"/>
+          <p:cNvSpPr txBox="1"/>
+          <p:nvPr/>
+        </p:nvSpPr>
+        <p:spPr>
+          <a:xfrm>
+            <a:off x="2395727" y="4901183"/>
+            <a:ext cx="1024128" cy="502920"/>
+          </a:xfrm>
+          <a:prstGeom prst="rect">
+            <a:avLst/>
+          </a:prstGeom>
+          <a:noFill/>
+        </p:spPr>
+        <p:txBody>
+          <a:bodyPr wrap="square" lIns="0" rIns="0" tIns="0" bIns="0" anchor="t">
+            <a:spAutoFit/>
+          </a:bodyPr>
+          <a:lstStyle/>
+          <a:p>
+            <a:pPr algn="ctr">
+              <a:lnSpc>
+                <a:spcPct val="90000"/>
+              </a:lnSpc>
+              <a:spcBef>
+                <a:spcPts val="0"/>
+              </a:spcBef>
+              <a:spcAft>
+                <a:spcPts val="100"/>
+              </a:spcAft>
+            </a:pPr>
+            <a:r>
+              <a:rPr sz="690" b="1" i="0">
+                <a:solidFill>
+                  <a:srgbClr val="333333"/>
+                </a:solidFill>
+                <a:latin typeface="Arial"/>
+              </a:rPr>
+              <a:t>Oils buy-timing
+4–5% spread</a:t>
+            </a:r>
+          </a:p>
+          <a:p>
+            <a:pPr algn="ctr">
+              <a:lnSpc>
+                <a:spcPct val="100000"/>
+              </a:lnSpc>
+              <a:spcBef>
+                <a:spcPts val="0"/>
+              </a:spcBef>
+              <a:spcAft>
+                <a:spcPts val="0"/>
+              </a:spcAft>
+            </a:pPr>
+            <a:r>
+              <a:rPr sz="600" b="0" i="1">
+                <a:solidFill>
+                  <a:srgbClr val="727375"/>
+                </a:solidFill>
+                <a:latin typeface="Arial"/>
+              </a:rPr>
+              <a:t>TAPF price data</a:t>
+            </a:r>
+          </a:p>
+        </p:txBody>
+      </p:sp>
+      <p:cxnSp>
+        <p:nvCxnSpPr>
+          <p:cNvPr id="24" name="Connector 23"/>
+          <p:cNvCxnSpPr/>
+          <p:nvPr/>
+        </p:nvCxnSpPr>
+        <p:spPr>
+          <a:xfrm>
+            <a:off x="2286000" y="2761487"/>
+            <a:ext cx="256032" cy="0"/>
+          </a:xfrm>
+          <a:prstGeom prst="line">
+            <a:avLst/>
+          </a:prstGeom>
+          <a:ln w="11430">
+            <a:solidFill>
+              <a:srgbClr val="727375"/>
+            </a:solidFill>
+            <a:prstDash val="sysDash"/>
+          </a:ln>
+          <a:effectLst/>
+        </p:spPr>
+        <p:style>
+          <a:lnRef idx="2">
+            <a:schemeClr val="accent1"/>
+          </a:lnRef>
+          <a:fillRef idx="0">
+            <a:schemeClr val="accent1"/>
+          </a:fillRef>
+          <a:effectRef idx="1">
+            <a:schemeClr val="accent1"/>
+          </a:effectRef>
+          <a:fontRef idx="minor">
+            <a:schemeClr val="tx1"/>
+          </a:fontRef>
+        </p:style>
+      </p:cxnSp>
+      <p:sp>
+        <p:nvSpPr>
+          <p:cNvPr id="25" name="Rectangle 24"/>
+          <p:cNvSpPr/>
+          <p:nvPr/>
+        </p:nvSpPr>
+        <p:spPr>
+          <a:xfrm>
+            <a:off x="3529584" y="2483510"/>
+            <a:ext cx="731520" cy="277977"/>
+          </a:xfrm>
+          <a:prstGeom prst="rect">
+            <a:avLst/>
+          </a:prstGeom>
+          <a:solidFill>
+            <a:srgbClr val="C22310"/>
+          </a:solidFill>
+          <a:ln>
+            <a:noFill/>
+          </a:ln>
+          <a:effectLst/>
+        </p:spPr>
+        <p:style>
+          <a:lnRef idx="1">
+            <a:schemeClr val="accent1"/>
+          </a:lnRef>
+          <a:fillRef idx="3">
+            <a:schemeClr val="accent1"/>
+          </a:fillRef>
+          <a:effectRef idx="2">
+            <a:schemeClr val="accent1"/>
+          </a:effectRef>
+          <a:fontRef idx="minor">
+            <a:schemeClr val="lt1"/>
+          </a:fontRef>
+        </p:style>
+        <p:txBody>
+          <a:bodyPr rtlCol="0" anchor="ctr"/>
+          <a:lstStyle/>
+          <a:p>
+            <a:pPr algn="ctr"/>
+          </a:p>
+        </p:txBody>
+      </p:sp>
+      <p:sp>
+        <p:nvSpPr>
+          <p:cNvPr id="26" name="TextBox 25"/>
+          <p:cNvSpPr txBox="1"/>
+          <p:nvPr/>
+        </p:nvSpPr>
+        <p:spPr>
+          <a:xfrm>
+            <a:off x="3392424" y="2264054"/>
+            <a:ext cx="1005840" cy="201168"/>
+          </a:xfrm>
+          <a:prstGeom prst="rect">
+            <a:avLst/>
+          </a:prstGeom>
+          <a:noFill/>
+        </p:spPr>
+        <p:txBody>
+          <a:bodyPr wrap="square" lIns="0" rIns="0" tIns="0" bIns="0" anchor="t">
+            <a:spAutoFit/>
+          </a:bodyPr>
+          <a:lstStyle/>
+          <a:p>
+            <a:pPr algn="ctr">
+              <a:lnSpc>
+                <a:spcPct val="100000"/>
+              </a:lnSpc>
+              <a:spcBef>
+                <a:spcPts val="0"/>
+              </a:spcBef>
+              <a:spcAft>
+                <a:spcPts val="0"/>
+              </a:spcAft>
+            </a:pPr>
+            <a:r>
+              <a:rPr sz="950" b="1" i="0">
+                <a:solidFill>
+                  <a:srgbClr val="C22310"/>
+                </a:solidFill>
+                <a:latin typeface="Arial"/>
+              </a:rPr>
+              <a:t>−0.8</a:t>
+            </a:r>
+          </a:p>
+        </p:txBody>
+      </p:sp>
+      <p:sp>
+        <p:nvSpPr>
+          <p:cNvPr id="27" name="TextBox 26"/>
+          <p:cNvSpPr txBox="1"/>
+          <p:nvPr/>
+        </p:nvSpPr>
+        <p:spPr>
+          <a:xfrm>
+            <a:off x="3383279" y="4901183"/>
+            <a:ext cx="1024128" cy="502920"/>
+          </a:xfrm>
+          <a:prstGeom prst="rect">
+            <a:avLst/>
+          </a:prstGeom>
+          <a:noFill/>
+        </p:spPr>
+        <p:txBody>
+          <a:bodyPr wrap="square" lIns="0" rIns="0" tIns="0" bIns="0" anchor="t">
+            <a:spAutoFit/>
+          </a:bodyPr>
+          <a:lstStyle/>
+          <a:p>
+            <a:pPr algn="ctr">
+              <a:lnSpc>
+                <a:spcPct val="90000"/>
+              </a:lnSpc>
+              <a:spcBef>
+                <a:spcPts val="0"/>
+              </a:spcBef>
+              <a:spcAft>
+                <a:spcPts val="100"/>
+              </a:spcAft>
+            </a:pPr>
+            <a:r>
+              <a:rPr sz="690" b="1" i="0">
+                <a:solidFill>
+                  <a:srgbClr val="333333"/>
+                </a:solidFill>
+                <a:latin typeface="Arial"/>
+              </a:rPr>
+              <a:t>Storage &amp;
+carry cost</a:t>
+            </a:r>
+          </a:p>
+          <a:p>
+            <a:pPr algn="ctr">
+              <a:lnSpc>
+                <a:spcPct val="100000"/>
+              </a:lnSpc>
+              <a:spcBef>
+                <a:spcPts val="0"/>
+              </a:spcBef>
+              <a:spcAft>
+                <a:spcPts val="0"/>
+              </a:spcAft>
+            </a:pPr>
+            <a:r>
+              <a:rPr sz="600" b="0" i="1">
+                <a:solidFill>
+                  <a:srgbClr val="727375"/>
+                </a:solidFill>
+                <a:latin typeface="Arial"/>
+              </a:rPr>
+              <a:t>netted off</a:t>
+            </a:r>
+          </a:p>
+        </p:txBody>
+      </p:sp>
+      <p:cxnSp>
+        <p:nvCxnSpPr>
+          <p:cNvPr id="28" name="Connector 27"/>
+          <p:cNvCxnSpPr/>
+          <p:nvPr/>
+        </p:nvCxnSpPr>
+        <p:spPr>
+          <a:xfrm>
+            <a:off x="3273552" y="2483510"/>
+            <a:ext cx="256032" cy="0"/>
+          </a:xfrm>
+          <a:prstGeom prst="line">
+            <a:avLst/>
+          </a:prstGeom>
+          <a:ln w="11430">
+            <a:solidFill>
+              <a:srgbClr val="727375"/>
+            </a:solidFill>
+            <a:prstDash val="sysDash"/>
+          </a:ln>
+          <a:effectLst/>
+        </p:spPr>
+        <p:style>
+          <a:lnRef idx="2">
+            <a:schemeClr val="accent1"/>
+          </a:lnRef>
+          <a:fillRef idx="0">
+            <a:schemeClr val="accent1"/>
+          </a:fillRef>
+          <a:effectRef idx="1">
+            <a:schemeClr val="accent1"/>
+          </a:effectRef>
+          <a:fontRef idx="minor">
+            <a:schemeClr val="tx1"/>
+          </a:fontRef>
+        </p:style>
+      </p:cxnSp>
+      <p:sp>
+        <p:nvSpPr>
+          <p:cNvPr id="29" name="Rectangle 28"/>
+          <p:cNvSpPr/>
+          <p:nvPr/>
+        </p:nvSpPr>
+        <p:spPr>
+          <a:xfrm>
+            <a:off x="4517136" y="2761487"/>
+            <a:ext cx="731520" cy="2084832"/>
+          </a:xfrm>
+          <a:prstGeom prst="rect">
+            <a:avLst/>
+          </a:prstGeom>
+          <a:solidFill>
+            <a:srgbClr val="1B3E6E"/>
+          </a:solidFill>
+          <a:ln>
+            <a:noFill/>
+          </a:ln>
+          <a:effectLst/>
+        </p:spPr>
+        <p:style>
+          <a:lnRef idx="1">
+            <a:schemeClr val="accent1"/>
+          </a:lnRef>
+          <a:fillRef idx="3">
+            <a:schemeClr val="accent1"/>
+          </a:fillRef>
+          <a:effectRef idx="2">
+            <a:schemeClr val="accent1"/>
+          </a:effectRef>
+          <a:fontRef idx="minor">
+            <a:schemeClr val="lt1"/>
+          </a:fontRef>
+        </p:style>
+        <p:txBody>
+          <a:bodyPr rtlCol="0" anchor="ctr"/>
+          <a:lstStyle/>
+          <a:p>
+            <a:pPr algn="ctr"/>
+          </a:p>
+        </p:txBody>
+      </p:sp>
+      <p:sp>
+        <p:nvSpPr>
+          <p:cNvPr id="30" name="TextBox 29"/>
+          <p:cNvSpPr txBox="1"/>
+          <p:nvPr/>
+        </p:nvSpPr>
+        <p:spPr>
+          <a:xfrm>
+            <a:off x="4379976" y="2542031"/>
+            <a:ext cx="1005840" cy="201168"/>
+          </a:xfrm>
+          <a:prstGeom prst="rect">
+            <a:avLst/>
+          </a:prstGeom>
+          <a:noFill/>
+        </p:spPr>
+        <p:txBody>
+          <a:bodyPr wrap="square" lIns="0" rIns="0" tIns="0" bIns="0" anchor="t">
+            <a:spAutoFit/>
+          </a:bodyPr>
+          <a:lstStyle/>
+          <a:p>
+            <a:pPr algn="ctr">
+              <a:lnSpc>
+                <a:spcPct val="100000"/>
+              </a:lnSpc>
+              <a:spcBef>
+                <a:spcPts val="0"/>
+              </a:spcBef>
+              <a:spcAft>
+                <a:spcPts val="0"/>
+              </a:spcAft>
+            </a:pPr>
+            <a:r>
+              <a:rPr sz="950" b="1" i="0">
+                <a:solidFill>
+                  <a:srgbClr val="1B3E6E"/>
+                </a:solidFill>
+                <a:latin typeface="Arial"/>
+              </a:rPr>
+              <a:t>₹6.0 Cr</a:t>
+            </a:r>
+          </a:p>
+        </p:txBody>
+      </p:sp>
+      <p:sp>
+        <p:nvSpPr>
+          <p:cNvPr id="31" name="TextBox 30"/>
+          <p:cNvSpPr txBox="1"/>
+          <p:nvPr/>
+        </p:nvSpPr>
+        <p:spPr>
+          <a:xfrm>
+            <a:off x="4370832" y="4901183"/>
+            <a:ext cx="1024128" cy="502920"/>
+          </a:xfrm>
+          <a:prstGeom prst="rect">
+            <a:avLst/>
+          </a:prstGeom>
+          <a:noFill/>
+        </p:spPr>
+        <p:txBody>
+          <a:bodyPr wrap="square" lIns="0" rIns="0" tIns="0" bIns="0" anchor="t">
+            <a:spAutoFit/>
+          </a:bodyPr>
+          <a:lstStyle/>
+          <a:p>
+            <a:pPr algn="ctr">
+              <a:lnSpc>
+                <a:spcPct val="90000"/>
+              </a:lnSpc>
+              <a:spcBef>
+                <a:spcPts val="0"/>
+              </a:spcBef>
+              <a:spcAft>
+                <a:spcPts val="100"/>
+              </a:spcAft>
+            </a:pPr>
+            <a:r>
+              <a:rPr sz="690" b="1" i="0">
+                <a:solidFill>
+                  <a:srgbClr val="333333"/>
+                </a:solidFill>
+                <a:latin typeface="Arial"/>
+              </a:rPr>
+              <a:t>NET SAVINGS
+every year</a:t>
+            </a:r>
+          </a:p>
+          <a:p>
+            <a:pPr algn="ctr">
+              <a:lnSpc>
+                <a:spcPct val="100000"/>
+              </a:lnSpc>
+              <a:spcBef>
+                <a:spcPts val="0"/>
+              </a:spcBef>
+              <a:spcAft>
+                <a:spcPts val="0"/>
+              </a:spcAft>
+            </a:pPr>
+            <a:r>
+              <a:rPr sz="600" b="0" i="1">
+                <a:solidFill>
+                  <a:srgbClr val="727375"/>
+                </a:solidFill>
+                <a:latin typeface="Arial"/>
+              </a:rPr>
+              <a:t>recurring</a:t>
+            </a:r>
+          </a:p>
+        </p:txBody>
+      </p:sp>
+      <p:cxnSp>
+        <p:nvCxnSpPr>
+          <p:cNvPr id="32" name="Connector 31"/>
+          <p:cNvCxnSpPr/>
+          <p:nvPr/>
+        </p:nvCxnSpPr>
+        <p:spPr>
+          <a:xfrm>
+            <a:off x="4261104" y="2761487"/>
+            <a:ext cx="256032" cy="0"/>
+          </a:xfrm>
+          <a:prstGeom prst="line">
+            <a:avLst/>
+          </a:prstGeom>
+          <a:ln w="11430">
+            <a:solidFill>
+              <a:srgbClr val="727375"/>
+            </a:solidFill>
+            <a:prstDash val="sysDash"/>
+          </a:ln>
+          <a:effectLst/>
+        </p:spPr>
+        <p:style>
+          <a:lnRef idx="2">
+            <a:schemeClr val="accent1"/>
+          </a:lnRef>
+          <a:fillRef idx="0">
+            <a:schemeClr val="accent1"/>
+          </a:fillRef>
+          <a:effectRef idx="1">
+            <a:schemeClr val="accent1"/>
+          </a:effectRef>
+          <a:fontRef idx="minor">
+            <a:schemeClr val="tx1"/>
+          </a:fontRef>
+        </p:style>
+      </p:cxnSp>
+      <p:sp>
+        <p:nvSpPr>
+          <p:cNvPr id="33" name="Rectangle 32"/>
+          <p:cNvSpPr/>
+          <p:nvPr/>
+        </p:nvSpPr>
+        <p:spPr>
+          <a:xfrm>
+            <a:off x="5870448" y="1399032"/>
+            <a:ext cx="54864" cy="182880"/>
+          </a:xfrm>
+          <a:prstGeom prst="rect">
+            <a:avLst/>
+          </a:prstGeom>
+          <a:solidFill>
+            <a:srgbClr val="3B6EA5"/>
+          </a:solidFill>
+          <a:ln>
+            <a:noFill/>
+          </a:ln>
+          <a:effectLst/>
+        </p:spPr>
+        <p:style>
+          <a:lnRef idx="1">
+            <a:schemeClr val="accent1"/>
+          </a:lnRef>
+          <a:fillRef idx="3">
+            <a:schemeClr val="accent1"/>
+          </a:fillRef>
+          <a:effectRef idx="2">
+            <a:schemeClr val="accent1"/>
+          </a:effectRef>
+          <a:fontRef idx="minor">
+            <a:schemeClr val="lt1"/>
+          </a:fontRef>
+        </p:style>
+        <p:txBody>
+          <a:bodyPr rtlCol="0" anchor="ctr"/>
+          <a:lstStyle/>
+          <a:p>
+            <a:pPr algn="ctr"/>
+          </a:p>
+        </p:txBody>
+      </p:sp>
+      <p:sp>
+        <p:nvSpPr>
+          <p:cNvPr id="34" name="TextBox 33"/>
+          <p:cNvSpPr txBox="1"/>
+          <p:nvPr/>
+        </p:nvSpPr>
+        <p:spPr>
+          <a:xfrm>
+            <a:off x="6016752" y="1371600"/>
+            <a:ext cx="2761487" cy="256032"/>
+          </a:xfrm>
+          <a:prstGeom prst="rect">
+            <a:avLst/>
+          </a:prstGeom>
+          <a:noFill/>
+        </p:spPr>
+        <p:txBody>
+          <a:bodyPr wrap="square" lIns="0" rIns="0" tIns="0" bIns="0" anchor="t">
+            <a:spAutoFit/>
+          </a:bodyPr>
+          <a:lstStyle/>
+          <a:p>
+            <a:pPr algn="l">
+              <a:lnSpc>
+                <a:spcPct val="100000"/>
+              </a:lnSpc>
+              <a:spcBef>
+                <a:spcPts val="0"/>
+              </a:spcBef>
+              <a:spcAft>
+                <a:spcPts val="0"/>
+              </a:spcAft>
+            </a:pPr>
+            <a:r>
+              <a:rPr sz="950" b="1" i="0">
+                <a:solidFill>
+                  <a:srgbClr val="1B3E6E"/>
+                </a:solidFill>
+                <a:latin typeface="Arial"/>
+              </a:rPr>
+              <a:t>Capture ramp (₹ Cr saved / yr)</a:t>
+            </a:r>
+          </a:p>
+        </p:txBody>
+      </p:sp>
+      <p:sp>
+        <p:nvSpPr>
+          <p:cNvPr id="35" name="Rectangle 34"/>
+          <p:cNvSpPr/>
+          <p:nvPr/>
+        </p:nvSpPr>
+        <p:spPr>
+          <a:xfrm>
+            <a:off x="5870448" y="1645920"/>
+            <a:ext cx="2907791" cy="10972"/>
+          </a:xfrm>
+          <a:prstGeom prst="rect">
+            <a:avLst/>
+          </a:prstGeom>
+          <a:solidFill>
+            <a:srgbClr val="BFBFBF"/>
+          </a:solidFill>
+          <a:ln>
+            <a:noFill/>
+          </a:ln>
+          <a:effectLst/>
+        </p:spPr>
+        <p:style>
+          <a:lnRef idx="1">
+            <a:schemeClr val="accent1"/>
+          </a:lnRef>
+          <a:fillRef idx="3">
+            <a:schemeClr val="accent1"/>
+          </a:fillRef>
+          <a:effectRef idx="2">
+            <a:schemeClr val="accent1"/>
+          </a:effectRef>
+          <a:fontRef idx="minor">
+            <a:schemeClr val="lt1"/>
+          </a:fontRef>
+        </p:style>
+        <p:txBody>
+          <a:bodyPr rtlCol="0" anchor="ctr"/>
+          <a:lstStyle/>
+          <a:p>
+            <a:pPr algn="ctr"/>
+          </a:p>
+        </p:txBody>
+      </p:sp>
+      <p:graphicFrame>
+        <p:nvGraphicFramePr>
+          <p:cNvPr id="36" name="Chart 35"/>
+          <p:cNvGraphicFramePr>
+            <a:graphicFrameLocks noGrp="1"/>
+          </p:cNvGraphicFramePr>
+          <p:nvPr/>
+        </p:nvGraphicFramePr>
+        <p:xfrm>
+          <a:off x="5870448" y="1737360"/>
+          <a:ext cx="2907791" cy="1188720"/>
+        </p:xfrm>
+        <a:graphic>
+          <a:graphicData uri="http://schemas.openxmlformats.org/drawingml/2006/chart">
+            <c:chart xmlns:c="http://schemas.openxmlformats.org/drawingml/2006/chart" r:id="rId2"/>
+          </a:graphicData>
+        </a:graphic>
+      </p:graphicFrame>
+      <p:sp>
+        <p:nvSpPr>
+          <p:cNvPr id="37" name="TextBox 36"/>
+          <p:cNvSpPr txBox="1"/>
+          <p:nvPr/>
+        </p:nvSpPr>
+        <p:spPr>
+          <a:xfrm>
+            <a:off x="5870448" y="2962656"/>
+            <a:ext cx="2907791" cy="182880"/>
+          </a:xfrm>
+          <a:prstGeom prst="rect">
+            <a:avLst/>
+          </a:prstGeom>
+          <a:noFill/>
+        </p:spPr>
+        <p:txBody>
+          <a:bodyPr wrap="square" lIns="0" rIns="0" tIns="0" bIns="0" anchor="t">
+            <a:spAutoFit/>
+          </a:bodyPr>
+          <a:lstStyle/>
+          <a:p>
+            <a:pPr algn="ctr">
+              <a:lnSpc>
+                <a:spcPct val="100000"/>
+              </a:lnSpc>
+              <a:spcBef>
+                <a:spcPts val="0"/>
+              </a:spcBef>
+              <a:spcAft>
+                <a:spcPts val="0"/>
+              </a:spcAft>
+            </a:pPr>
+            <a:r>
+              <a:rPr sz="650" b="0" i="1">
+                <a:solidFill>
+                  <a:srgbClr val="727375"/>
+                </a:solidFill>
+                <a:latin typeface="Arial"/>
+              </a:rPr>
+              <a:t>pilot 30% → scale 60% → steady-state 85% capture</a:t>
+            </a:r>
+          </a:p>
+        </p:txBody>
+      </p:sp>
+      <p:sp>
+        <p:nvSpPr>
+          <p:cNvPr id="38" name="Rectangle 37"/>
+          <p:cNvSpPr/>
+          <p:nvPr/>
+        </p:nvSpPr>
+        <p:spPr>
+          <a:xfrm>
+            <a:off x="5870448" y="3337560"/>
+            <a:ext cx="54864" cy="182880"/>
+          </a:xfrm>
+          <a:prstGeom prst="rect">
+            <a:avLst/>
+          </a:prstGeom>
+          <a:solidFill>
+            <a:srgbClr val="398025"/>
+          </a:solidFill>
+          <a:ln>
+            <a:noFill/>
+          </a:ln>
+          <a:effectLst/>
+        </p:spPr>
+        <p:style>
+          <a:lnRef idx="1">
+            <a:schemeClr val="accent1"/>
+          </a:lnRef>
+          <a:fillRef idx="3">
+            <a:schemeClr val="accent1"/>
+          </a:fillRef>
+          <a:effectRef idx="2">
+            <a:schemeClr val="accent1"/>
+          </a:effectRef>
+          <a:fontRef idx="minor">
+            <a:schemeClr val="lt1"/>
+          </a:fontRef>
+        </p:style>
+        <p:txBody>
+          <a:bodyPr rtlCol="0" anchor="ctr"/>
+          <a:lstStyle/>
+          <a:p>
+            <a:pPr algn="ctr"/>
+          </a:p>
+        </p:txBody>
+      </p:sp>
+      <p:sp>
+        <p:nvSpPr>
+          <p:cNvPr id="39" name="TextBox 38"/>
+          <p:cNvSpPr txBox="1"/>
+          <p:nvPr/>
+        </p:nvSpPr>
+        <p:spPr>
+          <a:xfrm>
+            <a:off x="6016752" y="3310128"/>
+            <a:ext cx="2761487" cy="256032"/>
+          </a:xfrm>
+          <a:prstGeom prst="rect">
+            <a:avLst/>
+          </a:prstGeom>
+          <a:noFill/>
+        </p:spPr>
+        <p:txBody>
+          <a:bodyPr wrap="square" lIns="0" rIns="0" tIns="0" bIns="0" anchor="t">
+            <a:spAutoFit/>
+          </a:bodyPr>
+          <a:lstStyle/>
+          <a:p>
+            <a:pPr algn="l">
+              <a:lnSpc>
+                <a:spcPct val="100000"/>
+              </a:lnSpc>
+              <a:spcBef>
+                <a:spcPts val="0"/>
+              </a:spcBef>
+              <a:spcAft>
+                <a:spcPts val="0"/>
+              </a:spcAft>
+            </a:pPr>
+            <a:r>
+              <a:rPr sz="950" b="1" i="0">
+                <a:solidFill>
+                  <a:srgbClr val="1B3E6E"/>
+                </a:solidFill>
+                <a:latin typeface="Arial"/>
+              </a:rPr>
+              <a:t>What ₹6 Cr/yr buys — every year</a:t>
+            </a:r>
+          </a:p>
+        </p:txBody>
+      </p:sp>
+      <p:sp>
+        <p:nvSpPr>
+          <p:cNvPr id="40" name="Rectangle 39"/>
+          <p:cNvSpPr/>
+          <p:nvPr/>
+        </p:nvSpPr>
+        <p:spPr>
+          <a:xfrm>
+            <a:off x="5870448" y="3584448"/>
+            <a:ext cx="2907791" cy="10972"/>
+          </a:xfrm>
+          <a:prstGeom prst="rect">
+            <a:avLst/>
+          </a:prstGeom>
+          <a:solidFill>
+            <a:srgbClr val="BFBFBF"/>
+          </a:solidFill>
+          <a:ln>
+            <a:noFill/>
+          </a:ln>
+          <a:effectLst/>
+        </p:spPr>
+        <p:style>
+          <a:lnRef idx="1">
+            <a:schemeClr val="accent1"/>
+          </a:lnRef>
+          <a:fillRef idx="3">
+            <a:schemeClr val="accent1"/>
+          </a:fillRef>
+          <a:effectRef idx="2">
+            <a:schemeClr val="accent1"/>
+          </a:effectRef>
+          <a:fontRef idx="minor">
+            <a:schemeClr val="lt1"/>
+          </a:fontRef>
+        </p:style>
+        <p:txBody>
+          <a:bodyPr rtlCol="0" anchor="ctr"/>
+          <a:lstStyle/>
+          <a:p>
+            <a:pPr algn="ctr"/>
+          </a:p>
+        </p:txBody>
+      </p:sp>
+      <p:sp>
+        <p:nvSpPr>
+          <p:cNvPr id="41" name="TextBox 40"/>
+          <p:cNvSpPr txBox="1"/>
+          <p:nvPr/>
+        </p:nvSpPr>
+        <p:spPr>
+          <a:xfrm>
+            <a:off x="5870448" y="3694176"/>
+            <a:ext cx="2907791" cy="512064"/>
+          </a:xfrm>
+          <a:prstGeom prst="rect">
+            <a:avLst/>
+          </a:prstGeom>
+          <a:noFill/>
+        </p:spPr>
+        <p:txBody>
+          <a:bodyPr wrap="square" lIns="0" rIns="0" tIns="0" bIns="0" anchor="t">
+            <a:spAutoFit/>
+          </a:bodyPr>
+          <a:lstStyle/>
+          <a:p>
+            <a:pPr algn="l">
+              <a:lnSpc>
+                <a:spcPct val="95000"/>
+              </a:lnSpc>
+              <a:spcBef>
+                <a:spcPts val="0"/>
+              </a:spcBef>
+              <a:spcAft>
+                <a:spcPts val="0"/>
+              </a:spcAft>
+            </a:pPr>
+            <a:r>
+              <a:rPr sz="950" b="1" i="0">
+                <a:solidFill>
+                  <a:srgbClr val="1B3E6E"/>
+                </a:solidFill>
+                <a:latin typeface="Arial"/>
+              </a:rPr>
+              <a:t>₹6.0 Cr  </a:t>
+            </a:r>
+            <a:r>
+              <a:rPr sz="950" b="0" i="0">
+                <a:solidFill>
+                  <a:srgbClr val="333333"/>
+                </a:solidFill>
+                <a:latin typeface="Arial"/>
+              </a:rPr>
+              <a:t>saved annually, steady-state</a:t>
+            </a:r>
+          </a:p>
+        </p:txBody>
+      </p:sp>
+      <p:cxnSp>
+        <p:nvCxnSpPr>
+          <p:cNvPr id="42" name="Connector 41"/>
+          <p:cNvCxnSpPr/>
+          <p:nvPr/>
+        </p:nvCxnSpPr>
+        <p:spPr>
+          <a:xfrm>
+            <a:off x="6144768" y="3950208"/>
+            <a:ext cx="0" cy="219456"/>
+          </a:xfrm>
+          <a:prstGeom prst="line">
+            <a:avLst/>
+          </a:prstGeom>
+          <a:ln w="12700">
+            <a:solidFill>
+              <a:srgbClr val="BFBFBF"/>
+            </a:solidFill>
+            <a:prstDash val="sysDash"/>
+            <a:tailEnd type="triangle" w="med" len="med"/>
+          </a:ln>
+          <a:effectLst/>
+        </p:spPr>
+        <p:style>
+          <a:lnRef idx="2">
+            <a:schemeClr val="accent1"/>
+          </a:lnRef>
+          <a:fillRef idx="0">
+            <a:schemeClr val="accent1"/>
+          </a:fillRef>
+          <a:effectRef idx="1">
+            <a:schemeClr val="accent1"/>
+          </a:effectRef>
+          <a:fontRef idx="minor">
+            <a:schemeClr val="tx1"/>
+          </a:fontRef>
+        </p:style>
+      </p:cxnSp>
+      <p:sp>
+        <p:nvSpPr>
+          <p:cNvPr id="43" name="TextBox 42"/>
+          <p:cNvSpPr txBox="1"/>
+          <p:nvPr/>
+        </p:nvSpPr>
+        <p:spPr>
+          <a:xfrm>
+            <a:off x="5870448" y="4242816"/>
+            <a:ext cx="2907791" cy="512064"/>
+          </a:xfrm>
+          <a:prstGeom prst="rect">
+            <a:avLst/>
+          </a:prstGeom>
+          <a:noFill/>
+        </p:spPr>
+        <p:txBody>
+          <a:bodyPr wrap="square" lIns="0" rIns="0" tIns="0" bIns="0" anchor="t">
+            <a:spAutoFit/>
+          </a:bodyPr>
+          <a:lstStyle/>
+          <a:p>
+            <a:pPr algn="l">
+              <a:lnSpc>
+                <a:spcPct val="95000"/>
+              </a:lnSpc>
+              <a:spcBef>
+                <a:spcPts val="0"/>
+              </a:spcBef>
+              <a:spcAft>
+                <a:spcPts val="0"/>
+              </a:spcAft>
+            </a:pPr>
+            <a:r>
+              <a:rPr sz="800" b="1" i="0">
+                <a:solidFill>
+                  <a:srgbClr val="727375"/>
+                </a:solidFill>
+                <a:latin typeface="Arial"/>
+              </a:rPr>
+              <a:t>at ₹6.56  </a:t>
+            </a:r>
+            <a:r>
+              <a:rPr sz="800" b="0" i="0">
+                <a:solidFill>
+                  <a:srgbClr val="333333"/>
+                </a:solidFill>
+                <a:latin typeface="Arial"/>
+              </a:rPr>
+              <a:t>donor cost per meal (govt funds the rest)</a:t>
+            </a:r>
+          </a:p>
+        </p:txBody>
+      </p:sp>
+      <p:cxnSp>
+        <p:nvCxnSpPr>
+          <p:cNvPr id="44" name="Connector 43"/>
+          <p:cNvCxnSpPr/>
+          <p:nvPr/>
+        </p:nvCxnSpPr>
+        <p:spPr>
+          <a:xfrm>
+            <a:off x="6144768" y="4498848"/>
+            <a:ext cx="0" cy="219456"/>
+          </a:xfrm>
+          <a:prstGeom prst="line">
+            <a:avLst/>
+          </a:prstGeom>
+          <a:ln w="12700">
+            <a:solidFill>
+              <a:srgbClr val="BFBFBF"/>
+            </a:solidFill>
+            <a:prstDash val="sysDash"/>
+            <a:tailEnd type="triangle" w="med" len="med"/>
+          </a:ln>
+          <a:effectLst/>
+        </p:spPr>
+        <p:style>
+          <a:lnRef idx="2">
+            <a:schemeClr val="accent1"/>
+          </a:lnRef>
+          <a:fillRef idx="0">
+            <a:schemeClr val="accent1"/>
+          </a:fillRef>
+          <a:effectRef idx="1">
+            <a:schemeClr val="accent1"/>
+          </a:effectRef>
+          <a:fontRef idx="minor">
+            <a:schemeClr val="tx1"/>
+          </a:fontRef>
+        </p:style>
+      </p:cxnSp>
+      <p:sp>
+        <p:nvSpPr>
+          <p:cNvPr id="45" name="TextBox 44"/>
+          <p:cNvSpPr txBox="1"/>
+          <p:nvPr/>
+        </p:nvSpPr>
+        <p:spPr>
+          <a:xfrm>
+            <a:off x="5870448" y="4791455"/>
+            <a:ext cx="2907791" cy="512064"/>
+          </a:xfrm>
+          <a:prstGeom prst="rect">
+            <a:avLst/>
+          </a:prstGeom>
+          <a:noFill/>
+        </p:spPr>
+        <p:txBody>
+          <a:bodyPr wrap="square" lIns="0" rIns="0" tIns="0" bIns="0" anchor="t">
+            <a:spAutoFit/>
+          </a:bodyPr>
+          <a:lstStyle/>
+          <a:p>
+            <a:pPr algn="l">
+              <a:lnSpc>
+                <a:spcPct val="95000"/>
+              </a:lnSpc>
+              <a:spcBef>
+                <a:spcPts val="0"/>
+              </a:spcBef>
+              <a:spcAft>
+                <a:spcPts val="0"/>
+              </a:spcAft>
+            </a:pPr>
+            <a:r>
+              <a:rPr sz="950" b="1" i="0">
+                <a:solidFill>
+                  <a:srgbClr val="398025"/>
+                </a:solidFill>
+                <a:latin typeface="Arial"/>
+              </a:rPr>
+              <a:t>9.1M+  </a:t>
+            </a:r>
+            <a:r>
+              <a:rPr sz="950" b="0" i="0">
+                <a:solidFill>
+                  <a:srgbClr val="333333"/>
+                </a:solidFill>
+                <a:latin typeface="Arial"/>
+              </a:rPr>
+              <a:t>additional meals every year</a:t>
+            </a:r>
+          </a:p>
+        </p:txBody>
+      </p:sp>
+      <p:cxnSp>
+        <p:nvCxnSpPr>
+          <p:cNvPr id="46" name="Connector 45"/>
+          <p:cNvCxnSpPr/>
+          <p:nvPr/>
+        </p:nvCxnSpPr>
+        <p:spPr>
+          <a:xfrm>
+            <a:off x="6144768" y="5047488"/>
+            <a:ext cx="0" cy="219456"/>
+          </a:xfrm>
+          <a:prstGeom prst="line">
+            <a:avLst/>
+          </a:prstGeom>
+          <a:ln w="12700">
+            <a:solidFill>
+              <a:srgbClr val="BFBFBF"/>
+            </a:solidFill>
+            <a:prstDash val="sysDash"/>
+            <a:tailEnd type="triangle" w="med" len="med"/>
+          </a:ln>
+          <a:effectLst/>
+        </p:spPr>
+        <p:style>
+          <a:lnRef idx="2">
+            <a:schemeClr val="accent1"/>
+          </a:lnRef>
+          <a:fillRef idx="0">
+            <a:schemeClr val="accent1"/>
+          </a:fillRef>
+          <a:effectRef idx="1">
+            <a:schemeClr val="accent1"/>
+          </a:effectRef>
+          <a:fontRef idx="minor">
+            <a:schemeClr val="tx1"/>
+          </a:fontRef>
+        </p:style>
+      </p:cxnSp>
+      <p:sp>
+        <p:nvSpPr>
+          <p:cNvPr id="47" name="TextBox 46"/>
+          <p:cNvSpPr txBox="1"/>
+          <p:nvPr/>
+        </p:nvSpPr>
+        <p:spPr>
+          <a:xfrm>
+            <a:off x="5870448" y="5340095"/>
+            <a:ext cx="2907791" cy="512064"/>
+          </a:xfrm>
+          <a:prstGeom prst="rect">
+            <a:avLst/>
+          </a:prstGeom>
+          <a:noFill/>
+        </p:spPr>
+        <p:txBody>
+          <a:bodyPr wrap="square" lIns="0" rIns="0" tIns="0" bIns="0" anchor="t">
+            <a:spAutoFit/>
+          </a:bodyPr>
+          <a:lstStyle/>
+          <a:p>
+            <a:pPr algn="l">
+              <a:lnSpc>
+                <a:spcPct val="95000"/>
+              </a:lnSpc>
+              <a:spcBef>
+                <a:spcPts val="0"/>
+              </a:spcBef>
+              <a:spcAft>
+                <a:spcPts val="0"/>
+              </a:spcAft>
+            </a:pPr>
+            <a:r>
+              <a:rPr sz="950" b="1" i="0">
+                <a:solidFill>
+                  <a:srgbClr val="E08A1E"/>
+                </a:solidFill>
+                <a:latin typeface="Arial"/>
+              </a:rPr>
+              <a:t>40,000+  </a:t>
+            </a:r>
+            <a:r>
+              <a:rPr sz="950" b="0" i="0">
+                <a:solidFill>
+                  <a:srgbClr val="333333"/>
+                </a:solidFill>
+                <a:latin typeface="Arial"/>
+              </a:rPr>
+              <a:t>children fed for a full year — every year</a:t>
+            </a:r>
+          </a:p>
+        </p:txBody>
+      </p:sp>
+      <p:sp>
+        <p:nvSpPr>
+          <p:cNvPr id="48" name="TextBox 47"/>
+          <p:cNvSpPr txBox="1"/>
+          <p:nvPr/>
+        </p:nvSpPr>
+        <p:spPr>
+          <a:xfrm>
+            <a:off x="365760" y="5577840"/>
+            <a:ext cx="5120640" cy="402336"/>
+          </a:xfrm>
+          <a:prstGeom prst="rect">
+            <a:avLst/>
+          </a:prstGeom>
+          <a:noFill/>
+        </p:spPr>
+        <p:txBody>
+          <a:bodyPr wrap="square" lIns="0" rIns="0" tIns="0" bIns="0" anchor="t">
+            <a:spAutoFit/>
+          </a:bodyPr>
+          <a:lstStyle/>
+          <a:p>
+            <a:pPr algn="l">
+              <a:lnSpc>
+                <a:spcPct val="100000"/>
+              </a:lnSpc>
+              <a:spcBef>
+                <a:spcPts val="0"/>
+              </a:spcBef>
+              <a:spcAft>
+                <a:spcPts val="0"/>
+              </a:spcAft>
+            </a:pPr>
+            <a:r>
+              <a:rPr sz="620" b="0" i="1">
+                <a:solidFill>
+                  <a:srgbClr val="727375"/>
+                </a:solidFill>
+                <a:latin typeface="Arial"/>
+              </a:rPr>
+              <a:t>Assumptions: illustrative commodity split of TAPF's ₹450 Cr+ food spend; seasonal spreads per TAPF (dhals 6–7%, oils 4–5%, excl. taxation &amp; global events); wastage per TAPF supply-chain data (4.1–5.6%/month). Spatial sourcing &amp; spot-premium avoidance: not modelled — upside.</a:t>
+            </a:r>
+          </a:p>
+        </p:txBody>
+      </p:sp>
+      <p:sp>
+        <p:nvSpPr>
+          <p:cNvPr id="49" name="TextBox 48"/>
+          <p:cNvSpPr txBox="1"/>
+          <p:nvPr/>
+        </p:nvSpPr>
+        <p:spPr>
+          <a:xfrm>
+            <a:off x="4846320" y="6547104"/>
+            <a:ext cx="3401568" cy="274320"/>
+          </a:xfrm>
+          <a:prstGeom prst="rect">
+            <a:avLst/>
+          </a:prstGeom>
+          <a:noFill/>
+        </p:spPr>
+        <p:txBody>
+          <a:bodyPr wrap="square" lIns="0" rIns="0" tIns="0" bIns="0" anchor="t">
+            <a:spAutoFit/>
+          </a:bodyPr>
+          <a:lstStyle/>
+          <a:p>
+            <a:pPr algn="r">
+              <a:lnSpc>
+                <a:spcPct val="100000"/>
+              </a:lnSpc>
+              <a:spcBef>
+                <a:spcPts val="0"/>
+              </a:spcBef>
+              <a:spcAft>
+                <a:spcPts val="0"/>
+              </a:spcAft>
+            </a:pPr>
+            <a:r>
+              <a:rPr sz="650" b="0" i="1">
+                <a:solidFill>
+                  <a:srgbClr val="727375"/>
+                </a:solidFill>
+                <a:latin typeface="Arial"/>
+              </a:rPr>
+              <a:t>Source: The Akshaya Patra Foundation — official documents</a:t>
             </a:r>
           </a:p>
         </p:txBody>

</xml_diff>